<commit_message>
Defense deck: present the methodology as knowledge engineering (CommonKADS)
</commit_message>
<xml_diff>
--- a/Internal_Defense_Presentation.pptx
+++ b/Internal_Defense_Presentation.pptx
@@ -2220,7 +2220,7 @@
           <a:lstStyle/>
           <a:p>
             <a:r>
-              <a:t>The study follows the Design Science Research Methodology of Peffers and colleagues as its overall process: problem identification, objectives, design and development, demonstration, evaluation and communication. Inside that process, CommonKADS is the knowledge engineering and design framework. The Technology Acceptance Model is used only as a design lens, and it is not tested empirically because no practitioner data was collected. The Kaliisa and colleagues checklist guided the dashboard design.</a:t>
+              <a:t>The methodology is knowledge engineering, using CommonKADS. I chose it because the central design problem is a knowledge problem: how to represent the knowledge the prediction system produces, the predictions and their SHAP and LIME explanations, and deliver it to instructors, advisors and administrators according to what each of them needs. The work ran in four iterative knowledge engineering phases: knowledge acquisition and organisation analysis, knowledge and system modelling, artefact design and development, and technical evaluation. Knowledge acquisition drew on published literature, not interviews, because no practitioners were involved. Design science, following Peffers and colleagues, structures the research steps around the artefact, and the Technology Acceptance Model is only a design lens, not tested.</a:t>
             </a:r>
           </a:p>
         </p:txBody>
@@ -8996,7 +8996,7 @@
                 </a:solidFill>
                 <a:latin typeface="Calibri"/>
               </a:rPr>
-              <a:t>Methodology</a:t>
+              <a:t>Methodology: Knowledge Engineering</a:t>
             </a:r>
           </a:p>
         </p:txBody>
@@ -9042,14 +9042,14 @@
       </p:sp>
       <p:sp>
         <p:nvSpPr>
-          <p:cNvPr id="4" name="DSRM step 1"/>
+          <p:cNvPr id="4" name="KE banner"/>
           <p:cNvSpPr/>
           <p:nvPr/>
         </p:nvSpPr>
         <p:spPr>
           <a:xfrm>
-            <a:off x="2240280" y="1645919"/>
-            <a:ext cx="1828800" cy="713232"/>
+            <a:off x="2240280" y="1371600"/>
+            <a:ext cx="6309359" cy="1097280"/>
           </a:xfrm>
           <a:prstGeom prst="roundRect">
             <a:avLst>
@@ -9086,14 +9086,14 @@
       </p:sp>
       <p:sp>
         <p:nvSpPr>
-          <p:cNvPr id="5" name="DSRM text 1"/>
+          <p:cNvPr id="5" name="KE banner text"/>
           <p:cNvSpPr txBox="1"/>
           <p:nvPr/>
         </p:nvSpPr>
         <p:spPr>
           <a:xfrm>
-            <a:off x="2286000" y="1645919"/>
-            <a:ext cx="1737360" cy="713232"/>
+            <a:off x="2468880" y="1417320"/>
+            <a:ext cx="5852159" cy="1005840"/>
           </a:xfrm>
           <a:prstGeom prst="rect">
             <a:avLst/>
@@ -9106,33 +9106,148 @@
           </a:bodyPr>
           <a:lstStyle/>
           <a:p>
+            <a:pPr algn="l">
+              <a:spcAft>
+                <a:spcPts val="400"/>
+              </a:spcAft>
+            </a:pPr>
+            <a:r>
+              <a:rPr sz="1900" b="1" i="0">
+                <a:solidFill>
+                  <a:srgbClr val="FFFFFF"/>
+                </a:solidFill>
+                <a:latin typeface="Calibri"/>
+              </a:rPr>
+              <a:t>CommonKADS knowledge engineering methodology</a:t>
+            </a:r>
+          </a:p>
+          <a:p>
+            <a:pPr algn="l">
+              <a:spcAft>
+                <a:spcPts val="400"/>
+              </a:spcAft>
+            </a:pPr>
+            <a:r>
+              <a:rPr sz="1400" b="0" i="0">
+                <a:solidFill>
+                  <a:srgbClr val="E4E3F2"/>
+                </a:solidFill>
+                <a:latin typeface="Calibri"/>
+              </a:rPr>
+              <a:t>Core problem: represent the knowledge the prediction system produces and deliver it to each role according to its needs</a:t>
+            </a:r>
+          </a:p>
+        </p:txBody>
+      </p:sp>
+      <p:sp>
+        <p:nvSpPr>
+          <p:cNvPr id="6" name="KE phase 1"/>
+          <p:cNvSpPr/>
+          <p:nvPr/>
+        </p:nvSpPr>
+        <p:spPr>
+          <a:xfrm>
+            <a:off x="2240280" y="2697480"/>
+            <a:ext cx="1371600" cy="1417320"/>
+          </a:xfrm>
+          <a:prstGeom prst="roundRect">
+            <a:avLst>
+              <a:gd name="adj" fmla="val 8000"/>
+            </a:avLst>
+          </a:prstGeom>
+          <a:solidFill>
+            <a:srgbClr val="FDEBEC"/>
+          </a:solidFill>
+          <a:ln>
+            <a:noFill/>
+          </a:ln>
+          <a:effectLst/>
+        </p:spPr>
+        <p:style>
+          <a:lnRef idx="1">
+            <a:schemeClr val="accent1"/>
+          </a:lnRef>
+          <a:fillRef idx="3">
+            <a:schemeClr val="accent1"/>
+          </a:fillRef>
+          <a:effectRef idx="2">
+            <a:schemeClr val="accent1"/>
+          </a:effectRef>
+          <a:fontRef idx="minor">
+            <a:schemeClr val="lt1"/>
+          </a:fontRef>
+        </p:style>
+        <p:txBody>
+          <a:bodyPr rtlCol="0" anchor="ctr"/>
+          <a:lstStyle/>
+          <a:p/>
+        </p:txBody>
+      </p:sp>
+      <p:sp>
+        <p:nvSpPr>
+          <p:cNvPr id="7" name="KE phase text 1"/>
+          <p:cNvSpPr txBox="1"/>
+          <p:nvPr/>
+        </p:nvSpPr>
+        <p:spPr>
+          <a:xfrm>
+            <a:off x="2295144" y="2770632"/>
+            <a:ext cx="1261872" cy="1280160"/>
+          </a:xfrm>
+          <a:prstGeom prst="rect">
+            <a:avLst/>
+          </a:prstGeom>
+          <a:noFill/>
+        </p:spPr>
+        <p:txBody>
+          <a:bodyPr wrap="square" anchor="ctr" lIns="0" rIns="0" tIns="0" bIns="0">
+            <a:spAutoFit/>
+          </a:bodyPr>
+          <a:lstStyle/>
+          <a:p>
             <a:pPr algn="ctr">
               <a:spcAft>
-                <a:spcPts val="600"/>
+                <a:spcPts val="200"/>
               </a:spcAft>
             </a:pPr>
             <a:r>
-              <a:rPr sz="1500" b="1" i="0">
-                <a:solidFill>
-                  <a:srgbClr val="FFFFFF"/>
-                </a:solidFill>
-                <a:latin typeface="Calibri"/>
-              </a:rPr>
-              <a:t>1. Problem identification</a:t>
-            </a:r>
-          </a:p>
-        </p:txBody>
-      </p:sp>
-      <p:sp>
-        <p:nvSpPr>
-          <p:cNvPr id="6" name="Right Arrow 5"/>
+              <a:rPr sz="1800" b="1" i="0">
+                <a:solidFill>
+                  <a:srgbClr val="EE3138"/>
+                </a:solidFill>
+                <a:latin typeface="Calibri"/>
+              </a:rPr>
+              <a:t>1</a:t>
+            </a:r>
+          </a:p>
+          <a:p>
+            <a:pPr algn="ctr">
+              <a:spcAft>
+                <a:spcPts val="200"/>
+              </a:spcAft>
+            </a:pPr>
+            <a:r>
+              <a:rPr sz="1400" b="1" i="0">
+                <a:solidFill>
+                  <a:srgbClr val="22222A"/>
+                </a:solidFill>
+                <a:latin typeface="Calibri"/>
+              </a:rPr>
+              <a:t>Knowledge acquisition and organisation analysis</a:t>
+            </a:r>
+          </a:p>
+        </p:txBody>
+      </p:sp>
+      <p:sp>
+        <p:nvSpPr>
+          <p:cNvPr id="8" name="Right Arrow 7"/>
           <p:cNvSpPr/>
           <p:nvPr/>
         </p:nvSpPr>
         <p:spPr>
           <a:xfrm>
-            <a:off x="4142232" y="1883663"/>
-            <a:ext cx="265176" cy="237744"/>
+            <a:off x="3657600" y="3291840"/>
+            <a:ext cx="182879" cy="219456"/>
           </a:xfrm>
           <a:prstGeom prst="rightArrow">
             <a:avLst/>
@@ -9169,14 +9284,14 @@
       </p:sp>
       <p:sp>
         <p:nvSpPr>
-          <p:cNvPr id="7" name="DSRM step 2"/>
+          <p:cNvPr id="9" name="KE phase 2"/>
           <p:cNvSpPr/>
           <p:nvPr/>
         </p:nvSpPr>
         <p:spPr>
           <a:xfrm>
-            <a:off x="4480560" y="1645919"/>
-            <a:ext cx="1828800" cy="713232"/>
+            <a:off x="3886200" y="2697480"/>
+            <a:ext cx="1371600" cy="1417320"/>
           </a:xfrm>
           <a:prstGeom prst="roundRect">
             <a:avLst>
@@ -9184,7 +9299,7 @@
             </a:avLst>
           </a:prstGeom>
           <a:solidFill>
-            <a:srgbClr val="343174"/>
+            <a:srgbClr val="ECEBF5"/>
           </a:solidFill>
           <a:ln>
             <a:noFill/>
@@ -9213,14 +9328,14 @@
       </p:sp>
       <p:sp>
         <p:nvSpPr>
-          <p:cNvPr id="8" name="DSRM text 2"/>
+          <p:cNvPr id="10" name="KE phase text 2"/>
           <p:cNvSpPr txBox="1"/>
           <p:nvPr/>
         </p:nvSpPr>
         <p:spPr>
           <a:xfrm>
-            <a:off x="4526280" y="1645919"/>
-            <a:ext cx="1737360" cy="713232"/>
+            <a:off x="3941063" y="2770632"/>
+            <a:ext cx="1261872" cy="1280160"/>
           </a:xfrm>
           <a:prstGeom prst="rect">
             <a:avLst/>
@@ -9235,31 +9350,47 @@
           <a:p>
             <a:pPr algn="ctr">
               <a:spcAft>
-                <a:spcPts val="600"/>
+                <a:spcPts val="200"/>
               </a:spcAft>
             </a:pPr>
             <a:r>
-              <a:rPr sz="1500" b="1" i="0">
-                <a:solidFill>
-                  <a:srgbClr val="FFFFFF"/>
-                </a:solidFill>
-                <a:latin typeface="Calibri"/>
-              </a:rPr>
-              <a:t>2. Objectives</a:t>
-            </a:r>
-          </a:p>
-        </p:txBody>
-      </p:sp>
-      <p:sp>
-        <p:nvSpPr>
-          <p:cNvPr id="9" name="Right Arrow 8"/>
+              <a:rPr sz="1800" b="1" i="0">
+                <a:solidFill>
+                  <a:srgbClr val="343174"/>
+                </a:solidFill>
+                <a:latin typeface="Calibri"/>
+              </a:rPr>
+              <a:t>2</a:t>
+            </a:r>
+          </a:p>
+          <a:p>
+            <a:pPr algn="ctr">
+              <a:spcAft>
+                <a:spcPts val="200"/>
+              </a:spcAft>
+            </a:pPr>
+            <a:r>
+              <a:rPr sz="1400" b="1" i="0">
+                <a:solidFill>
+                  <a:srgbClr val="22222A"/>
+                </a:solidFill>
+                <a:latin typeface="Calibri"/>
+              </a:rPr>
+              <a:t>Knowledge and system modelling</a:t>
+            </a:r>
+          </a:p>
+        </p:txBody>
+      </p:sp>
+      <p:sp>
+        <p:nvSpPr>
+          <p:cNvPr id="11" name="Right Arrow 10"/>
           <p:cNvSpPr/>
           <p:nvPr/>
         </p:nvSpPr>
         <p:spPr>
           <a:xfrm>
-            <a:off x="6382512" y="1883663"/>
-            <a:ext cx="265176" cy="237744"/>
+            <a:off x="5303520" y="3291840"/>
+            <a:ext cx="182879" cy="219456"/>
           </a:xfrm>
           <a:prstGeom prst="rightArrow">
             <a:avLst/>
@@ -9296,14 +9427,14 @@
       </p:sp>
       <p:sp>
         <p:nvSpPr>
-          <p:cNvPr id="10" name="DSRM step 3"/>
+          <p:cNvPr id="12" name="KE phase 3"/>
           <p:cNvSpPr/>
           <p:nvPr/>
         </p:nvSpPr>
         <p:spPr>
           <a:xfrm>
-            <a:off x="6720840" y="1645919"/>
-            <a:ext cx="1828800" cy="713232"/>
+            <a:off x="5532120" y="2697480"/>
+            <a:ext cx="1371600" cy="1417320"/>
           </a:xfrm>
           <a:prstGeom prst="roundRect">
             <a:avLst>
@@ -9311,7 +9442,7 @@
             </a:avLst>
           </a:prstGeom>
           <a:solidFill>
-            <a:srgbClr val="343174"/>
+            <a:srgbClr val="ECEBF5"/>
           </a:solidFill>
           <a:ln>
             <a:noFill/>
@@ -9340,14 +9471,14 @@
       </p:sp>
       <p:sp>
         <p:nvSpPr>
-          <p:cNvPr id="11" name="DSRM text 3"/>
+          <p:cNvPr id="13" name="KE phase text 3"/>
           <p:cNvSpPr txBox="1"/>
           <p:nvPr/>
         </p:nvSpPr>
         <p:spPr>
           <a:xfrm>
-            <a:off x="6766560" y="1645919"/>
-            <a:ext cx="1737360" cy="713232"/>
+            <a:off x="5586984" y="2770632"/>
+            <a:ext cx="1261872" cy="1280160"/>
           </a:xfrm>
           <a:prstGeom prst="rect">
             <a:avLst/>
@@ -9362,100 +9493,33 @@
           <a:p>
             <a:pPr algn="ctr">
               <a:spcAft>
-                <a:spcPts val="600"/>
+                <a:spcPts val="200"/>
               </a:spcAft>
             </a:pPr>
             <a:r>
-              <a:rPr sz="1500" b="1" i="0">
-                <a:solidFill>
-                  <a:srgbClr val="FFFFFF"/>
-                </a:solidFill>
-                <a:latin typeface="Calibri"/>
-              </a:rPr>
-              <a:t>3. Design and development</a:t>
-            </a:r>
-          </a:p>
-        </p:txBody>
-      </p:sp>
-      <p:sp>
-        <p:nvSpPr>
-          <p:cNvPr id="12" name="DSRM step 4"/>
-          <p:cNvSpPr/>
-          <p:nvPr/>
-        </p:nvSpPr>
-        <p:spPr>
-          <a:xfrm>
-            <a:off x="2240280" y="2697479"/>
-            <a:ext cx="1828800" cy="713232"/>
-          </a:xfrm>
-          <a:prstGeom prst="roundRect">
-            <a:avLst>
-              <a:gd name="adj" fmla="val 8000"/>
-            </a:avLst>
-          </a:prstGeom>
-          <a:solidFill>
-            <a:srgbClr val="018A4B"/>
-          </a:solidFill>
-          <a:ln>
-            <a:noFill/>
-          </a:ln>
-          <a:effectLst/>
-        </p:spPr>
-        <p:style>
-          <a:lnRef idx="1">
-            <a:schemeClr val="accent1"/>
-          </a:lnRef>
-          <a:fillRef idx="3">
-            <a:schemeClr val="accent1"/>
-          </a:fillRef>
-          <a:effectRef idx="2">
-            <a:schemeClr val="accent1"/>
-          </a:effectRef>
-          <a:fontRef idx="minor">
-            <a:schemeClr val="lt1"/>
-          </a:fontRef>
-        </p:style>
-        <p:txBody>
-          <a:bodyPr rtlCol="0" anchor="ctr"/>
-          <a:lstStyle/>
-          <a:p/>
-        </p:txBody>
-      </p:sp>
-      <p:sp>
-        <p:nvSpPr>
-          <p:cNvPr id="13" name="DSRM text 4"/>
-          <p:cNvSpPr txBox="1"/>
-          <p:nvPr/>
-        </p:nvSpPr>
-        <p:spPr>
-          <a:xfrm>
-            <a:off x="2286000" y="2697479"/>
-            <a:ext cx="1737360" cy="713232"/>
-          </a:xfrm>
-          <a:prstGeom prst="rect">
-            <a:avLst/>
-          </a:prstGeom>
-          <a:noFill/>
-        </p:spPr>
-        <p:txBody>
-          <a:bodyPr wrap="square" anchor="ctr" lIns="0" rIns="0" tIns="0" bIns="0">
-            <a:spAutoFit/>
-          </a:bodyPr>
-          <a:lstStyle/>
+              <a:rPr sz="1800" b="1" i="0">
+                <a:solidFill>
+                  <a:srgbClr val="343174"/>
+                </a:solidFill>
+                <a:latin typeface="Calibri"/>
+              </a:rPr>
+              <a:t>3</a:t>
+            </a:r>
+          </a:p>
           <a:p>
             <a:pPr algn="ctr">
               <a:spcAft>
-                <a:spcPts val="600"/>
+                <a:spcPts val="200"/>
               </a:spcAft>
             </a:pPr>
             <a:r>
-              <a:rPr sz="1500" b="1" i="0">
-                <a:solidFill>
-                  <a:srgbClr val="FFFFFF"/>
-                </a:solidFill>
-                <a:latin typeface="Calibri"/>
-              </a:rPr>
-              <a:t>4. Demonstration</a:t>
+              <a:rPr sz="1400" b="1" i="0">
+                <a:solidFill>
+                  <a:srgbClr val="22222A"/>
+                </a:solidFill>
+                <a:latin typeface="Calibri"/>
+              </a:rPr>
+              <a:t>Artefact design and development</a:t>
             </a:r>
           </a:p>
         </p:txBody>
@@ -9468,8 +9532,8 @@
         </p:nvSpPr>
         <p:spPr>
           <a:xfrm>
-            <a:off x="4142232" y="2935224"/>
-            <a:ext cx="265176" cy="237744"/>
+            <a:off x="6949440" y="3291840"/>
+            <a:ext cx="182879" cy="219456"/>
           </a:xfrm>
           <a:prstGeom prst="rightArrow">
             <a:avLst/>
@@ -9506,14 +9570,14 @@
       </p:sp>
       <p:sp>
         <p:nvSpPr>
-          <p:cNvPr id="15" name="DSRM step 5"/>
+          <p:cNvPr id="15" name="KE phase 4"/>
           <p:cNvSpPr/>
           <p:nvPr/>
         </p:nvSpPr>
         <p:spPr>
           <a:xfrm>
-            <a:off x="4480560" y="2697479"/>
-            <a:ext cx="1828800" cy="713232"/>
+            <a:off x="7178040" y="2697480"/>
+            <a:ext cx="1371600" cy="1417320"/>
           </a:xfrm>
           <a:prstGeom prst="roundRect">
             <a:avLst>
@@ -9521,7 +9585,7 @@
             </a:avLst>
           </a:prstGeom>
           <a:solidFill>
-            <a:srgbClr val="018A4B"/>
+            <a:srgbClr val="E6F5EC"/>
           </a:solidFill>
           <a:ln>
             <a:noFill/>
@@ -9550,14 +9614,14 @@
       </p:sp>
       <p:sp>
         <p:nvSpPr>
-          <p:cNvPr id="16" name="DSRM text 5"/>
+          <p:cNvPr id="16" name="KE phase text 4"/>
           <p:cNvSpPr txBox="1"/>
           <p:nvPr/>
         </p:nvSpPr>
         <p:spPr>
           <a:xfrm>
-            <a:off x="4526280" y="2697479"/>
-            <a:ext cx="1737360" cy="713232"/>
+            <a:off x="7232904" y="2770632"/>
+            <a:ext cx="1261872" cy="1280160"/>
           </a:xfrm>
           <a:prstGeom prst="rect">
             <a:avLst/>
@@ -9572,158 +9636,47 @@
           <a:p>
             <a:pPr algn="ctr">
               <a:spcAft>
-                <a:spcPts val="600"/>
+                <a:spcPts val="200"/>
               </a:spcAft>
             </a:pPr>
             <a:r>
-              <a:rPr sz="1500" b="1" i="0">
-                <a:solidFill>
-                  <a:srgbClr val="FFFFFF"/>
-                </a:solidFill>
-                <a:latin typeface="Calibri"/>
-              </a:rPr>
-              <a:t>5. Evaluation</a:t>
-            </a:r>
-          </a:p>
-        </p:txBody>
-      </p:sp>
-      <p:sp>
-        <p:nvSpPr>
-          <p:cNvPr id="17" name="Right Arrow 16"/>
-          <p:cNvSpPr/>
-          <p:nvPr/>
-        </p:nvSpPr>
-        <p:spPr>
-          <a:xfrm>
-            <a:off x="6382512" y="2935224"/>
-            <a:ext cx="265176" cy="237744"/>
-          </a:xfrm>
-          <a:prstGeom prst="rightArrow">
-            <a:avLst/>
-          </a:prstGeom>
-          <a:solidFill>
-            <a:srgbClr val="555560"/>
-          </a:solidFill>
-          <a:ln>
-            <a:noFill/>
-          </a:ln>
-          <a:effectLst/>
-        </p:spPr>
-        <p:style>
-          <a:lnRef idx="1">
-            <a:schemeClr val="accent1"/>
-          </a:lnRef>
-          <a:fillRef idx="3">
-            <a:schemeClr val="accent1"/>
-          </a:fillRef>
-          <a:effectRef idx="2">
-            <a:schemeClr val="accent1"/>
-          </a:effectRef>
-          <a:fontRef idx="minor">
-            <a:schemeClr val="lt1"/>
-          </a:fontRef>
-        </p:style>
-        <p:txBody>
-          <a:bodyPr rtlCol="0" anchor="ctr"/>
-          <a:lstStyle/>
-          <a:p>
-            <a:pPr algn="ctr"/>
-          </a:p>
-        </p:txBody>
-      </p:sp>
-      <p:sp>
-        <p:nvSpPr>
-          <p:cNvPr id="18" name="DSRM step 6"/>
-          <p:cNvSpPr/>
-          <p:nvPr/>
-        </p:nvSpPr>
-        <p:spPr>
-          <a:xfrm>
-            <a:off x="6720840" y="2697479"/>
-            <a:ext cx="1828800" cy="713232"/>
-          </a:xfrm>
-          <a:prstGeom prst="roundRect">
-            <a:avLst>
-              <a:gd name="adj" fmla="val 8000"/>
-            </a:avLst>
-          </a:prstGeom>
-          <a:solidFill>
-            <a:srgbClr val="018A4B"/>
-          </a:solidFill>
-          <a:ln>
-            <a:noFill/>
-          </a:ln>
-          <a:effectLst/>
-        </p:spPr>
-        <p:style>
-          <a:lnRef idx="1">
-            <a:schemeClr val="accent1"/>
-          </a:lnRef>
-          <a:fillRef idx="3">
-            <a:schemeClr val="accent1"/>
-          </a:fillRef>
-          <a:effectRef idx="2">
-            <a:schemeClr val="accent1"/>
-          </a:effectRef>
-          <a:fontRef idx="minor">
-            <a:schemeClr val="lt1"/>
-          </a:fontRef>
-        </p:style>
-        <p:txBody>
-          <a:bodyPr rtlCol="0" anchor="ctr"/>
-          <a:lstStyle/>
-          <a:p/>
-        </p:txBody>
-      </p:sp>
-      <p:sp>
-        <p:nvSpPr>
-          <p:cNvPr id="19" name="DSRM text 6"/>
-          <p:cNvSpPr txBox="1"/>
-          <p:nvPr/>
-        </p:nvSpPr>
-        <p:spPr>
-          <a:xfrm>
-            <a:off x="6766560" y="2697479"/>
-            <a:ext cx="1737360" cy="713232"/>
-          </a:xfrm>
-          <a:prstGeom prst="rect">
-            <a:avLst/>
-          </a:prstGeom>
-          <a:noFill/>
-        </p:spPr>
-        <p:txBody>
-          <a:bodyPr wrap="square" anchor="ctr" lIns="0" rIns="0" tIns="0" bIns="0">
-            <a:spAutoFit/>
-          </a:bodyPr>
-          <a:lstStyle/>
+              <a:rPr sz="1800" b="1" i="0">
+                <a:solidFill>
+                  <a:srgbClr val="018A4B"/>
+                </a:solidFill>
+                <a:latin typeface="Calibri"/>
+              </a:rPr>
+              <a:t>4</a:t>
+            </a:r>
+          </a:p>
           <a:p>
             <a:pPr algn="ctr">
               <a:spcAft>
-                <a:spcPts val="600"/>
+                <a:spcPts val="200"/>
               </a:spcAft>
             </a:pPr>
             <a:r>
-              <a:rPr sz="1500" b="1" i="0">
-                <a:solidFill>
-                  <a:srgbClr val="FFFFFF"/>
-                </a:solidFill>
-                <a:latin typeface="Calibri"/>
-              </a:rPr>
-              <a:t>6. Communication</a:t>
-            </a:r>
-          </a:p>
-        </p:txBody>
-      </p:sp>
-      <p:sp>
-        <p:nvSpPr>
-          <p:cNvPr id="20" name="DSRM label"/>
+              <a:rPr sz="1400" b="1" i="0">
+                <a:solidFill>
+                  <a:srgbClr val="22222A"/>
+                </a:solidFill>
+                <a:latin typeface="Calibri"/>
+              </a:rPr>
+              <a:t>Technical evaluation</a:t>
+            </a:r>
+          </a:p>
+        </p:txBody>
+      </p:sp>
+      <p:sp>
+        <p:nvSpPr>
+          <p:cNvPr id="17" name="KE note"/>
           <p:cNvSpPr txBox="1"/>
           <p:nvPr/>
         </p:nvSpPr>
         <p:spPr>
           <a:xfrm>
-            <a:off x="2240280" y="1325880"/>
-            <a:ext cx="6309359" cy="274320"/>
+            <a:off x="2240280" y="4206240"/>
+            <a:ext cx="6309359" cy="365760"/>
           </a:xfrm>
           <a:prstGeom prst="rect">
             <a:avLst/>
@@ -9742,27 +9695,27 @@
               </a:spcAft>
             </a:pPr>
             <a:r>
-              <a:rPr sz="1300" b="1" i="0">
+              <a:rPr sz="1400" b="0" i="1">
                 <a:solidFill>
                   <a:srgbClr val="555560"/>
                 </a:solidFill>
                 <a:latin typeface="Calibri"/>
               </a:rPr>
-              <a:t>DSRM process (Peffers et al.)</a:t>
-            </a:r>
-          </a:p>
-        </p:txBody>
-      </p:sp>
-      <p:sp>
-        <p:nvSpPr>
-          <p:cNvPr id="21" name="Framework card 1"/>
+              <a:t>Iterative, with feedback between phases; knowledge acquired from published literature</a:t>
+            </a:r>
+          </a:p>
+        </p:txBody>
+      </p:sp>
+      <p:sp>
+        <p:nvSpPr>
+          <p:cNvPr id="18" name="Framework card 1"/>
           <p:cNvSpPr/>
           <p:nvPr/>
         </p:nvSpPr>
         <p:spPr>
           <a:xfrm>
-            <a:off x="2240280" y="3931920"/>
-            <a:ext cx="1981199" cy="1325880"/>
+            <a:off x="2240280" y="4709160"/>
+            <a:ext cx="3040379" cy="1234440"/>
           </a:xfrm>
           <a:prstGeom prst="roundRect">
             <a:avLst>
@@ -9801,14 +9754,14 @@
       </p:sp>
       <p:sp>
         <p:nvSpPr>
-          <p:cNvPr id="22" name="Framework text 1"/>
+          <p:cNvPr id="19" name="Framework text 1"/>
           <p:cNvSpPr txBox="1"/>
           <p:nvPr/>
         </p:nvSpPr>
         <p:spPr>
           <a:xfrm>
-            <a:off x="2377440" y="4041648"/>
-            <a:ext cx="1706879" cy="1143000"/>
+            <a:off x="2404872" y="4818888"/>
+            <a:ext cx="2711196" cy="1051560"/>
           </a:xfrm>
           <a:prstGeom prst="rect">
             <a:avLst/>
@@ -9823,23 +9776,32 @@
           <a:p>
             <a:pPr algn="l">
               <a:spcAft>
-                <a:spcPts val="600"/>
+                <a:spcPts val="400"/>
               </a:spcAft>
             </a:pPr>
             <a:r>
-              <a:rPr sz="1900" b="1" i="0">
+              <a:rPr sz="1300" b="0" i="0">
+                <a:solidFill>
+                  <a:srgbClr val="555560"/>
+                </a:solidFill>
+                <a:latin typeface="Calibri"/>
+              </a:rPr>
+              <a:t>Supporting: </a:t>
+            </a:r>
+            <a:r>
+              <a:rPr sz="1700" b="1" i="0">
                 <a:solidFill>
                   <a:srgbClr val="343174"/>
                 </a:solidFill>
                 <a:latin typeface="Calibri"/>
               </a:rPr>
-              <a:t>DSRM</a:t>
+              <a:t>Design science (DSRM)</a:t>
             </a:r>
           </a:p>
           <a:p>
             <a:pPr algn="l">
               <a:spcAft>
-                <a:spcPts val="600"/>
+                <a:spcPts val="400"/>
               </a:spcAft>
             </a:pPr>
             <a:r>
@@ -9849,21 +9811,21 @@
                 </a:solidFill>
                 <a:latin typeface="Calibri"/>
               </a:rPr>
-              <a:t>Overall research process</a:t>
-            </a:r>
-          </a:p>
-        </p:txBody>
-      </p:sp>
-      <p:sp>
-        <p:nvSpPr>
-          <p:cNvPr id="23" name="Framework card 2"/>
+              <a:t>Structures the research steps around the built artefact</a:t>
+            </a:r>
+          </a:p>
+        </p:txBody>
+      </p:sp>
+      <p:sp>
+        <p:nvSpPr>
+          <p:cNvPr id="20" name="Framework card 2"/>
           <p:cNvSpPr/>
           <p:nvPr/>
         </p:nvSpPr>
         <p:spPr>
           <a:xfrm>
-            <a:off x="4404360" y="3931920"/>
-            <a:ext cx="1981199" cy="1325880"/>
+            <a:off x="5509260" y="4709160"/>
+            <a:ext cx="3040379" cy="1234440"/>
           </a:xfrm>
           <a:prstGeom prst="roundRect">
             <a:avLst>
@@ -9902,14 +9864,14 @@
       </p:sp>
       <p:sp>
         <p:nvSpPr>
-          <p:cNvPr id="24" name="Framework text 2"/>
+          <p:cNvPr id="21" name="Framework text 2"/>
           <p:cNvSpPr txBox="1"/>
           <p:nvPr/>
         </p:nvSpPr>
         <p:spPr>
           <a:xfrm>
-            <a:off x="4541520" y="4041648"/>
-            <a:ext cx="1706879" cy="1143000"/>
+            <a:off x="5673852" y="4818888"/>
+            <a:ext cx="2711196" cy="1051560"/>
           </a:xfrm>
           <a:prstGeom prst="rect">
             <a:avLst/>
@@ -9924,23 +9886,32 @@
           <a:p>
             <a:pPr algn="l">
               <a:spcAft>
-                <a:spcPts val="600"/>
+                <a:spcPts val="400"/>
               </a:spcAft>
             </a:pPr>
             <a:r>
-              <a:rPr sz="1900" b="1" i="0">
-                <a:solidFill>
-                  <a:srgbClr val="EE3138"/>
-                </a:solidFill>
-                <a:latin typeface="Calibri"/>
-              </a:rPr>
-              <a:t>CommonKADS</a:t>
+              <a:rPr sz="1300" b="0" i="0">
+                <a:solidFill>
+                  <a:srgbClr val="555560"/>
+                </a:solidFill>
+                <a:latin typeface="Calibri"/>
+              </a:rPr>
+              <a:t>Supporting: </a:t>
+            </a:r>
+            <a:r>
+              <a:rPr sz="1700" b="1" i="0">
+                <a:solidFill>
+                  <a:srgbClr val="018A4B"/>
+                </a:solidFill>
+                <a:latin typeface="Calibri"/>
+              </a:rPr>
+              <a:t>TAM</a:t>
             </a:r>
           </a:p>
           <a:p>
             <a:pPr algn="l">
               <a:spcAft>
-                <a:spcPts val="600"/>
+                <a:spcPts val="400"/>
               </a:spcAft>
             </a:pPr>
             <a:r>
@@ -9950,108 +9921,7 @@
                 </a:solidFill>
                 <a:latin typeface="Calibri"/>
               </a:rPr>
-              <a:t>Knowledge engineering and design framework</a:t>
-            </a:r>
-          </a:p>
-        </p:txBody>
-      </p:sp>
-      <p:sp>
-        <p:nvSpPr>
-          <p:cNvPr id="25" name="Framework card 3"/>
-          <p:cNvSpPr/>
-          <p:nvPr/>
-        </p:nvSpPr>
-        <p:spPr>
-          <a:xfrm>
-            <a:off x="6568440" y="3931920"/>
-            <a:ext cx="1981199" cy="1325880"/>
-          </a:xfrm>
-          <a:prstGeom prst="roundRect">
-            <a:avLst>
-              <a:gd name="adj" fmla="val 8000"/>
-            </a:avLst>
-          </a:prstGeom>
-          <a:solidFill>
-            <a:srgbClr val="FFFFFF"/>
-          </a:solidFill>
-          <a:ln w="12700">
-            <a:solidFill>
-              <a:srgbClr val="D5D4E2"/>
-            </a:solidFill>
-          </a:ln>
-          <a:effectLst/>
-        </p:spPr>
-        <p:style>
-          <a:lnRef idx="1">
-            <a:schemeClr val="accent1"/>
-          </a:lnRef>
-          <a:fillRef idx="3">
-            <a:schemeClr val="accent1"/>
-          </a:fillRef>
-          <a:effectRef idx="2">
-            <a:schemeClr val="accent1"/>
-          </a:effectRef>
-          <a:fontRef idx="minor">
-            <a:schemeClr val="lt1"/>
-          </a:fontRef>
-        </p:style>
-        <p:txBody>
-          <a:bodyPr rtlCol="0" anchor="ctr"/>
-          <a:lstStyle/>
-          <a:p/>
-        </p:txBody>
-      </p:sp>
-      <p:sp>
-        <p:nvSpPr>
-          <p:cNvPr id="26" name="Framework text 3"/>
-          <p:cNvSpPr txBox="1"/>
-          <p:nvPr/>
-        </p:nvSpPr>
-        <p:spPr>
-          <a:xfrm>
-            <a:off x="6705600" y="4041648"/>
-            <a:ext cx="1706879" cy="1143000"/>
-          </a:xfrm>
-          <a:prstGeom prst="rect">
-            <a:avLst/>
-          </a:prstGeom>
-          <a:noFill/>
-        </p:spPr>
-        <p:txBody>
-          <a:bodyPr wrap="square" anchor="t" lIns="0" rIns="0" tIns="0" bIns="0">
-            <a:spAutoFit/>
-          </a:bodyPr>
-          <a:lstStyle/>
-          <a:p>
-            <a:pPr algn="l">
-              <a:spcAft>
-                <a:spcPts val="600"/>
-              </a:spcAft>
-            </a:pPr>
-            <a:r>
-              <a:rPr sz="1900" b="1" i="0">
-                <a:solidFill>
-                  <a:srgbClr val="018A4B"/>
-                </a:solidFill>
-                <a:latin typeface="Calibri"/>
-              </a:rPr>
-              <a:t>TAM</a:t>
-            </a:r>
-          </a:p>
-          <a:p>
-            <a:pPr algn="l">
-              <a:spcAft>
-                <a:spcPts val="600"/>
-              </a:spcAft>
-            </a:pPr>
-            <a:r>
-              <a:rPr sz="1500" b="0" i="0">
-                <a:solidFill>
-                  <a:srgbClr val="22222A"/>
-                </a:solidFill>
-                <a:latin typeface="Calibri"/>
-              </a:rPr>
-              <a:t>Design lens only; not tested empirically</a:t>
+              <a:t>Design lens for usefulness and ease of use; not tested empirically</a:t>
             </a:r>
           </a:p>
         </p:txBody>
@@ -10104,7 +9974,7 @@
                 </a:solidFill>
                 <a:latin typeface="Calibri"/>
               </a:rPr>
-              <a:t>CommonKADS in This Study</a:t>
+              <a:t>CommonKADS Models in This Study</a:t>
             </a:r>
           </a:p>
         </p:txBody>
@@ -19273,7 +19143,7 @@
                 </a:solidFill>
                 <a:latin typeface="Calibri"/>
               </a:rPr>
-              <a:t>Methodology: DSRM and CommonKADS</a:t>
+              <a:t>Methodology: knowledge engineering</a:t>
             </a:r>
           </a:p>
         </p:txBody>

</xml_diff>

<commit_message>
Defense deck: formal navy-only styling
</commit_message>
<xml_diff>
--- a/Internal_Defense_Presentation.pptx
+++ b/Internal_Defense_Presentation.pptx
@@ -232,7 +232,7 @@
           <c:spPr>
             <a:ln w="31750">
               <a:solidFill>
-                <a:srgbClr val="EE3138"/>
+                <a:srgbClr val="8E91A8"/>
               </a:solidFill>
             </a:ln>
           </c:spPr>
@@ -241,11 +241,11 @@
             <c:size val="8"/>
             <c:spPr>
               <a:solidFill>
-                <a:srgbClr val="EE3138"/>
+                <a:srgbClr val="8E91A8"/>
               </a:solidFill>
               <a:ln>
                 <a:solidFill>
-                  <a:srgbClr val="EE3138"/>
+                  <a:srgbClr val="8E91A8"/>
                 </a:solidFill>
               </a:ln>
             </c:spPr>
@@ -310,7 +310,7 @@
           <c:spPr>
             <a:ln w="31750">
               <a:solidFill>
-                <a:srgbClr val="01A85A"/>
+                <a:srgbClr val="3E3E48"/>
               </a:solidFill>
             </a:ln>
           </c:spPr>
@@ -319,11 +319,11 @@
             <c:size val="8"/>
             <c:spPr>
               <a:solidFill>
-                <a:srgbClr val="01A85A"/>
+                <a:srgbClr val="3E3E48"/>
               </a:solidFill>
               <a:ln>
                 <a:solidFill>
-                  <a:srgbClr val="01A85A"/>
+                  <a:srgbClr val="3E3E48"/>
                 </a:solidFill>
               </a:ln>
             </c:spPr>
@@ -389,7 +389,7 @@
         <c:spPr>
           <a:ln>
             <a:solidFill>
-              <a:srgbClr val="D5D4E2"/>
+              <a:srgbClr val="C9CAD3"/>
             </a:solidFill>
           </a:ln>
         </c:spPr>
@@ -9051,10 +9051,8 @@
             <a:off x="2240280" y="1371600"/>
             <a:ext cx="6309359" cy="1097280"/>
           </a:xfrm>
-          <a:prstGeom prst="roundRect">
-            <a:avLst>
-              <a:gd name="adj" fmla="val 8000"/>
-            </a:avLst>
+          <a:prstGeom prst="rect">
+            <a:avLst/>
           </a:prstGeom>
           <a:solidFill>
             <a:srgbClr val="343174"/>
@@ -9064,20 +9062,6 @@
           </a:ln>
           <a:effectLst/>
         </p:spPr>
-        <p:style>
-          <a:lnRef idx="1">
-            <a:schemeClr val="accent1"/>
-          </a:lnRef>
-          <a:fillRef idx="3">
-            <a:schemeClr val="accent1"/>
-          </a:fillRef>
-          <a:effectRef idx="2">
-            <a:schemeClr val="accent1"/>
-          </a:effectRef>
-          <a:fontRef idx="minor">
-            <a:schemeClr val="lt1"/>
-          </a:fontRef>
-        </p:style>
         <p:txBody>
           <a:bodyPr rtlCol="0" anchor="ctr"/>
           <a:lstStyle/>
@@ -9150,33 +9134,17 @@
             <a:off x="2240280" y="2697480"/>
             <a:ext cx="1371600" cy="1417320"/>
           </a:xfrm>
-          <a:prstGeom prst="roundRect">
-            <a:avLst>
-              <a:gd name="adj" fmla="val 8000"/>
-            </a:avLst>
+          <a:prstGeom prst="rect">
+            <a:avLst/>
           </a:prstGeom>
           <a:solidFill>
-            <a:srgbClr val="FDEBEC"/>
+            <a:srgbClr val="F2F2F5"/>
           </a:solidFill>
           <a:ln>
             <a:noFill/>
           </a:ln>
           <a:effectLst/>
         </p:spPr>
-        <p:style>
-          <a:lnRef idx="1">
-            <a:schemeClr val="accent1"/>
-          </a:lnRef>
-          <a:fillRef idx="3">
-            <a:schemeClr val="accent1"/>
-          </a:fillRef>
-          <a:effectRef idx="2">
-            <a:schemeClr val="accent1"/>
-          </a:effectRef>
-          <a:fontRef idx="minor">
-            <a:schemeClr val="lt1"/>
-          </a:fontRef>
-        </p:style>
         <p:txBody>
           <a:bodyPr rtlCol="0" anchor="ctr"/>
           <a:lstStyle/>
@@ -9213,7 +9181,7 @@
             <a:r>
               <a:rPr sz="1800" b="1" i="0">
                 <a:solidFill>
-                  <a:srgbClr val="EE3138"/>
+                  <a:srgbClr val="343174"/>
                 </a:solidFill>
                 <a:latin typeface="Calibri"/>
               </a:rPr>
@@ -9260,20 +9228,6 @@
           </a:ln>
           <a:effectLst/>
         </p:spPr>
-        <p:style>
-          <a:lnRef idx="1">
-            <a:schemeClr val="accent1"/>
-          </a:lnRef>
-          <a:fillRef idx="3">
-            <a:schemeClr val="accent1"/>
-          </a:fillRef>
-          <a:effectRef idx="2">
-            <a:schemeClr val="accent1"/>
-          </a:effectRef>
-          <a:fontRef idx="minor">
-            <a:schemeClr val="lt1"/>
-          </a:fontRef>
-        </p:style>
         <p:txBody>
           <a:bodyPr rtlCol="0" anchor="ctr"/>
           <a:lstStyle/>
@@ -9293,33 +9247,17 @@
             <a:off x="3886200" y="2697480"/>
             <a:ext cx="1371600" cy="1417320"/>
           </a:xfrm>
-          <a:prstGeom prst="roundRect">
-            <a:avLst>
-              <a:gd name="adj" fmla="val 8000"/>
-            </a:avLst>
+          <a:prstGeom prst="rect">
+            <a:avLst/>
           </a:prstGeom>
           <a:solidFill>
-            <a:srgbClr val="ECEBF5"/>
+            <a:srgbClr val="F2F2F5"/>
           </a:solidFill>
           <a:ln>
             <a:noFill/>
           </a:ln>
           <a:effectLst/>
         </p:spPr>
-        <p:style>
-          <a:lnRef idx="1">
-            <a:schemeClr val="accent1"/>
-          </a:lnRef>
-          <a:fillRef idx="3">
-            <a:schemeClr val="accent1"/>
-          </a:fillRef>
-          <a:effectRef idx="2">
-            <a:schemeClr val="accent1"/>
-          </a:effectRef>
-          <a:fontRef idx="minor">
-            <a:schemeClr val="lt1"/>
-          </a:fontRef>
-        </p:style>
         <p:txBody>
           <a:bodyPr rtlCol="0" anchor="ctr"/>
           <a:lstStyle/>
@@ -9403,20 +9341,6 @@
           </a:ln>
           <a:effectLst/>
         </p:spPr>
-        <p:style>
-          <a:lnRef idx="1">
-            <a:schemeClr val="accent1"/>
-          </a:lnRef>
-          <a:fillRef idx="3">
-            <a:schemeClr val="accent1"/>
-          </a:fillRef>
-          <a:effectRef idx="2">
-            <a:schemeClr val="accent1"/>
-          </a:effectRef>
-          <a:fontRef idx="minor">
-            <a:schemeClr val="lt1"/>
-          </a:fontRef>
-        </p:style>
         <p:txBody>
           <a:bodyPr rtlCol="0" anchor="ctr"/>
           <a:lstStyle/>
@@ -9436,33 +9360,17 @@
             <a:off x="5532120" y="2697480"/>
             <a:ext cx="1371600" cy="1417320"/>
           </a:xfrm>
-          <a:prstGeom prst="roundRect">
-            <a:avLst>
-              <a:gd name="adj" fmla="val 8000"/>
-            </a:avLst>
+          <a:prstGeom prst="rect">
+            <a:avLst/>
           </a:prstGeom>
           <a:solidFill>
-            <a:srgbClr val="ECEBF5"/>
+            <a:srgbClr val="F2F2F5"/>
           </a:solidFill>
           <a:ln>
             <a:noFill/>
           </a:ln>
           <a:effectLst/>
         </p:spPr>
-        <p:style>
-          <a:lnRef idx="1">
-            <a:schemeClr val="accent1"/>
-          </a:lnRef>
-          <a:fillRef idx="3">
-            <a:schemeClr val="accent1"/>
-          </a:fillRef>
-          <a:effectRef idx="2">
-            <a:schemeClr val="accent1"/>
-          </a:effectRef>
-          <a:fontRef idx="minor">
-            <a:schemeClr val="lt1"/>
-          </a:fontRef>
-        </p:style>
         <p:txBody>
           <a:bodyPr rtlCol="0" anchor="ctr"/>
           <a:lstStyle/>
@@ -9546,20 +9454,6 @@
           </a:ln>
           <a:effectLst/>
         </p:spPr>
-        <p:style>
-          <a:lnRef idx="1">
-            <a:schemeClr val="accent1"/>
-          </a:lnRef>
-          <a:fillRef idx="3">
-            <a:schemeClr val="accent1"/>
-          </a:fillRef>
-          <a:effectRef idx="2">
-            <a:schemeClr val="accent1"/>
-          </a:effectRef>
-          <a:fontRef idx="minor">
-            <a:schemeClr val="lt1"/>
-          </a:fontRef>
-        </p:style>
         <p:txBody>
           <a:bodyPr rtlCol="0" anchor="ctr"/>
           <a:lstStyle/>
@@ -9579,33 +9473,17 @@
             <a:off x="7178040" y="2697480"/>
             <a:ext cx="1371600" cy="1417320"/>
           </a:xfrm>
-          <a:prstGeom prst="roundRect">
-            <a:avLst>
-              <a:gd name="adj" fmla="val 8000"/>
-            </a:avLst>
+          <a:prstGeom prst="rect">
+            <a:avLst/>
           </a:prstGeom>
           <a:solidFill>
-            <a:srgbClr val="E6F5EC"/>
+            <a:srgbClr val="F2F2F5"/>
           </a:solidFill>
           <a:ln>
             <a:noFill/>
           </a:ln>
           <a:effectLst/>
         </p:spPr>
-        <p:style>
-          <a:lnRef idx="1">
-            <a:schemeClr val="accent1"/>
-          </a:lnRef>
-          <a:fillRef idx="3">
-            <a:schemeClr val="accent1"/>
-          </a:fillRef>
-          <a:effectRef idx="2">
-            <a:schemeClr val="accent1"/>
-          </a:effectRef>
-          <a:fontRef idx="minor">
-            <a:schemeClr val="lt1"/>
-          </a:fontRef>
-        </p:style>
         <p:txBody>
           <a:bodyPr rtlCol="0" anchor="ctr"/>
           <a:lstStyle/>
@@ -9642,7 +9520,7 @@
             <a:r>
               <a:rPr sz="1800" b="1" i="0">
                 <a:solidFill>
-                  <a:srgbClr val="018A4B"/>
+                  <a:srgbClr val="343174"/>
                 </a:solidFill>
                 <a:latin typeface="Calibri"/>
               </a:rPr>
@@ -9717,35 +9595,19 @@
             <a:off x="2240280" y="4709160"/>
             <a:ext cx="3040379" cy="1234440"/>
           </a:xfrm>
-          <a:prstGeom prst="roundRect">
-            <a:avLst>
-              <a:gd name="adj" fmla="val 8000"/>
-            </a:avLst>
+          <a:prstGeom prst="rect">
+            <a:avLst/>
           </a:prstGeom>
           <a:solidFill>
             <a:srgbClr val="FFFFFF"/>
           </a:solidFill>
           <a:ln w="12700">
             <a:solidFill>
-              <a:srgbClr val="D5D4E2"/>
+              <a:srgbClr val="C9CAD3"/>
             </a:solidFill>
           </a:ln>
           <a:effectLst/>
         </p:spPr>
-        <p:style>
-          <a:lnRef idx="1">
-            <a:schemeClr val="accent1"/>
-          </a:lnRef>
-          <a:fillRef idx="3">
-            <a:schemeClr val="accent1"/>
-          </a:fillRef>
-          <a:effectRef idx="2">
-            <a:schemeClr val="accent1"/>
-          </a:effectRef>
-          <a:fontRef idx="minor">
-            <a:schemeClr val="lt1"/>
-          </a:fontRef>
-        </p:style>
         <p:txBody>
           <a:bodyPr rtlCol="0" anchor="ctr"/>
           <a:lstStyle/>
@@ -9827,35 +9689,19 @@
             <a:off x="5509260" y="4709160"/>
             <a:ext cx="3040379" cy="1234440"/>
           </a:xfrm>
-          <a:prstGeom prst="roundRect">
-            <a:avLst>
-              <a:gd name="adj" fmla="val 8000"/>
-            </a:avLst>
+          <a:prstGeom prst="rect">
+            <a:avLst/>
           </a:prstGeom>
           <a:solidFill>
             <a:srgbClr val="FFFFFF"/>
           </a:solidFill>
           <a:ln w="12700">
             <a:solidFill>
-              <a:srgbClr val="D5D4E2"/>
+              <a:srgbClr val="C9CAD3"/>
             </a:solidFill>
           </a:ln>
           <a:effectLst/>
         </p:spPr>
-        <p:style>
-          <a:lnRef idx="1">
-            <a:schemeClr val="accent1"/>
-          </a:lnRef>
-          <a:fillRef idx="3">
-            <a:schemeClr val="accent1"/>
-          </a:fillRef>
-          <a:effectRef idx="2">
-            <a:schemeClr val="accent1"/>
-          </a:effectRef>
-          <a:fontRef idx="minor">
-            <a:schemeClr val="lt1"/>
-          </a:fontRef>
-        </p:style>
         <p:txBody>
           <a:bodyPr rtlCol="0" anchor="ctr"/>
           <a:lstStyle/>
@@ -9901,7 +9747,7 @@
             <a:r>
               <a:rPr sz="1700" b="1" i="0">
                 <a:solidFill>
-                  <a:srgbClr val="018A4B"/>
+                  <a:srgbClr val="343174"/>
                 </a:solidFill>
                 <a:latin typeface="Calibri"/>
               </a:rPr>
@@ -10029,33 +9875,17 @@
             <a:off x="2240280" y="1371600"/>
             <a:ext cx="1981199" cy="2011680"/>
           </a:xfrm>
-          <a:prstGeom prst="roundRect">
-            <a:avLst>
-              <a:gd name="adj" fmla="val 8000"/>
-            </a:avLst>
+          <a:prstGeom prst="rect">
+            <a:avLst/>
           </a:prstGeom>
           <a:solidFill>
-            <a:srgbClr val="ECEBF5"/>
+            <a:srgbClr val="F2F2F5"/>
           </a:solidFill>
           <a:ln>
             <a:noFill/>
           </a:ln>
           <a:effectLst/>
         </p:spPr>
-        <p:style>
-          <a:lnRef idx="1">
-            <a:schemeClr val="accent1"/>
-          </a:lnRef>
-          <a:fillRef idx="3">
-            <a:schemeClr val="accent1"/>
-          </a:fillRef>
-          <a:effectRef idx="2">
-            <a:schemeClr val="accent1"/>
-          </a:effectRef>
-          <a:fontRef idx="minor">
-            <a:schemeClr val="lt1"/>
-          </a:fontRef>
-        </p:style>
         <p:txBody>
           <a:bodyPr rtlCol="0" anchor="ctr"/>
           <a:lstStyle/>
@@ -10144,33 +9974,17 @@
             <a:off x="4404360" y="1371600"/>
             <a:ext cx="1981199" cy="2011680"/>
           </a:xfrm>
-          <a:prstGeom prst="roundRect">
-            <a:avLst>
-              <a:gd name="adj" fmla="val 8000"/>
-            </a:avLst>
+          <a:prstGeom prst="rect">
+            <a:avLst/>
           </a:prstGeom>
           <a:solidFill>
-            <a:srgbClr val="ECEBF5"/>
+            <a:srgbClr val="F2F2F5"/>
           </a:solidFill>
           <a:ln>
             <a:noFill/>
           </a:ln>
           <a:effectLst/>
         </p:spPr>
-        <p:style>
-          <a:lnRef idx="1">
-            <a:schemeClr val="accent1"/>
-          </a:lnRef>
-          <a:fillRef idx="3">
-            <a:schemeClr val="accent1"/>
-          </a:fillRef>
-          <a:effectRef idx="2">
-            <a:schemeClr val="accent1"/>
-          </a:effectRef>
-          <a:fontRef idx="minor">
-            <a:schemeClr val="lt1"/>
-          </a:fontRef>
-        </p:style>
         <p:txBody>
           <a:bodyPr rtlCol="0" anchor="ctr"/>
           <a:lstStyle/>
@@ -10259,33 +10073,17 @@
             <a:off x="6568440" y="1371600"/>
             <a:ext cx="1981199" cy="2011680"/>
           </a:xfrm>
-          <a:prstGeom prst="roundRect">
-            <a:avLst>
-              <a:gd name="adj" fmla="val 8000"/>
-            </a:avLst>
+          <a:prstGeom prst="rect">
+            <a:avLst/>
           </a:prstGeom>
           <a:solidFill>
-            <a:srgbClr val="ECEBF5"/>
+            <a:srgbClr val="F2F2F5"/>
           </a:solidFill>
           <a:ln>
             <a:noFill/>
           </a:ln>
           <a:effectLst/>
         </p:spPr>
-        <p:style>
-          <a:lnRef idx="1">
-            <a:schemeClr val="accent1"/>
-          </a:lnRef>
-          <a:fillRef idx="3">
-            <a:schemeClr val="accent1"/>
-          </a:fillRef>
-          <a:effectRef idx="2">
-            <a:schemeClr val="accent1"/>
-          </a:effectRef>
-          <a:fontRef idx="minor">
-            <a:schemeClr val="lt1"/>
-          </a:fontRef>
-        </p:style>
         <p:txBody>
           <a:bodyPr rtlCol="0" anchor="ctr"/>
           <a:lstStyle/>
@@ -10374,33 +10172,17 @@
             <a:off x="2240280" y="3566160"/>
             <a:ext cx="1981199" cy="2011680"/>
           </a:xfrm>
-          <a:prstGeom prst="roundRect">
-            <a:avLst>
-              <a:gd name="adj" fmla="val 8000"/>
-            </a:avLst>
+          <a:prstGeom prst="rect">
+            <a:avLst/>
           </a:prstGeom>
           <a:solidFill>
-            <a:srgbClr val="E6F5EC"/>
+            <a:srgbClr val="F2F2F5"/>
           </a:solidFill>
           <a:ln>
             <a:noFill/>
           </a:ln>
           <a:effectLst/>
         </p:spPr>
-        <p:style>
-          <a:lnRef idx="1">
-            <a:schemeClr val="accent1"/>
-          </a:lnRef>
-          <a:fillRef idx="3">
-            <a:schemeClr val="accent1"/>
-          </a:fillRef>
-          <a:effectRef idx="2">
-            <a:schemeClr val="accent1"/>
-          </a:effectRef>
-          <a:fontRef idx="minor">
-            <a:schemeClr val="lt1"/>
-          </a:fontRef>
-        </p:style>
         <p:txBody>
           <a:bodyPr rtlCol="0" anchor="ctr"/>
           <a:lstStyle/>
@@ -10437,7 +10219,7 @@
             <a:r>
               <a:rPr sz="1700" b="1" i="0">
                 <a:solidFill>
-                  <a:srgbClr val="018A4B"/>
+                  <a:srgbClr val="343174"/>
                 </a:solidFill>
                 <a:latin typeface="Calibri"/>
               </a:rPr>
@@ -10489,33 +10271,17 @@
             <a:off x="4404360" y="3566160"/>
             <a:ext cx="1981199" cy="2011680"/>
           </a:xfrm>
-          <a:prstGeom prst="roundRect">
-            <a:avLst>
-              <a:gd name="adj" fmla="val 8000"/>
-            </a:avLst>
+          <a:prstGeom prst="rect">
+            <a:avLst/>
           </a:prstGeom>
           <a:solidFill>
-            <a:srgbClr val="E6F5EC"/>
+            <a:srgbClr val="F2F2F5"/>
           </a:solidFill>
           <a:ln>
             <a:noFill/>
           </a:ln>
           <a:effectLst/>
         </p:spPr>
-        <p:style>
-          <a:lnRef idx="1">
-            <a:schemeClr val="accent1"/>
-          </a:lnRef>
-          <a:fillRef idx="3">
-            <a:schemeClr val="accent1"/>
-          </a:fillRef>
-          <a:effectRef idx="2">
-            <a:schemeClr val="accent1"/>
-          </a:effectRef>
-          <a:fontRef idx="minor">
-            <a:schemeClr val="lt1"/>
-          </a:fontRef>
-        </p:style>
         <p:txBody>
           <a:bodyPr rtlCol="0" anchor="ctr"/>
           <a:lstStyle/>
@@ -10552,7 +10318,7 @@
             <a:r>
               <a:rPr sz="1700" b="1" i="0">
                 <a:solidFill>
-                  <a:srgbClr val="018A4B"/>
+                  <a:srgbClr val="343174"/>
                 </a:solidFill>
                 <a:latin typeface="Calibri"/>
               </a:rPr>
@@ -10604,33 +10370,17 @@
             <a:off x="6568440" y="3566160"/>
             <a:ext cx="1981199" cy="2011680"/>
           </a:xfrm>
-          <a:prstGeom prst="roundRect">
-            <a:avLst>
-              <a:gd name="adj" fmla="val 8000"/>
-            </a:avLst>
+          <a:prstGeom prst="rect">
+            <a:avLst/>
           </a:prstGeom>
           <a:solidFill>
-            <a:srgbClr val="E6F5EC"/>
+            <a:srgbClr val="F2F2F5"/>
           </a:solidFill>
           <a:ln>
             <a:noFill/>
           </a:ln>
           <a:effectLst/>
         </p:spPr>
-        <p:style>
-          <a:lnRef idx="1">
-            <a:schemeClr val="accent1"/>
-          </a:lnRef>
-          <a:fillRef idx="3">
-            <a:schemeClr val="accent1"/>
-          </a:fillRef>
-          <a:effectRef idx="2">
-            <a:schemeClr val="accent1"/>
-          </a:effectRef>
-          <a:fontRef idx="minor">
-            <a:schemeClr val="lt1"/>
-          </a:fontRef>
-        </p:style>
         <p:txBody>
           <a:bodyPr rtlCol="0" anchor="ctr"/>
           <a:lstStyle/>
@@ -10667,7 +10417,7 @@
             <a:r>
               <a:rPr sz="1700" b="1" i="0">
                 <a:solidFill>
-                  <a:srgbClr val="018A4B"/>
+                  <a:srgbClr val="343174"/>
                 </a:solidFill>
                 <a:latin typeface="Calibri"/>
               </a:rPr>
@@ -10811,33 +10561,17 @@
             <a:off x="2240280" y="1371600"/>
             <a:ext cx="1474469" cy="1143000"/>
           </a:xfrm>
-          <a:prstGeom prst="roundRect">
-            <a:avLst>
-              <a:gd name="adj" fmla="val 8000"/>
-            </a:avLst>
+          <a:prstGeom prst="rect">
+            <a:avLst/>
           </a:prstGeom>
           <a:solidFill>
-            <a:srgbClr val="ECEBF5"/>
+            <a:srgbClr val="F2F2F5"/>
           </a:solidFill>
           <a:ln>
             <a:noFill/>
           </a:ln>
           <a:effectLst/>
         </p:spPr>
-        <p:style>
-          <a:lnRef idx="1">
-            <a:schemeClr val="accent1"/>
-          </a:lnRef>
-          <a:fillRef idx="3">
-            <a:schemeClr val="accent1"/>
-          </a:fillRef>
-          <a:effectRef idx="2">
-            <a:schemeClr val="accent1"/>
-          </a:effectRef>
-          <a:fontRef idx="minor">
-            <a:schemeClr val="lt1"/>
-          </a:fontRef>
-        </p:style>
         <p:txBody>
           <a:bodyPr rtlCol="0" anchor="ctr"/>
           <a:lstStyle/>
@@ -10910,33 +10644,17 @@
             <a:off x="3851910" y="1371600"/>
             <a:ext cx="1474469" cy="1143000"/>
           </a:xfrm>
-          <a:prstGeom prst="roundRect">
-            <a:avLst>
-              <a:gd name="adj" fmla="val 8000"/>
-            </a:avLst>
+          <a:prstGeom prst="rect">
+            <a:avLst/>
           </a:prstGeom>
           <a:solidFill>
-            <a:srgbClr val="ECEBF5"/>
+            <a:srgbClr val="F2F2F5"/>
           </a:solidFill>
           <a:ln>
             <a:noFill/>
           </a:ln>
           <a:effectLst/>
         </p:spPr>
-        <p:style>
-          <a:lnRef idx="1">
-            <a:schemeClr val="accent1"/>
-          </a:lnRef>
-          <a:fillRef idx="3">
-            <a:schemeClr val="accent1"/>
-          </a:fillRef>
-          <a:effectRef idx="2">
-            <a:schemeClr val="accent1"/>
-          </a:effectRef>
-          <a:fontRef idx="minor">
-            <a:schemeClr val="lt1"/>
-          </a:fontRef>
-        </p:style>
         <p:txBody>
           <a:bodyPr rtlCol="0" anchor="ctr"/>
           <a:lstStyle/>
@@ -11009,33 +10727,17 @@
             <a:off x="5463540" y="1371600"/>
             <a:ext cx="1474469" cy="1143000"/>
           </a:xfrm>
-          <a:prstGeom prst="roundRect">
-            <a:avLst>
-              <a:gd name="adj" fmla="val 8000"/>
-            </a:avLst>
+          <a:prstGeom prst="rect">
+            <a:avLst/>
           </a:prstGeom>
           <a:solidFill>
-            <a:srgbClr val="ECEBF5"/>
+            <a:srgbClr val="F2F2F5"/>
           </a:solidFill>
           <a:ln>
             <a:noFill/>
           </a:ln>
           <a:effectLst/>
         </p:spPr>
-        <p:style>
-          <a:lnRef idx="1">
-            <a:schemeClr val="accent1"/>
-          </a:lnRef>
-          <a:fillRef idx="3">
-            <a:schemeClr val="accent1"/>
-          </a:fillRef>
-          <a:effectRef idx="2">
-            <a:schemeClr val="accent1"/>
-          </a:effectRef>
-          <a:fontRef idx="minor">
-            <a:schemeClr val="lt1"/>
-          </a:fontRef>
-        </p:style>
         <p:txBody>
           <a:bodyPr rtlCol="0" anchor="ctr"/>
           <a:lstStyle/>
@@ -11072,7 +10774,7 @@
             <a:r>
               <a:rPr sz="2800" b="1" i="0">
                 <a:solidFill>
-                  <a:srgbClr val="EE3138"/>
+                  <a:srgbClr val="343174"/>
                 </a:solidFill>
                 <a:latin typeface="Calibri"/>
               </a:rPr>
@@ -11108,33 +10810,17 @@
             <a:off x="7075170" y="1371600"/>
             <a:ext cx="1474469" cy="1143000"/>
           </a:xfrm>
-          <a:prstGeom prst="roundRect">
-            <a:avLst>
-              <a:gd name="adj" fmla="val 8000"/>
-            </a:avLst>
+          <a:prstGeom prst="rect">
+            <a:avLst/>
           </a:prstGeom>
           <a:solidFill>
-            <a:srgbClr val="ECEBF5"/>
+            <a:srgbClr val="F2F2F5"/>
           </a:solidFill>
           <a:ln>
             <a:noFill/>
           </a:ln>
           <a:effectLst/>
         </p:spPr>
-        <p:style>
-          <a:lnRef idx="1">
-            <a:schemeClr val="accent1"/>
-          </a:lnRef>
-          <a:fillRef idx="3">
-            <a:schemeClr val="accent1"/>
-          </a:fillRef>
-          <a:effectRef idx="2">
-            <a:schemeClr val="accent1"/>
-          </a:effectRef>
-          <a:fontRef idx="minor">
-            <a:schemeClr val="lt1"/>
-          </a:fontRef>
-        </p:style>
         <p:txBody>
           <a:bodyPr rtlCol="0" anchor="ctr"/>
           <a:lstStyle/>
@@ -11171,7 +10857,7 @@
             <a:r>
               <a:rPr sz="2800" b="1" i="0">
                 <a:solidFill>
-                  <a:srgbClr val="018A4B"/>
+                  <a:srgbClr val="343174"/>
                 </a:solidFill>
                 <a:latin typeface="Calibri"/>
               </a:rPr>
@@ -11257,20 +10943,6 @@
           </a:ln>
           <a:effectLst/>
         </p:spPr>
-        <p:style>
-          <a:lnRef idx="1">
-            <a:schemeClr val="accent1"/>
-          </a:lnRef>
-          <a:fillRef idx="3">
-            <a:schemeClr val="accent1"/>
-          </a:fillRef>
-          <a:effectRef idx="2">
-            <a:schemeClr val="accent1"/>
-          </a:effectRef>
-          <a:fontRef idx="minor">
-            <a:schemeClr val="lt1"/>
-          </a:fontRef>
-        </p:style>
         <p:txBody>
           <a:bodyPr rtlCol="0" anchor="ctr"/>
           <a:lstStyle/>
@@ -11290,33 +10962,17 @@
             <a:off x="6172200" y="2743200"/>
             <a:ext cx="2377439" cy="457200"/>
           </a:xfrm>
-          <a:prstGeom prst="roundRect">
-            <a:avLst>
-              <a:gd name="adj" fmla="val 8000"/>
-            </a:avLst>
+          <a:prstGeom prst="rect">
+            <a:avLst/>
           </a:prstGeom>
           <a:solidFill>
-            <a:srgbClr val="FDEBEC"/>
+            <a:srgbClr val="F2F2F5"/>
           </a:solidFill>
           <a:ln>
             <a:noFill/>
           </a:ln>
           <a:effectLst/>
         </p:spPr>
-        <p:style>
-          <a:lnRef idx="1">
-            <a:schemeClr val="accent1"/>
-          </a:lnRef>
-          <a:fillRef idx="3">
-            <a:schemeClr val="accent1"/>
-          </a:fillRef>
-          <a:effectRef idx="2">
-            <a:schemeClr val="accent1"/>
-          </a:effectRef>
-          <a:fontRef idx="minor">
-            <a:schemeClr val="lt1"/>
-          </a:fontRef>
-        </p:style>
         <p:txBody>
           <a:bodyPr rtlCol="0" anchor="ctr"/>
           <a:lstStyle/>
@@ -11353,7 +11009,7 @@
             <a:r>
               <a:rPr sz="1500" b="1" i="0">
                 <a:solidFill>
-                  <a:srgbClr val="EE3138"/>
+                  <a:srgbClr val="343174"/>
                 </a:solidFill>
                 <a:latin typeface="Calibri"/>
               </a:rPr>
@@ -11423,20 +11079,6 @@
           </a:ln>
           <a:effectLst/>
         </p:spPr>
-        <p:style>
-          <a:lnRef idx="1">
-            <a:schemeClr val="accent1"/>
-          </a:lnRef>
-          <a:fillRef idx="3">
-            <a:schemeClr val="accent1"/>
-          </a:fillRef>
-          <a:effectRef idx="2">
-            <a:schemeClr val="accent1"/>
-          </a:effectRef>
-          <a:fontRef idx="minor">
-            <a:schemeClr val="lt1"/>
-          </a:fontRef>
-        </p:style>
         <p:txBody>
           <a:bodyPr rtlCol="0" anchor="ctr"/>
           <a:lstStyle/>
@@ -11456,33 +11098,17 @@
             <a:off x="6172200" y="3310128"/>
             <a:ext cx="2377439" cy="457200"/>
           </a:xfrm>
-          <a:prstGeom prst="roundRect">
-            <a:avLst>
-              <a:gd name="adj" fmla="val 8000"/>
-            </a:avLst>
+          <a:prstGeom prst="rect">
+            <a:avLst/>
           </a:prstGeom>
           <a:solidFill>
-            <a:srgbClr val="E6F5EC"/>
+            <a:srgbClr val="F2F2F5"/>
           </a:solidFill>
           <a:ln>
             <a:noFill/>
           </a:ln>
           <a:effectLst/>
         </p:spPr>
-        <p:style>
-          <a:lnRef idx="1">
-            <a:schemeClr val="accent1"/>
-          </a:lnRef>
-          <a:fillRef idx="3">
-            <a:schemeClr val="accent1"/>
-          </a:fillRef>
-          <a:effectRef idx="2">
-            <a:schemeClr val="accent1"/>
-          </a:effectRef>
-          <a:fontRef idx="minor">
-            <a:schemeClr val="lt1"/>
-          </a:fontRef>
-        </p:style>
         <p:txBody>
           <a:bodyPr rtlCol="0" anchor="ctr"/>
           <a:lstStyle/>
@@ -11519,7 +11145,7 @@
             <a:r>
               <a:rPr sz="1500" b="1" i="0">
                 <a:solidFill>
-                  <a:srgbClr val="018A4B"/>
+                  <a:srgbClr val="343174"/>
                 </a:solidFill>
                 <a:latin typeface="Calibri"/>
               </a:rPr>
@@ -11539,35 +11165,19 @@
             <a:off x="2240280" y="4023360"/>
             <a:ext cx="1981199" cy="1600200"/>
           </a:xfrm>
-          <a:prstGeom prst="roundRect">
-            <a:avLst>
-              <a:gd name="adj" fmla="val 8000"/>
-            </a:avLst>
+          <a:prstGeom prst="rect">
+            <a:avLst/>
           </a:prstGeom>
           <a:solidFill>
             <a:srgbClr val="FFFFFF"/>
           </a:solidFill>
           <a:ln w="12700">
             <a:solidFill>
-              <a:srgbClr val="D5D4E2"/>
+              <a:srgbClr val="C9CAD3"/>
             </a:solidFill>
           </a:ln>
           <a:effectLst/>
         </p:spPr>
-        <p:style>
-          <a:lnRef idx="1">
-            <a:schemeClr val="accent1"/>
-          </a:lnRef>
-          <a:fillRef idx="3">
-            <a:schemeClr val="accent1"/>
-          </a:fillRef>
-          <a:effectRef idx="2">
-            <a:schemeClr val="accent1"/>
-          </a:effectRef>
-          <a:fontRef idx="minor">
-            <a:schemeClr val="lt1"/>
-          </a:fontRef>
-        </p:style>
         <p:txBody>
           <a:bodyPr rtlCol="0" anchor="ctr"/>
           <a:lstStyle/>
@@ -11640,35 +11250,19 @@
             <a:off x="4404360" y="4023360"/>
             <a:ext cx="1981199" cy="1600200"/>
           </a:xfrm>
-          <a:prstGeom prst="roundRect">
-            <a:avLst>
-              <a:gd name="adj" fmla="val 8000"/>
-            </a:avLst>
+          <a:prstGeom prst="rect">
+            <a:avLst/>
           </a:prstGeom>
           <a:solidFill>
             <a:srgbClr val="FFFFFF"/>
           </a:solidFill>
           <a:ln w="12700">
             <a:solidFill>
-              <a:srgbClr val="D5D4E2"/>
+              <a:srgbClr val="C9CAD3"/>
             </a:solidFill>
           </a:ln>
           <a:effectLst/>
         </p:spPr>
-        <p:style>
-          <a:lnRef idx="1">
-            <a:schemeClr val="accent1"/>
-          </a:lnRef>
-          <a:fillRef idx="3">
-            <a:schemeClr val="accent1"/>
-          </a:fillRef>
-          <a:effectRef idx="2">
-            <a:schemeClr val="accent1"/>
-          </a:effectRef>
-          <a:fontRef idx="minor">
-            <a:schemeClr val="lt1"/>
-          </a:fontRef>
-        </p:style>
         <p:txBody>
           <a:bodyPr rtlCol="0" anchor="ctr"/>
           <a:lstStyle/>
@@ -11741,35 +11335,19 @@
             <a:off x="6568440" y="4023360"/>
             <a:ext cx="1981199" cy="1600200"/>
           </a:xfrm>
-          <a:prstGeom prst="roundRect">
-            <a:avLst>
-              <a:gd name="adj" fmla="val 8000"/>
-            </a:avLst>
+          <a:prstGeom prst="rect">
+            <a:avLst/>
           </a:prstGeom>
           <a:solidFill>
             <a:srgbClr val="FFFFFF"/>
           </a:solidFill>
           <a:ln w="12700">
             <a:solidFill>
-              <a:srgbClr val="D5D4E2"/>
+              <a:srgbClr val="C9CAD3"/>
             </a:solidFill>
           </a:ln>
           <a:effectLst/>
         </p:spPr>
-        <p:style>
-          <a:lnRef idx="1">
-            <a:schemeClr val="accent1"/>
-          </a:lnRef>
-          <a:fillRef idx="3">
-            <a:schemeClr val="accent1"/>
-          </a:fillRef>
-          <a:effectRef idx="2">
-            <a:schemeClr val="accent1"/>
-          </a:effectRef>
-          <a:fontRef idx="minor">
-            <a:schemeClr val="lt1"/>
-          </a:fontRef>
-        </p:style>
         <p:txBody>
           <a:bodyPr rtlCol="0" anchor="ctr"/>
           <a:lstStyle/>
@@ -11934,111 +11512,8 @@
             <a:off x="2240280" y="1371600"/>
             <a:ext cx="3977639" cy="777240"/>
           </a:xfrm>
-          <a:prstGeom prst="roundRect">
-            <a:avLst>
-              <a:gd name="adj" fmla="val 8000"/>
-            </a:avLst>
-          </a:prstGeom>
-          <a:solidFill>
-            <a:srgbClr val="FFFFFF"/>
-          </a:solidFill>
-          <a:ln w="12700">
-            <a:solidFill>
-              <a:srgbClr val="EE3138"/>
-            </a:solidFill>
-          </a:ln>
-          <a:effectLst/>
-        </p:spPr>
-        <p:style>
-          <a:lnRef idx="1">
-            <a:schemeClr val="accent1"/>
-          </a:lnRef>
-          <a:fillRef idx="3">
-            <a:schemeClr val="accent1"/>
-          </a:fillRef>
-          <a:effectRef idx="2">
-            <a:schemeClr val="accent1"/>
-          </a:effectRef>
-          <a:fontRef idx="minor">
-            <a:schemeClr val="lt1"/>
-          </a:fontRef>
-        </p:style>
-        <p:txBody>
-          <a:bodyPr rtlCol="0" anchor="ctr"/>
-          <a:lstStyle/>
-          <a:p/>
-        </p:txBody>
-      </p:sp>
-      <p:sp>
-        <p:nvSpPr>
-          <p:cNvPr id="5" name="Layer text 1"/>
-          <p:cNvSpPr txBox="1"/>
-          <p:nvPr/>
-        </p:nvSpPr>
-        <p:spPr>
-          <a:xfrm>
-            <a:off x="2423160" y="1408176"/>
-            <a:ext cx="3657599" cy="713232"/>
-          </a:xfrm>
-          <a:prstGeom prst="rect">
-            <a:avLst/>
-          </a:prstGeom>
-          <a:noFill/>
-        </p:spPr>
-        <p:txBody>
-          <a:bodyPr wrap="square" anchor="ctr" lIns="0" rIns="0" tIns="0" bIns="0">
-            <a:spAutoFit/>
-          </a:bodyPr>
-          <a:lstStyle/>
-          <a:p>
-            <a:pPr algn="l">
-              <a:spcAft>
-                <a:spcPts val="100"/>
-              </a:spcAft>
-            </a:pPr>
-            <a:r>
-              <a:rPr sz="1600" b="1" i="0">
-                <a:solidFill>
-                  <a:srgbClr val="22222A"/>
-                </a:solidFill>
-                <a:latin typeface="Calibri"/>
-              </a:rPr>
-              <a:t>Presentation</a:t>
-            </a:r>
-          </a:p>
-          <a:p>
-            <a:pPr algn="l">
-              <a:spcAft>
-                <a:spcPts val="100"/>
-              </a:spcAft>
-            </a:pPr>
-            <a:r>
-              <a:rPr sz="1300" b="0" i="0">
-                <a:solidFill>
-                  <a:srgbClr val="555560"/>
-                </a:solidFill>
-                <a:latin typeface="Calibri"/>
-              </a:rPr>
-              <a:t>React: instructor, advisor and administrator views</a:t>
-            </a:r>
-          </a:p>
-        </p:txBody>
-      </p:sp>
-      <p:sp>
-        <p:nvSpPr>
-          <p:cNvPr id="6" name="Layer 2"/>
-          <p:cNvSpPr/>
-          <p:nvPr/>
-        </p:nvSpPr>
-        <p:spPr>
-          <a:xfrm>
-            <a:off x="2240280" y="2286000"/>
-            <a:ext cx="3977639" cy="777240"/>
-          </a:xfrm>
-          <a:prstGeom prst="roundRect">
-            <a:avLst>
-              <a:gd name="adj" fmla="val 8000"/>
-            </a:avLst>
+          <a:prstGeom prst="rect">
+            <a:avLst/>
           </a:prstGeom>
           <a:solidFill>
             <a:srgbClr val="FFFFFF"/>
@@ -12050,20 +11525,6 @@
           </a:ln>
           <a:effectLst/>
         </p:spPr>
-        <p:style>
-          <a:lnRef idx="1">
-            <a:schemeClr val="accent1"/>
-          </a:lnRef>
-          <a:fillRef idx="3">
-            <a:schemeClr val="accent1"/>
-          </a:fillRef>
-          <a:effectRef idx="2">
-            <a:schemeClr val="accent1"/>
-          </a:effectRef>
-          <a:fontRef idx="minor">
-            <a:schemeClr val="lt1"/>
-          </a:fontRef>
-        </p:style>
         <p:txBody>
           <a:bodyPr rtlCol="0" anchor="ctr"/>
           <a:lstStyle/>
@@ -12072,13 +11533,13 @@
       </p:sp>
       <p:sp>
         <p:nvSpPr>
-          <p:cNvPr id="7" name="Layer text 2"/>
+          <p:cNvPr id="5" name="Layer text 1"/>
           <p:cNvSpPr txBox="1"/>
           <p:nvPr/>
         </p:nvSpPr>
         <p:spPr>
           <a:xfrm>
-            <a:off x="2423160" y="2322576"/>
+            <a:off x="2423160" y="1408176"/>
             <a:ext cx="3657599" cy="713232"/>
           </a:xfrm>
           <a:prstGeom prst="rect">
@@ -12104,7 +11565,7 @@
                 </a:solidFill>
                 <a:latin typeface="Calibri"/>
               </a:rPr>
-              <a:t>Interface / API</a:t>
+              <a:t>Presentation</a:t>
             </a:r>
           </a:p>
           <a:p>
@@ -12120,127 +11581,24 @@
                 </a:solidFill>
                 <a:latin typeface="Calibri"/>
               </a:rPr>
-              <a:t>Flask, JWT login, role-based access control</a:t>
-            </a:r>
-          </a:p>
-        </p:txBody>
-      </p:sp>
-      <p:sp>
-        <p:nvSpPr>
-          <p:cNvPr id="8" name="Layer 3"/>
+              <a:t>React: instructor, advisor and administrator views</a:t>
+            </a:r>
+          </a:p>
+        </p:txBody>
+      </p:sp>
+      <p:sp>
+        <p:nvSpPr>
+          <p:cNvPr id="6" name="Layer 2"/>
           <p:cNvSpPr/>
           <p:nvPr/>
         </p:nvSpPr>
         <p:spPr>
           <a:xfrm>
-            <a:off x="2240280" y="3200400"/>
+            <a:off x="2240280" y="2286000"/>
             <a:ext cx="3977639" cy="777240"/>
           </a:xfrm>
-          <a:prstGeom prst="roundRect">
-            <a:avLst>
-              <a:gd name="adj" fmla="val 8000"/>
-            </a:avLst>
-          </a:prstGeom>
-          <a:solidFill>
-            <a:srgbClr val="FFFFFF"/>
-          </a:solidFill>
-          <a:ln w="12700">
-            <a:solidFill>
-              <a:srgbClr val="018A4B"/>
-            </a:solidFill>
-          </a:ln>
-          <a:effectLst/>
-        </p:spPr>
-        <p:style>
-          <a:lnRef idx="1">
-            <a:schemeClr val="accent1"/>
-          </a:lnRef>
-          <a:fillRef idx="3">
-            <a:schemeClr val="accent1"/>
-          </a:fillRef>
-          <a:effectRef idx="2">
-            <a:schemeClr val="accent1"/>
-          </a:effectRef>
-          <a:fontRef idx="minor">
-            <a:schemeClr val="lt1"/>
-          </a:fontRef>
-        </p:style>
-        <p:txBody>
-          <a:bodyPr rtlCol="0" anchor="ctr"/>
-          <a:lstStyle/>
-          <a:p/>
-        </p:txBody>
-      </p:sp>
-      <p:sp>
-        <p:nvSpPr>
-          <p:cNvPr id="9" name="Layer text 3"/>
-          <p:cNvSpPr txBox="1"/>
-          <p:nvPr/>
-        </p:nvSpPr>
-        <p:spPr>
-          <a:xfrm>
-            <a:off x="2423160" y="3236976"/>
-            <a:ext cx="3657599" cy="713232"/>
-          </a:xfrm>
-          <a:prstGeom prst="rect">
-            <a:avLst/>
-          </a:prstGeom>
-          <a:noFill/>
-        </p:spPr>
-        <p:txBody>
-          <a:bodyPr wrap="square" anchor="ctr" lIns="0" rIns="0" tIns="0" bIns="0">
-            <a:spAutoFit/>
-          </a:bodyPr>
-          <a:lstStyle/>
-          <a:p>
-            <a:pPr algn="l">
-              <a:spcAft>
-                <a:spcPts val="100"/>
-              </a:spcAft>
-            </a:pPr>
-            <a:r>
-              <a:rPr sz="1600" b="1" i="0">
-                <a:solidFill>
-                  <a:srgbClr val="22222A"/>
-                </a:solidFill>
-                <a:latin typeface="Calibri"/>
-              </a:rPr>
-              <a:t>Explainability</a:t>
-            </a:r>
-          </a:p>
-          <a:p>
-            <a:pPr algn="l">
-              <a:spcAft>
-                <a:spcPts val="100"/>
-              </a:spcAft>
-            </a:pPr>
-            <a:r>
-              <a:rPr sz="1300" b="0" i="0">
-                <a:solidFill>
-                  <a:srgbClr val="555560"/>
-                </a:solidFill>
-                <a:latin typeface="Calibri"/>
-              </a:rPr>
-              <a:t>TreeSHAP global (cached), LIME local (on demand)</a:t>
-            </a:r>
-          </a:p>
-        </p:txBody>
-      </p:sp>
-      <p:sp>
-        <p:nvSpPr>
-          <p:cNvPr id="10" name="Layer 4"/>
-          <p:cNvSpPr/>
-          <p:nvPr/>
-        </p:nvSpPr>
-        <p:spPr>
-          <a:xfrm>
-            <a:off x="2240280" y="4114800"/>
-            <a:ext cx="3977639" cy="777240"/>
-          </a:xfrm>
-          <a:prstGeom prst="roundRect">
-            <a:avLst>
-              <a:gd name="adj" fmla="val 8000"/>
-            </a:avLst>
+          <a:prstGeom prst="rect">
+            <a:avLst/>
           </a:prstGeom>
           <a:solidFill>
             <a:srgbClr val="FFFFFF"/>
@@ -12252,20 +11610,6 @@
           </a:ln>
           <a:effectLst/>
         </p:spPr>
-        <p:style>
-          <a:lnRef idx="1">
-            <a:schemeClr val="accent1"/>
-          </a:lnRef>
-          <a:fillRef idx="3">
-            <a:schemeClr val="accent1"/>
-          </a:fillRef>
-          <a:effectRef idx="2">
-            <a:schemeClr val="accent1"/>
-          </a:effectRef>
-          <a:fontRef idx="minor">
-            <a:schemeClr val="lt1"/>
-          </a:fontRef>
-        </p:style>
         <p:txBody>
           <a:bodyPr rtlCol="0" anchor="ctr"/>
           <a:lstStyle/>
@@ -12274,13 +11618,13 @@
       </p:sp>
       <p:sp>
         <p:nvSpPr>
-          <p:cNvPr id="11" name="Layer text 4"/>
+          <p:cNvPr id="7" name="Layer text 2"/>
           <p:cNvSpPr txBox="1"/>
           <p:nvPr/>
         </p:nvSpPr>
         <p:spPr>
           <a:xfrm>
-            <a:off x="2423160" y="4151376"/>
+            <a:off x="2423160" y="2322576"/>
             <a:ext cx="3657599" cy="713232"/>
           </a:xfrm>
           <a:prstGeom prst="rect">
@@ -12306,6 +11650,176 @@
                 </a:solidFill>
                 <a:latin typeface="Calibri"/>
               </a:rPr>
+              <a:t>Interface / API</a:t>
+            </a:r>
+          </a:p>
+          <a:p>
+            <a:pPr algn="l">
+              <a:spcAft>
+                <a:spcPts val="100"/>
+              </a:spcAft>
+            </a:pPr>
+            <a:r>
+              <a:rPr sz="1300" b="0" i="0">
+                <a:solidFill>
+                  <a:srgbClr val="555560"/>
+                </a:solidFill>
+                <a:latin typeface="Calibri"/>
+              </a:rPr>
+              <a:t>Flask, JWT login, role-based access control</a:t>
+            </a:r>
+          </a:p>
+        </p:txBody>
+      </p:sp>
+      <p:sp>
+        <p:nvSpPr>
+          <p:cNvPr id="8" name="Layer 3"/>
+          <p:cNvSpPr/>
+          <p:nvPr/>
+        </p:nvSpPr>
+        <p:spPr>
+          <a:xfrm>
+            <a:off x="2240280" y="3200400"/>
+            <a:ext cx="3977639" cy="777240"/>
+          </a:xfrm>
+          <a:prstGeom prst="rect">
+            <a:avLst/>
+          </a:prstGeom>
+          <a:solidFill>
+            <a:srgbClr val="FFFFFF"/>
+          </a:solidFill>
+          <a:ln w="12700">
+            <a:solidFill>
+              <a:srgbClr val="343174"/>
+            </a:solidFill>
+          </a:ln>
+          <a:effectLst/>
+        </p:spPr>
+        <p:txBody>
+          <a:bodyPr rtlCol="0" anchor="ctr"/>
+          <a:lstStyle/>
+          <a:p/>
+        </p:txBody>
+      </p:sp>
+      <p:sp>
+        <p:nvSpPr>
+          <p:cNvPr id="9" name="Layer text 3"/>
+          <p:cNvSpPr txBox="1"/>
+          <p:nvPr/>
+        </p:nvSpPr>
+        <p:spPr>
+          <a:xfrm>
+            <a:off x="2423160" y="3236976"/>
+            <a:ext cx="3657599" cy="713232"/>
+          </a:xfrm>
+          <a:prstGeom prst="rect">
+            <a:avLst/>
+          </a:prstGeom>
+          <a:noFill/>
+        </p:spPr>
+        <p:txBody>
+          <a:bodyPr wrap="square" anchor="ctr" lIns="0" rIns="0" tIns="0" bIns="0">
+            <a:spAutoFit/>
+          </a:bodyPr>
+          <a:lstStyle/>
+          <a:p>
+            <a:pPr algn="l">
+              <a:spcAft>
+                <a:spcPts val="100"/>
+              </a:spcAft>
+            </a:pPr>
+            <a:r>
+              <a:rPr sz="1600" b="1" i="0">
+                <a:solidFill>
+                  <a:srgbClr val="22222A"/>
+                </a:solidFill>
+                <a:latin typeface="Calibri"/>
+              </a:rPr>
+              <a:t>Explainability</a:t>
+            </a:r>
+          </a:p>
+          <a:p>
+            <a:pPr algn="l">
+              <a:spcAft>
+                <a:spcPts val="100"/>
+              </a:spcAft>
+            </a:pPr>
+            <a:r>
+              <a:rPr sz="1300" b="0" i="0">
+                <a:solidFill>
+                  <a:srgbClr val="555560"/>
+                </a:solidFill>
+                <a:latin typeface="Calibri"/>
+              </a:rPr>
+              <a:t>TreeSHAP global (cached), LIME local (on demand)</a:t>
+            </a:r>
+          </a:p>
+        </p:txBody>
+      </p:sp>
+      <p:sp>
+        <p:nvSpPr>
+          <p:cNvPr id="10" name="Layer 4"/>
+          <p:cNvSpPr/>
+          <p:nvPr/>
+        </p:nvSpPr>
+        <p:spPr>
+          <a:xfrm>
+            <a:off x="2240280" y="4114800"/>
+            <a:ext cx="3977639" cy="777240"/>
+          </a:xfrm>
+          <a:prstGeom prst="rect">
+            <a:avLst/>
+          </a:prstGeom>
+          <a:solidFill>
+            <a:srgbClr val="FFFFFF"/>
+          </a:solidFill>
+          <a:ln w="12700">
+            <a:solidFill>
+              <a:srgbClr val="343174"/>
+            </a:solidFill>
+          </a:ln>
+          <a:effectLst/>
+        </p:spPr>
+        <p:txBody>
+          <a:bodyPr rtlCol="0" anchor="ctr"/>
+          <a:lstStyle/>
+          <a:p/>
+        </p:txBody>
+      </p:sp>
+      <p:sp>
+        <p:nvSpPr>
+          <p:cNvPr id="11" name="Layer text 4"/>
+          <p:cNvSpPr txBox="1"/>
+          <p:nvPr/>
+        </p:nvSpPr>
+        <p:spPr>
+          <a:xfrm>
+            <a:off x="2423160" y="4151376"/>
+            <a:ext cx="3657599" cy="713232"/>
+          </a:xfrm>
+          <a:prstGeom prst="rect">
+            <a:avLst/>
+          </a:prstGeom>
+          <a:noFill/>
+        </p:spPr>
+        <p:txBody>
+          <a:bodyPr wrap="square" anchor="ctr" lIns="0" rIns="0" tIns="0" bIns="0">
+            <a:spAutoFit/>
+          </a:bodyPr>
+          <a:lstStyle/>
+          <a:p>
+            <a:pPr algn="l">
+              <a:spcAft>
+                <a:spcPts val="100"/>
+              </a:spcAft>
+            </a:pPr>
+            <a:r>
+              <a:rPr sz="1600" b="1" i="0">
+                <a:solidFill>
+                  <a:srgbClr val="22222A"/>
+                </a:solidFill>
+                <a:latin typeface="Calibri"/>
+              </a:rPr>
               <a:t>Prediction engine</a:t>
             </a:r>
           </a:p>
@@ -12338,10 +11852,8 @@
             <a:off x="2240280" y="5029200"/>
             <a:ext cx="3977639" cy="777240"/>
           </a:xfrm>
-          <a:prstGeom prst="roundRect">
-            <a:avLst>
-              <a:gd name="adj" fmla="val 8000"/>
-            </a:avLst>
+          <a:prstGeom prst="rect">
+            <a:avLst/>
           </a:prstGeom>
           <a:solidFill>
             <a:srgbClr val="FFFFFF"/>
@@ -12353,20 +11865,6 @@
           </a:ln>
           <a:effectLst/>
         </p:spPr>
-        <p:style>
-          <a:lnRef idx="1">
-            <a:schemeClr val="accent1"/>
-          </a:lnRef>
-          <a:fillRef idx="3">
-            <a:schemeClr val="accent1"/>
-          </a:fillRef>
-          <a:effectRef idx="2">
-            <a:schemeClr val="accent1"/>
-          </a:effectRef>
-          <a:fontRef idx="minor">
-            <a:schemeClr val="lt1"/>
-          </a:fontRef>
-        </p:style>
         <p:txBody>
           <a:bodyPr rtlCol="0" anchor="ctr"/>
           <a:lstStyle/>
@@ -12478,33 +11976,17 @@
             <a:off x="6446520" y="1737360"/>
             <a:ext cx="2103120" cy="1234440"/>
           </a:xfrm>
-          <a:prstGeom prst="roundRect">
-            <a:avLst>
-              <a:gd name="adj" fmla="val 8000"/>
-            </a:avLst>
+          <a:prstGeom prst="rect">
+            <a:avLst/>
           </a:prstGeom>
           <a:solidFill>
-            <a:srgbClr val="ECEBF5"/>
+            <a:srgbClr val="F2F2F5"/>
           </a:solidFill>
           <a:ln>
             <a:noFill/>
           </a:ln>
           <a:effectLst/>
         </p:spPr>
-        <p:style>
-          <a:lnRef idx="1">
-            <a:schemeClr val="accent1"/>
-          </a:lnRef>
-          <a:fillRef idx="3">
-            <a:schemeClr val="accent1"/>
-          </a:fillRef>
-          <a:effectRef idx="2">
-            <a:schemeClr val="accent1"/>
-          </a:effectRef>
-          <a:fontRef idx="minor">
-            <a:schemeClr val="lt1"/>
-          </a:fontRef>
-        </p:style>
         <p:txBody>
           <a:bodyPr rtlCol="0" anchor="ctr"/>
           <a:lstStyle/>
@@ -12577,33 +12059,17 @@
             <a:off x="6446520" y="3108960"/>
             <a:ext cx="2103120" cy="1234440"/>
           </a:xfrm>
-          <a:prstGeom prst="roundRect">
-            <a:avLst>
-              <a:gd name="adj" fmla="val 8000"/>
-            </a:avLst>
+          <a:prstGeom prst="rect">
+            <a:avLst/>
           </a:prstGeom>
           <a:solidFill>
-            <a:srgbClr val="ECEBF5"/>
+            <a:srgbClr val="F2F2F5"/>
           </a:solidFill>
           <a:ln>
             <a:noFill/>
           </a:ln>
           <a:effectLst/>
         </p:spPr>
-        <p:style>
-          <a:lnRef idx="1">
-            <a:schemeClr val="accent1"/>
-          </a:lnRef>
-          <a:fillRef idx="3">
-            <a:schemeClr val="accent1"/>
-          </a:fillRef>
-          <a:effectRef idx="2">
-            <a:schemeClr val="accent1"/>
-          </a:effectRef>
-          <a:fontRef idx="minor">
-            <a:schemeClr val="lt1"/>
-          </a:fontRef>
-        </p:style>
         <p:txBody>
           <a:bodyPr rtlCol="0" anchor="ctr"/>
           <a:lstStyle/>
@@ -12676,33 +12142,17 @@
             <a:off x="6446520" y="4480560"/>
             <a:ext cx="2103120" cy="1234440"/>
           </a:xfrm>
-          <a:prstGeom prst="roundRect">
-            <a:avLst>
-              <a:gd name="adj" fmla="val 8000"/>
-            </a:avLst>
+          <a:prstGeom prst="rect">
+            <a:avLst/>
           </a:prstGeom>
           <a:solidFill>
-            <a:srgbClr val="ECEBF5"/>
+            <a:srgbClr val="F2F2F5"/>
           </a:solidFill>
           <a:ln>
             <a:noFill/>
           </a:ln>
           <a:effectLst/>
         </p:spPr>
-        <p:style>
-          <a:lnRef idx="1">
-            <a:schemeClr val="accent1"/>
-          </a:lnRef>
-          <a:fillRef idx="3">
-            <a:schemeClr val="accent1"/>
-          </a:fillRef>
-          <a:effectRef idx="2">
-            <a:schemeClr val="accent1"/>
-          </a:effectRef>
-          <a:fontRef idx="minor">
-            <a:schemeClr val="lt1"/>
-          </a:fontRef>
-        </p:style>
         <p:txBody>
           <a:bodyPr rtlCol="0" anchor="ctr"/>
           <a:lstStyle/>
@@ -12867,33 +12317,17 @@
             <a:off x="2240280" y="1371600"/>
             <a:ext cx="1188719" cy="1188720"/>
           </a:xfrm>
-          <a:prstGeom prst="roundRect">
-            <a:avLst>
-              <a:gd name="adj" fmla="val 8000"/>
-            </a:avLst>
+          <a:prstGeom prst="rect">
+            <a:avLst/>
           </a:prstGeom>
           <a:solidFill>
-            <a:srgbClr val="ECEBF5"/>
+            <a:srgbClr val="F2F2F5"/>
           </a:solidFill>
           <a:ln>
             <a:noFill/>
           </a:ln>
           <a:effectLst/>
         </p:spPr>
-        <p:style>
-          <a:lnRef idx="1">
-            <a:schemeClr val="accent1"/>
-          </a:lnRef>
-          <a:fillRef idx="3">
-            <a:schemeClr val="accent1"/>
-          </a:fillRef>
-          <a:effectRef idx="2">
-            <a:schemeClr val="accent1"/>
-          </a:effectRef>
-          <a:fontRef idx="minor">
-            <a:schemeClr val="lt1"/>
-          </a:fontRef>
-        </p:style>
         <p:txBody>
           <a:bodyPr rtlCol="0" anchor="ctr"/>
           <a:lstStyle/>
@@ -12966,33 +12400,17 @@
             <a:off x="3520440" y="1371600"/>
             <a:ext cx="1188719" cy="1188720"/>
           </a:xfrm>
-          <a:prstGeom prst="roundRect">
-            <a:avLst>
-              <a:gd name="adj" fmla="val 8000"/>
-            </a:avLst>
+          <a:prstGeom prst="rect">
+            <a:avLst/>
           </a:prstGeom>
           <a:solidFill>
-            <a:srgbClr val="ECEBF5"/>
+            <a:srgbClr val="F2F2F5"/>
           </a:solidFill>
           <a:ln>
             <a:noFill/>
           </a:ln>
           <a:effectLst/>
         </p:spPr>
-        <p:style>
-          <a:lnRef idx="1">
-            <a:schemeClr val="accent1"/>
-          </a:lnRef>
-          <a:fillRef idx="3">
-            <a:schemeClr val="accent1"/>
-          </a:fillRef>
-          <a:effectRef idx="2">
-            <a:schemeClr val="accent1"/>
-          </a:effectRef>
-          <a:fontRef idx="minor">
-            <a:schemeClr val="lt1"/>
-          </a:fontRef>
-        </p:style>
         <p:txBody>
           <a:bodyPr rtlCol="0" anchor="ctr"/>
           <a:lstStyle/>
@@ -13065,33 +12483,17 @@
             <a:off x="4800600" y="1371600"/>
             <a:ext cx="1188719" cy="1188720"/>
           </a:xfrm>
-          <a:prstGeom prst="roundRect">
-            <a:avLst>
-              <a:gd name="adj" fmla="val 8000"/>
-            </a:avLst>
+          <a:prstGeom prst="rect">
+            <a:avLst/>
           </a:prstGeom>
           <a:solidFill>
-            <a:srgbClr val="EE3138"/>
+            <a:srgbClr val="343174"/>
           </a:solidFill>
           <a:ln>
             <a:noFill/>
           </a:ln>
           <a:effectLst/>
         </p:spPr>
-        <p:style>
-          <a:lnRef idx="1">
-            <a:schemeClr val="accent1"/>
-          </a:lnRef>
-          <a:fillRef idx="3">
-            <a:schemeClr val="accent1"/>
-          </a:fillRef>
-          <a:effectRef idx="2">
-            <a:schemeClr val="accent1"/>
-          </a:effectRef>
-          <a:fontRef idx="minor">
-            <a:schemeClr val="lt1"/>
-          </a:fontRef>
-        </p:style>
         <p:txBody>
           <a:bodyPr rtlCol="0" anchor="ctr"/>
           <a:lstStyle/>
@@ -13164,33 +12566,17 @@
             <a:off x="6080759" y="1371600"/>
             <a:ext cx="1188719" cy="1188720"/>
           </a:xfrm>
-          <a:prstGeom prst="roundRect">
-            <a:avLst>
-              <a:gd name="adj" fmla="val 8000"/>
-            </a:avLst>
+          <a:prstGeom prst="rect">
+            <a:avLst/>
           </a:prstGeom>
           <a:solidFill>
-            <a:srgbClr val="ECEBF5"/>
+            <a:srgbClr val="F2F2F5"/>
           </a:solidFill>
           <a:ln>
             <a:noFill/>
           </a:ln>
           <a:effectLst/>
         </p:spPr>
-        <p:style>
-          <a:lnRef idx="1">
-            <a:schemeClr val="accent1"/>
-          </a:lnRef>
-          <a:fillRef idx="3">
-            <a:schemeClr val="accent1"/>
-          </a:fillRef>
-          <a:effectRef idx="2">
-            <a:schemeClr val="accent1"/>
-          </a:effectRef>
-          <a:fontRef idx="minor">
-            <a:schemeClr val="lt1"/>
-          </a:fontRef>
-        </p:style>
         <p:txBody>
           <a:bodyPr rtlCol="0" anchor="ctr"/>
           <a:lstStyle/>
@@ -13263,33 +12649,17 @@
             <a:off x="7360920" y="1371600"/>
             <a:ext cx="1188719" cy="1188720"/>
           </a:xfrm>
-          <a:prstGeom prst="roundRect">
-            <a:avLst>
-              <a:gd name="adj" fmla="val 8000"/>
-            </a:avLst>
+          <a:prstGeom prst="rect">
+            <a:avLst/>
           </a:prstGeom>
           <a:solidFill>
-            <a:srgbClr val="ECEBF5"/>
+            <a:srgbClr val="F2F2F5"/>
           </a:solidFill>
           <a:ln>
             <a:noFill/>
           </a:ln>
           <a:effectLst/>
         </p:spPr>
-        <p:style>
-          <a:lnRef idx="1">
-            <a:schemeClr val="accent1"/>
-          </a:lnRef>
-          <a:fillRef idx="3">
-            <a:schemeClr val="accent1"/>
-          </a:fillRef>
-          <a:effectRef idx="2">
-            <a:schemeClr val="accent1"/>
-          </a:effectRef>
-          <a:fontRef idx="minor">
-            <a:schemeClr val="lt1"/>
-          </a:fontRef>
-        </p:style>
         <p:txBody>
           <a:bodyPr rtlCol="0" anchor="ctr"/>
           <a:lstStyle/>
@@ -13527,7 +12897,7 @@
                   </a:txBody>
                   <a:tcPr marL="73152" marR="73152" marT="36576" marB="36576" anchor="ctr">
                     <a:solidFill>
-                      <a:srgbClr val="E6F5EC"/>
+                      <a:srgbClr val="DCDDEA"/>
                     </a:solidFill>
                   </a:tcPr>
                 </a:tc>
@@ -13621,7 +12991,7 @@
                   </a:txBody>
                   <a:tcPr marL="73152" marR="73152" marT="36576" marB="36576" anchor="ctr">
                     <a:solidFill>
-                      <a:srgbClr val="E6F5EC"/>
+                      <a:srgbClr val="DCDDEA"/>
                     </a:solidFill>
                   </a:tcPr>
                 </a:tc>
@@ -13641,35 +13011,19 @@
             <a:off x="6035040" y="2788920"/>
             <a:ext cx="2514599" cy="2697480"/>
           </a:xfrm>
-          <a:prstGeom prst="roundRect">
-            <a:avLst>
-              <a:gd name="adj" fmla="val 8000"/>
-            </a:avLst>
+          <a:prstGeom prst="rect">
+            <a:avLst/>
           </a:prstGeom>
           <a:solidFill>
             <a:srgbClr val="FFFFFF"/>
           </a:solidFill>
           <a:ln w="12700">
             <a:solidFill>
-              <a:srgbClr val="D5D4E2"/>
+              <a:srgbClr val="C9CAD3"/>
             </a:solidFill>
           </a:ln>
           <a:effectLst/>
         </p:spPr>
-        <p:style>
-          <a:lnRef idx="1">
-            <a:schemeClr val="accent1"/>
-          </a:lnRef>
-          <a:fillRef idx="3">
-            <a:schemeClr val="accent1"/>
-          </a:fillRef>
-          <a:effectRef idx="2">
-            <a:schemeClr val="accent1"/>
-          </a:effectRef>
-          <a:fontRef idx="minor">
-            <a:schemeClr val="lt1"/>
-          </a:fontRef>
-        </p:style>
         <p:txBody>
           <a:bodyPr rtlCol="0" anchor="ctr"/>
           <a:lstStyle/>
@@ -13782,7 +13136,7 @@
                 <a:spcPts val="600"/>
               </a:spcAft>
               <a:buClr>
-                <a:srgbClr val="EE3138"/>
+                <a:srgbClr val="343174"/>
               </a:buClr>
               <a:buFont typeface="Arial"/>
               <a:buChar char="•"/>
@@ -13790,7 +13144,7 @@
             <a:r>
               <a:rPr sz="1400" b="0" i="0">
                 <a:solidFill>
-                  <a:srgbClr val="EE3138"/>
+                  <a:srgbClr val="343174"/>
                 </a:solidFill>
                 <a:latin typeface="Calibri"/>
               </a:rPr>
@@ -13829,7 +13183,7 @@
             <a:r>
               <a:rPr sz="2000" b="1" i="0">
                 <a:solidFill>
-                  <a:srgbClr val="EE3138"/>
+                  <a:srgbClr val="343174"/>
                 </a:solidFill>
                 <a:latin typeface="Calibri"/>
               </a:rPr>
@@ -14177,7 +13531,7 @@
                   </a:txBody>
                   <a:tcPr marL="73152" marR="73152" marT="36576" marB="36576" anchor="ctr">
                     <a:solidFill>
-                      <a:srgbClr val="E6F5EC"/>
+                      <a:srgbClr val="DCDDEA"/>
                     </a:solidFill>
                   </a:tcPr>
                 </a:tc>
@@ -14248,7 +13602,7 @@
                   </a:txBody>
                   <a:tcPr marL="73152" marR="73152" marT="36576" marB="36576" anchor="ctr">
                     <a:solidFill>
-                      <a:srgbClr val="E6F5EC"/>
+                      <a:srgbClr val="DCDDEA"/>
                     </a:solidFill>
                   </a:tcPr>
                 </a:tc>
@@ -14271,7 +13625,7 @@
                   </a:txBody>
                   <a:tcPr marL="73152" marR="73152" marT="36576" marB="36576" anchor="ctr">
                     <a:solidFill>
-                      <a:srgbClr val="E6F5EC"/>
+                      <a:srgbClr val="DCDDEA"/>
                     </a:solidFill>
                   </a:tcPr>
                 </a:tc>
@@ -14317,7 +13671,7 @@
                   </a:txBody>
                   <a:tcPr marL="73152" marR="73152" marT="36576" marB="36576" anchor="ctr">
                     <a:solidFill>
-                      <a:srgbClr val="E6F5EC"/>
+                      <a:srgbClr val="DCDDEA"/>
                     </a:solidFill>
                   </a:tcPr>
                 </a:tc>
@@ -14493,33 +13847,17 @@
             <a:off x="2240280" y="3840480"/>
             <a:ext cx="3040379" cy="1371600"/>
           </a:xfrm>
-          <a:prstGeom prst="roundRect">
-            <a:avLst>
-              <a:gd name="adj" fmla="val 8000"/>
-            </a:avLst>
+          <a:prstGeom prst="rect">
+            <a:avLst/>
           </a:prstGeom>
           <a:solidFill>
-            <a:srgbClr val="ECEBF5"/>
+            <a:srgbClr val="F2F2F5"/>
           </a:solidFill>
           <a:ln>
             <a:noFill/>
           </a:ln>
           <a:effectLst/>
         </p:spPr>
-        <p:style>
-          <a:lnRef idx="1">
-            <a:schemeClr val="accent1"/>
-          </a:lnRef>
-          <a:fillRef idx="3">
-            <a:schemeClr val="accent1"/>
-          </a:fillRef>
-          <a:effectRef idx="2">
-            <a:schemeClr val="accent1"/>
-          </a:effectRef>
-          <a:fontRef idx="minor">
-            <a:schemeClr val="lt1"/>
-          </a:fontRef>
-        </p:style>
         <p:txBody>
           <a:bodyPr rtlCol="0" anchor="ctr"/>
           <a:lstStyle/>
@@ -14592,33 +13930,17 @@
             <a:off x="5509260" y="3840480"/>
             <a:ext cx="3040379" cy="1371600"/>
           </a:xfrm>
-          <a:prstGeom prst="roundRect">
-            <a:avLst>
-              <a:gd name="adj" fmla="val 8000"/>
-            </a:avLst>
+          <a:prstGeom prst="rect">
+            <a:avLst/>
           </a:prstGeom>
           <a:solidFill>
-            <a:srgbClr val="FDEBEC"/>
+            <a:srgbClr val="F2F2F5"/>
           </a:solidFill>
           <a:ln>
             <a:noFill/>
           </a:ln>
           <a:effectLst/>
         </p:spPr>
-        <p:style>
-          <a:lnRef idx="1">
-            <a:schemeClr val="accent1"/>
-          </a:lnRef>
-          <a:fillRef idx="3">
-            <a:schemeClr val="accent1"/>
-          </a:fillRef>
-          <a:effectRef idx="2">
-            <a:schemeClr val="accent1"/>
-          </a:effectRef>
-          <a:fontRef idx="minor">
-            <a:schemeClr val="lt1"/>
-          </a:fontRef>
-        </p:style>
         <p:txBody>
           <a:bodyPr rtlCol="0" anchor="ctr"/>
           <a:lstStyle/>
@@ -14655,7 +13977,7 @@
             <a:r>
               <a:rPr sz="1800" b="1" i="0">
                 <a:solidFill>
-                  <a:srgbClr val="EE3138"/>
+                  <a:srgbClr val="343174"/>
                 </a:solidFill>
                 <a:latin typeface="Calibri"/>
               </a:rPr>
@@ -14937,7 +14259,7 @@
             <a:r>
               <a:rPr sz="1500" b="1" i="0">
                 <a:solidFill>
-                  <a:srgbClr val="EE3138"/>
+                  <a:srgbClr val="343174"/>
                 </a:solidFill>
                 <a:latin typeface="Calibri"/>
               </a:rPr>
@@ -15015,7 +14337,7 @@
             <a:r>
               <a:rPr sz="1500" b="1" i="0">
                 <a:solidFill>
-                  <a:srgbClr val="018A4B"/>
+                  <a:srgbClr val="343174"/>
                 </a:solidFill>
                 <a:latin typeface="Calibri"/>
               </a:rPr>
@@ -15190,33 +14512,17 @@
             <a:off x="2240280" y="3874770"/>
             <a:ext cx="1981199" cy="1234440"/>
           </a:xfrm>
-          <a:prstGeom prst="roundRect">
-            <a:avLst>
-              <a:gd name="adj" fmla="val 8000"/>
-            </a:avLst>
+          <a:prstGeom prst="rect">
+            <a:avLst/>
           </a:prstGeom>
           <a:solidFill>
-            <a:srgbClr val="ECEBF5"/>
+            <a:srgbClr val="F2F2F5"/>
           </a:solidFill>
           <a:ln>
             <a:noFill/>
           </a:ln>
           <a:effectLst/>
         </p:spPr>
-        <p:style>
-          <a:lnRef idx="1">
-            <a:schemeClr val="accent1"/>
-          </a:lnRef>
-          <a:fillRef idx="3">
-            <a:schemeClr val="accent1"/>
-          </a:fillRef>
-          <a:effectRef idx="2">
-            <a:schemeClr val="accent1"/>
-          </a:effectRef>
-          <a:fontRef idx="minor">
-            <a:schemeClr val="lt1"/>
-          </a:fontRef>
-        </p:style>
         <p:txBody>
           <a:bodyPr rtlCol="0" anchor="ctr"/>
           <a:lstStyle/>
@@ -15289,33 +14595,17 @@
             <a:off x="4404360" y="3874770"/>
             <a:ext cx="1981199" cy="1234440"/>
           </a:xfrm>
-          <a:prstGeom prst="roundRect">
-            <a:avLst>
-              <a:gd name="adj" fmla="val 8000"/>
-            </a:avLst>
+          <a:prstGeom prst="rect">
+            <a:avLst/>
           </a:prstGeom>
           <a:solidFill>
-            <a:srgbClr val="E6F5EC"/>
+            <a:srgbClr val="F2F2F5"/>
           </a:solidFill>
           <a:ln>
             <a:noFill/>
           </a:ln>
           <a:effectLst/>
         </p:spPr>
-        <p:style>
-          <a:lnRef idx="1">
-            <a:schemeClr val="accent1"/>
-          </a:lnRef>
-          <a:fillRef idx="3">
-            <a:schemeClr val="accent1"/>
-          </a:fillRef>
-          <a:effectRef idx="2">
-            <a:schemeClr val="accent1"/>
-          </a:effectRef>
-          <a:fontRef idx="minor">
-            <a:schemeClr val="lt1"/>
-          </a:fontRef>
-        </p:style>
         <p:txBody>
           <a:bodyPr rtlCol="0" anchor="ctr"/>
           <a:lstStyle/>
@@ -15352,7 +14642,7 @@
             <a:r>
               <a:rPr sz="2400" b="1" i="0">
                 <a:solidFill>
-                  <a:srgbClr val="018A4B"/>
+                  <a:srgbClr val="343174"/>
                 </a:solidFill>
                 <a:latin typeface="Calibri"/>
               </a:rPr>
@@ -15388,33 +14678,17 @@
             <a:off x="6568440" y="3874770"/>
             <a:ext cx="1981199" cy="1234440"/>
           </a:xfrm>
-          <a:prstGeom prst="roundRect">
-            <a:avLst>
-              <a:gd name="adj" fmla="val 8000"/>
-            </a:avLst>
+          <a:prstGeom prst="rect">
+            <a:avLst/>
           </a:prstGeom>
           <a:solidFill>
-            <a:srgbClr val="FDEBEC"/>
+            <a:srgbClr val="F2F2F5"/>
           </a:solidFill>
           <a:ln>
             <a:noFill/>
           </a:ln>
           <a:effectLst/>
         </p:spPr>
-        <p:style>
-          <a:lnRef idx="1">
-            <a:schemeClr val="accent1"/>
-          </a:lnRef>
-          <a:fillRef idx="3">
-            <a:schemeClr val="accent1"/>
-          </a:fillRef>
-          <a:effectRef idx="2">
-            <a:schemeClr val="accent1"/>
-          </a:effectRef>
-          <a:fontRef idx="minor">
-            <a:schemeClr val="lt1"/>
-          </a:fontRef>
-        </p:style>
         <p:txBody>
           <a:bodyPr rtlCol="0" anchor="ctr"/>
           <a:lstStyle/>
@@ -15451,7 +14725,7 @@
             <a:r>
               <a:rPr sz="2400" b="1" i="0">
                 <a:solidFill>
-                  <a:srgbClr val="EE3138"/>
+                  <a:srgbClr val="343174"/>
                 </a:solidFill>
                 <a:latin typeface="Calibri"/>
               </a:rPr>
@@ -15631,7 +14905,7 @@
           </a:prstGeom>
           <a:ln w="9525">
             <a:solidFill>
-              <a:srgbClr val="D5D4E2"/>
+              <a:srgbClr val="C9CAD3"/>
             </a:solidFill>
           </a:ln>
         </p:spPr>
@@ -15686,10 +14960,8 @@
             <a:off x="2240280" y="3200400"/>
             <a:ext cx="1234440" cy="329184"/>
           </a:xfrm>
-          <a:prstGeom prst="roundRect">
-            <a:avLst>
-              <a:gd name="adj" fmla="val 8000"/>
-            </a:avLst>
+          <a:prstGeom prst="rect">
+            <a:avLst/>
           </a:prstGeom>
           <a:solidFill>
             <a:srgbClr val="343174"/>
@@ -15699,20 +14971,6 @@
           </a:ln>
           <a:effectLst/>
         </p:spPr>
-        <p:style>
-          <a:lnRef idx="1">
-            <a:schemeClr val="accent1"/>
-          </a:lnRef>
-          <a:fillRef idx="3">
-            <a:schemeClr val="accent1"/>
-          </a:fillRef>
-          <a:effectRef idx="2">
-            <a:schemeClr val="accent1"/>
-          </a:effectRef>
-          <a:fontRef idx="minor">
-            <a:schemeClr val="lt1"/>
-          </a:fontRef>
-        </p:style>
         <p:txBody>
           <a:bodyPr rtlCol="0" anchor="ctr"/>
           <a:lstStyle/>
@@ -15869,7 +15127,7 @@
           </a:prstGeom>
           <a:ln w="9525">
             <a:solidFill>
-              <a:srgbClr val="D5D4E2"/>
+              <a:srgbClr val="C9CAD3"/>
             </a:solidFill>
           </a:ln>
         </p:spPr>
@@ -15904,7 +15162,7 @@
             <a:r>
               <a:rPr sz="1800" b="1" i="0">
                 <a:solidFill>
-                  <a:srgbClr val="EE3138"/>
+                  <a:srgbClr val="343174"/>
                 </a:solidFill>
                 <a:latin typeface="Calibri"/>
               </a:rPr>
@@ -15924,33 +15182,17 @@
             <a:off x="4389120" y="3200400"/>
             <a:ext cx="1234440" cy="329184"/>
           </a:xfrm>
-          <a:prstGeom prst="roundRect">
-            <a:avLst>
-              <a:gd name="adj" fmla="val 8000"/>
-            </a:avLst>
+          <a:prstGeom prst="rect">
+            <a:avLst/>
           </a:prstGeom>
           <a:solidFill>
-            <a:srgbClr val="EE3138"/>
+            <a:srgbClr val="343174"/>
           </a:solidFill>
           <a:ln>
             <a:noFill/>
           </a:ln>
           <a:effectLst/>
         </p:spPr>
-        <p:style>
-          <a:lnRef idx="1">
-            <a:schemeClr val="accent1"/>
-          </a:lnRef>
-          <a:fillRef idx="3">
-            <a:schemeClr val="accent1"/>
-          </a:fillRef>
-          <a:effectRef idx="2">
-            <a:schemeClr val="accent1"/>
-          </a:effectRef>
-          <a:fontRef idx="minor">
-            <a:schemeClr val="lt1"/>
-          </a:fontRef>
-        </p:style>
         <p:txBody>
           <a:bodyPr rtlCol="0" anchor="ctr"/>
           <a:lstStyle/>
@@ -16107,7 +15349,7 @@
           </a:prstGeom>
           <a:ln w="9525">
             <a:solidFill>
-              <a:srgbClr val="D5D4E2"/>
+              <a:srgbClr val="C9CAD3"/>
             </a:solidFill>
           </a:ln>
         </p:spPr>
@@ -16142,7 +15384,7 @@
             <a:r>
               <a:rPr sz="1800" b="1" i="0">
                 <a:solidFill>
-                  <a:srgbClr val="018A4B"/>
+                  <a:srgbClr val="343174"/>
                 </a:solidFill>
                 <a:latin typeface="Calibri"/>
               </a:rPr>
@@ -16162,33 +15404,17 @@
             <a:off x="6537959" y="3200400"/>
             <a:ext cx="1234440" cy="329184"/>
           </a:xfrm>
-          <a:prstGeom prst="roundRect">
-            <a:avLst>
-              <a:gd name="adj" fmla="val 8000"/>
-            </a:avLst>
+          <a:prstGeom prst="rect">
+            <a:avLst/>
           </a:prstGeom>
           <a:solidFill>
-            <a:srgbClr val="018A4B"/>
+            <a:srgbClr val="343174"/>
           </a:solidFill>
           <a:ln>
             <a:noFill/>
           </a:ln>
           <a:effectLst/>
         </p:spPr>
-        <p:style>
-          <a:lnRef idx="1">
-            <a:schemeClr val="accent1"/>
-          </a:lnRef>
-          <a:fillRef idx="3">
-            <a:schemeClr val="accent1"/>
-          </a:fillRef>
-          <a:effectRef idx="2">
-            <a:schemeClr val="accent1"/>
-          </a:effectRef>
-          <a:fontRef idx="minor">
-            <a:schemeClr val="lt1"/>
-          </a:fontRef>
-        </p:style>
         <p:txBody>
           <a:bodyPr rtlCol="0" anchor="ctr"/>
           <a:lstStyle/>
@@ -16332,33 +15558,17 @@
             <a:off x="2240280" y="5486400"/>
             <a:ext cx="6309359" cy="548640"/>
           </a:xfrm>
-          <a:prstGeom prst="roundRect">
-            <a:avLst>
-              <a:gd name="adj" fmla="val 8000"/>
-            </a:avLst>
+          <a:prstGeom prst="rect">
+            <a:avLst/>
           </a:prstGeom>
           <a:solidFill>
-            <a:srgbClr val="ECEBF5"/>
+            <a:srgbClr val="F2F2F5"/>
           </a:solidFill>
           <a:ln>
             <a:noFill/>
           </a:ln>
           <a:effectLst/>
         </p:spPr>
-        <p:style>
-          <a:lnRef idx="1">
-            <a:schemeClr val="accent1"/>
-          </a:lnRef>
-          <a:fillRef idx="3">
-            <a:schemeClr val="accent1"/>
-          </a:fillRef>
-          <a:effectRef idx="2">
-            <a:schemeClr val="accent1"/>
-          </a:effectRef>
-          <a:fontRef idx="minor">
-            <a:schemeClr val="lt1"/>
-          </a:fontRef>
-        </p:style>
         <p:txBody>
           <a:bodyPr rtlCol="0" anchor="ctr"/>
           <a:lstStyle/>
@@ -16520,7 +15730,7 @@
           </a:prstGeom>
           <a:ln w="9525">
             <a:solidFill>
-              <a:srgbClr val="D5D4E2"/>
+              <a:srgbClr val="C9CAD3"/>
             </a:solidFill>
           </a:ln>
         </p:spPr>
@@ -16547,20 +15757,6 @@
           </a:ln>
           <a:effectLst/>
         </p:spPr>
-        <p:style>
-          <a:lnRef idx="1">
-            <a:schemeClr val="accent1"/>
-          </a:lnRef>
-          <a:fillRef idx="3">
-            <a:schemeClr val="accent1"/>
-          </a:fillRef>
-          <a:effectRef idx="2">
-            <a:schemeClr val="accent1"/>
-          </a:effectRef>
-          <a:fontRef idx="minor">
-            <a:schemeClr val="lt1"/>
-          </a:fontRef>
-        </p:style>
         <p:txBody>
           <a:bodyPr rtlCol="0" anchor="ctr" lIns="0" rIns="0" tIns="0" bIns="0"/>
           <a:lstStyle/>
@@ -16632,27 +15828,13 @@
             <a:avLst/>
           </a:prstGeom>
           <a:solidFill>
-            <a:srgbClr val="EE3138"/>
+            <a:srgbClr val="343174"/>
           </a:solidFill>
           <a:ln>
             <a:noFill/>
           </a:ln>
           <a:effectLst/>
         </p:spPr>
-        <p:style>
-          <a:lnRef idx="1">
-            <a:schemeClr val="accent1"/>
-          </a:lnRef>
-          <a:fillRef idx="3">
-            <a:schemeClr val="accent1"/>
-          </a:fillRef>
-          <a:effectRef idx="2">
-            <a:schemeClr val="accent1"/>
-          </a:effectRef>
-          <a:fontRef idx="minor">
-            <a:schemeClr val="lt1"/>
-          </a:fontRef>
-        </p:style>
         <p:txBody>
           <a:bodyPr rtlCol="0" anchor="ctr" lIns="0" rIns="0" tIns="0" bIns="0"/>
           <a:lstStyle/>
@@ -16724,27 +15906,13 @@
             <a:avLst/>
           </a:prstGeom>
           <a:solidFill>
-            <a:srgbClr val="018A4B"/>
+            <a:srgbClr val="343174"/>
           </a:solidFill>
           <a:ln>
             <a:noFill/>
           </a:ln>
           <a:effectLst/>
         </p:spPr>
-        <p:style>
-          <a:lnRef idx="1">
-            <a:schemeClr val="accent1"/>
-          </a:lnRef>
-          <a:fillRef idx="3">
-            <a:schemeClr val="accent1"/>
-          </a:fillRef>
-          <a:effectRef idx="2">
-            <a:schemeClr val="accent1"/>
-          </a:effectRef>
-          <a:fontRef idx="minor">
-            <a:schemeClr val="lt1"/>
-          </a:fontRef>
-        </p:style>
         <p:txBody>
           <a:bodyPr rtlCol="0" anchor="ctr" lIns="0" rIns="0" tIns="0" bIns="0"/>
           <a:lstStyle/>
@@ -17013,20 +16181,6 @@
           </a:ln>
           <a:effectLst/>
         </p:spPr>
-        <p:style>
-          <a:lnRef idx="1">
-            <a:schemeClr val="accent1"/>
-          </a:lnRef>
-          <a:fillRef idx="3">
-            <a:schemeClr val="accent1"/>
-          </a:fillRef>
-          <a:effectRef idx="2">
-            <a:schemeClr val="accent1"/>
-          </a:effectRef>
-          <a:fontRef idx="minor">
-            <a:schemeClr val="lt1"/>
-          </a:fontRef>
-        </p:style>
         <p:txBody>
           <a:bodyPr rtlCol="0" anchor="ctr" lIns="0" rIns="0" tIns="0" bIns="0"/>
           <a:lstStyle/>
@@ -17121,20 +16275,6 @@
           </a:ln>
           <a:effectLst/>
         </p:spPr>
-        <p:style>
-          <a:lnRef idx="1">
-            <a:schemeClr val="accent1"/>
-          </a:lnRef>
-          <a:fillRef idx="3">
-            <a:schemeClr val="accent1"/>
-          </a:fillRef>
-          <a:effectRef idx="2">
-            <a:schemeClr val="accent1"/>
-          </a:effectRef>
-          <a:fontRef idx="minor">
-            <a:schemeClr val="lt1"/>
-          </a:fontRef>
-        </p:style>
         <p:txBody>
           <a:bodyPr rtlCol="0" anchor="ctr" lIns="0" rIns="0" tIns="0" bIns="0"/>
           <a:lstStyle/>
@@ -17229,20 +16369,6 @@
           </a:ln>
           <a:effectLst/>
         </p:spPr>
-        <p:style>
-          <a:lnRef idx="1">
-            <a:schemeClr val="accent1"/>
-          </a:lnRef>
-          <a:fillRef idx="3">
-            <a:schemeClr val="accent1"/>
-          </a:fillRef>
-          <a:effectRef idx="2">
-            <a:schemeClr val="accent1"/>
-          </a:effectRef>
-          <a:fontRef idx="minor">
-            <a:schemeClr val="lt1"/>
-          </a:fontRef>
-        </p:style>
         <p:txBody>
           <a:bodyPr rtlCol="0" anchor="ctr" lIns="0" rIns="0" tIns="0" bIns="0"/>
           <a:lstStyle/>
@@ -17337,20 +16463,6 @@
           </a:ln>
           <a:effectLst/>
         </p:spPr>
-        <p:style>
-          <a:lnRef idx="1">
-            <a:schemeClr val="accent1"/>
-          </a:lnRef>
-          <a:fillRef idx="3">
-            <a:schemeClr val="accent1"/>
-          </a:fillRef>
-          <a:effectRef idx="2">
-            <a:schemeClr val="accent1"/>
-          </a:effectRef>
-          <a:fontRef idx="minor">
-            <a:schemeClr val="lt1"/>
-          </a:fontRef>
-        </p:style>
         <p:txBody>
           <a:bodyPr rtlCol="0" anchor="ctr" lIns="0" rIns="0" tIns="0" bIns="0"/>
           <a:lstStyle/>
@@ -17526,33 +16638,17 @@
             <a:off x="2240280" y="1371600"/>
             <a:ext cx="3040379" cy="4572000"/>
           </a:xfrm>
-          <a:prstGeom prst="roundRect">
-            <a:avLst>
-              <a:gd name="adj" fmla="val 8000"/>
-            </a:avLst>
+          <a:prstGeom prst="rect">
+            <a:avLst/>
           </a:prstGeom>
           <a:solidFill>
-            <a:srgbClr val="FDEBEC"/>
+            <a:srgbClr val="F2F2F5"/>
           </a:solidFill>
           <a:ln>
             <a:noFill/>
           </a:ln>
           <a:effectLst/>
         </p:spPr>
-        <p:style>
-          <a:lnRef idx="1">
-            <a:schemeClr val="accent1"/>
-          </a:lnRef>
-          <a:fillRef idx="3">
-            <a:schemeClr val="accent1"/>
-          </a:fillRef>
-          <a:effectRef idx="2">
-            <a:schemeClr val="accent1"/>
-          </a:effectRef>
-          <a:fontRef idx="minor">
-            <a:schemeClr val="lt1"/>
-          </a:fontRef>
-        </p:style>
         <p:txBody>
           <a:bodyPr rtlCol="0" anchor="ctr"/>
           <a:lstStyle/>
@@ -17589,7 +16685,7 @@
             <a:r>
               <a:rPr sz="2000" b="1" i="0">
                 <a:solidFill>
-                  <a:srgbClr val="EE3138"/>
+                  <a:srgbClr val="343174"/>
                 </a:solidFill>
                 <a:latin typeface="Calibri"/>
               </a:rPr>
@@ -17602,7 +16698,7 @@
                 <a:spcPts val="1400"/>
               </a:spcAft>
               <a:buClr>
-                <a:srgbClr val="EE3138"/>
+                <a:srgbClr val="343174"/>
               </a:buClr>
               <a:buFont typeface="Arial"/>
               <a:buChar char="•"/>
@@ -17623,7 +16719,7 @@
                 <a:spcPts val="1400"/>
               </a:spcAft>
               <a:buClr>
-                <a:srgbClr val="EE3138"/>
+                <a:srgbClr val="343174"/>
               </a:buClr>
               <a:buFont typeface="Arial"/>
               <a:buChar char="•"/>
@@ -17644,7 +16740,7 @@
                 <a:spcPts val="1400"/>
               </a:spcAft>
               <a:buClr>
-                <a:srgbClr val="EE3138"/>
+                <a:srgbClr val="343174"/>
               </a:buClr>
               <a:buFont typeface="Arial"/>
               <a:buChar char="•"/>
@@ -17665,7 +16761,7 @@
                 <a:spcPts val="1400"/>
               </a:spcAft>
               <a:buClr>
-                <a:srgbClr val="EE3138"/>
+                <a:srgbClr val="343174"/>
               </a:buClr>
               <a:buFont typeface="Arial"/>
               <a:buChar char="•"/>
@@ -17693,33 +16789,17 @@
             <a:off x="5509260" y="1371600"/>
             <a:ext cx="3040379" cy="4572000"/>
           </a:xfrm>
-          <a:prstGeom prst="roundRect">
-            <a:avLst>
-              <a:gd name="adj" fmla="val 8000"/>
-            </a:avLst>
+          <a:prstGeom prst="rect">
+            <a:avLst/>
           </a:prstGeom>
           <a:solidFill>
-            <a:srgbClr val="E6F5EC"/>
+            <a:srgbClr val="F2F2F5"/>
           </a:solidFill>
           <a:ln>
             <a:noFill/>
           </a:ln>
           <a:effectLst/>
         </p:spPr>
-        <p:style>
-          <a:lnRef idx="1">
-            <a:schemeClr val="accent1"/>
-          </a:lnRef>
-          <a:fillRef idx="3">
-            <a:schemeClr val="accent1"/>
-          </a:fillRef>
-          <a:effectRef idx="2">
-            <a:schemeClr val="accent1"/>
-          </a:effectRef>
-          <a:fontRef idx="minor">
-            <a:schemeClr val="lt1"/>
-          </a:fontRef>
-        </p:style>
         <p:txBody>
           <a:bodyPr rtlCol="0" anchor="ctr"/>
           <a:lstStyle/>
@@ -17756,7 +16836,7 @@
             <a:r>
               <a:rPr sz="2000" b="1" i="0">
                 <a:solidFill>
-                  <a:srgbClr val="018A4B"/>
+                  <a:srgbClr val="343174"/>
                 </a:solidFill>
                 <a:latin typeface="Calibri"/>
               </a:rPr>
@@ -17769,7 +16849,7 @@
                 <a:spcPts val="1400"/>
               </a:spcAft>
               <a:buClr>
-                <a:srgbClr val="018A4B"/>
+                <a:srgbClr val="343174"/>
               </a:buClr>
               <a:buFont typeface="Arial"/>
               <a:buChar char="•"/>
@@ -17790,7 +16870,7 @@
                 <a:spcPts val="1400"/>
               </a:spcAft>
               <a:buClr>
-                <a:srgbClr val="018A4B"/>
+                <a:srgbClr val="343174"/>
               </a:buClr>
               <a:buFont typeface="Arial"/>
               <a:buChar char="•"/>
@@ -17811,7 +16891,7 @@
                 <a:spcPts val="1400"/>
               </a:spcAft>
               <a:buClr>
-                <a:srgbClr val="018A4B"/>
+                <a:srgbClr val="343174"/>
               </a:buClr>
               <a:buFont typeface="Arial"/>
               <a:buChar char="•"/>
@@ -17832,7 +16912,7 @@
                 <a:spcPts val="1400"/>
               </a:spcAft>
               <a:buClr>
-                <a:srgbClr val="018A4B"/>
+                <a:srgbClr val="343174"/>
               </a:buClr>
               <a:buFont typeface="Arial"/>
               <a:buChar char="•"/>
@@ -17853,7 +16933,7 @@
                 <a:spcPts val="1400"/>
               </a:spcAft>
               <a:buClr>
-                <a:srgbClr val="018A4B"/>
+                <a:srgbClr val="343174"/>
               </a:buClr>
               <a:buFont typeface="Arial"/>
               <a:buChar char="•"/>
@@ -17973,33 +17053,17 @@
             <a:off x="2240280" y="1371600"/>
             <a:ext cx="6309359" cy="1143000"/>
           </a:xfrm>
-          <a:prstGeom prst="roundRect">
-            <a:avLst>
-              <a:gd name="adj" fmla="val 8000"/>
-            </a:avLst>
+          <a:prstGeom prst="rect">
+            <a:avLst/>
           </a:prstGeom>
           <a:solidFill>
-            <a:srgbClr val="ECEBF5"/>
+            <a:srgbClr val="F2F2F5"/>
           </a:solidFill>
           <a:ln>
             <a:noFill/>
           </a:ln>
           <a:effectLst/>
         </p:spPr>
-        <p:style>
-          <a:lnRef idx="1">
-            <a:schemeClr val="accent1"/>
-          </a:lnRef>
-          <a:fillRef idx="3">
-            <a:schemeClr val="accent1"/>
-          </a:fillRef>
-          <a:effectRef idx="2">
-            <a:schemeClr val="accent1"/>
-          </a:effectRef>
-          <a:fontRef idx="minor">
-            <a:schemeClr val="lt1"/>
-          </a:fontRef>
-        </p:style>
         <p:txBody>
           <a:bodyPr rtlCol="0" anchor="ctr"/>
           <a:lstStyle/>
@@ -18017,10 +17081,8 @@
             <a:off x="2240280" y="1371600"/>
             <a:ext cx="868680" cy="1143000"/>
           </a:xfrm>
-          <a:prstGeom prst="roundRect">
-            <a:avLst>
-              <a:gd name="adj" fmla="val 8000"/>
-            </a:avLst>
+          <a:prstGeom prst="rect">
+            <a:avLst/>
           </a:prstGeom>
           <a:solidFill>
             <a:srgbClr val="343174"/>
@@ -18030,20 +17092,6 @@
           </a:ln>
           <a:effectLst/>
         </p:spPr>
-        <p:style>
-          <a:lnRef idx="1">
-            <a:schemeClr val="accent1"/>
-          </a:lnRef>
-          <a:fillRef idx="3">
-            <a:schemeClr val="accent1"/>
-          </a:fillRef>
-          <a:effectRef idx="2">
-            <a:schemeClr val="accent1"/>
-          </a:effectRef>
-          <a:fontRef idx="minor">
-            <a:schemeClr val="lt1"/>
-          </a:fontRef>
-        </p:style>
         <p:txBody>
           <a:bodyPr rtlCol="0" anchor="ctr"/>
           <a:lstStyle/>
@@ -18139,33 +17187,17 @@
             <a:off x="2240280" y="2670048"/>
             <a:ext cx="6309359" cy="1143000"/>
           </a:xfrm>
-          <a:prstGeom prst="roundRect">
-            <a:avLst>
-              <a:gd name="adj" fmla="val 8000"/>
-            </a:avLst>
+          <a:prstGeom prst="rect">
+            <a:avLst/>
           </a:prstGeom>
           <a:solidFill>
-            <a:srgbClr val="ECEBF5"/>
+            <a:srgbClr val="F2F2F5"/>
           </a:solidFill>
           <a:ln>
             <a:noFill/>
           </a:ln>
           <a:effectLst/>
         </p:spPr>
-        <p:style>
-          <a:lnRef idx="1">
-            <a:schemeClr val="accent1"/>
-          </a:lnRef>
-          <a:fillRef idx="3">
-            <a:schemeClr val="accent1"/>
-          </a:fillRef>
-          <a:effectRef idx="2">
-            <a:schemeClr val="accent1"/>
-          </a:effectRef>
-          <a:fontRef idx="minor">
-            <a:schemeClr val="lt1"/>
-          </a:fontRef>
-        </p:style>
         <p:txBody>
           <a:bodyPr rtlCol="0" anchor="ctr"/>
           <a:lstStyle/>
@@ -18183,33 +17215,17 @@
             <a:off x="2240280" y="2670048"/>
             <a:ext cx="868680" cy="1143000"/>
           </a:xfrm>
-          <a:prstGeom prst="roundRect">
-            <a:avLst>
-              <a:gd name="adj" fmla="val 8000"/>
-            </a:avLst>
+          <a:prstGeom prst="rect">
+            <a:avLst/>
           </a:prstGeom>
           <a:solidFill>
-            <a:srgbClr val="EE3138"/>
+            <a:srgbClr val="343174"/>
           </a:solidFill>
           <a:ln>
             <a:noFill/>
           </a:ln>
           <a:effectLst/>
         </p:spPr>
-        <p:style>
-          <a:lnRef idx="1">
-            <a:schemeClr val="accent1"/>
-          </a:lnRef>
-          <a:fillRef idx="3">
-            <a:schemeClr val="accent1"/>
-          </a:fillRef>
-          <a:effectRef idx="2">
-            <a:schemeClr val="accent1"/>
-          </a:effectRef>
-          <a:fontRef idx="minor">
-            <a:schemeClr val="lt1"/>
-          </a:fontRef>
-        </p:style>
         <p:txBody>
           <a:bodyPr rtlCol="0" anchor="ctr"/>
           <a:lstStyle/>
@@ -18305,33 +17321,17 @@
             <a:off x="2240280" y="3968496"/>
             <a:ext cx="6309359" cy="1143000"/>
           </a:xfrm>
-          <a:prstGeom prst="roundRect">
-            <a:avLst>
-              <a:gd name="adj" fmla="val 8000"/>
-            </a:avLst>
+          <a:prstGeom prst="rect">
+            <a:avLst/>
           </a:prstGeom>
           <a:solidFill>
-            <a:srgbClr val="ECEBF5"/>
+            <a:srgbClr val="F2F2F5"/>
           </a:solidFill>
           <a:ln>
             <a:noFill/>
           </a:ln>
           <a:effectLst/>
         </p:spPr>
-        <p:style>
-          <a:lnRef idx="1">
-            <a:schemeClr val="accent1"/>
-          </a:lnRef>
-          <a:fillRef idx="3">
-            <a:schemeClr val="accent1"/>
-          </a:fillRef>
-          <a:effectRef idx="2">
-            <a:schemeClr val="accent1"/>
-          </a:effectRef>
-          <a:fontRef idx="minor">
-            <a:schemeClr val="lt1"/>
-          </a:fontRef>
-        </p:style>
         <p:txBody>
           <a:bodyPr rtlCol="0" anchor="ctr"/>
           <a:lstStyle/>
@@ -18349,33 +17349,17 @@
             <a:off x="2240280" y="3968496"/>
             <a:ext cx="868680" cy="1143000"/>
           </a:xfrm>
-          <a:prstGeom prst="roundRect">
-            <a:avLst>
-              <a:gd name="adj" fmla="val 8000"/>
-            </a:avLst>
+          <a:prstGeom prst="rect">
+            <a:avLst/>
           </a:prstGeom>
           <a:solidFill>
-            <a:srgbClr val="018A4B"/>
+            <a:srgbClr val="343174"/>
           </a:solidFill>
           <a:ln>
             <a:noFill/>
           </a:ln>
           <a:effectLst/>
         </p:spPr>
-        <p:style>
-          <a:lnRef idx="1">
-            <a:schemeClr val="accent1"/>
-          </a:lnRef>
-          <a:fillRef idx="3">
-            <a:schemeClr val="accent1"/>
-          </a:fillRef>
-          <a:effectRef idx="2">
-            <a:schemeClr val="accent1"/>
-          </a:effectRef>
-          <a:fontRef idx="minor">
-            <a:schemeClr val="lt1"/>
-          </a:fontRef>
-        </p:style>
         <p:txBody>
           <a:bodyPr rtlCol="0" anchor="ctr"/>
           <a:lstStyle/>
@@ -18576,7 +17560,7 @@
             <a:r>
               <a:rPr sz="2000" b="1" i="0">
                 <a:solidFill>
-                  <a:srgbClr val="FFD7D9"/>
+                  <a:srgbClr val="FFFFFF"/>
                 </a:solidFill>
                 <a:latin typeface="Calibri"/>
               </a:rPr>
@@ -18802,20 +17786,6 @@
           </a:ln>
           <a:effectLst/>
         </p:spPr>
-        <p:style>
-          <a:lnRef idx="1">
-            <a:schemeClr val="accent1"/>
-          </a:lnRef>
-          <a:fillRef idx="3">
-            <a:schemeClr val="accent1"/>
-          </a:fillRef>
-          <a:effectRef idx="2">
-            <a:schemeClr val="accent1"/>
-          </a:effectRef>
-          <a:fontRef idx="minor">
-            <a:schemeClr val="lt1"/>
-          </a:fontRef>
-        </p:style>
         <p:txBody>
           <a:bodyPr rtlCol="0" anchor="ctr" lIns="0" rIns="0" tIns="0" bIns="0"/>
           <a:lstStyle/>
@@ -18881,190 +17851,6 @@
         <p:spPr>
           <a:xfrm>
             <a:off x="2240280" y="1965960"/>
-            <a:ext cx="402336" cy="402336"/>
-          </a:xfrm>
-          <a:prstGeom prst="ellipse">
-            <a:avLst/>
-          </a:prstGeom>
-          <a:solidFill>
-            <a:srgbClr val="EE3138"/>
-          </a:solidFill>
-          <a:ln>
-            <a:noFill/>
-          </a:ln>
-          <a:effectLst/>
-        </p:spPr>
-        <p:style>
-          <a:lnRef idx="1">
-            <a:schemeClr val="accent1"/>
-          </a:lnRef>
-          <a:fillRef idx="3">
-            <a:schemeClr val="accent1"/>
-          </a:fillRef>
-          <a:effectRef idx="2">
-            <a:schemeClr val="accent1"/>
-          </a:effectRef>
-          <a:fontRef idx="minor">
-            <a:schemeClr val="lt1"/>
-          </a:fontRef>
-        </p:style>
-        <p:txBody>
-          <a:bodyPr rtlCol="0" anchor="ctr" lIns="0" rIns="0" tIns="0" bIns="0"/>
-          <a:lstStyle/>
-          <a:p>
-            <a:pPr algn="ctr"/>
-            <a:r>
-              <a:rPr sz="1500" b="1" i="0">
-                <a:solidFill>
-                  <a:srgbClr val="FFFFFF"/>
-                </a:solidFill>
-                <a:latin typeface="Calibri"/>
-              </a:rPr>
-              <a:t>2</a:t>
-            </a:r>
-          </a:p>
-        </p:txBody>
-      </p:sp>
-      <p:sp>
-        <p:nvSpPr>
-          <p:cNvPr id="7" name="Outline item 2"/>
-          <p:cNvSpPr txBox="1"/>
-          <p:nvPr/>
-        </p:nvSpPr>
-        <p:spPr>
-          <a:xfrm>
-            <a:off x="2834640" y="1965960"/>
-            <a:ext cx="5714999" cy="402336"/>
-          </a:xfrm>
-          <a:prstGeom prst="rect">
-            <a:avLst/>
-          </a:prstGeom>
-          <a:noFill/>
-        </p:spPr>
-        <p:txBody>
-          <a:bodyPr wrap="square" anchor="ctr" lIns="0" rIns="0" tIns="0" bIns="0">
-            <a:spAutoFit/>
-          </a:bodyPr>
-          <a:lstStyle/>
-          <a:p>
-            <a:pPr algn="l">
-              <a:spcAft>
-                <a:spcPts val="600"/>
-              </a:spcAft>
-            </a:pPr>
-            <a:r>
-              <a:rPr sz="1900" b="0" i="0">
-                <a:solidFill>
-                  <a:srgbClr val="22222A"/>
-                </a:solidFill>
-                <a:latin typeface="Calibri"/>
-              </a:rPr>
-              <a:t>Aim, objectives and research questions</a:t>
-            </a:r>
-          </a:p>
-        </p:txBody>
-      </p:sp>
-      <p:sp>
-        <p:nvSpPr>
-          <p:cNvPr id="8" name="Number 3"/>
-          <p:cNvSpPr/>
-          <p:nvPr/>
-        </p:nvSpPr>
-        <p:spPr>
-          <a:xfrm>
-            <a:off x="2240280" y="2514600"/>
-            <a:ext cx="402336" cy="402336"/>
-          </a:xfrm>
-          <a:prstGeom prst="ellipse">
-            <a:avLst/>
-          </a:prstGeom>
-          <a:solidFill>
-            <a:srgbClr val="018A4B"/>
-          </a:solidFill>
-          <a:ln>
-            <a:noFill/>
-          </a:ln>
-          <a:effectLst/>
-        </p:spPr>
-        <p:style>
-          <a:lnRef idx="1">
-            <a:schemeClr val="accent1"/>
-          </a:lnRef>
-          <a:fillRef idx="3">
-            <a:schemeClr val="accent1"/>
-          </a:fillRef>
-          <a:effectRef idx="2">
-            <a:schemeClr val="accent1"/>
-          </a:effectRef>
-          <a:fontRef idx="minor">
-            <a:schemeClr val="lt1"/>
-          </a:fontRef>
-        </p:style>
-        <p:txBody>
-          <a:bodyPr rtlCol="0" anchor="ctr" lIns="0" rIns="0" tIns="0" bIns="0"/>
-          <a:lstStyle/>
-          <a:p>
-            <a:pPr algn="ctr"/>
-            <a:r>
-              <a:rPr sz="1500" b="1" i="0">
-                <a:solidFill>
-                  <a:srgbClr val="FFFFFF"/>
-                </a:solidFill>
-                <a:latin typeface="Calibri"/>
-              </a:rPr>
-              <a:t>3</a:t>
-            </a:r>
-          </a:p>
-        </p:txBody>
-      </p:sp>
-      <p:sp>
-        <p:nvSpPr>
-          <p:cNvPr id="9" name="Outline item 3"/>
-          <p:cNvSpPr txBox="1"/>
-          <p:nvPr/>
-        </p:nvSpPr>
-        <p:spPr>
-          <a:xfrm>
-            <a:off x="2834640" y="2514600"/>
-            <a:ext cx="5714999" cy="402336"/>
-          </a:xfrm>
-          <a:prstGeom prst="rect">
-            <a:avLst/>
-          </a:prstGeom>
-          <a:noFill/>
-        </p:spPr>
-        <p:txBody>
-          <a:bodyPr wrap="square" anchor="ctr" lIns="0" rIns="0" tIns="0" bIns="0">
-            <a:spAutoFit/>
-          </a:bodyPr>
-          <a:lstStyle/>
-          <a:p>
-            <a:pPr algn="l">
-              <a:spcAft>
-                <a:spcPts val="600"/>
-              </a:spcAft>
-            </a:pPr>
-            <a:r>
-              <a:rPr sz="1900" b="0" i="0">
-                <a:solidFill>
-                  <a:srgbClr val="22222A"/>
-                </a:solidFill>
-                <a:latin typeface="Calibri"/>
-              </a:rPr>
-              <a:t>Research gap</a:t>
-            </a:r>
-          </a:p>
-        </p:txBody>
-      </p:sp>
-      <p:sp>
-        <p:nvSpPr>
-          <p:cNvPr id="10" name="Number 4"/>
-          <p:cNvSpPr/>
-          <p:nvPr/>
-        </p:nvSpPr>
-        <p:spPr>
-          <a:xfrm>
-            <a:off x="2240280" y="3063239"/>
             <a:ext cx="402336" cy="402336"/>
           </a:xfrm>
           <a:prstGeom prst="ellipse">
@@ -19078,20 +17864,6 @@
           </a:ln>
           <a:effectLst/>
         </p:spPr>
-        <p:style>
-          <a:lnRef idx="1">
-            <a:schemeClr val="accent1"/>
-          </a:lnRef>
-          <a:fillRef idx="3">
-            <a:schemeClr val="accent1"/>
-          </a:fillRef>
-          <a:effectRef idx="2">
-            <a:schemeClr val="accent1"/>
-          </a:effectRef>
-          <a:fontRef idx="minor">
-            <a:schemeClr val="lt1"/>
-          </a:fontRef>
-        </p:style>
         <p:txBody>
           <a:bodyPr rtlCol="0" anchor="ctr" lIns="0" rIns="0" tIns="0" bIns="0"/>
           <a:lstStyle/>
@@ -19104,20 +17876,20 @@
                 </a:solidFill>
                 <a:latin typeface="Calibri"/>
               </a:rPr>
-              <a:t>4</a:t>
-            </a:r>
-          </a:p>
-        </p:txBody>
-      </p:sp>
-      <p:sp>
-        <p:nvSpPr>
-          <p:cNvPr id="11" name="Outline item 4"/>
+              <a:t>2</a:t>
+            </a:r>
+          </a:p>
+        </p:txBody>
+      </p:sp>
+      <p:sp>
+        <p:nvSpPr>
+          <p:cNvPr id="7" name="Outline item 2"/>
           <p:cNvSpPr txBox="1"/>
           <p:nvPr/>
         </p:nvSpPr>
         <p:spPr>
           <a:xfrm>
-            <a:off x="2834640" y="3063239"/>
+            <a:off x="2834640" y="1965960"/>
             <a:ext cx="5714999" cy="402336"/>
           </a:xfrm>
           <a:prstGeom prst="rect">
@@ -19143,204 +17915,20 @@
                 </a:solidFill>
                 <a:latin typeface="Calibri"/>
               </a:rPr>
-              <a:t>Methodology: knowledge engineering</a:t>
-            </a:r>
-          </a:p>
-        </p:txBody>
-      </p:sp>
-      <p:sp>
-        <p:nvSpPr>
-          <p:cNvPr id="12" name="Number 5"/>
+              <a:t>Aim, objectives and research questions</a:t>
+            </a:r>
+          </a:p>
+        </p:txBody>
+      </p:sp>
+      <p:sp>
+        <p:nvSpPr>
+          <p:cNvPr id="8" name="Number 3"/>
           <p:cNvSpPr/>
           <p:nvPr/>
         </p:nvSpPr>
         <p:spPr>
           <a:xfrm>
-            <a:off x="2240280" y="3611880"/>
-            <a:ext cx="402336" cy="402336"/>
-          </a:xfrm>
-          <a:prstGeom prst="ellipse">
-            <a:avLst/>
-          </a:prstGeom>
-          <a:solidFill>
-            <a:srgbClr val="EE3138"/>
-          </a:solidFill>
-          <a:ln>
-            <a:noFill/>
-          </a:ln>
-          <a:effectLst/>
-        </p:spPr>
-        <p:style>
-          <a:lnRef idx="1">
-            <a:schemeClr val="accent1"/>
-          </a:lnRef>
-          <a:fillRef idx="3">
-            <a:schemeClr val="accent1"/>
-          </a:fillRef>
-          <a:effectRef idx="2">
-            <a:schemeClr val="accent1"/>
-          </a:effectRef>
-          <a:fontRef idx="minor">
-            <a:schemeClr val="lt1"/>
-          </a:fontRef>
-        </p:style>
-        <p:txBody>
-          <a:bodyPr rtlCol="0" anchor="ctr" lIns="0" rIns="0" tIns="0" bIns="0"/>
-          <a:lstStyle/>
-          <a:p>
-            <a:pPr algn="ctr"/>
-            <a:r>
-              <a:rPr sz="1500" b="1" i="0">
-                <a:solidFill>
-                  <a:srgbClr val="FFFFFF"/>
-                </a:solidFill>
-                <a:latin typeface="Calibri"/>
-              </a:rPr>
-              <a:t>5</a:t>
-            </a:r>
-          </a:p>
-        </p:txBody>
-      </p:sp>
-      <p:sp>
-        <p:nvSpPr>
-          <p:cNvPr id="13" name="Outline item 5"/>
-          <p:cNvSpPr txBox="1"/>
-          <p:nvPr/>
-        </p:nvSpPr>
-        <p:spPr>
-          <a:xfrm>
-            <a:off x="2834640" y="3611880"/>
-            <a:ext cx="5714999" cy="402336"/>
-          </a:xfrm>
-          <a:prstGeom prst="rect">
-            <a:avLst/>
-          </a:prstGeom>
-          <a:noFill/>
-        </p:spPr>
-        <p:txBody>
-          <a:bodyPr wrap="square" anchor="ctr" lIns="0" rIns="0" tIns="0" bIns="0">
-            <a:spAutoFit/>
-          </a:bodyPr>
-          <a:lstStyle/>
-          <a:p>
-            <a:pPr algn="l">
-              <a:spcAft>
-                <a:spcPts val="600"/>
-              </a:spcAft>
-            </a:pPr>
-            <a:r>
-              <a:rPr sz="1900" b="0" i="0">
-                <a:solidFill>
-                  <a:srgbClr val="22222A"/>
-                </a:solidFill>
-                <a:latin typeface="Calibri"/>
-              </a:rPr>
-              <a:t>System design and implementation</a:t>
-            </a:r>
-          </a:p>
-        </p:txBody>
-      </p:sp>
-      <p:sp>
-        <p:nvSpPr>
-          <p:cNvPr id="14" name="Number 6"/>
-          <p:cNvSpPr/>
-          <p:nvPr/>
-        </p:nvSpPr>
-        <p:spPr>
-          <a:xfrm>
-            <a:off x="2240280" y="4160520"/>
-            <a:ext cx="402336" cy="402336"/>
-          </a:xfrm>
-          <a:prstGeom prst="ellipse">
-            <a:avLst/>
-          </a:prstGeom>
-          <a:solidFill>
-            <a:srgbClr val="018A4B"/>
-          </a:solidFill>
-          <a:ln>
-            <a:noFill/>
-          </a:ln>
-          <a:effectLst/>
-        </p:spPr>
-        <p:style>
-          <a:lnRef idx="1">
-            <a:schemeClr val="accent1"/>
-          </a:lnRef>
-          <a:fillRef idx="3">
-            <a:schemeClr val="accent1"/>
-          </a:fillRef>
-          <a:effectRef idx="2">
-            <a:schemeClr val="accent1"/>
-          </a:effectRef>
-          <a:fontRef idx="minor">
-            <a:schemeClr val="lt1"/>
-          </a:fontRef>
-        </p:style>
-        <p:txBody>
-          <a:bodyPr rtlCol="0" anchor="ctr" lIns="0" rIns="0" tIns="0" bIns="0"/>
-          <a:lstStyle/>
-          <a:p>
-            <a:pPr algn="ctr"/>
-            <a:r>
-              <a:rPr sz="1500" b="1" i="0">
-                <a:solidFill>
-                  <a:srgbClr val="FFFFFF"/>
-                </a:solidFill>
-                <a:latin typeface="Calibri"/>
-              </a:rPr>
-              <a:t>6</a:t>
-            </a:r>
-          </a:p>
-        </p:txBody>
-      </p:sp>
-      <p:sp>
-        <p:nvSpPr>
-          <p:cNvPr id="15" name="Outline item 6"/>
-          <p:cNvSpPr txBox="1"/>
-          <p:nvPr/>
-        </p:nvSpPr>
-        <p:spPr>
-          <a:xfrm>
-            <a:off x="2834640" y="4160520"/>
-            <a:ext cx="5714999" cy="402336"/>
-          </a:xfrm>
-          <a:prstGeom prst="rect">
-            <a:avLst/>
-          </a:prstGeom>
-          <a:noFill/>
-        </p:spPr>
-        <p:txBody>
-          <a:bodyPr wrap="square" anchor="ctr" lIns="0" rIns="0" tIns="0" bIns="0">
-            <a:spAutoFit/>
-          </a:bodyPr>
-          <a:lstStyle/>
-          <a:p>
-            <a:pPr algn="l">
-              <a:spcAft>
-                <a:spcPts val="600"/>
-              </a:spcAft>
-            </a:pPr>
-            <a:r>
-              <a:rPr sz="1900" b="0" i="0">
-                <a:solidFill>
-                  <a:srgbClr val="22222A"/>
-                </a:solidFill>
-                <a:latin typeface="Calibri"/>
-              </a:rPr>
-              <a:t>Results: prediction and explainability</a:t>
-            </a:r>
-          </a:p>
-        </p:txBody>
-      </p:sp>
-      <p:sp>
-        <p:nvSpPr>
-          <p:cNvPr id="16" name="Number 7"/>
-          <p:cNvSpPr/>
-          <p:nvPr/>
-        </p:nvSpPr>
-        <p:spPr>
-          <a:xfrm>
-            <a:off x="2240280" y="4709159"/>
+            <a:off x="2240280" y="2514600"/>
             <a:ext cx="402336" cy="402336"/>
           </a:xfrm>
           <a:prstGeom prst="ellipse">
@@ -19354,20 +17942,6 @@
           </a:ln>
           <a:effectLst/>
         </p:spPr>
-        <p:style>
-          <a:lnRef idx="1">
-            <a:schemeClr val="accent1"/>
-          </a:lnRef>
-          <a:fillRef idx="3">
-            <a:schemeClr val="accent1"/>
-          </a:fillRef>
-          <a:effectRef idx="2">
-            <a:schemeClr val="accent1"/>
-          </a:effectRef>
-          <a:fontRef idx="minor">
-            <a:schemeClr val="lt1"/>
-          </a:fontRef>
-        </p:style>
         <p:txBody>
           <a:bodyPr rtlCol="0" anchor="ctr" lIns="0" rIns="0" tIns="0" bIns="0"/>
           <a:lstStyle/>
@@ -19380,20 +17954,20 @@
                 </a:solidFill>
                 <a:latin typeface="Calibri"/>
               </a:rPr>
-              <a:t>7</a:t>
-            </a:r>
-          </a:p>
-        </p:txBody>
-      </p:sp>
-      <p:sp>
-        <p:nvSpPr>
-          <p:cNvPr id="17" name="Outline item 7"/>
+              <a:t>3</a:t>
+            </a:r>
+          </a:p>
+        </p:txBody>
+      </p:sp>
+      <p:sp>
+        <p:nvSpPr>
+          <p:cNvPr id="9" name="Outline item 3"/>
           <p:cNvSpPr txBox="1"/>
           <p:nvPr/>
         </p:nvSpPr>
         <p:spPr>
           <a:xfrm>
-            <a:off x="2834640" y="4709159"/>
+            <a:off x="2834640" y="2514600"/>
             <a:ext cx="5714999" cy="402336"/>
           </a:xfrm>
           <a:prstGeom prst="rect">
@@ -19419,47 +17993,345 @@
                 </a:solidFill>
                 <a:latin typeface="Calibri"/>
               </a:rPr>
-              <a:t>The role-aware dashboard</a:t>
-            </a:r>
-          </a:p>
-        </p:txBody>
-      </p:sp>
-      <p:sp>
-        <p:nvSpPr>
-          <p:cNvPr id="18" name="Number 8"/>
+              <a:t>Research gap</a:t>
+            </a:r>
+          </a:p>
+        </p:txBody>
+      </p:sp>
+      <p:sp>
+        <p:nvSpPr>
+          <p:cNvPr id="10" name="Number 4"/>
           <p:cNvSpPr/>
           <p:nvPr/>
         </p:nvSpPr>
         <p:spPr>
           <a:xfrm>
-            <a:off x="2240280" y="5257800"/>
+            <a:off x="2240280" y="3063239"/>
             <a:ext cx="402336" cy="402336"/>
           </a:xfrm>
           <a:prstGeom prst="ellipse">
             <a:avLst/>
           </a:prstGeom>
           <a:solidFill>
-            <a:srgbClr val="EE3138"/>
+            <a:srgbClr val="343174"/>
           </a:solidFill>
           <a:ln>
             <a:noFill/>
           </a:ln>
           <a:effectLst/>
         </p:spPr>
-        <p:style>
-          <a:lnRef idx="1">
-            <a:schemeClr val="accent1"/>
-          </a:lnRef>
-          <a:fillRef idx="3">
-            <a:schemeClr val="accent1"/>
-          </a:fillRef>
-          <a:effectRef idx="2">
-            <a:schemeClr val="accent1"/>
-          </a:effectRef>
-          <a:fontRef idx="minor">
-            <a:schemeClr val="lt1"/>
-          </a:fontRef>
-        </p:style>
+        <p:txBody>
+          <a:bodyPr rtlCol="0" anchor="ctr" lIns="0" rIns="0" tIns="0" bIns="0"/>
+          <a:lstStyle/>
+          <a:p>
+            <a:pPr algn="ctr"/>
+            <a:r>
+              <a:rPr sz="1500" b="1" i="0">
+                <a:solidFill>
+                  <a:srgbClr val="FFFFFF"/>
+                </a:solidFill>
+                <a:latin typeface="Calibri"/>
+              </a:rPr>
+              <a:t>4</a:t>
+            </a:r>
+          </a:p>
+        </p:txBody>
+      </p:sp>
+      <p:sp>
+        <p:nvSpPr>
+          <p:cNvPr id="11" name="Outline item 4"/>
+          <p:cNvSpPr txBox="1"/>
+          <p:nvPr/>
+        </p:nvSpPr>
+        <p:spPr>
+          <a:xfrm>
+            <a:off x="2834640" y="3063239"/>
+            <a:ext cx="5714999" cy="402336"/>
+          </a:xfrm>
+          <a:prstGeom prst="rect">
+            <a:avLst/>
+          </a:prstGeom>
+          <a:noFill/>
+        </p:spPr>
+        <p:txBody>
+          <a:bodyPr wrap="square" anchor="ctr" lIns="0" rIns="0" tIns="0" bIns="0">
+            <a:spAutoFit/>
+          </a:bodyPr>
+          <a:lstStyle/>
+          <a:p>
+            <a:pPr algn="l">
+              <a:spcAft>
+                <a:spcPts val="600"/>
+              </a:spcAft>
+            </a:pPr>
+            <a:r>
+              <a:rPr sz="1900" b="0" i="0">
+                <a:solidFill>
+                  <a:srgbClr val="22222A"/>
+                </a:solidFill>
+                <a:latin typeface="Calibri"/>
+              </a:rPr>
+              <a:t>Methodology: knowledge engineering</a:t>
+            </a:r>
+          </a:p>
+        </p:txBody>
+      </p:sp>
+      <p:sp>
+        <p:nvSpPr>
+          <p:cNvPr id="12" name="Number 5"/>
+          <p:cNvSpPr/>
+          <p:nvPr/>
+        </p:nvSpPr>
+        <p:spPr>
+          <a:xfrm>
+            <a:off x="2240280" y="3611880"/>
+            <a:ext cx="402336" cy="402336"/>
+          </a:xfrm>
+          <a:prstGeom prst="ellipse">
+            <a:avLst/>
+          </a:prstGeom>
+          <a:solidFill>
+            <a:srgbClr val="343174"/>
+          </a:solidFill>
+          <a:ln>
+            <a:noFill/>
+          </a:ln>
+          <a:effectLst/>
+        </p:spPr>
+        <p:txBody>
+          <a:bodyPr rtlCol="0" anchor="ctr" lIns="0" rIns="0" tIns="0" bIns="0"/>
+          <a:lstStyle/>
+          <a:p>
+            <a:pPr algn="ctr"/>
+            <a:r>
+              <a:rPr sz="1500" b="1" i="0">
+                <a:solidFill>
+                  <a:srgbClr val="FFFFFF"/>
+                </a:solidFill>
+                <a:latin typeface="Calibri"/>
+              </a:rPr>
+              <a:t>5</a:t>
+            </a:r>
+          </a:p>
+        </p:txBody>
+      </p:sp>
+      <p:sp>
+        <p:nvSpPr>
+          <p:cNvPr id="13" name="Outline item 5"/>
+          <p:cNvSpPr txBox="1"/>
+          <p:nvPr/>
+        </p:nvSpPr>
+        <p:spPr>
+          <a:xfrm>
+            <a:off x="2834640" y="3611880"/>
+            <a:ext cx="5714999" cy="402336"/>
+          </a:xfrm>
+          <a:prstGeom prst="rect">
+            <a:avLst/>
+          </a:prstGeom>
+          <a:noFill/>
+        </p:spPr>
+        <p:txBody>
+          <a:bodyPr wrap="square" anchor="ctr" lIns="0" rIns="0" tIns="0" bIns="0">
+            <a:spAutoFit/>
+          </a:bodyPr>
+          <a:lstStyle/>
+          <a:p>
+            <a:pPr algn="l">
+              <a:spcAft>
+                <a:spcPts val="600"/>
+              </a:spcAft>
+            </a:pPr>
+            <a:r>
+              <a:rPr sz="1900" b="0" i="0">
+                <a:solidFill>
+                  <a:srgbClr val="22222A"/>
+                </a:solidFill>
+                <a:latin typeface="Calibri"/>
+              </a:rPr>
+              <a:t>System design and implementation</a:t>
+            </a:r>
+          </a:p>
+        </p:txBody>
+      </p:sp>
+      <p:sp>
+        <p:nvSpPr>
+          <p:cNvPr id="14" name="Number 6"/>
+          <p:cNvSpPr/>
+          <p:nvPr/>
+        </p:nvSpPr>
+        <p:spPr>
+          <a:xfrm>
+            <a:off x="2240280" y="4160520"/>
+            <a:ext cx="402336" cy="402336"/>
+          </a:xfrm>
+          <a:prstGeom prst="ellipse">
+            <a:avLst/>
+          </a:prstGeom>
+          <a:solidFill>
+            <a:srgbClr val="343174"/>
+          </a:solidFill>
+          <a:ln>
+            <a:noFill/>
+          </a:ln>
+          <a:effectLst/>
+        </p:spPr>
+        <p:txBody>
+          <a:bodyPr rtlCol="0" anchor="ctr" lIns="0" rIns="0" tIns="0" bIns="0"/>
+          <a:lstStyle/>
+          <a:p>
+            <a:pPr algn="ctr"/>
+            <a:r>
+              <a:rPr sz="1500" b="1" i="0">
+                <a:solidFill>
+                  <a:srgbClr val="FFFFFF"/>
+                </a:solidFill>
+                <a:latin typeface="Calibri"/>
+              </a:rPr>
+              <a:t>6</a:t>
+            </a:r>
+          </a:p>
+        </p:txBody>
+      </p:sp>
+      <p:sp>
+        <p:nvSpPr>
+          <p:cNvPr id="15" name="Outline item 6"/>
+          <p:cNvSpPr txBox="1"/>
+          <p:nvPr/>
+        </p:nvSpPr>
+        <p:spPr>
+          <a:xfrm>
+            <a:off x="2834640" y="4160520"/>
+            <a:ext cx="5714999" cy="402336"/>
+          </a:xfrm>
+          <a:prstGeom prst="rect">
+            <a:avLst/>
+          </a:prstGeom>
+          <a:noFill/>
+        </p:spPr>
+        <p:txBody>
+          <a:bodyPr wrap="square" anchor="ctr" lIns="0" rIns="0" tIns="0" bIns="0">
+            <a:spAutoFit/>
+          </a:bodyPr>
+          <a:lstStyle/>
+          <a:p>
+            <a:pPr algn="l">
+              <a:spcAft>
+                <a:spcPts val="600"/>
+              </a:spcAft>
+            </a:pPr>
+            <a:r>
+              <a:rPr sz="1900" b="0" i="0">
+                <a:solidFill>
+                  <a:srgbClr val="22222A"/>
+                </a:solidFill>
+                <a:latin typeface="Calibri"/>
+              </a:rPr>
+              <a:t>Results: prediction and explainability</a:t>
+            </a:r>
+          </a:p>
+        </p:txBody>
+      </p:sp>
+      <p:sp>
+        <p:nvSpPr>
+          <p:cNvPr id="16" name="Number 7"/>
+          <p:cNvSpPr/>
+          <p:nvPr/>
+        </p:nvSpPr>
+        <p:spPr>
+          <a:xfrm>
+            <a:off x="2240280" y="4709159"/>
+            <a:ext cx="402336" cy="402336"/>
+          </a:xfrm>
+          <a:prstGeom prst="ellipse">
+            <a:avLst/>
+          </a:prstGeom>
+          <a:solidFill>
+            <a:srgbClr val="343174"/>
+          </a:solidFill>
+          <a:ln>
+            <a:noFill/>
+          </a:ln>
+          <a:effectLst/>
+        </p:spPr>
+        <p:txBody>
+          <a:bodyPr rtlCol="0" anchor="ctr" lIns="0" rIns="0" tIns="0" bIns="0"/>
+          <a:lstStyle/>
+          <a:p>
+            <a:pPr algn="ctr"/>
+            <a:r>
+              <a:rPr sz="1500" b="1" i="0">
+                <a:solidFill>
+                  <a:srgbClr val="FFFFFF"/>
+                </a:solidFill>
+                <a:latin typeface="Calibri"/>
+              </a:rPr>
+              <a:t>7</a:t>
+            </a:r>
+          </a:p>
+        </p:txBody>
+      </p:sp>
+      <p:sp>
+        <p:nvSpPr>
+          <p:cNvPr id="17" name="Outline item 7"/>
+          <p:cNvSpPr txBox="1"/>
+          <p:nvPr/>
+        </p:nvSpPr>
+        <p:spPr>
+          <a:xfrm>
+            <a:off x="2834640" y="4709159"/>
+            <a:ext cx="5714999" cy="402336"/>
+          </a:xfrm>
+          <a:prstGeom prst="rect">
+            <a:avLst/>
+          </a:prstGeom>
+          <a:noFill/>
+        </p:spPr>
+        <p:txBody>
+          <a:bodyPr wrap="square" anchor="ctr" lIns="0" rIns="0" tIns="0" bIns="0">
+            <a:spAutoFit/>
+          </a:bodyPr>
+          <a:lstStyle/>
+          <a:p>
+            <a:pPr algn="l">
+              <a:spcAft>
+                <a:spcPts val="600"/>
+              </a:spcAft>
+            </a:pPr>
+            <a:r>
+              <a:rPr sz="1900" b="0" i="0">
+                <a:solidFill>
+                  <a:srgbClr val="22222A"/>
+                </a:solidFill>
+                <a:latin typeface="Calibri"/>
+              </a:rPr>
+              <a:t>The role-aware dashboard</a:t>
+            </a:r>
+          </a:p>
+        </p:txBody>
+      </p:sp>
+      <p:sp>
+        <p:nvSpPr>
+          <p:cNvPr id="18" name="Number 8"/>
+          <p:cNvSpPr/>
+          <p:nvPr/>
+        </p:nvSpPr>
+        <p:spPr>
+          <a:xfrm>
+            <a:off x="2240280" y="5257800"/>
+            <a:ext cx="402336" cy="402336"/>
+          </a:xfrm>
+          <a:prstGeom prst="ellipse">
+            <a:avLst/>
+          </a:prstGeom>
+          <a:solidFill>
+            <a:srgbClr val="343174"/>
+          </a:solidFill>
+          <a:ln>
+            <a:noFill/>
+          </a:ln>
+          <a:effectLst/>
+        </p:spPr>
         <p:txBody>
           <a:bodyPr rtlCol="0" anchor="ctr" lIns="0" rIns="0" tIns="0" bIns="0"/>
           <a:lstStyle/>
@@ -19715,7 +18587,7 @@
             <a:r>
               <a:rPr sz="1700" b="1" i="0">
                 <a:solidFill>
-                  <a:srgbClr val="EE3138"/>
+                  <a:srgbClr val="343174"/>
                 </a:solidFill>
                 <a:latin typeface="Calibri"/>
               </a:rPr>
@@ -19744,10 +18616,8 @@
             <a:off x="6080760" y="1417320"/>
             <a:ext cx="2468880" cy="3429000"/>
           </a:xfrm>
-          <a:prstGeom prst="roundRect">
-            <a:avLst>
-              <a:gd name="adj" fmla="val 8000"/>
-            </a:avLst>
+          <a:prstGeom prst="rect">
+            <a:avLst/>
           </a:prstGeom>
           <a:solidFill>
             <a:srgbClr val="343174"/>
@@ -19757,20 +18627,6 @@
           </a:ln>
           <a:effectLst/>
         </p:spPr>
-        <p:style>
-          <a:lnRef idx="1">
-            <a:schemeClr val="accent1"/>
-          </a:lnRef>
-          <a:fillRef idx="3">
-            <a:schemeClr val="accent1"/>
-          </a:fillRef>
-          <a:effectRef idx="2">
-            <a:schemeClr val="accent1"/>
-          </a:effectRef>
-          <a:fontRef idx="minor">
-            <a:schemeClr val="lt1"/>
-          </a:fontRef>
-        </p:style>
         <p:txBody>
           <a:bodyPr rtlCol="0" anchor="ctr"/>
           <a:lstStyle/>
@@ -19807,7 +18663,7 @@
             <a:r>
               <a:rPr sz="1300" b="1" i="0">
                 <a:solidFill>
-                  <a:srgbClr val="FFB8BB"/>
+                  <a:srgbClr val="C9C8E0"/>
                 </a:solidFill>
                 <a:latin typeface="Calibri"/>
               </a:rPr>
@@ -19951,33 +18807,17 @@
             <a:off x="2240280" y="1371600"/>
             <a:ext cx="6309359" cy="1188720"/>
           </a:xfrm>
-          <a:prstGeom prst="roundRect">
-            <a:avLst>
-              <a:gd name="adj" fmla="val 8000"/>
-            </a:avLst>
+          <a:prstGeom prst="rect">
+            <a:avLst/>
           </a:prstGeom>
           <a:solidFill>
-            <a:srgbClr val="FDEBEC"/>
+            <a:srgbClr val="F2F2F5"/>
           </a:solidFill>
           <a:ln>
             <a:noFill/>
           </a:ln>
           <a:effectLst/>
         </p:spPr>
-        <p:style>
-          <a:lnRef idx="1">
-            <a:schemeClr val="accent1"/>
-          </a:lnRef>
-          <a:fillRef idx="3">
-            <a:schemeClr val="accent1"/>
-          </a:fillRef>
-          <a:effectRef idx="2">
-            <a:schemeClr val="accent1"/>
-          </a:effectRef>
-          <a:fontRef idx="minor">
-            <a:schemeClr val="lt1"/>
-          </a:fontRef>
-        </p:style>
         <p:txBody>
           <a:bodyPr rtlCol="0" anchor="ctr"/>
           <a:lstStyle/>
@@ -19993,158 +18833,6 @@
         <p:spPr>
           <a:xfrm>
             <a:off x="2441448" y="1719072"/>
-            <a:ext cx="493776" cy="493776"/>
-          </a:xfrm>
-          <a:prstGeom prst="ellipse">
-            <a:avLst/>
-          </a:prstGeom>
-          <a:solidFill>
-            <a:srgbClr val="EE3138"/>
-          </a:solidFill>
-          <a:ln>
-            <a:noFill/>
-          </a:ln>
-          <a:effectLst/>
-        </p:spPr>
-        <p:style>
-          <a:lnRef idx="1">
-            <a:schemeClr val="accent1"/>
-          </a:lnRef>
-          <a:fillRef idx="3">
-            <a:schemeClr val="accent1"/>
-          </a:fillRef>
-          <a:effectRef idx="2">
-            <a:schemeClr val="accent1"/>
-          </a:effectRef>
-          <a:fontRef idx="minor">
-            <a:schemeClr val="lt1"/>
-          </a:fontRef>
-        </p:style>
-        <p:txBody>
-          <a:bodyPr rtlCol="0" anchor="ctr" lIns="0" rIns="0" tIns="0" bIns="0"/>
-          <a:lstStyle/>
-          <a:p>
-            <a:pPr algn="ctr"/>
-            <a:r>
-              <a:rPr sz="1800" b="1" i="0">
-                <a:solidFill>
-                  <a:srgbClr val="FFFFFF"/>
-                </a:solidFill>
-                <a:latin typeface="Calibri"/>
-              </a:rPr>
-              <a:t>1</a:t>
-            </a:r>
-          </a:p>
-        </p:txBody>
-      </p:sp>
-      <p:sp>
-        <p:nvSpPr>
-          <p:cNvPr id="6" name="Problem text 1"/>
-          <p:cNvSpPr txBox="1"/>
-          <p:nvPr/>
-        </p:nvSpPr>
-        <p:spPr>
-          <a:xfrm>
-            <a:off x="3136392" y="1481328"/>
-            <a:ext cx="5257800" cy="1005840"/>
-          </a:xfrm>
-          <a:prstGeom prst="rect">
-            <a:avLst/>
-          </a:prstGeom>
-          <a:noFill/>
-        </p:spPr>
-        <p:txBody>
-          <a:bodyPr wrap="square" anchor="ctr" lIns="0" rIns="0" tIns="0" bIns="0">
-            <a:spAutoFit/>
-          </a:bodyPr>
-          <a:lstStyle/>
-          <a:p>
-            <a:pPr algn="l">
-              <a:spcAft>
-                <a:spcPts val="300"/>
-              </a:spcAft>
-            </a:pPr>
-            <a:r>
-              <a:rPr sz="1800" b="1" i="0">
-                <a:solidFill>
-                  <a:srgbClr val="22222A"/>
-                </a:solidFill>
-                <a:latin typeface="Calibri"/>
-              </a:rPr>
-              <a:t>Risk scores without reasons</a:t>
-            </a:r>
-          </a:p>
-          <a:p>
-            <a:pPr algn="l">
-              <a:spcAft>
-                <a:spcPts val="300"/>
-              </a:spcAft>
-            </a:pPr>
-            <a:r>
-              <a:rPr sz="1500" b="0" i="0">
-                <a:solidFill>
-                  <a:srgbClr val="555560"/>
-                </a:solidFill>
-                <a:latin typeface="Calibri"/>
-              </a:rPr>
-              <a:t>Most systems output a score with no account of the reasoning behind it.</a:t>
-            </a:r>
-          </a:p>
-        </p:txBody>
-      </p:sp>
-      <p:sp>
-        <p:nvSpPr>
-          <p:cNvPr id="7" name="Problem card 2"/>
-          <p:cNvSpPr/>
-          <p:nvPr/>
-        </p:nvSpPr>
-        <p:spPr>
-          <a:xfrm>
-            <a:off x="2240280" y="2743200"/>
-            <a:ext cx="6309359" cy="1188720"/>
-          </a:xfrm>
-          <a:prstGeom prst="roundRect">
-            <a:avLst>
-              <a:gd name="adj" fmla="val 8000"/>
-            </a:avLst>
-          </a:prstGeom>
-          <a:solidFill>
-            <a:srgbClr val="ECEBF5"/>
-          </a:solidFill>
-          <a:ln>
-            <a:noFill/>
-          </a:ln>
-          <a:effectLst/>
-        </p:spPr>
-        <p:style>
-          <a:lnRef idx="1">
-            <a:schemeClr val="accent1"/>
-          </a:lnRef>
-          <a:fillRef idx="3">
-            <a:schemeClr val="accent1"/>
-          </a:fillRef>
-          <a:effectRef idx="2">
-            <a:schemeClr val="accent1"/>
-          </a:effectRef>
-          <a:fontRef idx="minor">
-            <a:schemeClr val="lt1"/>
-          </a:fontRef>
-        </p:style>
-        <p:txBody>
-          <a:bodyPr rtlCol="0" anchor="ctr"/>
-          <a:lstStyle/>
-          <a:p/>
-        </p:txBody>
-      </p:sp>
-      <p:sp>
-        <p:nvSpPr>
-          <p:cNvPr id="8" name="Oval 7"/>
-          <p:cNvSpPr/>
-          <p:nvPr/>
-        </p:nvSpPr>
-        <p:spPr>
-          <a:xfrm>
-            <a:off x="2441448" y="3090672"/>
             <a:ext cx="493776" cy="493776"/>
           </a:xfrm>
           <a:prstGeom prst="ellipse">
@@ -20158,20 +18846,6 @@
           </a:ln>
           <a:effectLst/>
         </p:spPr>
-        <p:style>
-          <a:lnRef idx="1">
-            <a:schemeClr val="accent1"/>
-          </a:lnRef>
-          <a:fillRef idx="3">
-            <a:schemeClr val="accent1"/>
-          </a:fillRef>
-          <a:effectRef idx="2">
-            <a:schemeClr val="accent1"/>
-          </a:effectRef>
-          <a:fontRef idx="minor">
-            <a:schemeClr val="lt1"/>
-          </a:fontRef>
-        </p:style>
         <p:txBody>
           <a:bodyPr rtlCol="0" anchor="ctr" lIns="0" rIns="0" tIns="0" bIns="0"/>
           <a:lstStyle/>
@@ -20184,20 +18858,20 @@
                 </a:solidFill>
                 <a:latin typeface="Calibri"/>
               </a:rPr>
-              <a:t>2</a:t>
-            </a:r>
-          </a:p>
-        </p:txBody>
-      </p:sp>
-      <p:sp>
-        <p:nvSpPr>
-          <p:cNvPr id="9" name="Problem text 2"/>
+              <a:t>1</a:t>
+            </a:r>
+          </a:p>
+        </p:txBody>
+      </p:sp>
+      <p:sp>
+        <p:nvSpPr>
+          <p:cNvPr id="6" name="Problem text 1"/>
           <p:cNvSpPr txBox="1"/>
           <p:nvPr/>
         </p:nvSpPr>
         <p:spPr>
           <a:xfrm>
-            <a:off x="3136392" y="2852928"/>
+            <a:off x="3136392" y="1481328"/>
             <a:ext cx="5257800" cy="1005840"/>
           </a:xfrm>
           <a:prstGeom prst="rect">
@@ -20223,7 +18897,7 @@
                 </a:solidFill>
                 <a:latin typeface="Calibri"/>
               </a:rPr>
-              <a:t>One view for every role</a:t>
+              <a:t>Risk scores without reasons</a:t>
             </a:r>
           </a:p>
           <a:p>
@@ -20239,49 +18913,33 @@
                 </a:solidFill>
                 <a:latin typeface="Calibri"/>
               </a:rPr>
-              <a:t>Instructors, advisors and administrators decide different things, yet dashboards rarely differ by role.</a:t>
-            </a:r>
-          </a:p>
-        </p:txBody>
-      </p:sp>
-      <p:sp>
-        <p:nvSpPr>
-          <p:cNvPr id="10" name="Problem card 3"/>
+              <a:t>Most systems output a score with no account of the reasoning behind it.</a:t>
+            </a:r>
+          </a:p>
+        </p:txBody>
+      </p:sp>
+      <p:sp>
+        <p:nvSpPr>
+          <p:cNvPr id="7" name="Problem card 2"/>
           <p:cNvSpPr/>
           <p:nvPr/>
         </p:nvSpPr>
         <p:spPr>
           <a:xfrm>
-            <a:off x="2240280" y="4114800"/>
+            <a:off x="2240280" y="2743200"/>
             <a:ext cx="6309359" cy="1188720"/>
           </a:xfrm>
-          <a:prstGeom prst="roundRect">
-            <a:avLst>
-              <a:gd name="adj" fmla="val 8000"/>
-            </a:avLst>
+          <a:prstGeom prst="rect">
+            <a:avLst/>
           </a:prstGeom>
           <a:solidFill>
-            <a:srgbClr val="E6F5EC"/>
+            <a:srgbClr val="F2F2F5"/>
           </a:solidFill>
           <a:ln>
             <a:noFill/>
           </a:ln>
           <a:effectLst/>
         </p:spPr>
-        <p:style>
-          <a:lnRef idx="1">
-            <a:schemeClr val="accent1"/>
-          </a:lnRef>
-          <a:fillRef idx="3">
-            <a:schemeClr val="accent1"/>
-          </a:fillRef>
-          <a:effectRef idx="2">
-            <a:schemeClr val="accent1"/>
-          </a:effectRef>
-          <a:fontRef idx="minor">
-            <a:schemeClr val="lt1"/>
-          </a:fontRef>
-        </p:style>
         <p:txBody>
           <a:bodyPr rtlCol="0" anchor="ctr"/>
           <a:lstStyle/>
@@ -20290,40 +18948,148 @@
       </p:sp>
       <p:sp>
         <p:nvSpPr>
-          <p:cNvPr id="11" name="Oval 10"/>
+          <p:cNvPr id="8" name="Oval 7"/>
           <p:cNvSpPr/>
           <p:nvPr/>
         </p:nvSpPr>
         <p:spPr>
           <a:xfrm>
-            <a:off x="2441448" y="4462272"/>
+            <a:off x="2441448" y="3090672"/>
             <a:ext cx="493776" cy="493776"/>
           </a:xfrm>
           <a:prstGeom prst="ellipse">
             <a:avLst/>
           </a:prstGeom>
           <a:solidFill>
-            <a:srgbClr val="018A4B"/>
+            <a:srgbClr val="343174"/>
           </a:solidFill>
           <a:ln>
             <a:noFill/>
           </a:ln>
           <a:effectLst/>
         </p:spPr>
-        <p:style>
-          <a:lnRef idx="1">
-            <a:schemeClr val="accent1"/>
-          </a:lnRef>
-          <a:fillRef idx="3">
-            <a:schemeClr val="accent1"/>
-          </a:fillRef>
-          <a:effectRef idx="2">
-            <a:schemeClr val="accent1"/>
-          </a:effectRef>
-          <a:fontRef idx="minor">
-            <a:schemeClr val="lt1"/>
-          </a:fontRef>
-        </p:style>
+        <p:txBody>
+          <a:bodyPr rtlCol="0" anchor="ctr" lIns="0" rIns="0" tIns="0" bIns="0"/>
+          <a:lstStyle/>
+          <a:p>
+            <a:pPr algn="ctr"/>
+            <a:r>
+              <a:rPr sz="1800" b="1" i="0">
+                <a:solidFill>
+                  <a:srgbClr val="FFFFFF"/>
+                </a:solidFill>
+                <a:latin typeface="Calibri"/>
+              </a:rPr>
+              <a:t>2</a:t>
+            </a:r>
+          </a:p>
+        </p:txBody>
+      </p:sp>
+      <p:sp>
+        <p:nvSpPr>
+          <p:cNvPr id="9" name="Problem text 2"/>
+          <p:cNvSpPr txBox="1"/>
+          <p:nvPr/>
+        </p:nvSpPr>
+        <p:spPr>
+          <a:xfrm>
+            <a:off x="3136392" y="2852928"/>
+            <a:ext cx="5257800" cy="1005840"/>
+          </a:xfrm>
+          <a:prstGeom prst="rect">
+            <a:avLst/>
+          </a:prstGeom>
+          <a:noFill/>
+        </p:spPr>
+        <p:txBody>
+          <a:bodyPr wrap="square" anchor="ctr" lIns="0" rIns="0" tIns="0" bIns="0">
+            <a:spAutoFit/>
+          </a:bodyPr>
+          <a:lstStyle/>
+          <a:p>
+            <a:pPr algn="l">
+              <a:spcAft>
+                <a:spcPts val="300"/>
+              </a:spcAft>
+            </a:pPr>
+            <a:r>
+              <a:rPr sz="1800" b="1" i="0">
+                <a:solidFill>
+                  <a:srgbClr val="22222A"/>
+                </a:solidFill>
+                <a:latin typeface="Calibri"/>
+              </a:rPr>
+              <a:t>One view for every role</a:t>
+            </a:r>
+          </a:p>
+          <a:p>
+            <a:pPr algn="l">
+              <a:spcAft>
+                <a:spcPts val="300"/>
+              </a:spcAft>
+            </a:pPr>
+            <a:r>
+              <a:rPr sz="1500" b="0" i="0">
+                <a:solidFill>
+                  <a:srgbClr val="555560"/>
+                </a:solidFill>
+                <a:latin typeface="Calibri"/>
+              </a:rPr>
+              <a:t>Instructors, advisors and administrators decide different things, yet dashboards rarely differ by role.</a:t>
+            </a:r>
+          </a:p>
+        </p:txBody>
+      </p:sp>
+      <p:sp>
+        <p:nvSpPr>
+          <p:cNvPr id="10" name="Problem card 3"/>
+          <p:cNvSpPr/>
+          <p:nvPr/>
+        </p:nvSpPr>
+        <p:spPr>
+          <a:xfrm>
+            <a:off x="2240280" y="4114800"/>
+            <a:ext cx="6309359" cy="1188720"/>
+          </a:xfrm>
+          <a:prstGeom prst="rect">
+            <a:avLst/>
+          </a:prstGeom>
+          <a:solidFill>
+            <a:srgbClr val="F2F2F5"/>
+          </a:solidFill>
+          <a:ln>
+            <a:noFill/>
+          </a:ln>
+          <a:effectLst/>
+        </p:spPr>
+        <p:txBody>
+          <a:bodyPr rtlCol="0" anchor="ctr"/>
+          <a:lstStyle/>
+          <a:p/>
+        </p:txBody>
+      </p:sp>
+      <p:sp>
+        <p:nvSpPr>
+          <p:cNvPr id="11" name="Oval 10"/>
+          <p:cNvSpPr/>
+          <p:nvPr/>
+        </p:nvSpPr>
+        <p:spPr>
+          <a:xfrm>
+            <a:off x="2441448" y="4462272"/>
+            <a:ext cx="493776" cy="493776"/>
+          </a:xfrm>
+          <a:prstGeom prst="ellipse">
+            <a:avLst/>
+          </a:prstGeom>
+          <a:solidFill>
+            <a:srgbClr val="343174"/>
+          </a:solidFill>
+          <a:ln>
+            <a:noFill/>
+          </a:ln>
+          <a:effectLst/>
+        </p:spPr>
         <p:txBody>
           <a:bodyPr rtlCol="0" anchor="ctr" lIns="0" rIns="0" tIns="0" bIns="0"/>
           <a:lstStyle/>
@@ -20547,10 +19313,8 @@
             <a:off x="2240280" y="1371600"/>
             <a:ext cx="6309359" cy="1234440"/>
           </a:xfrm>
-          <a:prstGeom prst="roundRect">
-            <a:avLst>
-              <a:gd name="adj" fmla="val 8000"/>
-            </a:avLst>
+          <a:prstGeom prst="rect">
+            <a:avLst/>
           </a:prstGeom>
           <a:solidFill>
             <a:srgbClr val="343174"/>
@@ -20560,20 +19324,6 @@
           </a:ln>
           <a:effectLst/>
         </p:spPr>
-        <p:style>
-          <a:lnRef idx="1">
-            <a:schemeClr val="accent1"/>
-          </a:lnRef>
-          <a:fillRef idx="3">
-            <a:schemeClr val="accent1"/>
-          </a:fillRef>
-          <a:effectRef idx="2">
-            <a:schemeClr val="accent1"/>
-          </a:effectRef>
-          <a:fontRef idx="minor">
-            <a:schemeClr val="lt1"/>
-          </a:fontRef>
-        </p:style>
         <p:txBody>
           <a:bodyPr rtlCol="0" anchor="ctr"/>
           <a:lstStyle/>
@@ -20610,7 +19360,7 @@
             <a:r>
               <a:rPr sz="1300" b="1" i="0">
                 <a:solidFill>
-                  <a:srgbClr val="FFB8BB"/>
+                  <a:srgbClr val="C9C8E0"/>
                 </a:solidFill>
                 <a:latin typeface="Calibri"/>
               </a:rPr>
@@ -20650,27 +19400,13 @@
             <a:avLst/>
           </a:prstGeom>
           <a:solidFill>
-            <a:srgbClr val="018A4B"/>
+            <a:srgbClr val="343174"/>
           </a:solidFill>
           <a:ln>
             <a:noFill/>
           </a:ln>
           <a:effectLst/>
         </p:spPr>
-        <p:style>
-          <a:lnRef idx="1">
-            <a:schemeClr val="accent1"/>
-          </a:lnRef>
-          <a:fillRef idx="3">
-            <a:schemeClr val="accent1"/>
-          </a:fillRef>
-          <a:effectRef idx="2">
-            <a:schemeClr val="accent1"/>
-          </a:effectRef>
-          <a:fontRef idx="minor">
-            <a:schemeClr val="lt1"/>
-          </a:fontRef>
-        </p:style>
         <p:txBody>
           <a:bodyPr rtlCol="0" anchor="ctr" lIns="0" rIns="0" tIns="0" bIns="0"/>
           <a:lstStyle/>
@@ -20758,27 +19494,13 @@
             <a:avLst/>
           </a:prstGeom>
           <a:solidFill>
-            <a:srgbClr val="018A4B"/>
+            <a:srgbClr val="343174"/>
           </a:solidFill>
           <a:ln>
             <a:noFill/>
           </a:ln>
           <a:effectLst/>
         </p:spPr>
-        <p:style>
-          <a:lnRef idx="1">
-            <a:schemeClr val="accent1"/>
-          </a:lnRef>
-          <a:fillRef idx="3">
-            <a:schemeClr val="accent1"/>
-          </a:fillRef>
-          <a:effectRef idx="2">
-            <a:schemeClr val="accent1"/>
-          </a:effectRef>
-          <a:fontRef idx="minor">
-            <a:schemeClr val="lt1"/>
-          </a:fontRef>
-        </p:style>
         <p:txBody>
           <a:bodyPr rtlCol="0" anchor="ctr" lIns="0" rIns="0" tIns="0" bIns="0"/>
           <a:lstStyle/>
@@ -20866,27 +19588,13 @@
             <a:avLst/>
           </a:prstGeom>
           <a:solidFill>
-            <a:srgbClr val="018A4B"/>
+            <a:srgbClr val="343174"/>
           </a:solidFill>
           <a:ln>
             <a:noFill/>
           </a:ln>
           <a:effectLst/>
         </p:spPr>
-        <p:style>
-          <a:lnRef idx="1">
-            <a:schemeClr val="accent1"/>
-          </a:lnRef>
-          <a:fillRef idx="3">
-            <a:schemeClr val="accent1"/>
-          </a:fillRef>
-          <a:effectRef idx="2">
-            <a:schemeClr val="accent1"/>
-          </a:effectRef>
-          <a:fontRef idx="minor">
-            <a:schemeClr val="lt1"/>
-          </a:fontRef>
-        </p:style>
         <p:txBody>
           <a:bodyPr rtlCol="0" anchor="ctr" lIns="0" rIns="0" tIns="0" bIns="0"/>
           <a:lstStyle/>
@@ -21062,33 +19770,17 @@
             <a:off x="2240280" y="1371600"/>
             <a:ext cx="6309359" cy="1353312"/>
           </a:xfrm>
-          <a:prstGeom prst="roundRect">
-            <a:avLst>
-              <a:gd name="adj" fmla="val 8000"/>
-            </a:avLst>
+          <a:prstGeom prst="rect">
+            <a:avLst/>
           </a:prstGeom>
           <a:solidFill>
-            <a:srgbClr val="ECEBF5"/>
+            <a:srgbClr val="F2F2F5"/>
           </a:solidFill>
           <a:ln>
             <a:noFill/>
           </a:ln>
           <a:effectLst/>
         </p:spPr>
-        <p:style>
-          <a:lnRef idx="1">
-            <a:schemeClr val="accent1"/>
-          </a:lnRef>
-          <a:fillRef idx="3">
-            <a:schemeClr val="accent1"/>
-          </a:fillRef>
-          <a:effectRef idx="2">
-            <a:schemeClr val="accent1"/>
-          </a:effectRef>
-          <a:fontRef idx="minor">
-            <a:schemeClr val="lt1"/>
-          </a:fontRef>
-        </p:style>
         <p:txBody>
           <a:bodyPr rtlCol="0" anchor="ctr"/>
           <a:lstStyle/>
@@ -21106,10 +19798,8 @@
             <a:off x="2240280" y="1371600"/>
             <a:ext cx="914400" cy="1353312"/>
           </a:xfrm>
-          <a:prstGeom prst="roundRect">
-            <a:avLst>
-              <a:gd name="adj" fmla="val 8000"/>
-            </a:avLst>
+          <a:prstGeom prst="rect">
+            <a:avLst/>
           </a:prstGeom>
           <a:solidFill>
             <a:srgbClr val="343174"/>
@@ -21119,20 +19809,6 @@
           </a:ln>
           <a:effectLst/>
         </p:spPr>
-        <p:style>
-          <a:lnRef idx="1">
-            <a:schemeClr val="accent1"/>
-          </a:lnRef>
-          <a:fillRef idx="3">
-            <a:schemeClr val="accent1"/>
-          </a:fillRef>
-          <a:effectRef idx="2">
-            <a:schemeClr val="accent1"/>
-          </a:effectRef>
-          <a:fontRef idx="minor">
-            <a:schemeClr val="lt1"/>
-          </a:fontRef>
-        </p:style>
         <p:txBody>
           <a:bodyPr rtlCol="0" anchor="ctr"/>
           <a:lstStyle/>
@@ -21228,33 +19904,17 @@
             <a:off x="2240280" y="2907791"/>
             <a:ext cx="6309359" cy="1353312"/>
           </a:xfrm>
-          <a:prstGeom prst="roundRect">
-            <a:avLst>
-              <a:gd name="adj" fmla="val 8000"/>
-            </a:avLst>
+          <a:prstGeom prst="rect">
+            <a:avLst/>
           </a:prstGeom>
           <a:solidFill>
-            <a:srgbClr val="ECEBF5"/>
+            <a:srgbClr val="F2F2F5"/>
           </a:solidFill>
           <a:ln>
             <a:noFill/>
           </a:ln>
           <a:effectLst/>
         </p:spPr>
-        <p:style>
-          <a:lnRef idx="1">
-            <a:schemeClr val="accent1"/>
-          </a:lnRef>
-          <a:fillRef idx="3">
-            <a:schemeClr val="accent1"/>
-          </a:fillRef>
-          <a:effectRef idx="2">
-            <a:schemeClr val="accent1"/>
-          </a:effectRef>
-          <a:fontRef idx="minor">
-            <a:schemeClr val="lt1"/>
-          </a:fontRef>
-        </p:style>
         <p:txBody>
           <a:bodyPr rtlCol="0" anchor="ctr"/>
           <a:lstStyle/>
@@ -21272,33 +19932,17 @@
             <a:off x="2240280" y="2907791"/>
             <a:ext cx="914400" cy="1353312"/>
           </a:xfrm>
-          <a:prstGeom prst="roundRect">
-            <a:avLst>
-              <a:gd name="adj" fmla="val 8000"/>
-            </a:avLst>
+          <a:prstGeom prst="rect">
+            <a:avLst/>
           </a:prstGeom>
           <a:solidFill>
-            <a:srgbClr val="EE3138"/>
+            <a:srgbClr val="343174"/>
           </a:solidFill>
           <a:ln>
             <a:noFill/>
           </a:ln>
           <a:effectLst/>
         </p:spPr>
-        <p:style>
-          <a:lnRef idx="1">
-            <a:schemeClr val="accent1"/>
-          </a:lnRef>
-          <a:fillRef idx="3">
-            <a:schemeClr val="accent1"/>
-          </a:fillRef>
-          <a:effectRef idx="2">
-            <a:schemeClr val="accent1"/>
-          </a:effectRef>
-          <a:fontRef idx="minor">
-            <a:schemeClr val="lt1"/>
-          </a:fontRef>
-        </p:style>
         <p:txBody>
           <a:bodyPr rtlCol="0" anchor="ctr"/>
           <a:lstStyle/>
@@ -21394,33 +20038,17 @@
             <a:off x="2240280" y="4443983"/>
             <a:ext cx="6309359" cy="1353312"/>
           </a:xfrm>
-          <a:prstGeom prst="roundRect">
-            <a:avLst>
-              <a:gd name="adj" fmla="val 8000"/>
-            </a:avLst>
+          <a:prstGeom prst="rect">
+            <a:avLst/>
           </a:prstGeom>
           <a:solidFill>
-            <a:srgbClr val="ECEBF5"/>
+            <a:srgbClr val="F2F2F5"/>
           </a:solidFill>
           <a:ln>
             <a:noFill/>
           </a:ln>
           <a:effectLst/>
         </p:spPr>
-        <p:style>
-          <a:lnRef idx="1">
-            <a:schemeClr val="accent1"/>
-          </a:lnRef>
-          <a:fillRef idx="3">
-            <a:schemeClr val="accent1"/>
-          </a:fillRef>
-          <a:effectRef idx="2">
-            <a:schemeClr val="accent1"/>
-          </a:effectRef>
-          <a:fontRef idx="minor">
-            <a:schemeClr val="lt1"/>
-          </a:fontRef>
-        </p:style>
         <p:txBody>
           <a:bodyPr rtlCol="0" anchor="ctr"/>
           <a:lstStyle/>
@@ -21438,33 +20066,17 @@
             <a:off x="2240280" y="4443983"/>
             <a:ext cx="914400" cy="1353312"/>
           </a:xfrm>
-          <a:prstGeom prst="roundRect">
-            <a:avLst>
-              <a:gd name="adj" fmla="val 8000"/>
-            </a:avLst>
+          <a:prstGeom prst="rect">
+            <a:avLst/>
           </a:prstGeom>
           <a:solidFill>
-            <a:srgbClr val="018A4B"/>
+            <a:srgbClr val="343174"/>
           </a:solidFill>
           <a:ln>
             <a:noFill/>
           </a:ln>
           <a:effectLst/>
         </p:spPr>
-        <p:style>
-          <a:lnRef idx="1">
-            <a:schemeClr val="accent1"/>
-          </a:lnRef>
-          <a:fillRef idx="3">
-            <a:schemeClr val="accent1"/>
-          </a:fillRef>
-          <a:effectRef idx="2">
-            <a:schemeClr val="accent1"/>
-          </a:effectRef>
-          <a:fontRef idx="minor">
-            <a:schemeClr val="lt1"/>
-          </a:fontRef>
-        </p:style>
         <p:txBody>
           <a:bodyPr rtlCol="0" anchor="ctr"/>
           <a:lstStyle/>
@@ -21652,33 +20264,17 @@
             <a:off x="2240280" y="1371600"/>
             <a:ext cx="6309359" cy="676656"/>
           </a:xfrm>
-          <a:prstGeom prst="roundRect">
-            <a:avLst>
-              <a:gd name="adj" fmla="val 8000"/>
-            </a:avLst>
+          <a:prstGeom prst="rect">
+            <a:avLst/>
           </a:prstGeom>
           <a:solidFill>
-            <a:srgbClr val="ECEBF5"/>
+            <a:srgbClr val="F2F2F5"/>
           </a:solidFill>
           <a:ln>
             <a:noFill/>
           </a:ln>
           <a:effectLst/>
         </p:spPr>
-        <p:style>
-          <a:lnRef idx="1">
-            <a:schemeClr val="accent1"/>
-          </a:lnRef>
-          <a:fillRef idx="3">
-            <a:schemeClr val="accent1"/>
-          </a:fillRef>
-          <a:effectRef idx="2">
-            <a:schemeClr val="accent1"/>
-          </a:effectRef>
-          <a:fontRef idx="minor">
-            <a:schemeClr val="lt1"/>
-          </a:fontRef>
-        </p:style>
         <p:txBody>
           <a:bodyPr rtlCol="0" anchor="ctr"/>
           <a:lstStyle/>
@@ -21774,10 +20370,8 @@
             <a:off x="2240280" y="2157984"/>
             <a:ext cx="6309359" cy="676656"/>
           </a:xfrm>
-          <a:prstGeom prst="roundRect">
-            <a:avLst>
-              <a:gd name="adj" fmla="val 8000"/>
-            </a:avLst>
+          <a:prstGeom prst="rect">
+            <a:avLst/>
           </a:prstGeom>
           <a:solidFill>
             <a:srgbClr val="F6F6FA"/>
@@ -21787,20 +20381,6 @@
           </a:ln>
           <a:effectLst/>
         </p:spPr>
-        <p:style>
-          <a:lnRef idx="1">
-            <a:schemeClr val="accent1"/>
-          </a:lnRef>
-          <a:fillRef idx="3">
-            <a:schemeClr val="accent1"/>
-          </a:fillRef>
-          <a:effectRef idx="2">
-            <a:schemeClr val="accent1"/>
-          </a:effectRef>
-          <a:fontRef idx="minor">
-            <a:schemeClr val="lt1"/>
-          </a:fontRef>
-        </p:style>
         <p:txBody>
           <a:bodyPr rtlCol="0" anchor="ctr"/>
           <a:lstStyle/>
@@ -21896,33 +20476,17 @@
             <a:off x="2240280" y="2944368"/>
             <a:ext cx="6309359" cy="676656"/>
           </a:xfrm>
-          <a:prstGeom prst="roundRect">
-            <a:avLst>
-              <a:gd name="adj" fmla="val 8000"/>
-            </a:avLst>
+          <a:prstGeom prst="rect">
+            <a:avLst/>
           </a:prstGeom>
           <a:solidFill>
-            <a:srgbClr val="ECEBF5"/>
+            <a:srgbClr val="F2F2F5"/>
           </a:solidFill>
           <a:ln>
             <a:noFill/>
           </a:ln>
           <a:effectLst/>
         </p:spPr>
-        <p:style>
-          <a:lnRef idx="1">
-            <a:schemeClr val="accent1"/>
-          </a:lnRef>
-          <a:fillRef idx="3">
-            <a:schemeClr val="accent1"/>
-          </a:fillRef>
-          <a:effectRef idx="2">
-            <a:schemeClr val="accent1"/>
-          </a:effectRef>
-          <a:fontRef idx="minor">
-            <a:schemeClr val="lt1"/>
-          </a:fontRef>
-        </p:style>
         <p:txBody>
           <a:bodyPr rtlCol="0" anchor="ctr"/>
           <a:lstStyle/>
@@ -22018,10 +20582,8 @@
             <a:off x="2240280" y="3730752"/>
             <a:ext cx="6309359" cy="676656"/>
           </a:xfrm>
-          <a:prstGeom prst="roundRect">
-            <a:avLst>
-              <a:gd name="adj" fmla="val 8000"/>
-            </a:avLst>
+          <a:prstGeom prst="rect">
+            <a:avLst/>
           </a:prstGeom>
           <a:solidFill>
             <a:srgbClr val="F6F6FA"/>
@@ -22031,20 +20593,6 @@
           </a:ln>
           <a:effectLst/>
         </p:spPr>
-        <p:style>
-          <a:lnRef idx="1">
-            <a:schemeClr val="accent1"/>
-          </a:lnRef>
-          <a:fillRef idx="3">
-            <a:schemeClr val="accent1"/>
-          </a:fillRef>
-          <a:effectRef idx="2">
-            <a:schemeClr val="accent1"/>
-          </a:effectRef>
-          <a:fontRef idx="minor">
-            <a:schemeClr val="lt1"/>
-          </a:fontRef>
-        </p:style>
         <p:txBody>
           <a:bodyPr rtlCol="0" anchor="ctr"/>
           <a:lstStyle/>
@@ -22140,33 +20688,17 @@
             <a:off x="2240280" y="4517136"/>
             <a:ext cx="6309359" cy="676656"/>
           </a:xfrm>
-          <a:prstGeom prst="roundRect">
-            <a:avLst>
-              <a:gd name="adj" fmla="val 8000"/>
-            </a:avLst>
+          <a:prstGeom prst="rect">
+            <a:avLst/>
           </a:prstGeom>
           <a:solidFill>
-            <a:srgbClr val="ECEBF5"/>
+            <a:srgbClr val="F2F2F5"/>
           </a:solidFill>
           <a:ln>
             <a:noFill/>
           </a:ln>
           <a:effectLst/>
         </p:spPr>
-        <p:style>
-          <a:lnRef idx="1">
-            <a:schemeClr val="accent1"/>
-          </a:lnRef>
-          <a:fillRef idx="3">
-            <a:schemeClr val="accent1"/>
-          </a:fillRef>
-          <a:effectRef idx="2">
-            <a:schemeClr val="accent1"/>
-          </a:effectRef>
-          <a:fontRef idx="minor">
-            <a:schemeClr val="lt1"/>
-          </a:fontRef>
-        </p:style>
         <p:txBody>
           <a:bodyPr rtlCol="0" anchor="ctr"/>
           <a:lstStyle/>
@@ -22281,7 +20813,7 @@
             <a:r>
               <a:rPr sz="1600" b="1" i="0">
                 <a:solidFill>
-                  <a:srgbClr val="EE3138"/>
+                  <a:srgbClr val="343174"/>
                 </a:solidFill>
                 <a:latin typeface="Calibri"/>
               </a:rPr>

</xml_diff>

<commit_message>
Defense deck: research questions worded exactly as in the thesis
</commit_message>
<xml_diff>
--- a/Internal_Defense_Presentation.pptx
+++ b/Internal_Defense_Presentation.pptx
@@ -19862,8 +19862,8 @@
         </p:nvSpPr>
         <p:spPr>
           <a:xfrm>
-            <a:off x="3337560" y="1444752"/>
-            <a:ext cx="5029200" cy="1207008"/>
+            <a:off x="3337560" y="1426464"/>
+            <a:ext cx="5074919" cy="1243584"/>
           </a:xfrm>
           <a:prstGeom prst="rect">
             <a:avLst/>
@@ -19882,13 +19882,13 @@
               </a:spcAft>
             </a:pPr>
             <a:r>
-              <a:rPr sz="1600" b="0" i="0">
+              <a:rPr sz="1500" b="0" i="0">
                 <a:solidFill>
                   <a:srgbClr val="22222A"/>
                 </a:solidFill>
                 <a:latin typeface="Calibri"/>
               </a:rPr>
-              <a:t>How can SHAP and LIME be integrated into a knowledge engineering pipeline to improve transparency in student at-risk prediction?</a:t>
+              <a:t>How can explainable AI techniques (specifically SHAP and LIME) be integrated into a knowledge engineering pipeline to improve transparency in student at-risk prediction models?</a:t>
             </a:r>
           </a:p>
         </p:txBody>
@@ -19996,8 +19996,8 @@
         </p:nvSpPr>
         <p:spPr>
           <a:xfrm>
-            <a:off x="3337560" y="2980944"/>
-            <a:ext cx="5029200" cy="1207008"/>
+            <a:off x="3337560" y="2962656"/>
+            <a:ext cx="5074919" cy="1243584"/>
           </a:xfrm>
           <a:prstGeom prst="rect">
             <a:avLst/>
@@ -20016,13 +20016,13 @@
               </a:spcAft>
             </a:pPr>
             <a:r>
-              <a:rPr sz="1600" b="0" i="0">
+              <a:rPr sz="1500" b="0" i="0">
                 <a:solidFill>
                   <a:srgbClr val="22222A"/>
                 </a:solidFill>
                 <a:latin typeface="Calibri"/>
               </a:rPr>
-              <a:t>What dashboard features and explanation structures, based on the CommonKADS Agent Model and the dashboard literature, can meet the different needs of instructors, advisors and administrators?</a:t>
+              <a:t>What dashboard features and explanation structures, based on the CommonKADS Agent Model and the learning analytics dashboard literature, can be specified to support the different information needs of instructors, advisors, and administrators within an LMS?</a:t>
             </a:r>
           </a:p>
         </p:txBody>
@@ -20130,8 +20130,8 @@
         </p:nvSpPr>
         <p:spPr>
           <a:xfrm>
-            <a:off x="3337560" y="4517136"/>
-            <a:ext cx="5029200" cy="1207008"/>
+            <a:off x="3337560" y="4498847"/>
+            <a:ext cx="5074919" cy="1243584"/>
           </a:xfrm>
           <a:prstGeom prst="rect">
             <a:avLst/>
@@ -20150,13 +20150,13 @@
               </a:spcAft>
             </a:pPr>
             <a:r>
-              <a:rPr sz="1600" b="0" i="0">
+              <a:rPr sz="1500" b="0" i="0">
                 <a:solidFill>
                   <a:srgbClr val="22222A"/>
                 </a:solidFill>
                 <a:latin typeface="Calibri"/>
               </a:rPr>
-              <a:t>What do the predictive and explainability findings indicate about the dashboard's technical potential to support practitioner interpretation and decision-making?</a:t>
+              <a:t>What do the predictive performance and explainability findings indicate about the technical potential of the proposed role-aware explainable dashboard to support practitioner interpretation and decision-making?</a:t>
             </a:r>
           </a:p>
         </p:txBody>

</xml_diff>

<commit_message>
Defense deck: use Moodle and Canvas prototype screenshots
</commit_message>
<xml_diff>
--- a/Internal_Defense_Presentation.pptx
+++ b/Internal_Defense_Presentation.pptx
@@ -26,6 +26,7 @@
     <p:sldId id="293" r:id="rId27"/>
     <p:sldId id="294" r:id="rId28"/>
     <p:sldId id="295" r:id="rId29"/>
+    <p:sldId id="296" r:id="rId30"/>
     <p:sldId id="274" r:id="rId4"/>
   </p:sldIdLst>
   <p:sldSz cx="9144000" cy="6858000" type="screen4x3"/>
@@ -1380,7 +1381,7 @@
           <a:lstStyle/>
           <a:p>
             <a:r>
-              <a:t>This is the core design idea. Every role sees the same prediction, but at a different depth. The instructor works inside a running course and sees individual students with SHAP and LIME side by side. The advisor manages a caseload and sees reasoning averaged over students at or above the watch threshold. The administrator directs resources and sees institution-wide performance and the full-population reasoning trail. These views were derived from the Agent Model and the literature and have not yet been tested with users.</a:t>
+              <a:t>This is the core design idea, shown running inside Moodle. Every role sees the same prediction, but at a different depth. The instructor works inside a running course and sees individual students with SHAP and LIME side by side. The advisor manages a caseload and sees reasoning averaged over students at or above the watch threshold. The administrator directs resources and sees institution-wide performance and the full-population reasoning trail. Moodle supplies the login, the role and the course context. These views were derived from the Agent Model and the literature and have not yet been tested with users.</a:t>
             </a:r>
           </a:p>
         </p:txBody>
@@ -1450,7 +1451,7 @@
           <a:lstStyle/>
           <a:p>
             <a:r>
-              <a:t>Here is the instructor view for module FFF, presentation 2014J. Students are ranked by predicted risk. Selecting one shows the top five SHAP contributions and the top five LIME weights next to each other, colour-coded by whether a feature pushes towards or away from at-risk. A note says how many features the two methods share for this student, here four of five, and reminds the reader that contributions describe the model's reasoning, not the student's situation. The same views also run inside Moodle as a plugin and inside Canvas.</a:t>
+              <a:t>Here is the At-risk insights page of the Moodle plugin in course FFF-2014J. Students are ranked by predicted risk. Selecting one shows the top five SHAP contributions and the top five LIME weights, colour-coded by whether a feature pushes towards or away from at-risk. A note says how many features the two methods share for this student, here four of five, and reminds the instructor that contributions describe the model's reasoning, not the causes of the student's situation, and that the decision stays with them.</a:t>
             </a:r>
           </a:p>
         </p:txBody>
@@ -1520,7 +1521,7 @@
           <a:lstStyle/>
           <a:p>
             <a:r>
-              <a:t>There are four contributions. First, a working system where prediction and explanation run together, with the explanation layer serving the interface directly, rather than explanation as an offline analysis. Second, role-aware explanation: distinct views derived from each role's responsibilities, with the reasoning documented. Third, a methodological one: applying CommonKADS shows that the design problem here is largely a knowledge problem. Fourth, evidence on where SHAP and LIME agree and differ, at global and local level.</a:t>
+              <a:t>The prototype was integrated with two LMSs, both running locally under Docker. In Moodle 5.2 a native plugin, local_xairisk, adds At-risk insights to each course's More menu and uses Moodle's own login, roles and enrolments, calling the API server to server. In Canvas the dashboard is added to every course as an External URL module item and embedded in an iframe, without LTI. All 22 OULAD module presentations were loaded as courses in both systems, with 28,785 students and 32,593 enrolments.</a:t>
             </a:r>
           </a:p>
         </p:txBody>
@@ -1590,7 +1591,7 @@
           <a:lstStyle/>
           <a:p>
             <a:r>
-              <a:t>I want to be clear about the limits. No practitioner used the system, so trust, usability and decision quality are untested. Features cover the whole presentation, so this is retrospective classification, not early warning. The study uses one dataset. The planned stability, fidelity, calibration and fairness checks were not completed. The future work follows directly: the three first-tier priorities are early-warning evaluation, calibration and a fairness assessment, and then a practitioner study and other institutions' data.</a:t>
+              <a:t>There are four contributions. First, a working system where prediction and explanation run together, with the explanation layer serving the interface directly, rather than explanation as an offline analysis. Second, role-aware explanation: distinct views derived from each role's responsibilities, with the reasoning documented. Third, a methodological one: applying CommonKADS shows that the design problem here is largely a knowledge problem. Fourth, evidence on where SHAP and LIME agree and differ, at global and local level.</a:t>
             </a:r>
           </a:p>
         </p:txBody>
@@ -1730,7 +1731,7 @@
           <a:lstStyle/>
           <a:p>
             <a:r>
-              <a:t>To close, the answers. RQ1: SHAP and LIME were integrated into a pipeline designed with CommonKADS, with global SHAP cached and LIME on demand; they agree on the main drivers and partly differ for individual students. RQ2: individual, caseload and cohort views were derived from the Agent Model and implemented; they are specified, not yet user-tested. RQ3: the technical preconditions are in place: high recall, reasons traceable to recorded behaviour, and cross-checked methods. Whether practitioners benefit is the next study. Thank you, I welcome your questions.</a:t>
+              <a:t>I want to be clear about the limits. No practitioner used the system, so trust, usability and decision quality are untested. Features cover the whole presentation, so this is retrospective classification, not early warning. The study uses one dataset. The planned stability, fidelity, calibration and fairness checks were not completed. The future work follows directly: the three first-tier priorities are early-warning evaluation, calibration and a fairness assessment, and then a practitioner study and other institutions' data.</a:t>
             </a:r>
           </a:p>
         </p:txBody>
@@ -1756,6 +1757,76 @@
 </file>
 
 <file path=ppt/notesSlides/notesSlide21.xml><?xml version="1.0" encoding="utf-8"?>
+<p:notes xmlns:a="http://schemas.openxmlformats.org/drawingml/2006/main" xmlns:p="http://schemas.openxmlformats.org/presentationml/2006/main" xmlns:r="http://schemas.openxmlformats.org/officeDocument/2006/relationships">
+  <p:cSld>
+    <p:spTree>
+      <p:nvGrpSpPr>
+        <p:cNvPr id="1" name=""/>
+        <p:cNvGrpSpPr/>
+        <p:nvPr/>
+      </p:nvGrpSpPr>
+      <p:grpSpPr>
+        <a:xfrm>
+          <a:off x="0" y="0"/>
+          <a:ext cx="0" cy="0"/>
+          <a:chOff x="0" y="0"/>
+          <a:chExt cx="0" cy="0"/>
+        </a:xfrm>
+      </p:grpSpPr>
+      <p:sp>
+        <p:nvSpPr>
+          <p:cNvPr id="2" name="Slide Image Placeholder 1"/>
+          <p:cNvSpPr>
+            <a:spLocks noGrp="1"/>
+          </p:cNvSpPr>
+          <p:nvPr>
+            <p:ph type="sldImg" idx="2"/>
+          </p:nvPr>
+        </p:nvSpPr>
+        <p:spPr/>
+      </p:sp>
+      <p:sp>
+        <p:nvSpPr>
+          <p:cNvPr id="3" name="Notes Placeholder 2"/>
+          <p:cNvSpPr>
+            <a:spLocks noGrp="1"/>
+          </p:cNvSpPr>
+          <p:nvPr>
+            <p:ph type="body" idx="3" sz="quarter"/>
+          </p:nvPr>
+        </p:nvSpPr>
+        <p:spPr/>
+        <p:txBody>
+          <a:bodyPr/>
+          <a:lstStyle/>
+          <a:p>
+            <a:r>
+              <a:t>To close, the answers. RQ1: SHAP and LIME were integrated into a pipeline designed with CommonKADS, with global SHAP cached and LIME on demand; they agree on the main drivers and partly differ for individual students. RQ2: individual, caseload and cohort views were derived from the Agent Model and implemented; they are specified, not yet user-tested. RQ3: the technical preconditions are in place: high recall, reasons traceable to recorded behaviour, and cross-checked methods. Whether practitioners benefit is the next study. Thank you, I welcome your questions.</a:t>
+            </a:r>
+          </a:p>
+        </p:txBody>
+      </p:sp>
+      <p:sp>
+        <p:nvSpPr>
+          <p:cNvPr id="4" name="Slide Number Placeholder 3"/>
+          <p:cNvSpPr>
+            <a:spLocks noGrp="1"/>
+          </p:cNvSpPr>
+          <p:nvPr>
+            <p:ph type="sldNum" idx="5" sz="quarter"/>
+          </p:nvPr>
+        </p:nvSpPr>
+        <p:spPr/>
+      </p:sp>
+    </p:spTree>
+  </p:cSld>
+  <p:clrMapOvr>
+    <a:masterClrMapping/>
+  </p:clrMapOvr>
+</p:notes>
+</file>
+
+<file path=ppt/notesSlides/notesSlide22.xml><?xml version="1.0" encoding="utf-8"?>
 <p:notes xmlns:a="http://schemas.openxmlformats.org/drawingml/2006/main" xmlns:p="http://schemas.openxmlformats.org/presentationml/2006/main" xmlns:r="http://schemas.openxmlformats.org/officeDocument/2006/relationships">
   <p:cSld>
     <p:spTree>
@@ -14837,7 +14908,7 @@
                 </a:solidFill>
                 <a:latin typeface="Calibri"/>
               </a:rPr>
-              <a:t>Role-Aware Dashboard: Three Views</a:t>
+              <a:t>Role-Aware Views in Moodle</a:t>
             </a:r>
           </a:p>
         </p:txBody>
@@ -14883,7 +14954,7 @@
       </p:sp>
       <p:pic>
         <p:nvPicPr>
-          <p:cNvPr id="4" name="Instructor screenshot" descr="image14.png"/>
+          <p:cNvPr id="4" name="Instructor Moodle screenshot" descr="t_instr.png"/>
           <p:cNvPicPr>
             <a:picLocks noChangeAspect="1"/>
           </p:cNvPicPr>
@@ -14898,7 +14969,7 @@
         <p:spPr>
           <a:xfrm>
             <a:off x="2240280" y="1371600"/>
-            <a:ext cx="2011679" cy="1127977"/>
+            <a:ext cx="2011679" cy="1396999"/>
           </a:xfrm>
           <a:prstGeom prst="rect">
             <a:avLst/>
@@ -14918,8 +14989,8 @@
         </p:nvSpPr>
         <p:spPr>
           <a:xfrm>
-            <a:off x="2240280" y="2743200"/>
-            <a:ext cx="2011679" cy="411480"/>
+            <a:off x="2240280" y="2951479"/>
+            <a:ext cx="2011679" cy="384048"/>
           </a:xfrm>
           <a:prstGeom prst="rect">
             <a:avLst/>
@@ -14957,8 +15028,8 @@
         </p:nvSpPr>
         <p:spPr>
           <a:xfrm>
-            <a:off x="2240280" y="3200400"/>
-            <a:ext cx="1234440" cy="329184"/>
+            <a:off x="2240280" y="3381247"/>
+            <a:ext cx="1234440" cy="310896"/>
           </a:xfrm>
           <a:prstGeom prst="rect">
             <a:avLst/>
@@ -14985,8 +15056,8 @@
         </p:nvSpPr>
         <p:spPr>
           <a:xfrm>
-            <a:off x="2240280" y="3200400"/>
-            <a:ext cx="1234440" cy="329184"/>
+            <a:off x="2240280" y="3381247"/>
+            <a:ext cx="1234440" cy="310896"/>
           </a:xfrm>
           <a:prstGeom prst="rect">
             <a:avLst/>
@@ -15024,8 +15095,8 @@
         </p:nvSpPr>
         <p:spPr>
           <a:xfrm>
-            <a:off x="2240280" y="3657600"/>
-            <a:ext cx="2011679" cy="1828800"/>
+            <a:off x="2240280" y="3792727"/>
+            <a:ext cx="2011679" cy="1600200"/>
           </a:xfrm>
           <a:prstGeom prst="rect">
             <a:avLst/>
@@ -15105,7 +15176,7 @@
       </p:sp>
       <p:pic>
         <p:nvPicPr>
-          <p:cNvPr id="9" name="Advisor screenshot" descr="image9.png"/>
+          <p:cNvPr id="9" name="Advisor Moodle screenshot" descr="t_adv.png"/>
           <p:cNvPicPr>
             <a:picLocks noChangeAspect="1"/>
           </p:cNvPicPr>
@@ -15120,7 +15191,7 @@
         <p:spPr>
           <a:xfrm>
             <a:off x="4389120" y="1371600"/>
-            <a:ext cx="2011679" cy="1092054"/>
+            <a:ext cx="2011679" cy="1396999"/>
           </a:xfrm>
           <a:prstGeom prst="rect">
             <a:avLst/>
@@ -15140,8 +15211,8 @@
         </p:nvSpPr>
         <p:spPr>
           <a:xfrm>
-            <a:off x="4389120" y="2743200"/>
-            <a:ext cx="2011679" cy="411480"/>
+            <a:off x="4389120" y="2951479"/>
+            <a:ext cx="2011679" cy="384048"/>
           </a:xfrm>
           <a:prstGeom prst="rect">
             <a:avLst/>
@@ -15179,8 +15250,8 @@
         </p:nvSpPr>
         <p:spPr>
           <a:xfrm>
-            <a:off x="4389120" y="3200400"/>
-            <a:ext cx="1234440" cy="329184"/>
+            <a:off x="4389120" y="3381247"/>
+            <a:ext cx="1234440" cy="310896"/>
           </a:xfrm>
           <a:prstGeom prst="rect">
             <a:avLst/>
@@ -15207,8 +15278,8 @@
         </p:nvSpPr>
         <p:spPr>
           <a:xfrm>
-            <a:off x="4389120" y="3200400"/>
-            <a:ext cx="1234440" cy="329184"/>
+            <a:off x="4389120" y="3381247"/>
+            <a:ext cx="1234440" cy="310896"/>
           </a:xfrm>
           <a:prstGeom prst="rect">
             <a:avLst/>
@@ -15246,8 +15317,8 @@
         </p:nvSpPr>
         <p:spPr>
           <a:xfrm>
-            <a:off x="4389120" y="3657600"/>
-            <a:ext cx="2011679" cy="1828800"/>
+            <a:off x="4389120" y="3792727"/>
+            <a:ext cx="2011679" cy="1600200"/>
           </a:xfrm>
           <a:prstGeom prst="rect">
             <a:avLst/>
@@ -15327,7 +15398,7 @@
       </p:sp>
       <p:pic>
         <p:nvPicPr>
-          <p:cNvPr id="14" name="Administrator screenshot" descr="image12.png"/>
+          <p:cNvPr id="14" name="Administrator Moodle screenshot" descr="t_admin.png"/>
           <p:cNvPicPr>
             <a:picLocks noChangeAspect="1"/>
           </p:cNvPicPr>
@@ -15342,7 +15413,7 @@
         <p:spPr>
           <a:xfrm>
             <a:off x="6537959" y="1371600"/>
-            <a:ext cx="2011679" cy="1214192"/>
+            <a:ext cx="2011679" cy="1396999"/>
           </a:xfrm>
           <a:prstGeom prst="rect">
             <a:avLst/>
@@ -15362,8 +15433,8 @@
         </p:nvSpPr>
         <p:spPr>
           <a:xfrm>
-            <a:off x="6537959" y="2743200"/>
-            <a:ext cx="2011679" cy="411480"/>
+            <a:off x="6537959" y="2951479"/>
+            <a:ext cx="2011679" cy="384048"/>
           </a:xfrm>
           <a:prstGeom prst="rect">
             <a:avLst/>
@@ -15401,8 +15472,8 @@
         </p:nvSpPr>
         <p:spPr>
           <a:xfrm>
-            <a:off x="6537959" y="3200400"/>
-            <a:ext cx="1234440" cy="329184"/>
+            <a:off x="6537959" y="3381247"/>
+            <a:ext cx="1234440" cy="310896"/>
           </a:xfrm>
           <a:prstGeom prst="rect">
             <a:avLst/>
@@ -15429,8 +15500,8 @@
         </p:nvSpPr>
         <p:spPr>
           <a:xfrm>
-            <a:off x="6537959" y="3200400"/>
-            <a:ext cx="1234440" cy="329184"/>
+            <a:off x="6537959" y="3381247"/>
+            <a:ext cx="1234440" cy="310896"/>
           </a:xfrm>
           <a:prstGeom prst="rect">
             <a:avLst/>
@@ -15468,8 +15539,8 @@
         </p:nvSpPr>
         <p:spPr>
           <a:xfrm>
-            <a:off x="6537959" y="3657600"/>
-            <a:ext cx="2011679" cy="1828800"/>
+            <a:off x="6537959" y="3792727"/>
+            <a:ext cx="2011679" cy="1600200"/>
           </a:xfrm>
           <a:prstGeom prst="rect">
             <a:avLst/>
@@ -15555,8 +15626,8 @@
         </p:nvSpPr>
         <p:spPr>
           <a:xfrm>
-            <a:off x="2240280" y="5486400"/>
-            <a:ext cx="6309359" cy="548640"/>
+            <a:off x="2240280" y="5623560"/>
+            <a:ext cx="6309359" cy="457200"/>
           </a:xfrm>
           <a:prstGeom prst="rect">
             <a:avLst/>
@@ -15583,8 +15654,8 @@
         </p:nvSpPr>
         <p:spPr>
           <a:xfrm>
-            <a:off x="2240280" y="5486400"/>
-            <a:ext cx="6309359" cy="548640"/>
+            <a:off x="2240280" y="5623560"/>
+            <a:ext cx="6309359" cy="457200"/>
           </a:xfrm>
           <a:prstGeom prst="rect">
             <a:avLst/>
@@ -15662,7 +15733,7 @@
                 </a:solidFill>
                 <a:latin typeface="Calibri"/>
               </a:rPr>
-              <a:t>Instructor View in Detail</a:t>
+              <a:t>Instructor View in Moodle</a:t>
             </a:r>
           </a:p>
         </p:txBody>
@@ -15708,7 +15779,7 @@
       </p:sp>
       <p:pic>
         <p:nvPicPr>
-          <p:cNvPr id="4" name="Instructor view screenshot" descr="image14.png"/>
+          <p:cNvPr id="4" name="Moodle instructor screenshot" descr="big_instr.png"/>
           <p:cNvPicPr>
             <a:picLocks noChangeAspect="1"/>
           </p:cNvPicPr>
@@ -15722,8 +15793,8 @@
         </p:blipFill>
         <p:spPr>
           <a:xfrm>
-            <a:off x="2240280" y="1325880"/>
-            <a:ext cx="6309359" cy="3537748"/>
+            <a:off x="2834640" y="1325880"/>
+            <a:ext cx="5120640" cy="3342640"/>
           </a:xfrm>
           <a:prstGeom prst="rect">
             <a:avLst/>
@@ -15743,8 +15814,8 @@
         </p:nvSpPr>
         <p:spPr>
           <a:xfrm>
-            <a:off x="2240280" y="5092228"/>
-            <a:ext cx="329184" cy="329184"/>
+            <a:off x="2240280" y="4869687"/>
+            <a:ext cx="310896" cy="310896"/>
           </a:xfrm>
           <a:prstGeom prst="ellipse">
             <a:avLst/>
@@ -15782,8 +15853,8 @@
         </p:nvSpPr>
         <p:spPr>
           <a:xfrm>
-            <a:off x="2697480" y="5073940"/>
-            <a:ext cx="5852159" cy="384048"/>
+            <a:off x="2679192" y="4842255"/>
+            <a:ext cx="5870448" cy="365760"/>
           </a:xfrm>
           <a:prstGeom prst="rect">
             <a:avLst/>
@@ -15802,13 +15873,13 @@
               </a:spcAft>
             </a:pPr>
             <a:r>
-              <a:rPr sz="1500" b="0" i="0">
+              <a:rPr sz="1400" b="0" i="0">
                 <a:solidFill>
                   <a:srgbClr val="22222A"/>
                 </a:solidFill>
                 <a:latin typeface="Calibri"/>
               </a:rPr>
-              <a:t>Students ranked by predicted risk in the selected course</a:t>
+              <a:t>Students in the Moodle course ranked by predicted risk</a:t>
             </a:r>
           </a:p>
         </p:txBody>
@@ -15821,8 +15892,8 @@
         </p:nvSpPr>
         <p:spPr>
           <a:xfrm>
-            <a:off x="2240280" y="5531140"/>
-            <a:ext cx="329184" cy="329184"/>
+            <a:off x="2240280" y="5272024"/>
+            <a:ext cx="310896" cy="310896"/>
           </a:xfrm>
           <a:prstGeom prst="ellipse">
             <a:avLst/>
@@ -15860,8 +15931,8 @@
         </p:nvSpPr>
         <p:spPr>
           <a:xfrm>
-            <a:off x="2697480" y="5512852"/>
-            <a:ext cx="5852159" cy="384048"/>
+            <a:off x="2679192" y="5244592"/>
+            <a:ext cx="5870448" cy="365760"/>
           </a:xfrm>
           <a:prstGeom prst="rect">
             <a:avLst/>
@@ -15880,13 +15951,13 @@
               </a:spcAft>
             </a:pPr>
             <a:r>
-              <a:rPr sz="1500" b="0" i="0">
+              <a:rPr sz="1400" b="0" i="0">
                 <a:solidFill>
                   <a:srgbClr val="22222A"/>
                 </a:solidFill>
                 <a:latin typeface="Calibri"/>
               </a:rPr>
-              <a:t>SHAP and LIME top 5 side by side, with direction of effect</a:t>
+              <a:t>SHAP and LIME top 5 for the selected student, with direction of effect</a:t>
             </a:r>
           </a:p>
         </p:txBody>
@@ -15899,8 +15970,8 @@
         </p:nvSpPr>
         <p:spPr>
           <a:xfrm>
-            <a:off x="2240280" y="5970052"/>
-            <a:ext cx="329184" cy="329184"/>
+            <a:off x="2240280" y="5674359"/>
+            <a:ext cx="310896" cy="310896"/>
           </a:xfrm>
           <a:prstGeom prst="ellipse">
             <a:avLst/>
@@ -15938,8 +16009,8 @@
         </p:nvSpPr>
         <p:spPr>
           <a:xfrm>
-            <a:off x="2697480" y="5951764"/>
-            <a:ext cx="5852159" cy="384048"/>
+            <a:off x="2679192" y="5646927"/>
+            <a:ext cx="5870448" cy="365760"/>
           </a:xfrm>
           <a:prstGeom prst="rect">
             <a:avLst/>
@@ -15958,7 +16029,7 @@
               </a:spcAft>
             </a:pPr>
             <a:r>
-              <a:rPr sz="1500" b="0" i="0">
+              <a:rPr sz="1400" b="0" i="0">
                 <a:solidFill>
                   <a:srgbClr val="22222A"/>
                 </a:solidFill>
@@ -16115,7 +16186,7 @@
                 </a:solidFill>
                 <a:latin typeface="Calibri"/>
               </a:rPr>
-              <a:t>Contributions</a:t>
+              <a:t>Running Inside Moodle and Canvas</a:t>
             </a:r>
           </a:p>
         </p:txBody>
@@ -16161,20 +16232,234 @@
       </p:sp>
       <p:sp>
         <p:nvSpPr>
-          <p:cNvPr id="4" name="Number 1"/>
+          <p:cNvPr id="4" name="Moodle 5.2 label"/>
+          <p:cNvSpPr txBox="1"/>
+          <p:nvPr/>
+        </p:nvSpPr>
+        <p:spPr>
+          <a:xfrm>
+            <a:off x="2240280" y="1344168"/>
+            <a:ext cx="3040379" cy="365760"/>
+          </a:xfrm>
+          <a:prstGeom prst="rect">
+            <a:avLst/>
+          </a:prstGeom>
+          <a:noFill/>
+        </p:spPr>
+        <p:txBody>
+          <a:bodyPr wrap="square" anchor="t" lIns="0" rIns="0" tIns="0" bIns="0">
+            <a:spAutoFit/>
+          </a:bodyPr>
+          <a:lstStyle/>
+          <a:p>
+            <a:pPr algn="l">
+              <a:spcAft>
+                <a:spcPts val="600"/>
+              </a:spcAft>
+            </a:pPr>
+            <a:r>
+              <a:rPr sz="1800" b="1" i="0">
+                <a:solidFill>
+                  <a:srgbClr val="343174"/>
+                </a:solidFill>
+                <a:latin typeface="Calibri"/>
+              </a:rPr>
+              <a:t>Moodle 5.2</a:t>
+            </a:r>
+          </a:p>
+        </p:txBody>
+      </p:sp>
+      <p:pic>
+        <p:nvPicPr>
+          <p:cNvPr id="5" name="Moodle 5.2 screenshot" descr="moodle_nav.png"/>
+          <p:cNvPicPr>
+            <a:picLocks noChangeAspect="1"/>
+          </p:cNvPicPr>
+          <p:nvPr/>
+        </p:nvPicPr>
+        <p:blipFill>
+          <a:blip r:embed="rId3"/>
+          <a:stretch>
+            <a:fillRect/>
+          </a:stretch>
+        </p:blipFill>
+        <p:spPr>
+          <a:xfrm>
+            <a:off x="2240280" y="1783080"/>
+            <a:ext cx="3040379" cy="2111374"/>
+          </a:xfrm>
+          <a:prstGeom prst="rect">
+            <a:avLst/>
+          </a:prstGeom>
+          <a:ln w="9525">
+            <a:solidFill>
+              <a:srgbClr val="C9CAD3"/>
+            </a:solidFill>
+          </a:ln>
+        </p:spPr>
+      </p:pic>
+      <p:sp>
+        <p:nvSpPr>
+          <p:cNvPr id="6" name="Moodle 5.2 caption"/>
+          <p:cNvSpPr txBox="1"/>
+          <p:nvPr/>
+        </p:nvSpPr>
+        <p:spPr>
+          <a:xfrm>
+            <a:off x="2240280" y="4031614"/>
+            <a:ext cx="3040379" cy="914400"/>
+          </a:xfrm>
+          <a:prstGeom prst="rect">
+            <a:avLst/>
+          </a:prstGeom>
+          <a:noFill/>
+        </p:spPr>
+        <p:txBody>
+          <a:bodyPr wrap="square" anchor="t" lIns="0" rIns="0" tIns="0" bIns="0">
+            <a:spAutoFit/>
+          </a:bodyPr>
+          <a:lstStyle/>
+          <a:p>
+            <a:pPr algn="l">
+              <a:spcAft>
+                <a:spcPts val="600"/>
+              </a:spcAft>
+            </a:pPr>
+            <a:r>
+              <a:rPr sz="1400" b="0" i="0">
+                <a:solidFill>
+                  <a:srgbClr val="22222A"/>
+                </a:solidFill>
+                <a:latin typeface="Calibri"/>
+              </a:rPr>
+              <a:t>Native plugin: At-risk insights in each course's menu, using Moodle login, roles and enrolments</a:t>
+            </a:r>
+          </a:p>
+        </p:txBody>
+      </p:sp>
+      <p:sp>
+        <p:nvSpPr>
+          <p:cNvPr id="7" name="Canvas label"/>
+          <p:cNvSpPr txBox="1"/>
+          <p:nvPr/>
+        </p:nvSpPr>
+        <p:spPr>
+          <a:xfrm>
+            <a:off x="5509260" y="1344168"/>
+            <a:ext cx="3040379" cy="365760"/>
+          </a:xfrm>
+          <a:prstGeom prst="rect">
+            <a:avLst/>
+          </a:prstGeom>
+          <a:noFill/>
+        </p:spPr>
+        <p:txBody>
+          <a:bodyPr wrap="square" anchor="t" lIns="0" rIns="0" tIns="0" bIns="0">
+            <a:spAutoFit/>
+          </a:bodyPr>
+          <a:lstStyle/>
+          <a:p>
+            <a:pPr algn="l">
+              <a:spcAft>
+                <a:spcPts val="600"/>
+              </a:spcAft>
+            </a:pPr>
+            <a:r>
+              <a:rPr sz="1800" b="1" i="0">
+                <a:solidFill>
+                  <a:srgbClr val="343174"/>
+                </a:solidFill>
+                <a:latin typeface="Calibri"/>
+              </a:rPr>
+              <a:t>Canvas</a:t>
+            </a:r>
+          </a:p>
+        </p:txBody>
+      </p:sp>
+      <p:pic>
+        <p:nvPicPr>
+          <p:cNvPr id="8" name="Canvas screenshot" descr="canvas_embed.png"/>
+          <p:cNvPicPr>
+            <a:picLocks noChangeAspect="1"/>
+          </p:cNvPicPr>
+          <p:nvPr/>
+        </p:nvPicPr>
+        <p:blipFill>
+          <a:blip r:embed="rId4"/>
+          <a:stretch>
+            <a:fillRect/>
+          </a:stretch>
+        </p:blipFill>
+        <p:spPr>
+          <a:xfrm>
+            <a:off x="5509260" y="1783080"/>
+            <a:ext cx="3040379" cy="2111374"/>
+          </a:xfrm>
+          <a:prstGeom prst="rect">
+            <a:avLst/>
+          </a:prstGeom>
+          <a:ln w="9525">
+            <a:solidFill>
+              <a:srgbClr val="C9CAD3"/>
+            </a:solidFill>
+          </a:ln>
+        </p:spPr>
+      </p:pic>
+      <p:sp>
+        <p:nvSpPr>
+          <p:cNvPr id="9" name="Canvas caption"/>
+          <p:cNvSpPr txBox="1"/>
+          <p:nvPr/>
+        </p:nvSpPr>
+        <p:spPr>
+          <a:xfrm>
+            <a:off x="5509260" y="4031614"/>
+            <a:ext cx="3040379" cy="914400"/>
+          </a:xfrm>
+          <a:prstGeom prst="rect">
+            <a:avLst/>
+          </a:prstGeom>
+          <a:noFill/>
+        </p:spPr>
+        <p:txBody>
+          <a:bodyPr wrap="square" anchor="t" lIns="0" rIns="0" tIns="0" bIns="0">
+            <a:spAutoFit/>
+          </a:bodyPr>
+          <a:lstStyle/>
+          <a:p>
+            <a:pPr algn="l">
+              <a:spcAft>
+                <a:spcPts val="600"/>
+              </a:spcAft>
+            </a:pPr>
+            <a:r>
+              <a:rPr sz="1400" b="0" i="0">
+                <a:solidFill>
+                  <a:srgbClr val="22222A"/>
+                </a:solidFill>
+                <a:latin typeface="Calibri"/>
+              </a:rPr>
+              <a:t>Dashboard embedded in the course through an External URL module item</a:t>
+            </a:r>
+          </a:p>
+        </p:txBody>
+      </p:sp>
+      <p:sp>
+        <p:nvSpPr>
+          <p:cNvPr id="10" name="LMS facts band"/>
           <p:cNvSpPr/>
           <p:nvPr/>
         </p:nvSpPr>
         <p:spPr>
           <a:xfrm>
-            <a:off x="2240280" y="1417320"/>
-            <a:ext cx="457200" cy="457200"/>
-          </a:xfrm>
-          <a:prstGeom prst="ellipse">
+            <a:off x="2240280" y="5120640"/>
+            <a:ext cx="6309359" cy="868680"/>
+          </a:xfrm>
+          <a:prstGeom prst="rect">
             <a:avLst/>
           </a:prstGeom>
           <a:solidFill>
-            <a:srgbClr val="343174"/>
+            <a:srgbClr val="F2F2F5"/>
           </a:solidFill>
           <a:ln>
             <a:noFill/>
@@ -16182,32 +16467,21 @@
           <a:effectLst/>
         </p:spPr>
         <p:txBody>
-          <a:bodyPr rtlCol="0" anchor="ctr" lIns="0" rIns="0" tIns="0" bIns="0"/>
-          <a:lstStyle/>
-          <a:p>
-            <a:pPr algn="ctr"/>
-            <a:r>
-              <a:rPr sz="1500" b="1" i="0">
-                <a:solidFill>
-                  <a:srgbClr val="FFFFFF"/>
-                </a:solidFill>
-                <a:latin typeface="Calibri"/>
-              </a:rPr>
-              <a:t>1</a:t>
-            </a:r>
-          </a:p>
-        </p:txBody>
-      </p:sp>
-      <p:sp>
-        <p:nvSpPr>
-          <p:cNvPr id="5" name="Item 1"/>
+          <a:bodyPr rtlCol="0" anchor="ctr"/>
+          <a:lstStyle/>
+          <a:p/>
+        </p:txBody>
+      </p:sp>
+      <p:sp>
+        <p:nvSpPr>
+          <p:cNvPr id="11" name="LMS facts"/>
           <p:cNvSpPr txBox="1"/>
           <p:nvPr/>
         </p:nvSpPr>
         <p:spPr>
           <a:xfrm>
-            <a:off x="2880360" y="1399032"/>
-            <a:ext cx="5669279" cy="1097280"/>
+            <a:off x="2423160" y="5120640"/>
+            <a:ext cx="5943599" cy="868680"/>
           </a:xfrm>
           <a:prstGeom prst="rect">
             <a:avLst/>
@@ -16215,322 +16489,33 @@
           <a:noFill/>
         </p:spPr>
         <p:txBody>
-          <a:bodyPr wrap="square" anchor="t" lIns="0" rIns="0" tIns="0" bIns="0">
+          <a:bodyPr wrap="square" anchor="ctr" lIns="0" rIns="0" tIns="0" bIns="0">
             <a:spAutoFit/>
           </a:bodyPr>
           <a:lstStyle/>
           <a:p>
             <a:pPr algn="l">
               <a:spcAft>
-                <a:spcPts val="200"/>
-              </a:spcAft>
-            </a:pPr>
-            <a:r>
-              <a:rPr sz="1800" b="1" i="0">
+                <a:spcPts val="600"/>
+              </a:spcAft>
+            </a:pPr>
+            <a:r>
+              <a:rPr sz="1500" b="1" i="0">
+                <a:solidFill>
+                  <a:srgbClr val="343174"/>
+                </a:solidFill>
+                <a:latin typeface="Calibri"/>
+              </a:rPr>
+              <a:t>All 22 module presentations loaded as courses in both LMSs: </a:t>
+            </a:r>
+            <a:r>
+              <a:rPr sz="1500" b="0" i="0">
                 <a:solidFill>
                   <a:srgbClr val="22222A"/>
                 </a:solidFill>
                 <a:latin typeface="Calibri"/>
               </a:rPr>
-              <a:t>Prediction and explanation in one running system</a:t>
-            </a:r>
-          </a:p>
-          <a:p>
-            <a:pPr algn="l">
-              <a:spcAft>
-                <a:spcPts val="200"/>
-              </a:spcAft>
-            </a:pPr>
-            <a:r>
-              <a:rPr sz="1500" b="0" i="0">
-                <a:solidFill>
-                  <a:srgbClr val="555560"/>
-                </a:solidFill>
-                <a:latin typeface="Calibri"/>
-              </a:rPr>
-              <a:t>The explanation layer serves the interface directly, not as an offline analysis.</a:t>
-            </a:r>
-          </a:p>
-        </p:txBody>
-      </p:sp>
-      <p:sp>
-        <p:nvSpPr>
-          <p:cNvPr id="6" name="Number 2"/>
-          <p:cNvSpPr/>
-          <p:nvPr/>
-        </p:nvSpPr>
-        <p:spPr>
-          <a:xfrm>
-            <a:off x="2240280" y="2560320"/>
-            <a:ext cx="457200" cy="457200"/>
-          </a:xfrm>
-          <a:prstGeom prst="ellipse">
-            <a:avLst/>
-          </a:prstGeom>
-          <a:solidFill>
-            <a:srgbClr val="343174"/>
-          </a:solidFill>
-          <a:ln>
-            <a:noFill/>
-          </a:ln>
-          <a:effectLst/>
-        </p:spPr>
-        <p:txBody>
-          <a:bodyPr rtlCol="0" anchor="ctr" lIns="0" rIns="0" tIns="0" bIns="0"/>
-          <a:lstStyle/>
-          <a:p>
-            <a:pPr algn="ctr"/>
-            <a:r>
-              <a:rPr sz="1500" b="1" i="0">
-                <a:solidFill>
-                  <a:srgbClr val="FFFFFF"/>
-                </a:solidFill>
-                <a:latin typeface="Calibri"/>
-              </a:rPr>
-              <a:t>2</a:t>
-            </a:r>
-          </a:p>
-        </p:txBody>
-      </p:sp>
-      <p:sp>
-        <p:nvSpPr>
-          <p:cNvPr id="7" name="Item 2"/>
-          <p:cNvSpPr txBox="1"/>
-          <p:nvPr/>
-        </p:nvSpPr>
-        <p:spPr>
-          <a:xfrm>
-            <a:off x="2880360" y="2542032"/>
-            <a:ext cx="5669279" cy="1097280"/>
-          </a:xfrm>
-          <a:prstGeom prst="rect">
-            <a:avLst/>
-          </a:prstGeom>
-          <a:noFill/>
-        </p:spPr>
-        <p:txBody>
-          <a:bodyPr wrap="square" anchor="t" lIns="0" rIns="0" tIns="0" bIns="0">
-            <a:spAutoFit/>
-          </a:bodyPr>
-          <a:lstStyle/>
-          <a:p>
-            <a:pPr algn="l">
-              <a:spcAft>
-                <a:spcPts val="200"/>
-              </a:spcAft>
-            </a:pPr>
-            <a:r>
-              <a:rPr sz="1800" b="1" i="0">
-                <a:solidFill>
-                  <a:srgbClr val="22222A"/>
-                </a:solidFill>
-                <a:latin typeface="Calibri"/>
-              </a:rPr>
-              <a:t>Role-aware treatment of explanation</a:t>
-            </a:r>
-          </a:p>
-          <a:p>
-            <a:pPr algn="l">
-              <a:spcAft>
-                <a:spcPts val="200"/>
-              </a:spcAft>
-            </a:pPr>
-            <a:r>
-              <a:rPr sz="1500" b="0" i="0">
-                <a:solidFill>
-                  <a:srgbClr val="555560"/>
-                </a:solidFill>
-                <a:latin typeface="Calibri"/>
-              </a:rPr>
-              <a:t>Distinct views derived from each role's responsibilities and questions.</a:t>
-            </a:r>
-          </a:p>
-        </p:txBody>
-      </p:sp>
-      <p:sp>
-        <p:nvSpPr>
-          <p:cNvPr id="8" name="Number 3"/>
-          <p:cNvSpPr/>
-          <p:nvPr/>
-        </p:nvSpPr>
-        <p:spPr>
-          <a:xfrm>
-            <a:off x="2240280" y="3703320"/>
-            <a:ext cx="457200" cy="457200"/>
-          </a:xfrm>
-          <a:prstGeom prst="ellipse">
-            <a:avLst/>
-          </a:prstGeom>
-          <a:solidFill>
-            <a:srgbClr val="343174"/>
-          </a:solidFill>
-          <a:ln>
-            <a:noFill/>
-          </a:ln>
-          <a:effectLst/>
-        </p:spPr>
-        <p:txBody>
-          <a:bodyPr rtlCol="0" anchor="ctr" lIns="0" rIns="0" tIns="0" bIns="0"/>
-          <a:lstStyle/>
-          <a:p>
-            <a:pPr algn="ctr"/>
-            <a:r>
-              <a:rPr sz="1500" b="1" i="0">
-                <a:solidFill>
-                  <a:srgbClr val="FFFFFF"/>
-                </a:solidFill>
-                <a:latin typeface="Calibri"/>
-              </a:rPr>
-              <a:t>3</a:t>
-            </a:r>
-          </a:p>
-        </p:txBody>
-      </p:sp>
-      <p:sp>
-        <p:nvSpPr>
-          <p:cNvPr id="9" name="Item 3"/>
-          <p:cNvSpPr txBox="1"/>
-          <p:nvPr/>
-        </p:nvSpPr>
-        <p:spPr>
-          <a:xfrm>
-            <a:off x="2880360" y="3685032"/>
-            <a:ext cx="5669279" cy="1097280"/>
-          </a:xfrm>
-          <a:prstGeom prst="rect">
-            <a:avLst/>
-          </a:prstGeom>
-          <a:noFill/>
-        </p:spPr>
-        <p:txBody>
-          <a:bodyPr wrap="square" anchor="t" lIns="0" rIns="0" tIns="0" bIns="0">
-            <a:spAutoFit/>
-          </a:bodyPr>
-          <a:lstStyle/>
-          <a:p>
-            <a:pPr algn="l">
-              <a:spcAft>
-                <a:spcPts val="200"/>
-              </a:spcAft>
-            </a:pPr>
-            <a:r>
-              <a:rPr sz="1800" b="1" i="0">
-                <a:solidFill>
-                  <a:srgbClr val="22222A"/>
-                </a:solidFill>
-                <a:latin typeface="Calibri"/>
-              </a:rPr>
-              <a:t>CommonKADS applied to explainable learning analytics</a:t>
-            </a:r>
-          </a:p>
-          <a:p>
-            <a:pPr algn="l">
-              <a:spcAft>
-                <a:spcPts val="200"/>
-              </a:spcAft>
-            </a:pPr>
-            <a:r>
-              <a:rPr sz="1500" b="0" i="0">
-                <a:solidFill>
-                  <a:srgbClr val="555560"/>
-                </a:solidFill>
-                <a:latin typeface="Calibri"/>
-              </a:rPr>
-              <a:t>Shows the design problem is largely a knowledge problem.</a:t>
-            </a:r>
-          </a:p>
-        </p:txBody>
-      </p:sp>
-      <p:sp>
-        <p:nvSpPr>
-          <p:cNvPr id="10" name="Number 4"/>
-          <p:cNvSpPr/>
-          <p:nvPr/>
-        </p:nvSpPr>
-        <p:spPr>
-          <a:xfrm>
-            <a:off x="2240280" y="4846320"/>
-            <a:ext cx="457200" cy="457200"/>
-          </a:xfrm>
-          <a:prstGeom prst="ellipse">
-            <a:avLst/>
-          </a:prstGeom>
-          <a:solidFill>
-            <a:srgbClr val="343174"/>
-          </a:solidFill>
-          <a:ln>
-            <a:noFill/>
-          </a:ln>
-          <a:effectLst/>
-        </p:spPr>
-        <p:txBody>
-          <a:bodyPr rtlCol="0" anchor="ctr" lIns="0" rIns="0" tIns="0" bIns="0"/>
-          <a:lstStyle/>
-          <a:p>
-            <a:pPr algn="ctr"/>
-            <a:r>
-              <a:rPr sz="1500" b="1" i="0">
-                <a:solidFill>
-                  <a:srgbClr val="FFFFFF"/>
-                </a:solidFill>
-                <a:latin typeface="Calibri"/>
-              </a:rPr>
-              <a:t>4</a:t>
-            </a:r>
-          </a:p>
-        </p:txBody>
-      </p:sp>
-      <p:sp>
-        <p:nvSpPr>
-          <p:cNvPr id="11" name="Item 4"/>
-          <p:cNvSpPr txBox="1"/>
-          <p:nvPr/>
-        </p:nvSpPr>
-        <p:spPr>
-          <a:xfrm>
-            <a:off x="2880360" y="4828032"/>
-            <a:ext cx="5669279" cy="1097280"/>
-          </a:xfrm>
-          <a:prstGeom prst="rect">
-            <a:avLst/>
-          </a:prstGeom>
-          <a:noFill/>
-        </p:spPr>
-        <p:txBody>
-          <a:bodyPr wrap="square" anchor="t" lIns="0" rIns="0" tIns="0" bIns="0">
-            <a:spAutoFit/>
-          </a:bodyPr>
-          <a:lstStyle/>
-          <a:p>
-            <a:pPr algn="l">
-              <a:spcAft>
-                <a:spcPts val="200"/>
-              </a:spcAft>
-            </a:pPr>
-            <a:r>
-              <a:rPr sz="1800" b="1" i="0">
-                <a:solidFill>
-                  <a:srgbClr val="22222A"/>
-                </a:solidFill>
-                <a:latin typeface="Calibri"/>
-              </a:rPr>
-              <a:t>Evidence on SHAP and LIME agreement</a:t>
-            </a:r>
-          </a:p>
-          <a:p>
-            <a:pPr algn="l">
-              <a:spcAft>
-                <a:spcPts val="200"/>
-              </a:spcAft>
-            </a:pPr>
-            <a:r>
-              <a:rPr sz="1500" b="0" i="0">
-                <a:solidFill>
-                  <a:srgbClr val="555560"/>
-                </a:solidFill>
-                <a:latin typeface="Calibri"/>
-              </a:rPr>
-              <a:t>Where the methods converge and differ, at global and local level.</a:t>
+              <a:t>28,785 students and 32,593 enrolments, all running locally under Docker Compose.</a:t>
             </a:r>
           </a:p>
         </p:txBody>
@@ -16583,7 +16568,7 @@
                 </a:solidFill>
                 <a:latin typeface="Calibri"/>
               </a:rPr>
-              <a:t>Limitations and Future Work</a:t>
+              <a:t>Contributions</a:t>
             </a:r>
           </a:p>
         </p:txBody>
@@ -16629,20 +16614,20 @@
       </p:sp>
       <p:sp>
         <p:nvSpPr>
-          <p:cNvPr id="4" name="Limitations card"/>
+          <p:cNvPr id="4" name="Number 1"/>
           <p:cNvSpPr/>
           <p:nvPr/>
         </p:nvSpPr>
         <p:spPr>
           <a:xfrm>
-            <a:off x="2240280" y="1371600"/>
-            <a:ext cx="3040379" cy="4572000"/>
-          </a:xfrm>
-          <a:prstGeom prst="rect">
+            <a:off x="2240280" y="1417320"/>
+            <a:ext cx="457200" cy="457200"/>
+          </a:xfrm>
+          <a:prstGeom prst="ellipse">
             <a:avLst/>
           </a:prstGeom>
           <a:solidFill>
-            <a:srgbClr val="F2F2F5"/>
+            <a:srgbClr val="343174"/>
           </a:solidFill>
           <a:ln>
             <a:noFill/>
@@ -16650,21 +16635,32 @@
           <a:effectLst/>
         </p:spPr>
         <p:txBody>
-          <a:bodyPr rtlCol="0" anchor="ctr"/>
-          <a:lstStyle/>
-          <a:p/>
-        </p:txBody>
-      </p:sp>
-      <p:sp>
-        <p:nvSpPr>
-          <p:cNvPr id="5" name="Limitations text"/>
+          <a:bodyPr rtlCol="0" anchor="ctr" lIns="0" rIns="0" tIns="0" bIns="0"/>
+          <a:lstStyle/>
+          <a:p>
+            <a:pPr algn="ctr"/>
+            <a:r>
+              <a:rPr sz="1500" b="1" i="0">
+                <a:solidFill>
+                  <a:srgbClr val="FFFFFF"/>
+                </a:solidFill>
+                <a:latin typeface="Calibri"/>
+              </a:rPr>
+              <a:t>1</a:t>
+            </a:r>
+          </a:p>
+        </p:txBody>
+      </p:sp>
+      <p:sp>
+        <p:nvSpPr>
+          <p:cNvPr id="5" name="Item 1"/>
           <p:cNvSpPr txBox="1"/>
           <p:nvPr/>
         </p:nvSpPr>
         <p:spPr>
           <a:xfrm>
-            <a:off x="2423160" y="1554480"/>
-            <a:ext cx="2674620" cy="4297680"/>
+            <a:off x="2880360" y="1399032"/>
+            <a:ext cx="5669279" cy="1097280"/>
           </a:xfrm>
           <a:prstGeom prst="rect">
             <a:avLst/>
@@ -16679,121 +16675,53 @@
           <a:p>
             <a:pPr algn="l">
               <a:spcAft>
-                <a:spcPts val="1400"/>
-              </a:spcAft>
-            </a:pPr>
-            <a:r>
-              <a:rPr sz="2000" b="1" i="0">
-                <a:solidFill>
-                  <a:srgbClr val="343174"/>
-                </a:solidFill>
-                <a:latin typeface="Calibri"/>
-              </a:rPr>
-              <a:t>Limitations</a:t>
-            </a:r>
-          </a:p>
-          <a:p>
-            <a:pPr algn="l" marL="201168" indent="-201168">
-              <a:spcAft>
-                <a:spcPts val="1400"/>
-              </a:spcAft>
-              <a:buClr>
-                <a:srgbClr val="343174"/>
-              </a:buClr>
-              <a:buFont typeface="Arial"/>
-              <a:buChar char="•"/>
-            </a:pPr>
-            <a:r>
-              <a:rPr sz="1700" b="0" i="0">
+                <a:spcPts val="200"/>
+              </a:spcAft>
+            </a:pPr>
+            <a:r>
+              <a:rPr sz="1800" b="1" i="0">
                 <a:solidFill>
                   <a:srgbClr val="22222A"/>
                 </a:solidFill>
                 <a:latin typeface="Calibri"/>
               </a:rPr>
-              <a:t>No practitioner data: trust, usability and decision quality untested</a:t>
-            </a:r>
-          </a:p>
-          <a:p>
-            <a:pPr algn="l" marL="201168" indent="-201168">
-              <a:spcAft>
-                <a:spcPts val="1400"/>
-              </a:spcAft>
-              <a:buClr>
-                <a:srgbClr val="343174"/>
-              </a:buClr>
-              <a:buFont typeface="Arial"/>
-              <a:buChar char="•"/>
-            </a:pPr>
-            <a:r>
-              <a:rPr sz="1700" b="0" i="0">
-                <a:solidFill>
-                  <a:srgbClr val="22222A"/>
-                </a:solidFill>
-                <a:latin typeface="Calibri"/>
-              </a:rPr>
-              <a:t>Retrospective features: no early-warning point evaluated</a:t>
-            </a:r>
-          </a:p>
-          <a:p>
-            <a:pPr algn="l" marL="201168" indent="-201168">
-              <a:spcAft>
-                <a:spcPts val="1400"/>
-              </a:spcAft>
-              <a:buClr>
-                <a:srgbClr val="343174"/>
-              </a:buClr>
-              <a:buFont typeface="Arial"/>
-              <a:buChar char="•"/>
-            </a:pPr>
-            <a:r>
-              <a:rPr sz="1700" b="0" i="0">
-                <a:solidFill>
-                  <a:srgbClr val="22222A"/>
-                </a:solidFill>
-                <a:latin typeface="Calibri"/>
-              </a:rPr>
-              <a:t>One dataset (OULAD) and context</a:t>
-            </a:r>
-          </a:p>
-          <a:p>
-            <a:pPr algn="l" marL="201168" indent="-201168">
-              <a:spcAft>
-                <a:spcPts val="1400"/>
-              </a:spcAft>
-              <a:buClr>
-                <a:srgbClr val="343174"/>
-              </a:buClr>
-              <a:buFont typeface="Arial"/>
-              <a:buChar char="•"/>
-            </a:pPr>
-            <a:r>
-              <a:rPr sz="1700" b="0" i="0">
-                <a:solidFill>
-                  <a:srgbClr val="22222A"/>
-                </a:solidFill>
-                <a:latin typeface="Calibri"/>
-              </a:rPr>
-              <a:t>Stability, fidelity, calibration and fairness checks not completed</a:t>
-            </a:r>
-          </a:p>
-        </p:txBody>
-      </p:sp>
-      <p:sp>
-        <p:nvSpPr>
-          <p:cNvPr id="6" name="Future work card"/>
+              <a:t>Prediction and explanation in one running system</a:t>
+            </a:r>
+          </a:p>
+          <a:p>
+            <a:pPr algn="l">
+              <a:spcAft>
+                <a:spcPts val="200"/>
+              </a:spcAft>
+            </a:pPr>
+            <a:r>
+              <a:rPr sz="1500" b="0" i="0">
+                <a:solidFill>
+                  <a:srgbClr val="555560"/>
+                </a:solidFill>
+                <a:latin typeface="Calibri"/>
+              </a:rPr>
+              <a:t>The explanation layer serves the interface directly, not as an offline analysis.</a:t>
+            </a:r>
+          </a:p>
+        </p:txBody>
+      </p:sp>
+      <p:sp>
+        <p:nvSpPr>
+          <p:cNvPr id="6" name="Number 2"/>
           <p:cNvSpPr/>
           <p:nvPr/>
         </p:nvSpPr>
         <p:spPr>
           <a:xfrm>
-            <a:off x="5509260" y="1371600"/>
-            <a:ext cx="3040379" cy="4572000"/>
-          </a:xfrm>
-          <a:prstGeom prst="rect">
+            <a:off x="2240280" y="2560320"/>
+            <a:ext cx="457200" cy="457200"/>
+          </a:xfrm>
+          <a:prstGeom prst="ellipse">
             <a:avLst/>
           </a:prstGeom>
           <a:solidFill>
-            <a:srgbClr val="F2F2F5"/>
+            <a:srgbClr val="343174"/>
           </a:solidFill>
           <a:ln>
             <a:noFill/>
@@ -16801,21 +16729,32 @@
           <a:effectLst/>
         </p:spPr>
         <p:txBody>
-          <a:bodyPr rtlCol="0" anchor="ctr"/>
-          <a:lstStyle/>
-          <a:p/>
-        </p:txBody>
-      </p:sp>
-      <p:sp>
-        <p:nvSpPr>
-          <p:cNvPr id="7" name="Future work text"/>
+          <a:bodyPr rtlCol="0" anchor="ctr" lIns="0" rIns="0" tIns="0" bIns="0"/>
+          <a:lstStyle/>
+          <a:p>
+            <a:pPr algn="ctr"/>
+            <a:r>
+              <a:rPr sz="1500" b="1" i="0">
+                <a:solidFill>
+                  <a:srgbClr val="FFFFFF"/>
+                </a:solidFill>
+                <a:latin typeface="Calibri"/>
+              </a:rPr>
+              <a:t>2</a:t>
+            </a:r>
+          </a:p>
+        </p:txBody>
+      </p:sp>
+      <p:sp>
+        <p:nvSpPr>
+          <p:cNvPr id="7" name="Item 2"/>
           <p:cNvSpPr txBox="1"/>
           <p:nvPr/>
         </p:nvSpPr>
         <p:spPr>
           <a:xfrm>
-            <a:off x="5692140" y="1554480"/>
-            <a:ext cx="2674620" cy="4297680"/>
+            <a:off x="2880360" y="2542032"/>
+            <a:ext cx="5669279" cy="1097280"/>
           </a:xfrm>
           <a:prstGeom prst="rect">
             <a:avLst/>
@@ -16830,122 +16769,221 @@
           <a:p>
             <a:pPr algn="l">
               <a:spcAft>
-                <a:spcPts val="1400"/>
-              </a:spcAft>
-            </a:pPr>
-            <a:r>
-              <a:rPr sz="2000" b="1" i="0">
-                <a:solidFill>
-                  <a:srgbClr val="343174"/>
-                </a:solidFill>
-                <a:latin typeface="Calibri"/>
-              </a:rPr>
-              <a:t>Future work</a:t>
-            </a:r>
-          </a:p>
-          <a:p>
-            <a:pPr algn="l" marL="201168" indent="-201168">
-              <a:spcAft>
-                <a:spcPts val="1400"/>
-              </a:spcAft>
-              <a:buClr>
-                <a:srgbClr val="343174"/>
-              </a:buClr>
-              <a:buFont typeface="Arial"/>
-              <a:buChar char="•"/>
-            </a:pPr>
-            <a:r>
-              <a:rPr sz="1700" b="0" i="0">
+                <a:spcPts val="200"/>
+              </a:spcAft>
+            </a:pPr>
+            <a:r>
+              <a:rPr sz="1800" b="1" i="0">
                 <a:solidFill>
                   <a:srgbClr val="22222A"/>
                 </a:solidFill>
                 <a:latin typeface="Calibri"/>
               </a:rPr>
-              <a:t>Early-warning evaluation at weeks 2, 4, 6 and 8</a:t>
-            </a:r>
-          </a:p>
-          <a:p>
-            <a:pPr algn="l" marL="201168" indent="-201168">
-              <a:spcAft>
-                <a:spcPts val="1400"/>
-              </a:spcAft>
-              <a:buClr>
-                <a:srgbClr val="343174"/>
-              </a:buClr>
-              <a:buFont typeface="Arial"/>
-              <a:buChar char="•"/>
-            </a:pPr>
-            <a:r>
-              <a:rPr sz="1700" b="0" i="0">
+              <a:t>Role-aware treatment of explanation</a:t>
+            </a:r>
+          </a:p>
+          <a:p>
+            <a:pPr algn="l">
+              <a:spcAft>
+                <a:spcPts val="200"/>
+              </a:spcAft>
+            </a:pPr>
+            <a:r>
+              <a:rPr sz="1500" b="0" i="0">
+                <a:solidFill>
+                  <a:srgbClr val="555560"/>
+                </a:solidFill>
+                <a:latin typeface="Calibri"/>
+              </a:rPr>
+              <a:t>Distinct views derived from each role's responsibilities and questions.</a:t>
+            </a:r>
+          </a:p>
+        </p:txBody>
+      </p:sp>
+      <p:sp>
+        <p:nvSpPr>
+          <p:cNvPr id="8" name="Number 3"/>
+          <p:cNvSpPr/>
+          <p:nvPr/>
+        </p:nvSpPr>
+        <p:spPr>
+          <a:xfrm>
+            <a:off x="2240280" y="3703320"/>
+            <a:ext cx="457200" cy="457200"/>
+          </a:xfrm>
+          <a:prstGeom prst="ellipse">
+            <a:avLst/>
+          </a:prstGeom>
+          <a:solidFill>
+            <a:srgbClr val="343174"/>
+          </a:solidFill>
+          <a:ln>
+            <a:noFill/>
+          </a:ln>
+          <a:effectLst/>
+        </p:spPr>
+        <p:txBody>
+          <a:bodyPr rtlCol="0" anchor="ctr" lIns="0" rIns="0" tIns="0" bIns="0"/>
+          <a:lstStyle/>
+          <a:p>
+            <a:pPr algn="ctr"/>
+            <a:r>
+              <a:rPr sz="1500" b="1" i="0">
+                <a:solidFill>
+                  <a:srgbClr val="FFFFFF"/>
+                </a:solidFill>
+                <a:latin typeface="Calibri"/>
+              </a:rPr>
+              <a:t>3</a:t>
+            </a:r>
+          </a:p>
+        </p:txBody>
+      </p:sp>
+      <p:sp>
+        <p:nvSpPr>
+          <p:cNvPr id="9" name="Item 3"/>
+          <p:cNvSpPr txBox="1"/>
+          <p:nvPr/>
+        </p:nvSpPr>
+        <p:spPr>
+          <a:xfrm>
+            <a:off x="2880360" y="3685032"/>
+            <a:ext cx="5669279" cy="1097280"/>
+          </a:xfrm>
+          <a:prstGeom prst="rect">
+            <a:avLst/>
+          </a:prstGeom>
+          <a:noFill/>
+        </p:spPr>
+        <p:txBody>
+          <a:bodyPr wrap="square" anchor="t" lIns="0" rIns="0" tIns="0" bIns="0">
+            <a:spAutoFit/>
+          </a:bodyPr>
+          <a:lstStyle/>
+          <a:p>
+            <a:pPr algn="l">
+              <a:spcAft>
+                <a:spcPts val="200"/>
+              </a:spcAft>
+            </a:pPr>
+            <a:r>
+              <a:rPr sz="1800" b="1" i="0">
                 <a:solidFill>
                   <a:srgbClr val="22222A"/>
                 </a:solidFill>
                 <a:latin typeface="Calibri"/>
               </a:rPr>
-              <a:t>Probability calibration (Platt, isotonic)</a:t>
-            </a:r>
-          </a:p>
-          <a:p>
-            <a:pPr algn="l" marL="201168" indent="-201168">
-              <a:spcAft>
-                <a:spcPts val="1400"/>
-              </a:spcAft>
-              <a:buClr>
-                <a:srgbClr val="343174"/>
-              </a:buClr>
-              <a:buFont typeface="Arial"/>
-              <a:buChar char="•"/>
-            </a:pPr>
-            <a:r>
-              <a:rPr sz="1700" b="0" i="0">
+              <a:t>CommonKADS applied to explainable learning analytics</a:t>
+            </a:r>
+          </a:p>
+          <a:p>
+            <a:pPr algn="l">
+              <a:spcAft>
+                <a:spcPts val="200"/>
+              </a:spcAft>
+            </a:pPr>
+            <a:r>
+              <a:rPr sz="1500" b="0" i="0">
+                <a:solidFill>
+                  <a:srgbClr val="555560"/>
+                </a:solidFill>
+                <a:latin typeface="Calibri"/>
+              </a:rPr>
+              <a:t>Shows the design problem is largely a knowledge problem.</a:t>
+            </a:r>
+          </a:p>
+        </p:txBody>
+      </p:sp>
+      <p:sp>
+        <p:nvSpPr>
+          <p:cNvPr id="10" name="Number 4"/>
+          <p:cNvSpPr/>
+          <p:nvPr/>
+        </p:nvSpPr>
+        <p:spPr>
+          <a:xfrm>
+            <a:off x="2240280" y="4846320"/>
+            <a:ext cx="457200" cy="457200"/>
+          </a:xfrm>
+          <a:prstGeom prst="ellipse">
+            <a:avLst/>
+          </a:prstGeom>
+          <a:solidFill>
+            <a:srgbClr val="343174"/>
+          </a:solidFill>
+          <a:ln>
+            <a:noFill/>
+          </a:ln>
+          <a:effectLst/>
+        </p:spPr>
+        <p:txBody>
+          <a:bodyPr rtlCol="0" anchor="ctr" lIns="0" rIns="0" tIns="0" bIns="0"/>
+          <a:lstStyle/>
+          <a:p>
+            <a:pPr algn="ctr"/>
+            <a:r>
+              <a:rPr sz="1500" b="1" i="0">
+                <a:solidFill>
+                  <a:srgbClr val="FFFFFF"/>
+                </a:solidFill>
+                <a:latin typeface="Calibri"/>
+              </a:rPr>
+              <a:t>4</a:t>
+            </a:r>
+          </a:p>
+        </p:txBody>
+      </p:sp>
+      <p:sp>
+        <p:nvSpPr>
+          <p:cNvPr id="11" name="Item 4"/>
+          <p:cNvSpPr txBox="1"/>
+          <p:nvPr/>
+        </p:nvSpPr>
+        <p:spPr>
+          <a:xfrm>
+            <a:off x="2880360" y="4828032"/>
+            <a:ext cx="5669279" cy="1097280"/>
+          </a:xfrm>
+          <a:prstGeom prst="rect">
+            <a:avLst/>
+          </a:prstGeom>
+          <a:noFill/>
+        </p:spPr>
+        <p:txBody>
+          <a:bodyPr wrap="square" anchor="t" lIns="0" rIns="0" tIns="0" bIns="0">
+            <a:spAutoFit/>
+          </a:bodyPr>
+          <a:lstStyle/>
+          <a:p>
+            <a:pPr algn="l">
+              <a:spcAft>
+                <a:spcPts val="200"/>
+              </a:spcAft>
+            </a:pPr>
+            <a:r>
+              <a:rPr sz="1800" b="1" i="0">
                 <a:solidFill>
                   <a:srgbClr val="22222A"/>
                 </a:solidFill>
                 <a:latin typeface="Calibri"/>
               </a:rPr>
-              <a:t>Subgroup fairness assessment</a:t>
-            </a:r>
-          </a:p>
-          <a:p>
-            <a:pPr algn="l" marL="201168" indent="-201168">
-              <a:spcAft>
-                <a:spcPts val="1400"/>
-              </a:spcAft>
-              <a:buClr>
-                <a:srgbClr val="343174"/>
-              </a:buClr>
-              <a:buFont typeface="Arial"/>
-              <a:buChar char="•"/>
-            </a:pPr>
-            <a:r>
-              <a:rPr sz="1700" b="0" i="0">
-                <a:solidFill>
-                  <a:srgbClr val="22222A"/>
-                </a:solidFill>
-                <a:latin typeface="Calibri"/>
-              </a:rPr>
-              <a:t>Practitioner study using TAM constructs</a:t>
-            </a:r>
-          </a:p>
-          <a:p>
-            <a:pPr algn="l" marL="201168" indent="-201168">
-              <a:spcAft>
-                <a:spcPts val="1400"/>
-              </a:spcAft>
-              <a:buClr>
-                <a:srgbClr val="343174"/>
-              </a:buClr>
-              <a:buFont typeface="Arial"/>
-              <a:buChar char="•"/>
-            </a:pPr>
-            <a:r>
-              <a:rPr sz="1700" b="0" i="0">
-                <a:solidFill>
-                  <a:srgbClr val="22222A"/>
-                </a:solidFill>
-                <a:latin typeface="Calibri"/>
-              </a:rPr>
-              <a:t>Other institutions and live data</a:t>
+              <a:t>Evidence on SHAP and LIME agreement</a:t>
+            </a:r>
+          </a:p>
+          <a:p>
+            <a:pPr algn="l">
+              <a:spcAft>
+                <a:spcPts val="200"/>
+              </a:spcAft>
+            </a:pPr>
+            <a:r>
+              <a:rPr sz="1500" b="0" i="0">
+                <a:solidFill>
+                  <a:srgbClr val="555560"/>
+                </a:solidFill>
+                <a:latin typeface="Calibri"/>
+              </a:rPr>
+              <a:t>Where the methods converge and differ, at global and local level.</a:t>
             </a:r>
           </a:p>
         </p:txBody>
@@ -16998,7 +17036,7 @@
                 </a:solidFill>
                 <a:latin typeface="Calibri"/>
               </a:rPr>
-              <a:t>Conclusion</a:t>
+              <a:t>Limitations and Future Work</a:t>
             </a:r>
           </a:p>
         </p:txBody>
@@ -17038,6 +17076,421 @@
                 <a:latin typeface="Calibri"/>
               </a:rPr>
               <a:t>20</a:t>
+            </a:r>
+          </a:p>
+        </p:txBody>
+      </p:sp>
+      <p:sp>
+        <p:nvSpPr>
+          <p:cNvPr id="4" name="Limitations card"/>
+          <p:cNvSpPr/>
+          <p:nvPr/>
+        </p:nvSpPr>
+        <p:spPr>
+          <a:xfrm>
+            <a:off x="2240280" y="1371600"/>
+            <a:ext cx="3040379" cy="4572000"/>
+          </a:xfrm>
+          <a:prstGeom prst="rect">
+            <a:avLst/>
+          </a:prstGeom>
+          <a:solidFill>
+            <a:srgbClr val="F2F2F5"/>
+          </a:solidFill>
+          <a:ln>
+            <a:noFill/>
+          </a:ln>
+          <a:effectLst/>
+        </p:spPr>
+        <p:txBody>
+          <a:bodyPr rtlCol="0" anchor="ctr"/>
+          <a:lstStyle/>
+          <a:p/>
+        </p:txBody>
+      </p:sp>
+      <p:sp>
+        <p:nvSpPr>
+          <p:cNvPr id="5" name="Limitations text"/>
+          <p:cNvSpPr txBox="1"/>
+          <p:nvPr/>
+        </p:nvSpPr>
+        <p:spPr>
+          <a:xfrm>
+            <a:off x="2423160" y="1554480"/>
+            <a:ext cx="2674620" cy="4297680"/>
+          </a:xfrm>
+          <a:prstGeom prst="rect">
+            <a:avLst/>
+          </a:prstGeom>
+          <a:noFill/>
+        </p:spPr>
+        <p:txBody>
+          <a:bodyPr wrap="square" anchor="t" lIns="0" rIns="0" tIns="0" bIns="0">
+            <a:spAutoFit/>
+          </a:bodyPr>
+          <a:lstStyle/>
+          <a:p>
+            <a:pPr algn="l">
+              <a:spcAft>
+                <a:spcPts val="1400"/>
+              </a:spcAft>
+            </a:pPr>
+            <a:r>
+              <a:rPr sz="2000" b="1" i="0">
+                <a:solidFill>
+                  <a:srgbClr val="343174"/>
+                </a:solidFill>
+                <a:latin typeface="Calibri"/>
+              </a:rPr>
+              <a:t>Limitations</a:t>
+            </a:r>
+          </a:p>
+          <a:p>
+            <a:pPr algn="l" marL="201168" indent="-201168">
+              <a:spcAft>
+                <a:spcPts val="1400"/>
+              </a:spcAft>
+              <a:buClr>
+                <a:srgbClr val="343174"/>
+              </a:buClr>
+              <a:buFont typeface="Arial"/>
+              <a:buChar char="•"/>
+            </a:pPr>
+            <a:r>
+              <a:rPr sz="1700" b="0" i="0">
+                <a:solidFill>
+                  <a:srgbClr val="22222A"/>
+                </a:solidFill>
+                <a:latin typeface="Calibri"/>
+              </a:rPr>
+              <a:t>No practitioner data: trust, usability and decision quality untested</a:t>
+            </a:r>
+          </a:p>
+          <a:p>
+            <a:pPr algn="l" marL="201168" indent="-201168">
+              <a:spcAft>
+                <a:spcPts val="1400"/>
+              </a:spcAft>
+              <a:buClr>
+                <a:srgbClr val="343174"/>
+              </a:buClr>
+              <a:buFont typeface="Arial"/>
+              <a:buChar char="•"/>
+            </a:pPr>
+            <a:r>
+              <a:rPr sz="1700" b="0" i="0">
+                <a:solidFill>
+                  <a:srgbClr val="22222A"/>
+                </a:solidFill>
+                <a:latin typeface="Calibri"/>
+              </a:rPr>
+              <a:t>Retrospective features: no early-warning point evaluated</a:t>
+            </a:r>
+          </a:p>
+          <a:p>
+            <a:pPr algn="l" marL="201168" indent="-201168">
+              <a:spcAft>
+                <a:spcPts val="1400"/>
+              </a:spcAft>
+              <a:buClr>
+                <a:srgbClr val="343174"/>
+              </a:buClr>
+              <a:buFont typeface="Arial"/>
+              <a:buChar char="•"/>
+            </a:pPr>
+            <a:r>
+              <a:rPr sz="1700" b="0" i="0">
+                <a:solidFill>
+                  <a:srgbClr val="22222A"/>
+                </a:solidFill>
+                <a:latin typeface="Calibri"/>
+              </a:rPr>
+              <a:t>One dataset (OULAD) and context</a:t>
+            </a:r>
+          </a:p>
+          <a:p>
+            <a:pPr algn="l" marL="201168" indent="-201168">
+              <a:spcAft>
+                <a:spcPts val="1400"/>
+              </a:spcAft>
+              <a:buClr>
+                <a:srgbClr val="343174"/>
+              </a:buClr>
+              <a:buFont typeface="Arial"/>
+              <a:buChar char="•"/>
+            </a:pPr>
+            <a:r>
+              <a:rPr sz="1700" b="0" i="0">
+                <a:solidFill>
+                  <a:srgbClr val="22222A"/>
+                </a:solidFill>
+                <a:latin typeface="Calibri"/>
+              </a:rPr>
+              <a:t>Stability, fidelity, calibration and fairness checks not completed</a:t>
+            </a:r>
+          </a:p>
+        </p:txBody>
+      </p:sp>
+      <p:sp>
+        <p:nvSpPr>
+          <p:cNvPr id="6" name="Future work card"/>
+          <p:cNvSpPr/>
+          <p:nvPr/>
+        </p:nvSpPr>
+        <p:spPr>
+          <a:xfrm>
+            <a:off x="5509260" y="1371600"/>
+            <a:ext cx="3040379" cy="4572000"/>
+          </a:xfrm>
+          <a:prstGeom prst="rect">
+            <a:avLst/>
+          </a:prstGeom>
+          <a:solidFill>
+            <a:srgbClr val="F2F2F5"/>
+          </a:solidFill>
+          <a:ln>
+            <a:noFill/>
+          </a:ln>
+          <a:effectLst/>
+        </p:spPr>
+        <p:txBody>
+          <a:bodyPr rtlCol="0" anchor="ctr"/>
+          <a:lstStyle/>
+          <a:p/>
+        </p:txBody>
+      </p:sp>
+      <p:sp>
+        <p:nvSpPr>
+          <p:cNvPr id="7" name="Future work text"/>
+          <p:cNvSpPr txBox="1"/>
+          <p:nvPr/>
+        </p:nvSpPr>
+        <p:spPr>
+          <a:xfrm>
+            <a:off x="5692140" y="1554480"/>
+            <a:ext cx="2674620" cy="4297680"/>
+          </a:xfrm>
+          <a:prstGeom prst="rect">
+            <a:avLst/>
+          </a:prstGeom>
+          <a:noFill/>
+        </p:spPr>
+        <p:txBody>
+          <a:bodyPr wrap="square" anchor="t" lIns="0" rIns="0" tIns="0" bIns="0">
+            <a:spAutoFit/>
+          </a:bodyPr>
+          <a:lstStyle/>
+          <a:p>
+            <a:pPr algn="l">
+              <a:spcAft>
+                <a:spcPts val="1400"/>
+              </a:spcAft>
+            </a:pPr>
+            <a:r>
+              <a:rPr sz="2000" b="1" i="0">
+                <a:solidFill>
+                  <a:srgbClr val="343174"/>
+                </a:solidFill>
+                <a:latin typeface="Calibri"/>
+              </a:rPr>
+              <a:t>Future work</a:t>
+            </a:r>
+          </a:p>
+          <a:p>
+            <a:pPr algn="l" marL="201168" indent="-201168">
+              <a:spcAft>
+                <a:spcPts val="1400"/>
+              </a:spcAft>
+              <a:buClr>
+                <a:srgbClr val="343174"/>
+              </a:buClr>
+              <a:buFont typeface="Arial"/>
+              <a:buChar char="•"/>
+            </a:pPr>
+            <a:r>
+              <a:rPr sz="1700" b="0" i="0">
+                <a:solidFill>
+                  <a:srgbClr val="22222A"/>
+                </a:solidFill>
+                <a:latin typeface="Calibri"/>
+              </a:rPr>
+              <a:t>Early-warning evaluation at weeks 2, 4, 6 and 8</a:t>
+            </a:r>
+          </a:p>
+          <a:p>
+            <a:pPr algn="l" marL="201168" indent="-201168">
+              <a:spcAft>
+                <a:spcPts val="1400"/>
+              </a:spcAft>
+              <a:buClr>
+                <a:srgbClr val="343174"/>
+              </a:buClr>
+              <a:buFont typeface="Arial"/>
+              <a:buChar char="•"/>
+            </a:pPr>
+            <a:r>
+              <a:rPr sz="1700" b="0" i="0">
+                <a:solidFill>
+                  <a:srgbClr val="22222A"/>
+                </a:solidFill>
+                <a:latin typeface="Calibri"/>
+              </a:rPr>
+              <a:t>Probability calibration (Platt, isotonic)</a:t>
+            </a:r>
+          </a:p>
+          <a:p>
+            <a:pPr algn="l" marL="201168" indent="-201168">
+              <a:spcAft>
+                <a:spcPts val="1400"/>
+              </a:spcAft>
+              <a:buClr>
+                <a:srgbClr val="343174"/>
+              </a:buClr>
+              <a:buFont typeface="Arial"/>
+              <a:buChar char="•"/>
+            </a:pPr>
+            <a:r>
+              <a:rPr sz="1700" b="0" i="0">
+                <a:solidFill>
+                  <a:srgbClr val="22222A"/>
+                </a:solidFill>
+                <a:latin typeface="Calibri"/>
+              </a:rPr>
+              <a:t>Subgroup fairness assessment</a:t>
+            </a:r>
+          </a:p>
+          <a:p>
+            <a:pPr algn="l" marL="201168" indent="-201168">
+              <a:spcAft>
+                <a:spcPts val="1400"/>
+              </a:spcAft>
+              <a:buClr>
+                <a:srgbClr val="343174"/>
+              </a:buClr>
+              <a:buFont typeface="Arial"/>
+              <a:buChar char="•"/>
+            </a:pPr>
+            <a:r>
+              <a:rPr sz="1700" b="0" i="0">
+                <a:solidFill>
+                  <a:srgbClr val="22222A"/>
+                </a:solidFill>
+                <a:latin typeface="Calibri"/>
+              </a:rPr>
+              <a:t>Practitioner study using TAM constructs</a:t>
+            </a:r>
+          </a:p>
+          <a:p>
+            <a:pPr algn="l" marL="201168" indent="-201168">
+              <a:spcAft>
+                <a:spcPts val="1400"/>
+              </a:spcAft>
+              <a:buClr>
+                <a:srgbClr val="343174"/>
+              </a:buClr>
+              <a:buFont typeface="Arial"/>
+              <a:buChar char="•"/>
+            </a:pPr>
+            <a:r>
+              <a:rPr sz="1700" b="0" i="0">
+                <a:solidFill>
+                  <a:srgbClr val="22222A"/>
+                </a:solidFill>
+                <a:latin typeface="Calibri"/>
+              </a:rPr>
+              <a:t>Other institutions and live data</a:t>
+            </a:r>
+          </a:p>
+        </p:txBody>
+      </p:sp>
+    </p:spTree>
+  </p:cSld>
+  <p:clrMapOvr>
+    <a:masterClrMapping/>
+  </p:clrMapOvr>
+</p:sld>
+</file>
+
+<file path=ppt/slides/slide23.xml><?xml version="1.0" encoding="utf-8"?>
+<p:sld xmlns:a="http://schemas.openxmlformats.org/drawingml/2006/main" xmlns:p="http://schemas.openxmlformats.org/presentationml/2006/main" xmlns:r="http://schemas.openxmlformats.org/officeDocument/2006/relationships">
+  <p:cSld>
+    <p:spTree>
+      <p:nvGrpSpPr>
+        <p:cNvPr id="1" name=""/>
+        <p:cNvGrpSpPr/>
+        <p:nvPr/>
+      </p:nvGrpSpPr>
+      <p:grpSpPr/>
+      <p:sp>
+        <p:nvSpPr>
+          <p:cNvPr id="2" name="Title 1"/>
+          <p:cNvSpPr>
+            <a:spLocks noGrp="1"/>
+          </p:cNvSpPr>
+          <p:nvPr>
+            <p:ph type="title"/>
+          </p:nvPr>
+        </p:nvSpPr>
+        <p:spPr>
+          <a:xfrm>
+            <a:off x="2240280" y="502920"/>
+            <a:ext cx="6309359" cy="731520"/>
+          </a:xfrm>
+        </p:spPr>
+        <p:txBody>
+          <a:bodyPr wrap="square" anchor="ctr" lIns="0" rIns="0">
+            <a:normAutofit/>
+          </a:bodyPr>
+          <a:lstStyle/>
+          <a:p>
+            <a:pPr algn="l"/>
+            <a:r>
+              <a:rPr sz="2800" b="1" i="0">
+                <a:solidFill>
+                  <a:srgbClr val="343174"/>
+                </a:solidFill>
+                <a:latin typeface="Calibri"/>
+              </a:rPr>
+              <a:t>Conclusion</a:t>
+            </a:r>
+          </a:p>
+        </p:txBody>
+      </p:sp>
+      <p:sp>
+        <p:nvSpPr>
+          <p:cNvPr id="3" name="Slide number"/>
+          <p:cNvSpPr txBox="1"/>
+          <p:nvPr/>
+        </p:nvSpPr>
+        <p:spPr>
+          <a:xfrm>
+            <a:off x="8001000" y="6108192"/>
+            <a:ext cx="548640" cy="256032"/>
+          </a:xfrm>
+          <a:prstGeom prst="rect">
+            <a:avLst/>
+          </a:prstGeom>
+          <a:noFill/>
+        </p:spPr>
+        <p:txBody>
+          <a:bodyPr wrap="square" anchor="t" lIns="0" rIns="0" tIns="0" bIns="0">
+            <a:spAutoFit/>
+          </a:bodyPr>
+          <a:lstStyle/>
+          <a:p>
+            <a:pPr algn="r">
+              <a:spcAft>
+                <a:spcPts val="600"/>
+              </a:spcAft>
+            </a:pPr>
+            <a:r>
+              <a:rPr sz="1100" b="0" i="0">
+                <a:solidFill>
+                  <a:srgbClr val="555560"/>
+                </a:solidFill>
+                <a:latin typeface="Calibri"/>
+              </a:rPr>
+              <a:t>21</a:t>
             </a:r>
           </a:p>
         </p:txBody>

</xml_diff>

<commit_message>
Defense deck: add how-to-read-an-explanation slide and prototype walkthrough notes
</commit_message>
<xml_diff>
--- a/Internal_Defense_Presentation.pptx
+++ b/Internal_Defense_Presentation.pptx
@@ -27,6 +27,7 @@
     <p:sldId id="294" r:id="rId28"/>
     <p:sldId id="295" r:id="rId29"/>
     <p:sldId id="296" r:id="rId30"/>
+    <p:sldId id="297" r:id="rId31"/>
     <p:sldId id="274" r:id="rId4"/>
   </p:sldIdLst>
   <p:sldSz cx="9144000" cy="6858000" type="screen4x3"/>
@@ -1381,7 +1382,7 @@
           <a:lstStyle/>
           <a:p>
             <a:r>
-              <a:t>This is the core design idea, shown running inside Moodle. Every role sees the same prediction, but at a different depth. The instructor works inside a running course and sees individual students with SHAP and LIME side by side. The advisor manages a caseload and sees reasoning averaged over students at or above the watch threshold. The administrator directs resources and sees institution-wide performance and the full-population reasoning trail. Moodle supplies the login, the role and the course context. These views were derived from the Agent Model and the literature and have not yet been tested with users.</a:t>
+              <a:t>These are the three role views, running inside Moodle. Moodle supplies the login, the role and the course, so each person lands on the view for their role. All three use the same model and the same prediction; what changes is the level of detail. Left, the instructor: one course, here FFF-2014J. 2,365 students, 1,207 flagged at or above 0.5. Click a student to see why that student was flagged. Middle, the advisor: a caseload across modules for one presentation, 2014J. 5,520 students are at or above 0.5 across 7 modules, with a bar per module and the highest-risk students listed. The reasoning trail is the average SHAP contribution across the caseload, so it shows what is common to these students, not one student's situation. Right, the administrator: the institution. Model performance first, so they know how far to trust it: accuracy 0.877, recall 0.909, ROC-AUC 0.962 over 32,593 records. Then performance by presentation, the confusion matrix, the model comparison, and the full-population reasoning trail. So: individual for instructors, caseload for advisors, cohort for administrators. These views come from the CommonKADS Agent Model and the literature; they have not yet been tested with real users.</a:t>
             </a:r>
           </a:p>
         </p:txBody>
@@ -1451,7 +1452,7 @@
           <a:lstStyle/>
           <a:p>
             <a:r>
-              <a:t>Here is the At-risk insights page of the Moodle plugin in course FFF-2014J. Students are ranked by predicted risk. Selecting one shows the top five SHAP contributions and the top five LIME weights, colour-coded by whether a feature pushes towards or away from at-risk. A note says how many features the two methods share for this student, here four of five, and reminds the instructor that contributions describe the model's reasoning, not the causes of the student's situation, and that the decision stays with them.</a:t>
+              <a:t>This is the screen an instructor uses. It is the At-risk insights page inside the Moodle course FFF-2014J. On the left, the class list is sorted by predicted risk, with assessments submitted, mean score and active days next to each student, so the instructor can sanity-check the flag against what they already know. I have selected student s678287, predicted above 99.9 percent at risk. On the right are two explanations of that one prediction: SHAP on top, LIME below. Both put assessments submitted first. The note at the bottom says the two methods share 4 of their top 5 features for this student, so the explanation is fairly firm, and it reminds the instructor that these describe the model's reasoning, not the cause of the student's situation, and that the decision stays with them. On the next slide I show how to read the numbers.</a:t>
             </a:r>
           </a:p>
         </p:txBody>
@@ -1521,7 +1522,7 @@
           <a:lstStyle/>
           <a:p>
             <a:r>
-              <a:t>The prototype was integrated with two LMSs, both running locally under Docker. In Moodle 5.2 a native plugin, local_xairisk, adds At-risk insights to each course's More menu and uses Moodle's own login, roles and enrolments, calling the API server to server. In Canvas the dashboard is added to every course as an External URL module item and embedded in an iframe, without LTI. All 22 OULAD module presentations were loaded as courses in both systems, with 28,785 students and 32,593 enrolments.</a:t>
+              <a:t>This is how to read the explanation for one student, using the student from the previous slide. The prediction is above 99.9 percent at risk. SHAP first. Each bar is how much a feature moved this student's prediction, in log-odds. A positive value, drawn in navy, pushes towards at-risk; a negative one, in grey, pushes away. Longer means stronger. Assessments submitted, plus 5.3, dominates: this student submitted almost nothing, and that alone pushes the prediction strongly towards at-risk. Being in module FFF adds 1.7, few active days adds 1.2, low total clicks adds 0.8. Clicks in the 28 days before deadlines pulls slightly the other way, minus 0.4; as the thesis notes, that is most likely collinearity among the click features, not a real protective effect. LIME second. LIME fits a simple local model around this student and returns rules with weights: assessments submitted at most 1, module is not AAA, module is FFF, active days at most 11, total clicks at most 142. All push towards at-risk. Then compare the two. They share 4 of their top 5 features, so we can be more confident in the explanation. Where they disagree, read with more caution. Finally, these are attributions about how the model reached its score, not causes. The useful message for the instructor is concrete: this student has submitted almost no assessments and is rarely active, which is something they can check and follow up. What to do remains their decision.</a:t>
             </a:r>
           </a:p>
         </p:txBody>
@@ -1591,7 +1592,7 @@
           <a:lstStyle/>
           <a:p>
             <a:r>
-              <a:t>There are four contributions. First, a working system where prediction and explanation run together, with the explanation layer serving the interface directly, rather than explanation as an offline analysis. Second, role-aware explanation: distinct views derived from each role's responsibilities, with the reasoning documented. Third, a methodological one: applying CommonKADS shows that the design problem here is largely a knowledge problem. Fourth, evidence on where SHAP and LIME agree and differ, at global and local level.</a:t>
+              <a:t>Finally, the prototype is not only a standalone web page: it runs inside two real LMSs, both deployed locally with Docker. On the left, Moodle 5.2. I wrote a native plugin, local_xairisk. It adds an At-risk insights link to each course's More menu, and it uses Moodle's own login, roles and enrolments, so a teacher sees the instructor view for their course, and the plugin calls the prediction API server to server. On the right, Canvas. Here the dashboard is added to every course as an External URL module item and shown in an iframe, without LTI. You can see the same instructor view inside the Canvas course FFF-2014J. All 22 OULAD module presentations were loaded as courses in both systems, with 28,785 students and 32,593 enrolments. This shows the design can sit inside the tools staff already use; real institutional deployment would still need live data, security review and user testing.</a:t>
             </a:r>
           </a:p>
         </p:txBody>
@@ -1731,7 +1732,7 @@
           <a:lstStyle/>
           <a:p>
             <a:r>
-              <a:t>I want to be clear about the limits. No practitioner used the system, so trust, usability and decision quality are untested. Features cover the whole presentation, so this is retrospective classification, not early warning. The study uses one dataset. The planned stability, fidelity, calibration and fairness checks were not completed. The future work follows directly: the three first-tier priorities are early-warning evaluation, calibration and a fairness assessment, and then a practitioner study and other institutions' data.</a:t>
+              <a:t>There are four contributions. First, a working system where prediction and explanation run together, with the explanation layer serving the interface directly, rather than explanation as an offline analysis. Second, role-aware explanation: distinct views derived from each role's responsibilities, with the reasoning documented. Third, a methodological one: applying CommonKADS shows that the design problem here is largely a knowledge problem. Fourth, evidence on where SHAP and LIME agree and differ, at global and local level.</a:t>
             </a:r>
           </a:p>
         </p:txBody>
@@ -1801,7 +1802,7 @@
           <a:lstStyle/>
           <a:p>
             <a:r>
-              <a:t>To close, the answers. RQ1: SHAP and LIME were integrated into a pipeline designed with CommonKADS, with global SHAP cached and LIME on demand; they agree on the main drivers and partly differ for individual students. RQ2: individual, caseload and cohort views were derived from the Agent Model and implemented; they are specified, not yet user-tested. RQ3: the technical preconditions are in place: high recall, reasons traceable to recorded behaviour, and cross-checked methods. Whether practitioners benefit is the next study. Thank you, I welcome your questions.</a:t>
+              <a:t>I want to be clear about the limits. No practitioner used the system, so trust, usability and decision quality are untested. Features cover the whole presentation, so this is retrospective classification, not early warning. The study uses one dataset. The planned stability, fidelity, calibration and fairness checks were not completed. The future work follows directly: the three first-tier priorities are early-warning evaluation, calibration and a fairness assessment, and then a practitioner study and other institutions' data.</a:t>
             </a:r>
           </a:p>
         </p:txBody>
@@ -1827,6 +1828,76 @@
 </file>
 
 <file path=ppt/notesSlides/notesSlide22.xml><?xml version="1.0" encoding="utf-8"?>
+<p:notes xmlns:a="http://schemas.openxmlformats.org/drawingml/2006/main" xmlns:p="http://schemas.openxmlformats.org/presentationml/2006/main" xmlns:r="http://schemas.openxmlformats.org/officeDocument/2006/relationships">
+  <p:cSld>
+    <p:spTree>
+      <p:nvGrpSpPr>
+        <p:cNvPr id="1" name=""/>
+        <p:cNvGrpSpPr/>
+        <p:nvPr/>
+      </p:nvGrpSpPr>
+      <p:grpSpPr>
+        <a:xfrm>
+          <a:off x="0" y="0"/>
+          <a:ext cx="0" cy="0"/>
+          <a:chOff x="0" y="0"/>
+          <a:chExt cx="0" cy="0"/>
+        </a:xfrm>
+      </p:grpSpPr>
+      <p:sp>
+        <p:nvSpPr>
+          <p:cNvPr id="2" name="Slide Image Placeholder 1"/>
+          <p:cNvSpPr>
+            <a:spLocks noGrp="1"/>
+          </p:cNvSpPr>
+          <p:nvPr>
+            <p:ph type="sldImg" idx="2"/>
+          </p:nvPr>
+        </p:nvSpPr>
+        <p:spPr/>
+      </p:sp>
+      <p:sp>
+        <p:nvSpPr>
+          <p:cNvPr id="3" name="Notes Placeholder 2"/>
+          <p:cNvSpPr>
+            <a:spLocks noGrp="1"/>
+          </p:cNvSpPr>
+          <p:nvPr>
+            <p:ph type="body" idx="3" sz="quarter"/>
+          </p:nvPr>
+        </p:nvSpPr>
+        <p:spPr/>
+        <p:txBody>
+          <a:bodyPr/>
+          <a:lstStyle/>
+          <a:p>
+            <a:r>
+              <a:t>To close, the answers. RQ1: SHAP and LIME were integrated into a pipeline designed with CommonKADS, with global SHAP cached and LIME on demand; they agree on the main drivers and partly differ for individual students. RQ2: individual, caseload and cohort views were derived from the Agent Model and implemented; they are specified, not yet user-tested. RQ3: the technical preconditions are in place: high recall, reasons traceable to recorded behaviour, and cross-checked methods. Whether practitioners benefit is the next study. Thank you, I welcome your questions.</a:t>
+            </a:r>
+          </a:p>
+        </p:txBody>
+      </p:sp>
+      <p:sp>
+        <p:nvSpPr>
+          <p:cNvPr id="4" name="Slide Number Placeholder 3"/>
+          <p:cNvSpPr>
+            <a:spLocks noGrp="1"/>
+          </p:cNvSpPr>
+          <p:nvPr>
+            <p:ph type="sldNum" idx="5" sz="quarter"/>
+          </p:nvPr>
+        </p:nvSpPr>
+        <p:spPr/>
+      </p:sp>
+    </p:spTree>
+  </p:cSld>
+  <p:clrMapOvr>
+    <a:masterClrMapping/>
+  </p:clrMapOvr>
+</p:notes>
+</file>
+
+<file path=ppt/notesSlides/notesSlide23.xml><?xml version="1.0" encoding="utf-8"?>
 <p:notes xmlns:a="http://schemas.openxmlformats.org/drawingml/2006/main" xmlns:p="http://schemas.openxmlformats.org/presentationml/2006/main" xmlns:r="http://schemas.openxmlformats.org/officeDocument/2006/relationships">
   <p:cSld>
     <p:spTree>
@@ -16186,7 +16257,7 @@
                 </a:solidFill>
                 <a:latin typeface="Calibri"/>
               </a:rPr>
-              <a:t>Running Inside Moodle and Canvas</a:t>
+              <a:t>How to Read an Explanation</a:t>
             </a:r>
           </a:p>
         </p:txBody>
@@ -16232,14 +16303,14 @@
       </p:sp>
       <p:sp>
         <p:nvSpPr>
-          <p:cNvPr id="4" name="Moodle 5.2 label"/>
+          <p:cNvPr id="4" name="Example header"/>
           <p:cNvSpPr txBox="1"/>
           <p:nvPr/>
         </p:nvSpPr>
         <p:spPr>
           <a:xfrm>
-            <a:off x="2240280" y="1344168"/>
-            <a:ext cx="3040379" cy="365760"/>
+            <a:off x="2240280" y="1325880"/>
+            <a:ext cx="6309359" cy="365760"/>
           </a:xfrm>
           <a:prstGeom prst="rect">
             <a:avLst/>
@@ -16258,56 +16329,640 @@
               </a:spcAft>
             </a:pPr>
             <a:r>
-              <a:rPr sz="1800" b="1" i="0">
+              <a:rPr sz="1500" b="1" i="0">
                 <a:solidFill>
                   <a:srgbClr val="343174"/>
                 </a:solidFill>
                 <a:latin typeface="Calibri"/>
               </a:rPr>
-              <a:t>Moodle 5.2</a:t>
-            </a:r>
-          </a:p>
-        </p:txBody>
-      </p:sp>
-      <p:pic>
-        <p:nvPicPr>
-          <p:cNvPr id="5" name="Moodle 5.2 screenshot" descr="moodle_nav.png"/>
-          <p:cNvPicPr>
-            <a:picLocks noChangeAspect="1"/>
-          </p:cNvPicPr>
-          <p:nvPr/>
-        </p:nvPicPr>
-        <p:blipFill>
-          <a:blip r:embed="rId3"/>
-          <a:stretch>
-            <a:fillRect/>
-          </a:stretch>
-        </p:blipFill>
+              <a:t>Student s678287, course FFF-2014J: </a:t>
+            </a:r>
+            <a:r>
+              <a:rPr sz="1500" b="0" i="0">
+                <a:solidFill>
+                  <a:srgbClr val="22222A"/>
+                </a:solidFill>
+                <a:latin typeface="Calibri"/>
+              </a:rPr>
+              <a:t>predicted &gt;99.9% at risk</a:t>
+            </a:r>
+          </a:p>
+        </p:txBody>
+      </p:sp>
+      <p:sp>
+        <p:nvSpPr>
+          <p:cNvPr id="5" name="SHAP: top 5 contributions (log-odds)"/>
+          <p:cNvSpPr txBox="1"/>
+          <p:nvPr/>
+        </p:nvSpPr>
         <p:spPr>
           <a:xfrm>
             <a:off x="2240280" y="1783080"/>
-            <a:ext cx="3040379" cy="2111374"/>
-          </a:xfrm>
-          <a:prstGeom prst="rect">
-            <a:avLst/>
-          </a:prstGeom>
-          <a:ln w="9525">
+            <a:ext cx="3840480" cy="274320"/>
+          </a:xfrm>
+          <a:prstGeom prst="rect">
+            <a:avLst/>
+          </a:prstGeom>
+          <a:noFill/>
+        </p:spPr>
+        <p:txBody>
+          <a:bodyPr wrap="square" anchor="t" lIns="0" rIns="0" tIns="0" bIns="0">
+            <a:spAutoFit/>
+          </a:bodyPr>
+          <a:lstStyle/>
+          <a:p>
+            <a:pPr algn="l">
+              <a:spcAft>
+                <a:spcPts val="600"/>
+              </a:spcAft>
+            </a:pPr>
+            <a:r>
+              <a:rPr sz="1400" b="1" i="0">
+                <a:solidFill>
+                  <a:srgbClr val="343174"/>
+                </a:solidFill>
+                <a:latin typeface="Calibri"/>
+              </a:rPr>
+              <a:t>SHAP: top 5 contributions (log-odds)</a:t>
+            </a:r>
+          </a:p>
+        </p:txBody>
+      </p:sp>
+      <p:sp>
+        <p:nvSpPr>
+          <p:cNvPr id="6" name="SHAP: top 5 contributions (log-odds) label 1"/>
+          <p:cNvSpPr txBox="1"/>
+          <p:nvPr/>
+        </p:nvSpPr>
+        <p:spPr>
+          <a:xfrm>
+            <a:off x="2240280" y="2112264"/>
+            <a:ext cx="1828800" cy="256032"/>
+          </a:xfrm>
+          <a:prstGeom prst="rect">
+            <a:avLst/>
+          </a:prstGeom>
+          <a:noFill/>
+        </p:spPr>
+        <p:txBody>
+          <a:bodyPr wrap="square" anchor="ctr" lIns="0" rIns="0" tIns="0" bIns="0">
+            <a:spAutoFit/>
+          </a:bodyPr>
+          <a:lstStyle/>
+          <a:p>
+            <a:pPr algn="l">
+              <a:spcAft>
+                <a:spcPts val="600"/>
+              </a:spcAft>
+            </a:pPr>
+            <a:r>
+              <a:rPr sz="1200" b="0" i="0">
+                <a:solidFill>
+                  <a:srgbClr val="22222A"/>
+                </a:solidFill>
+                <a:latin typeface="Calibri"/>
+              </a:rPr>
+              <a:t>Assessments submitted</a:t>
+            </a:r>
+          </a:p>
+        </p:txBody>
+      </p:sp>
+      <p:sp>
+        <p:nvSpPr>
+          <p:cNvPr id="7" name="SHAP: top 5 contributions (log-odds) bar 1"/>
+          <p:cNvSpPr/>
+          <p:nvPr/>
+        </p:nvSpPr>
+        <p:spPr>
+          <a:xfrm>
+            <a:off x="4206240" y="2157984"/>
+            <a:ext cx="1325880" cy="164592"/>
+          </a:xfrm>
+          <a:prstGeom prst="rect">
+            <a:avLst/>
+          </a:prstGeom>
+          <a:solidFill>
+            <a:srgbClr val="343174"/>
+          </a:solidFill>
+          <a:ln>
+            <a:noFill/>
+          </a:ln>
+          <a:effectLst/>
+        </p:spPr>
+        <p:txBody>
+          <a:bodyPr rtlCol="0" anchor="ctr"/>
+          <a:lstStyle/>
+          <a:p/>
+        </p:txBody>
+      </p:sp>
+      <p:sp>
+        <p:nvSpPr>
+          <p:cNvPr id="8" name="SHAP: top 5 contributions (log-odds) value 1"/>
+          <p:cNvSpPr txBox="1"/>
+          <p:nvPr/>
+        </p:nvSpPr>
+        <p:spPr>
+          <a:xfrm>
+            <a:off x="5605272" y="2112264"/>
+            <a:ext cx="548640" cy="256032"/>
+          </a:xfrm>
+          <a:prstGeom prst="rect">
+            <a:avLst/>
+          </a:prstGeom>
+          <a:noFill/>
+        </p:spPr>
+        <p:txBody>
+          <a:bodyPr wrap="square" anchor="ctr" lIns="0" rIns="0" tIns="0" bIns="0">
+            <a:spAutoFit/>
+          </a:bodyPr>
+          <a:lstStyle/>
+          <a:p>
+            <a:pPr algn="l">
+              <a:spcAft>
+                <a:spcPts val="600"/>
+              </a:spcAft>
+            </a:pPr>
+            <a:r>
+              <a:rPr sz="1200" b="0" i="0">
+                <a:solidFill>
+                  <a:srgbClr val="555560"/>
+                </a:solidFill>
+                <a:latin typeface="Calibri"/>
+              </a:rPr>
+              <a:t>+5.297</a:t>
+            </a:r>
+          </a:p>
+        </p:txBody>
+      </p:sp>
+      <p:sp>
+        <p:nvSpPr>
+          <p:cNvPr id="9" name="SHAP: top 5 contributions (log-odds) label 2"/>
+          <p:cNvSpPr txBox="1"/>
+          <p:nvPr/>
+        </p:nvSpPr>
+        <p:spPr>
+          <a:xfrm>
+            <a:off x="2240280" y="2395728"/>
+            <a:ext cx="1828800" cy="256032"/>
+          </a:xfrm>
+          <a:prstGeom prst="rect">
+            <a:avLst/>
+          </a:prstGeom>
+          <a:noFill/>
+        </p:spPr>
+        <p:txBody>
+          <a:bodyPr wrap="square" anchor="ctr" lIns="0" rIns="0" tIns="0" bIns="0">
+            <a:spAutoFit/>
+          </a:bodyPr>
+          <a:lstStyle/>
+          <a:p>
+            <a:pPr algn="l">
+              <a:spcAft>
+                <a:spcPts val="600"/>
+              </a:spcAft>
+            </a:pPr>
+            <a:r>
+              <a:rPr sz="1200" b="0" i="0">
+                <a:solidFill>
+                  <a:srgbClr val="22222A"/>
+                </a:solidFill>
+                <a:latin typeface="Calibri"/>
+              </a:rPr>
+              <a:t>Module: FFF</a:t>
+            </a:r>
+          </a:p>
+        </p:txBody>
+      </p:sp>
+      <p:sp>
+        <p:nvSpPr>
+          <p:cNvPr id="10" name="SHAP: top 5 contributions (log-odds) bar 2"/>
+          <p:cNvSpPr/>
+          <p:nvPr/>
+        </p:nvSpPr>
+        <p:spPr>
+          <a:xfrm>
+            <a:off x="4206240" y="2441448"/>
+            <a:ext cx="428026" cy="164592"/>
+          </a:xfrm>
+          <a:prstGeom prst="rect">
+            <a:avLst/>
+          </a:prstGeom>
+          <a:solidFill>
+            <a:srgbClr val="343174"/>
+          </a:solidFill>
+          <a:ln>
+            <a:noFill/>
+          </a:ln>
+          <a:effectLst/>
+        </p:spPr>
+        <p:txBody>
+          <a:bodyPr rtlCol="0" anchor="ctr"/>
+          <a:lstStyle/>
+          <a:p/>
+        </p:txBody>
+      </p:sp>
+      <p:sp>
+        <p:nvSpPr>
+          <p:cNvPr id="11" name="SHAP: top 5 contributions (log-odds) value 2"/>
+          <p:cNvSpPr txBox="1"/>
+          <p:nvPr/>
+        </p:nvSpPr>
+        <p:spPr>
+          <a:xfrm>
+            <a:off x="5605272" y="2395728"/>
+            <a:ext cx="548640" cy="256032"/>
+          </a:xfrm>
+          <a:prstGeom prst="rect">
+            <a:avLst/>
+          </a:prstGeom>
+          <a:noFill/>
+        </p:spPr>
+        <p:txBody>
+          <a:bodyPr wrap="square" anchor="ctr" lIns="0" rIns="0" tIns="0" bIns="0">
+            <a:spAutoFit/>
+          </a:bodyPr>
+          <a:lstStyle/>
+          <a:p>
+            <a:pPr algn="l">
+              <a:spcAft>
+                <a:spcPts val="600"/>
+              </a:spcAft>
+            </a:pPr>
+            <a:r>
+              <a:rPr sz="1200" b="0" i="0">
+                <a:solidFill>
+                  <a:srgbClr val="555560"/>
+                </a:solidFill>
+                <a:latin typeface="Calibri"/>
+              </a:rPr>
+              <a:t>+1.710</a:t>
+            </a:r>
+          </a:p>
+        </p:txBody>
+      </p:sp>
+      <p:sp>
+        <p:nvSpPr>
+          <p:cNvPr id="12" name="SHAP: top 5 contributions (log-odds) label 3"/>
+          <p:cNvSpPr txBox="1"/>
+          <p:nvPr/>
+        </p:nvSpPr>
+        <p:spPr>
+          <a:xfrm>
+            <a:off x="2240280" y="2679192"/>
+            <a:ext cx="1828800" cy="256032"/>
+          </a:xfrm>
+          <a:prstGeom prst="rect">
+            <a:avLst/>
+          </a:prstGeom>
+          <a:noFill/>
+        </p:spPr>
+        <p:txBody>
+          <a:bodyPr wrap="square" anchor="ctr" lIns="0" rIns="0" tIns="0" bIns="0">
+            <a:spAutoFit/>
+          </a:bodyPr>
+          <a:lstStyle/>
+          <a:p>
+            <a:pPr algn="l">
+              <a:spcAft>
+                <a:spcPts val="600"/>
+              </a:spcAft>
+            </a:pPr>
+            <a:r>
+              <a:rPr sz="1200" b="0" i="0">
+                <a:solidFill>
+                  <a:srgbClr val="22222A"/>
+                </a:solidFill>
+                <a:latin typeface="Calibri"/>
+              </a:rPr>
+              <a:t>Active days</a:t>
+            </a:r>
+          </a:p>
+        </p:txBody>
+      </p:sp>
+      <p:sp>
+        <p:nvSpPr>
+          <p:cNvPr id="13" name="SHAP: top 5 contributions (log-odds) bar 3"/>
+          <p:cNvSpPr/>
+          <p:nvPr/>
+        </p:nvSpPr>
+        <p:spPr>
+          <a:xfrm>
+            <a:off x="4206240" y="2724912"/>
+            <a:ext cx="288104" cy="164592"/>
+          </a:xfrm>
+          <a:prstGeom prst="rect">
+            <a:avLst/>
+          </a:prstGeom>
+          <a:solidFill>
+            <a:srgbClr val="343174"/>
+          </a:solidFill>
+          <a:ln>
+            <a:noFill/>
+          </a:ln>
+          <a:effectLst/>
+        </p:spPr>
+        <p:txBody>
+          <a:bodyPr rtlCol="0" anchor="ctr"/>
+          <a:lstStyle/>
+          <a:p/>
+        </p:txBody>
+      </p:sp>
+      <p:sp>
+        <p:nvSpPr>
+          <p:cNvPr id="14" name="SHAP: top 5 contributions (log-odds) value 3"/>
+          <p:cNvSpPr txBox="1"/>
+          <p:nvPr/>
+        </p:nvSpPr>
+        <p:spPr>
+          <a:xfrm>
+            <a:off x="5605272" y="2679192"/>
+            <a:ext cx="548640" cy="256032"/>
+          </a:xfrm>
+          <a:prstGeom prst="rect">
+            <a:avLst/>
+          </a:prstGeom>
+          <a:noFill/>
+        </p:spPr>
+        <p:txBody>
+          <a:bodyPr wrap="square" anchor="ctr" lIns="0" rIns="0" tIns="0" bIns="0">
+            <a:spAutoFit/>
+          </a:bodyPr>
+          <a:lstStyle/>
+          <a:p>
+            <a:pPr algn="l">
+              <a:spcAft>
+                <a:spcPts val="600"/>
+              </a:spcAft>
+            </a:pPr>
+            <a:r>
+              <a:rPr sz="1200" b="0" i="0">
+                <a:solidFill>
+                  <a:srgbClr val="555560"/>
+                </a:solidFill>
+                <a:latin typeface="Calibri"/>
+              </a:rPr>
+              <a:t>+1.151</a:t>
+            </a:r>
+          </a:p>
+        </p:txBody>
+      </p:sp>
+      <p:sp>
+        <p:nvSpPr>
+          <p:cNvPr id="15" name="SHAP: top 5 contributions (log-odds) label 4"/>
+          <p:cNvSpPr txBox="1"/>
+          <p:nvPr/>
+        </p:nvSpPr>
+        <p:spPr>
+          <a:xfrm>
+            <a:off x="2240280" y="2962656"/>
+            <a:ext cx="1828800" cy="256032"/>
+          </a:xfrm>
+          <a:prstGeom prst="rect">
+            <a:avLst/>
+          </a:prstGeom>
+          <a:noFill/>
+        </p:spPr>
+        <p:txBody>
+          <a:bodyPr wrap="square" anchor="ctr" lIns="0" rIns="0" tIns="0" bIns="0">
+            <a:spAutoFit/>
+          </a:bodyPr>
+          <a:lstStyle/>
+          <a:p>
+            <a:pPr algn="l">
+              <a:spcAft>
+                <a:spcPts val="600"/>
+              </a:spcAft>
+            </a:pPr>
+            <a:r>
+              <a:rPr sz="1200" b="0" i="0">
+                <a:solidFill>
+                  <a:srgbClr val="22222A"/>
+                </a:solidFill>
+                <a:latin typeface="Calibri"/>
+              </a:rPr>
+              <a:t>Total VLE clicks</a:t>
+            </a:r>
+          </a:p>
+        </p:txBody>
+      </p:sp>
+      <p:sp>
+        <p:nvSpPr>
+          <p:cNvPr id="16" name="SHAP: top 5 contributions (log-odds) bar 4"/>
+          <p:cNvSpPr/>
+          <p:nvPr/>
+        </p:nvSpPr>
+        <p:spPr>
+          <a:xfrm>
+            <a:off x="4206240" y="3008376"/>
+            <a:ext cx="189482" cy="164592"/>
+          </a:xfrm>
+          <a:prstGeom prst="rect">
+            <a:avLst/>
+          </a:prstGeom>
+          <a:solidFill>
+            <a:srgbClr val="343174"/>
+          </a:solidFill>
+          <a:ln>
+            <a:noFill/>
+          </a:ln>
+          <a:effectLst/>
+        </p:spPr>
+        <p:txBody>
+          <a:bodyPr rtlCol="0" anchor="ctr"/>
+          <a:lstStyle/>
+          <a:p/>
+        </p:txBody>
+      </p:sp>
+      <p:sp>
+        <p:nvSpPr>
+          <p:cNvPr id="17" name="SHAP: top 5 contributions (log-odds) value 4"/>
+          <p:cNvSpPr txBox="1"/>
+          <p:nvPr/>
+        </p:nvSpPr>
+        <p:spPr>
+          <a:xfrm>
+            <a:off x="5605272" y="2962656"/>
+            <a:ext cx="548640" cy="256032"/>
+          </a:xfrm>
+          <a:prstGeom prst="rect">
+            <a:avLst/>
+          </a:prstGeom>
+          <a:noFill/>
+        </p:spPr>
+        <p:txBody>
+          <a:bodyPr wrap="square" anchor="ctr" lIns="0" rIns="0" tIns="0" bIns="0">
+            <a:spAutoFit/>
+          </a:bodyPr>
+          <a:lstStyle/>
+          <a:p>
+            <a:pPr algn="l">
+              <a:spcAft>
+                <a:spcPts val="600"/>
+              </a:spcAft>
+            </a:pPr>
+            <a:r>
+              <a:rPr sz="1200" b="0" i="0">
+                <a:solidFill>
+                  <a:srgbClr val="555560"/>
+                </a:solidFill>
+                <a:latin typeface="Calibri"/>
+              </a:rPr>
+              <a:t>+0.757</a:t>
+            </a:r>
+          </a:p>
+        </p:txBody>
+      </p:sp>
+      <p:sp>
+        <p:nvSpPr>
+          <p:cNvPr id="18" name="SHAP: top 5 contributions (log-odds) label 5"/>
+          <p:cNvSpPr txBox="1"/>
+          <p:nvPr/>
+        </p:nvSpPr>
+        <p:spPr>
+          <a:xfrm>
+            <a:off x="2240280" y="3246120"/>
+            <a:ext cx="1828800" cy="256032"/>
+          </a:xfrm>
+          <a:prstGeom prst="rect">
+            <a:avLst/>
+          </a:prstGeom>
+          <a:noFill/>
+        </p:spPr>
+        <p:txBody>
+          <a:bodyPr wrap="square" anchor="ctr" lIns="0" rIns="0" tIns="0" bIns="0">
+            <a:spAutoFit/>
+          </a:bodyPr>
+          <a:lstStyle/>
+          <a:p>
+            <a:pPr algn="l">
+              <a:spcAft>
+                <a:spcPts val="600"/>
+              </a:spcAft>
+            </a:pPr>
+            <a:r>
+              <a:rPr sz="1200" b="0" i="0">
+                <a:solidFill>
+                  <a:srgbClr val="22222A"/>
+                </a:solidFill>
+                <a:latin typeface="Calibri"/>
+              </a:rPr>
+              <a:t>Clicks, 28d before deadlines</a:t>
+            </a:r>
+          </a:p>
+        </p:txBody>
+      </p:sp>
+      <p:sp>
+        <p:nvSpPr>
+          <p:cNvPr id="19" name="SHAP: top 5 contributions (log-odds) bar 5"/>
+          <p:cNvSpPr/>
+          <p:nvPr/>
+        </p:nvSpPr>
+        <p:spPr>
+          <a:xfrm>
+            <a:off x="4116629" y="3291839"/>
+            <a:ext cx="89610" cy="164592"/>
+          </a:xfrm>
+          <a:prstGeom prst="rect">
+            <a:avLst/>
+          </a:prstGeom>
+          <a:solidFill>
+            <a:srgbClr val="8E91A8"/>
+          </a:solidFill>
+          <a:ln>
+            <a:noFill/>
+          </a:ln>
+          <a:effectLst/>
+        </p:spPr>
+        <p:txBody>
+          <a:bodyPr rtlCol="0" anchor="ctr"/>
+          <a:lstStyle/>
+          <a:p/>
+        </p:txBody>
+      </p:sp>
+      <p:sp>
+        <p:nvSpPr>
+          <p:cNvPr id="20" name="SHAP: top 5 contributions (log-odds) value 5"/>
+          <p:cNvSpPr txBox="1"/>
+          <p:nvPr/>
+        </p:nvSpPr>
+        <p:spPr>
+          <a:xfrm>
+            <a:off x="5605272" y="3246120"/>
+            <a:ext cx="548640" cy="256032"/>
+          </a:xfrm>
+          <a:prstGeom prst="rect">
+            <a:avLst/>
+          </a:prstGeom>
+          <a:noFill/>
+        </p:spPr>
+        <p:txBody>
+          <a:bodyPr wrap="square" anchor="ctr" lIns="0" rIns="0" tIns="0" bIns="0">
+            <a:spAutoFit/>
+          </a:bodyPr>
+          <a:lstStyle/>
+          <a:p>
+            <a:pPr algn="l">
+              <a:spcAft>
+                <a:spcPts val="600"/>
+              </a:spcAft>
+            </a:pPr>
+            <a:r>
+              <a:rPr sz="1200" b="0" i="0">
+                <a:solidFill>
+                  <a:srgbClr val="555560"/>
+                </a:solidFill>
+                <a:latin typeface="Calibri"/>
+              </a:rPr>
+              <a:t>-0.358</a:t>
+            </a:r>
+          </a:p>
+        </p:txBody>
+      </p:sp>
+      <p:cxnSp>
+        <p:nvCxnSpPr>
+          <p:cNvPr id="21" name="Connector 20"/>
+          <p:cNvCxnSpPr/>
+          <p:nvPr/>
+        </p:nvCxnSpPr>
+        <p:spPr>
+          <a:xfrm>
+            <a:off x="4206240" y="2112264"/>
+            <a:ext cx="0" cy="1417320"/>
+          </a:xfrm>
+          <a:prstGeom prst="line">
+            <a:avLst/>
+          </a:prstGeom>
+          <a:ln>
             <a:solidFill>
               <a:srgbClr val="C9CAD3"/>
             </a:solidFill>
           </a:ln>
         </p:spPr>
-      </p:pic>
-      <p:sp>
-        <p:nvSpPr>
-          <p:cNvPr id="6" name="Moodle 5.2 caption"/>
+        <p:style>
+          <a:lnRef idx="2">
+            <a:schemeClr val="accent1"/>
+          </a:lnRef>
+          <a:fillRef idx="0">
+            <a:schemeClr val="accent1"/>
+          </a:fillRef>
+          <a:effectRef idx="1">
+            <a:schemeClr val="accent1"/>
+          </a:effectRef>
+          <a:fontRef idx="minor">
+            <a:schemeClr val="tx1"/>
+          </a:fontRef>
+        </p:style>
+      </p:cxnSp>
+      <p:sp>
+        <p:nvSpPr>
+          <p:cNvPr id="22" name="LIME: top 5 local rules (weights)"/>
           <p:cNvSpPr txBox="1"/>
           <p:nvPr/>
         </p:nvSpPr>
         <p:spPr>
           <a:xfrm>
-            <a:off x="2240280" y="4031614"/>
-            <a:ext cx="3040379" cy="914400"/>
+            <a:off x="2240280" y="3657600"/>
+            <a:ext cx="3840480" cy="274320"/>
           </a:xfrm>
           <a:prstGeom prst="rect">
             <a:avLst/>
@@ -16326,27 +16981,27 @@
               </a:spcAft>
             </a:pPr>
             <a:r>
-              <a:rPr sz="1400" b="0" i="0">
-                <a:solidFill>
-                  <a:srgbClr val="22222A"/>
-                </a:solidFill>
-                <a:latin typeface="Calibri"/>
-              </a:rPr>
-              <a:t>Native plugin: At-risk insights in each course's menu, using Moodle login, roles and enrolments</a:t>
-            </a:r>
-          </a:p>
-        </p:txBody>
-      </p:sp>
-      <p:sp>
-        <p:nvSpPr>
-          <p:cNvPr id="7" name="Canvas label"/>
+              <a:rPr sz="1400" b="1" i="0">
+                <a:solidFill>
+                  <a:srgbClr val="343174"/>
+                </a:solidFill>
+                <a:latin typeface="Calibri"/>
+              </a:rPr>
+              <a:t>LIME: top 5 local rules (weights)</a:t>
+            </a:r>
+          </a:p>
+        </p:txBody>
+      </p:sp>
+      <p:sp>
+        <p:nvSpPr>
+          <p:cNvPr id="23" name="LIME: top 5 local rules (weights) label 1"/>
           <p:cNvSpPr txBox="1"/>
           <p:nvPr/>
         </p:nvSpPr>
         <p:spPr>
           <a:xfrm>
-            <a:off x="5509260" y="1344168"/>
-            <a:ext cx="3040379" cy="365760"/>
+            <a:off x="2240280" y="3986784"/>
+            <a:ext cx="1828800" cy="256032"/>
           </a:xfrm>
           <a:prstGeom prst="rect">
             <a:avLst/>
@@ -16354,7 +17009,7 @@
           <a:noFill/>
         </p:spPr>
         <p:txBody>
-          <a:bodyPr wrap="square" anchor="t" lIns="0" rIns="0" tIns="0" bIns="0">
+          <a:bodyPr wrap="square" anchor="ctr" lIns="0" rIns="0" tIns="0" bIns="0">
             <a:spAutoFit/>
           </a:bodyPr>
           <a:lstStyle/>
@@ -16365,56 +17020,581 @@
               </a:spcAft>
             </a:pPr>
             <a:r>
-              <a:rPr sz="1800" b="1" i="0">
-                <a:solidFill>
-                  <a:srgbClr val="343174"/>
-                </a:solidFill>
-                <a:latin typeface="Calibri"/>
-              </a:rPr>
-              <a:t>Canvas</a:t>
-            </a:r>
-          </a:p>
-        </p:txBody>
-      </p:sp>
-      <p:pic>
-        <p:nvPicPr>
-          <p:cNvPr id="8" name="Canvas screenshot" descr="canvas_embed.png"/>
-          <p:cNvPicPr>
-            <a:picLocks noChangeAspect="1"/>
-          </p:cNvPicPr>
-          <p:nvPr/>
-        </p:nvPicPr>
-        <p:blipFill>
-          <a:blip r:embed="rId4"/>
-          <a:stretch>
-            <a:fillRect/>
-          </a:stretch>
-        </p:blipFill>
-        <p:spPr>
-          <a:xfrm>
-            <a:off x="5509260" y="1783080"/>
-            <a:ext cx="3040379" cy="2111374"/>
-          </a:xfrm>
-          <a:prstGeom prst="rect">
-            <a:avLst/>
-          </a:prstGeom>
-          <a:ln w="9525">
+              <a:rPr sz="1200" b="0" i="0">
+                <a:solidFill>
+                  <a:srgbClr val="22222A"/>
+                </a:solidFill>
+                <a:latin typeface="Calibri"/>
+              </a:rPr>
+              <a:t>Assessments submitted ≤ 1</a:t>
+            </a:r>
+          </a:p>
+        </p:txBody>
+      </p:sp>
+      <p:sp>
+        <p:nvSpPr>
+          <p:cNvPr id="24" name="LIME: top 5 local rules (weights) bar 1"/>
+          <p:cNvSpPr/>
+          <p:nvPr/>
+        </p:nvSpPr>
+        <p:spPr>
+          <a:xfrm>
+            <a:off x="4206240" y="4032504"/>
+            <a:ext cx="1325880" cy="164592"/>
+          </a:xfrm>
+          <a:prstGeom prst="rect">
+            <a:avLst/>
+          </a:prstGeom>
+          <a:solidFill>
+            <a:srgbClr val="343174"/>
+          </a:solidFill>
+          <a:ln>
+            <a:noFill/>
+          </a:ln>
+          <a:effectLst/>
+        </p:spPr>
+        <p:txBody>
+          <a:bodyPr rtlCol="0" anchor="ctr"/>
+          <a:lstStyle/>
+          <a:p/>
+        </p:txBody>
+      </p:sp>
+      <p:sp>
+        <p:nvSpPr>
+          <p:cNvPr id="25" name="LIME: top 5 local rules (weights) value 1"/>
+          <p:cNvSpPr txBox="1"/>
+          <p:nvPr/>
+        </p:nvSpPr>
+        <p:spPr>
+          <a:xfrm>
+            <a:off x="5605272" y="3986784"/>
+            <a:ext cx="548640" cy="256032"/>
+          </a:xfrm>
+          <a:prstGeom prst="rect">
+            <a:avLst/>
+          </a:prstGeom>
+          <a:noFill/>
+        </p:spPr>
+        <p:txBody>
+          <a:bodyPr wrap="square" anchor="ctr" lIns="0" rIns="0" tIns="0" bIns="0">
+            <a:spAutoFit/>
+          </a:bodyPr>
+          <a:lstStyle/>
+          <a:p>
+            <a:pPr algn="l">
+              <a:spcAft>
+                <a:spcPts val="600"/>
+              </a:spcAft>
+            </a:pPr>
+            <a:r>
+              <a:rPr sz="1200" b="0" i="0">
+                <a:solidFill>
+                  <a:srgbClr val="555560"/>
+                </a:solidFill>
+                <a:latin typeface="Calibri"/>
+              </a:rPr>
+              <a:t>+0.360</a:t>
+            </a:r>
+          </a:p>
+        </p:txBody>
+      </p:sp>
+      <p:sp>
+        <p:nvSpPr>
+          <p:cNvPr id="26" name="LIME: top 5 local rules (weights) label 2"/>
+          <p:cNvSpPr txBox="1"/>
+          <p:nvPr/>
+        </p:nvSpPr>
+        <p:spPr>
+          <a:xfrm>
+            <a:off x="2240280" y="4270248"/>
+            <a:ext cx="1828800" cy="256032"/>
+          </a:xfrm>
+          <a:prstGeom prst="rect">
+            <a:avLst/>
+          </a:prstGeom>
+          <a:noFill/>
+        </p:spPr>
+        <p:txBody>
+          <a:bodyPr wrap="square" anchor="ctr" lIns="0" rIns="0" tIns="0" bIns="0">
+            <a:spAutoFit/>
+          </a:bodyPr>
+          <a:lstStyle/>
+          <a:p>
+            <a:pPr algn="l">
+              <a:spcAft>
+                <a:spcPts val="600"/>
+              </a:spcAft>
+            </a:pPr>
+            <a:r>
+              <a:rPr sz="1200" b="0" i="0">
+                <a:solidFill>
+                  <a:srgbClr val="22222A"/>
+                </a:solidFill>
+                <a:latin typeface="Calibri"/>
+              </a:rPr>
+              <a:t>Module is not AAA</a:t>
+            </a:r>
+          </a:p>
+        </p:txBody>
+      </p:sp>
+      <p:sp>
+        <p:nvSpPr>
+          <p:cNvPr id="27" name="LIME: top 5 local rules (weights) bar 2"/>
+          <p:cNvSpPr/>
+          <p:nvPr/>
+        </p:nvSpPr>
+        <p:spPr>
+          <a:xfrm>
+            <a:off x="4206240" y="4315968"/>
+            <a:ext cx="607695" cy="164592"/>
+          </a:xfrm>
+          <a:prstGeom prst="rect">
+            <a:avLst/>
+          </a:prstGeom>
+          <a:solidFill>
+            <a:srgbClr val="343174"/>
+          </a:solidFill>
+          <a:ln>
+            <a:noFill/>
+          </a:ln>
+          <a:effectLst/>
+        </p:spPr>
+        <p:txBody>
+          <a:bodyPr rtlCol="0" anchor="ctr"/>
+          <a:lstStyle/>
+          <a:p/>
+        </p:txBody>
+      </p:sp>
+      <p:sp>
+        <p:nvSpPr>
+          <p:cNvPr id="28" name="LIME: top 5 local rules (weights) value 2"/>
+          <p:cNvSpPr txBox="1"/>
+          <p:nvPr/>
+        </p:nvSpPr>
+        <p:spPr>
+          <a:xfrm>
+            <a:off x="5605272" y="4270248"/>
+            <a:ext cx="548640" cy="256032"/>
+          </a:xfrm>
+          <a:prstGeom prst="rect">
+            <a:avLst/>
+          </a:prstGeom>
+          <a:noFill/>
+        </p:spPr>
+        <p:txBody>
+          <a:bodyPr wrap="square" anchor="ctr" lIns="0" rIns="0" tIns="0" bIns="0">
+            <a:spAutoFit/>
+          </a:bodyPr>
+          <a:lstStyle/>
+          <a:p>
+            <a:pPr algn="l">
+              <a:spcAft>
+                <a:spcPts val="600"/>
+              </a:spcAft>
+            </a:pPr>
+            <a:r>
+              <a:rPr sz="1200" b="0" i="0">
+                <a:solidFill>
+                  <a:srgbClr val="555560"/>
+                </a:solidFill>
+                <a:latin typeface="Calibri"/>
+              </a:rPr>
+              <a:t>+0.165</a:t>
+            </a:r>
+          </a:p>
+        </p:txBody>
+      </p:sp>
+      <p:sp>
+        <p:nvSpPr>
+          <p:cNvPr id="29" name="LIME: top 5 local rules (weights) label 3"/>
+          <p:cNvSpPr txBox="1"/>
+          <p:nvPr/>
+        </p:nvSpPr>
+        <p:spPr>
+          <a:xfrm>
+            <a:off x="2240280" y="4553712"/>
+            <a:ext cx="1828800" cy="256032"/>
+          </a:xfrm>
+          <a:prstGeom prst="rect">
+            <a:avLst/>
+          </a:prstGeom>
+          <a:noFill/>
+        </p:spPr>
+        <p:txBody>
+          <a:bodyPr wrap="square" anchor="ctr" lIns="0" rIns="0" tIns="0" bIns="0">
+            <a:spAutoFit/>
+          </a:bodyPr>
+          <a:lstStyle/>
+          <a:p>
+            <a:pPr algn="l">
+              <a:spcAft>
+                <a:spcPts val="600"/>
+              </a:spcAft>
+            </a:pPr>
+            <a:r>
+              <a:rPr sz="1200" b="0" i="0">
+                <a:solidFill>
+                  <a:srgbClr val="22222A"/>
+                </a:solidFill>
+                <a:latin typeface="Calibri"/>
+              </a:rPr>
+              <a:t>Module is FFF</a:t>
+            </a:r>
+          </a:p>
+        </p:txBody>
+      </p:sp>
+      <p:sp>
+        <p:nvSpPr>
+          <p:cNvPr id="30" name="LIME: top 5 local rules (weights) bar 3"/>
+          <p:cNvSpPr/>
+          <p:nvPr/>
+        </p:nvSpPr>
+        <p:spPr>
+          <a:xfrm>
+            <a:off x="4206240" y="4599432"/>
+            <a:ext cx="530352" cy="164592"/>
+          </a:xfrm>
+          <a:prstGeom prst="rect">
+            <a:avLst/>
+          </a:prstGeom>
+          <a:solidFill>
+            <a:srgbClr val="343174"/>
+          </a:solidFill>
+          <a:ln>
+            <a:noFill/>
+          </a:ln>
+          <a:effectLst/>
+        </p:spPr>
+        <p:txBody>
+          <a:bodyPr rtlCol="0" anchor="ctr"/>
+          <a:lstStyle/>
+          <a:p/>
+        </p:txBody>
+      </p:sp>
+      <p:sp>
+        <p:nvSpPr>
+          <p:cNvPr id="31" name="LIME: top 5 local rules (weights) value 3"/>
+          <p:cNvSpPr txBox="1"/>
+          <p:nvPr/>
+        </p:nvSpPr>
+        <p:spPr>
+          <a:xfrm>
+            <a:off x="5605272" y="4553712"/>
+            <a:ext cx="548640" cy="256032"/>
+          </a:xfrm>
+          <a:prstGeom prst="rect">
+            <a:avLst/>
+          </a:prstGeom>
+          <a:noFill/>
+        </p:spPr>
+        <p:txBody>
+          <a:bodyPr wrap="square" anchor="ctr" lIns="0" rIns="0" tIns="0" bIns="0">
+            <a:spAutoFit/>
+          </a:bodyPr>
+          <a:lstStyle/>
+          <a:p>
+            <a:pPr algn="l">
+              <a:spcAft>
+                <a:spcPts val="600"/>
+              </a:spcAft>
+            </a:pPr>
+            <a:r>
+              <a:rPr sz="1200" b="0" i="0">
+                <a:solidFill>
+                  <a:srgbClr val="555560"/>
+                </a:solidFill>
+                <a:latin typeface="Calibri"/>
+              </a:rPr>
+              <a:t>+0.144</a:t>
+            </a:r>
+          </a:p>
+        </p:txBody>
+      </p:sp>
+      <p:sp>
+        <p:nvSpPr>
+          <p:cNvPr id="32" name="LIME: top 5 local rules (weights) label 4"/>
+          <p:cNvSpPr txBox="1"/>
+          <p:nvPr/>
+        </p:nvSpPr>
+        <p:spPr>
+          <a:xfrm>
+            <a:off x="2240280" y="4837176"/>
+            <a:ext cx="1828800" cy="256032"/>
+          </a:xfrm>
+          <a:prstGeom prst="rect">
+            <a:avLst/>
+          </a:prstGeom>
+          <a:noFill/>
+        </p:spPr>
+        <p:txBody>
+          <a:bodyPr wrap="square" anchor="ctr" lIns="0" rIns="0" tIns="0" bIns="0">
+            <a:spAutoFit/>
+          </a:bodyPr>
+          <a:lstStyle/>
+          <a:p>
+            <a:pPr algn="l">
+              <a:spcAft>
+                <a:spcPts val="600"/>
+              </a:spcAft>
+            </a:pPr>
+            <a:r>
+              <a:rPr sz="1200" b="0" i="0">
+                <a:solidFill>
+                  <a:srgbClr val="22222A"/>
+                </a:solidFill>
+                <a:latin typeface="Calibri"/>
+              </a:rPr>
+              <a:t>Active days ≤ 11</a:t>
+            </a:r>
+          </a:p>
+        </p:txBody>
+      </p:sp>
+      <p:sp>
+        <p:nvSpPr>
+          <p:cNvPr id="33" name="LIME: top 5 local rules (weights) bar 4"/>
+          <p:cNvSpPr/>
+          <p:nvPr/>
+        </p:nvSpPr>
+        <p:spPr>
+          <a:xfrm>
+            <a:off x="4206240" y="4882896"/>
+            <a:ext cx="232029" cy="164592"/>
+          </a:xfrm>
+          <a:prstGeom prst="rect">
+            <a:avLst/>
+          </a:prstGeom>
+          <a:solidFill>
+            <a:srgbClr val="343174"/>
+          </a:solidFill>
+          <a:ln>
+            <a:noFill/>
+          </a:ln>
+          <a:effectLst/>
+        </p:spPr>
+        <p:txBody>
+          <a:bodyPr rtlCol="0" anchor="ctr"/>
+          <a:lstStyle/>
+          <a:p/>
+        </p:txBody>
+      </p:sp>
+      <p:sp>
+        <p:nvSpPr>
+          <p:cNvPr id="34" name="LIME: top 5 local rules (weights) value 4"/>
+          <p:cNvSpPr txBox="1"/>
+          <p:nvPr/>
+        </p:nvSpPr>
+        <p:spPr>
+          <a:xfrm>
+            <a:off x="5605272" y="4837176"/>
+            <a:ext cx="548640" cy="256032"/>
+          </a:xfrm>
+          <a:prstGeom prst="rect">
+            <a:avLst/>
+          </a:prstGeom>
+          <a:noFill/>
+        </p:spPr>
+        <p:txBody>
+          <a:bodyPr wrap="square" anchor="ctr" lIns="0" rIns="0" tIns="0" bIns="0">
+            <a:spAutoFit/>
+          </a:bodyPr>
+          <a:lstStyle/>
+          <a:p>
+            <a:pPr algn="l">
+              <a:spcAft>
+                <a:spcPts val="600"/>
+              </a:spcAft>
+            </a:pPr>
+            <a:r>
+              <a:rPr sz="1200" b="0" i="0">
+                <a:solidFill>
+                  <a:srgbClr val="555560"/>
+                </a:solidFill>
+                <a:latin typeface="Calibri"/>
+              </a:rPr>
+              <a:t>+0.063</a:t>
+            </a:r>
+          </a:p>
+        </p:txBody>
+      </p:sp>
+      <p:sp>
+        <p:nvSpPr>
+          <p:cNvPr id="35" name="LIME: top 5 local rules (weights) label 5"/>
+          <p:cNvSpPr txBox="1"/>
+          <p:nvPr/>
+        </p:nvSpPr>
+        <p:spPr>
+          <a:xfrm>
+            <a:off x="2240280" y="5120640"/>
+            <a:ext cx="1828800" cy="256032"/>
+          </a:xfrm>
+          <a:prstGeom prst="rect">
+            <a:avLst/>
+          </a:prstGeom>
+          <a:noFill/>
+        </p:spPr>
+        <p:txBody>
+          <a:bodyPr wrap="square" anchor="ctr" lIns="0" rIns="0" tIns="0" bIns="0">
+            <a:spAutoFit/>
+          </a:bodyPr>
+          <a:lstStyle/>
+          <a:p>
+            <a:pPr algn="l">
+              <a:spcAft>
+                <a:spcPts val="600"/>
+              </a:spcAft>
+            </a:pPr>
+            <a:r>
+              <a:rPr sz="1200" b="0" i="0">
+                <a:solidFill>
+                  <a:srgbClr val="22222A"/>
+                </a:solidFill>
+                <a:latin typeface="Calibri"/>
+              </a:rPr>
+              <a:t>Total VLE clicks ≤ 142</a:t>
+            </a:r>
+          </a:p>
+        </p:txBody>
+      </p:sp>
+      <p:sp>
+        <p:nvSpPr>
+          <p:cNvPr id="36" name="LIME: top 5 local rules (weights) bar 5"/>
+          <p:cNvSpPr/>
+          <p:nvPr/>
+        </p:nvSpPr>
+        <p:spPr>
+          <a:xfrm>
+            <a:off x="4206240" y="5166360"/>
+            <a:ext cx="184150" cy="164592"/>
+          </a:xfrm>
+          <a:prstGeom prst="rect">
+            <a:avLst/>
+          </a:prstGeom>
+          <a:solidFill>
+            <a:srgbClr val="343174"/>
+          </a:solidFill>
+          <a:ln>
+            <a:noFill/>
+          </a:ln>
+          <a:effectLst/>
+        </p:spPr>
+        <p:txBody>
+          <a:bodyPr rtlCol="0" anchor="ctr"/>
+          <a:lstStyle/>
+          <a:p/>
+        </p:txBody>
+      </p:sp>
+      <p:sp>
+        <p:nvSpPr>
+          <p:cNvPr id="37" name="LIME: top 5 local rules (weights) value 5"/>
+          <p:cNvSpPr txBox="1"/>
+          <p:nvPr/>
+        </p:nvSpPr>
+        <p:spPr>
+          <a:xfrm>
+            <a:off x="5605272" y="5120640"/>
+            <a:ext cx="548640" cy="256032"/>
+          </a:xfrm>
+          <a:prstGeom prst="rect">
+            <a:avLst/>
+          </a:prstGeom>
+          <a:noFill/>
+        </p:spPr>
+        <p:txBody>
+          <a:bodyPr wrap="square" anchor="ctr" lIns="0" rIns="0" tIns="0" bIns="0">
+            <a:spAutoFit/>
+          </a:bodyPr>
+          <a:lstStyle/>
+          <a:p>
+            <a:pPr algn="l">
+              <a:spcAft>
+                <a:spcPts val="600"/>
+              </a:spcAft>
+            </a:pPr>
+            <a:r>
+              <a:rPr sz="1200" b="0" i="0">
+                <a:solidFill>
+                  <a:srgbClr val="555560"/>
+                </a:solidFill>
+                <a:latin typeface="Calibri"/>
+              </a:rPr>
+              <a:t>+0.050</a:t>
+            </a:r>
+          </a:p>
+        </p:txBody>
+      </p:sp>
+      <p:cxnSp>
+        <p:nvCxnSpPr>
+          <p:cNvPr id="38" name="Connector 37"/>
+          <p:cNvCxnSpPr/>
+          <p:nvPr/>
+        </p:nvCxnSpPr>
+        <p:spPr>
+          <a:xfrm>
+            <a:off x="4206240" y="3986784"/>
+            <a:ext cx="0" cy="1417320"/>
+          </a:xfrm>
+          <a:prstGeom prst="line">
+            <a:avLst/>
+          </a:prstGeom>
+          <a:ln>
             <a:solidFill>
               <a:srgbClr val="C9CAD3"/>
             </a:solidFill>
           </a:ln>
         </p:spPr>
-      </p:pic>
-      <p:sp>
-        <p:nvSpPr>
-          <p:cNvPr id="9" name="Canvas caption"/>
+        <p:style>
+          <a:lnRef idx="2">
+            <a:schemeClr val="accent1"/>
+          </a:lnRef>
+          <a:fillRef idx="0">
+            <a:schemeClr val="accent1"/>
+          </a:fillRef>
+          <a:effectRef idx="1">
+            <a:schemeClr val="accent1"/>
+          </a:effectRef>
+          <a:fontRef idx="minor">
+            <a:schemeClr val="tx1"/>
+          </a:fontRef>
+        </p:style>
+      </p:cxnSp>
+      <p:sp>
+        <p:nvSpPr>
+          <p:cNvPr id="39" name="Legend toward"/>
+          <p:cNvSpPr/>
+          <p:nvPr/>
+        </p:nvSpPr>
+        <p:spPr>
+          <a:xfrm>
+            <a:off x="2240280" y="5532120"/>
+            <a:ext cx="146304" cy="146304"/>
+          </a:xfrm>
+          <a:prstGeom prst="rect">
+            <a:avLst/>
+          </a:prstGeom>
+          <a:solidFill>
+            <a:srgbClr val="343174"/>
+          </a:solidFill>
+          <a:ln>
+            <a:noFill/>
+          </a:ln>
+          <a:effectLst/>
+        </p:spPr>
+        <p:txBody>
+          <a:bodyPr rtlCol="0" anchor="ctr"/>
+          <a:lstStyle/>
+          <a:p/>
+        </p:txBody>
+      </p:sp>
+      <p:sp>
+        <p:nvSpPr>
+          <p:cNvPr id="40" name="Legend toward text"/>
           <p:cNvSpPr txBox="1"/>
           <p:nvPr/>
         </p:nvSpPr>
         <p:spPr>
           <a:xfrm>
-            <a:off x="5509260" y="4031614"/>
-            <a:ext cx="3040379" cy="914400"/>
+            <a:off x="2459736" y="5458968"/>
+            <a:ext cx="1737360" cy="292608"/>
           </a:xfrm>
           <a:prstGeom prst="rect">
             <a:avLst/>
@@ -16433,27 +17613,94 @@
               </a:spcAft>
             </a:pPr>
             <a:r>
-              <a:rPr sz="1400" b="0" i="0">
-                <a:solidFill>
-                  <a:srgbClr val="22222A"/>
-                </a:solidFill>
-                <a:latin typeface="Calibri"/>
-              </a:rPr>
-              <a:t>Dashboard embedded in the course through an External URL module item</a:t>
-            </a:r>
-          </a:p>
-        </p:txBody>
-      </p:sp>
-      <p:sp>
-        <p:nvSpPr>
-          <p:cNvPr id="10" name="LMS facts band"/>
+              <a:rPr sz="1200" b="0" i="0">
+                <a:solidFill>
+                  <a:srgbClr val="555560"/>
+                </a:solidFill>
+                <a:latin typeface="Calibri"/>
+              </a:rPr>
+              <a:t>pushes towards at-risk</a:t>
+            </a:r>
+          </a:p>
+        </p:txBody>
+      </p:sp>
+      <p:sp>
+        <p:nvSpPr>
+          <p:cNvPr id="41" name="Legend away"/>
           <p:cNvSpPr/>
           <p:nvPr/>
         </p:nvSpPr>
         <p:spPr>
           <a:xfrm>
-            <a:off x="2240280" y="5120640"/>
-            <a:ext cx="6309359" cy="868680"/>
+            <a:off x="4206240" y="5532120"/>
+            <a:ext cx="146304" cy="146304"/>
+          </a:xfrm>
+          <a:prstGeom prst="rect">
+            <a:avLst/>
+          </a:prstGeom>
+          <a:solidFill>
+            <a:srgbClr val="8E91A8"/>
+          </a:solidFill>
+          <a:ln>
+            <a:noFill/>
+          </a:ln>
+          <a:effectLst/>
+        </p:spPr>
+        <p:txBody>
+          <a:bodyPr rtlCol="0" anchor="ctr"/>
+          <a:lstStyle/>
+          <a:p/>
+        </p:txBody>
+      </p:sp>
+      <p:sp>
+        <p:nvSpPr>
+          <p:cNvPr id="42" name="Legend away text"/>
+          <p:cNvSpPr txBox="1"/>
+          <p:nvPr/>
+        </p:nvSpPr>
+        <p:spPr>
+          <a:xfrm>
+            <a:off x="4425696" y="5458968"/>
+            <a:ext cx="1737360" cy="292608"/>
+          </a:xfrm>
+          <a:prstGeom prst="rect">
+            <a:avLst/>
+          </a:prstGeom>
+          <a:noFill/>
+        </p:spPr>
+        <p:txBody>
+          <a:bodyPr wrap="square" anchor="t" lIns="0" rIns="0" tIns="0" bIns="0">
+            <a:spAutoFit/>
+          </a:bodyPr>
+          <a:lstStyle/>
+          <a:p>
+            <a:pPr algn="l">
+              <a:spcAft>
+                <a:spcPts val="600"/>
+              </a:spcAft>
+            </a:pPr>
+            <a:r>
+              <a:rPr sz="1200" b="0" i="0">
+                <a:solidFill>
+                  <a:srgbClr val="555560"/>
+                </a:solidFill>
+                <a:latin typeface="Calibri"/>
+              </a:rPr>
+              <a:t>pushes away</a:t>
+            </a:r>
+          </a:p>
+        </p:txBody>
+      </p:sp>
+      <p:sp>
+        <p:nvSpPr>
+          <p:cNvPr id="43" name="Reading guide card"/>
+          <p:cNvSpPr/>
+          <p:nvPr/>
+        </p:nvSpPr>
+        <p:spPr>
+          <a:xfrm>
+            <a:off x="6309360" y="1783080"/>
+            <a:ext cx="2240279" cy="4251960"/>
           </a:xfrm>
           <a:prstGeom prst="rect">
             <a:avLst/>
@@ -16474,14 +17721,14 @@
       </p:sp>
       <p:sp>
         <p:nvSpPr>
-          <p:cNvPr id="11" name="LMS facts"/>
+          <p:cNvPr id="44" name="Reading guide"/>
           <p:cNvSpPr txBox="1"/>
           <p:nvPr/>
         </p:nvSpPr>
         <p:spPr>
           <a:xfrm>
-            <a:off x="2423160" y="5120640"/>
-            <a:ext cx="5943599" cy="868680"/>
+            <a:off x="6446520" y="1874519"/>
+            <a:ext cx="1965959" cy="4069080"/>
           </a:xfrm>
           <a:prstGeom prst="rect">
             <a:avLst/>
@@ -16489,33 +17736,149 @@
           <a:noFill/>
         </p:spPr>
         <p:txBody>
-          <a:bodyPr wrap="square" anchor="ctr" lIns="0" rIns="0" tIns="0" bIns="0">
+          <a:bodyPr wrap="square" anchor="t" lIns="0" rIns="0" tIns="0" bIns="0">
             <a:spAutoFit/>
           </a:bodyPr>
           <a:lstStyle/>
           <a:p>
             <a:pPr algn="l">
               <a:spcAft>
-                <a:spcPts val="600"/>
-              </a:spcAft>
-            </a:pPr>
-            <a:r>
-              <a:rPr sz="1500" b="1" i="0">
+                <a:spcPts val="1000"/>
+              </a:spcAft>
+            </a:pPr>
+            <a:r>
+              <a:rPr sz="1600" b="1" i="0">
                 <a:solidFill>
                   <a:srgbClr val="343174"/>
                 </a:solidFill>
                 <a:latin typeface="Calibri"/>
               </a:rPr>
-              <a:t>All 22 module presentations loaded as courses in both LMSs: </a:t>
-            </a:r>
-            <a:r>
-              <a:rPr sz="1500" b="0" i="0">
+              <a:t>Reading guide</a:t>
+            </a:r>
+          </a:p>
+          <a:p>
+            <a:pPr algn="l">
+              <a:spcAft>
+                <a:spcPts val="1000"/>
+              </a:spcAft>
+            </a:pPr>
+            <a:r>
+              <a:rPr sz="1400" b="1" i="0">
                 <a:solidFill>
                   <a:srgbClr val="22222A"/>
                 </a:solidFill>
                 <a:latin typeface="Calibri"/>
               </a:rPr>
-              <a:t>28,785 students and 32,593 enrolments, all running locally under Docker Compose.</a:t>
+              <a:t>Direction: </a:t>
+            </a:r>
+            <a:r>
+              <a:rPr sz="1400" b="0" i="0">
+                <a:solidFill>
+                  <a:srgbClr val="22222A"/>
+                </a:solidFill>
+                <a:latin typeface="Calibri"/>
+              </a:rPr>
+              <a:t>positive pushes towards at-risk, negative away</a:t>
+            </a:r>
+          </a:p>
+          <a:p>
+            <a:pPr algn="l">
+              <a:spcAft>
+                <a:spcPts val="1000"/>
+              </a:spcAft>
+            </a:pPr>
+            <a:r>
+              <a:rPr sz="1400" b="1" i="0">
+                <a:solidFill>
+                  <a:srgbClr val="22222A"/>
+                </a:solidFill>
+                <a:latin typeface="Calibri"/>
+              </a:rPr>
+              <a:t>Size: </a:t>
+            </a:r>
+            <a:r>
+              <a:rPr sz="1400" b="0" i="0">
+                <a:solidFill>
+                  <a:srgbClr val="22222A"/>
+                </a:solidFill>
+                <a:latin typeface="Calibri"/>
+              </a:rPr>
+              <a:t>longer bar, stronger influence</a:t>
+            </a:r>
+          </a:p>
+          <a:p>
+            <a:pPr algn="l">
+              <a:spcAft>
+                <a:spcPts val="1000"/>
+              </a:spcAft>
+            </a:pPr>
+            <a:r>
+              <a:rPr sz="1400" b="1" i="0">
+                <a:solidFill>
+                  <a:srgbClr val="22222A"/>
+                </a:solidFill>
+                <a:latin typeface="Calibri"/>
+              </a:rPr>
+              <a:t>Agreement: </a:t>
+            </a:r>
+            <a:r>
+              <a:rPr sz="1400" b="0" i="0">
+                <a:solidFill>
+                  <a:srgbClr val="22222A"/>
+                </a:solidFill>
+                <a:latin typeface="Calibri"/>
+              </a:rPr>
+              <a:t>4 of 5 features shared, so the explanation is firmer</a:t>
+            </a:r>
+          </a:p>
+          <a:p>
+            <a:pPr algn="l">
+              <a:spcAft>
+                <a:spcPts val="1000"/>
+              </a:spcAft>
+            </a:pPr>
+            <a:r>
+              <a:rPr sz="1400" b="1" i="0">
+                <a:solidFill>
+                  <a:srgbClr val="22222A"/>
+                </a:solidFill>
+                <a:latin typeface="Calibri"/>
+              </a:rPr>
+              <a:t>Meaning: </a:t>
+            </a:r>
+            <a:r>
+              <a:rPr sz="1400" b="0" i="0">
+                <a:solidFill>
+                  <a:srgbClr val="22222A"/>
+                </a:solidFill>
+                <a:latin typeface="Calibri"/>
+              </a:rPr>
+              <a:t>how the model reasoned, not why the student struggles</a:t>
+            </a:r>
+          </a:p>
+          <a:p>
+            <a:pPr algn="l">
+              <a:spcAft>
+                <a:spcPts val="1000"/>
+              </a:spcAft>
+            </a:pPr>
+            <a:r>
+              <a:rPr sz="1400" b="1" i="0">
+                <a:solidFill>
+                  <a:srgbClr val="22222A"/>
+                </a:solidFill>
+                <a:latin typeface="Calibri"/>
+              </a:rPr>
+              <a:t>Action: </a:t>
+            </a:r>
+            <a:r>
+              <a:rPr sz="1400" b="0" i="0">
+                <a:solidFill>
+                  <a:srgbClr val="22222A"/>
+                </a:solidFill>
+                <a:latin typeface="Calibri"/>
+              </a:rPr>
+              <a:t>the instructor decides what to do</a:t>
             </a:r>
           </a:p>
         </p:txBody>
@@ -16568,7 +17931,7 @@
                 </a:solidFill>
                 <a:latin typeface="Calibri"/>
               </a:rPr>
-              <a:t>Contributions</a:t>
+              <a:t>Running Inside Moodle and Canvas</a:t>
             </a:r>
           </a:p>
         </p:txBody>
@@ -16614,20 +17977,234 @@
       </p:sp>
       <p:sp>
         <p:nvSpPr>
-          <p:cNvPr id="4" name="Number 1"/>
+          <p:cNvPr id="4" name="Moodle 5.2 label"/>
+          <p:cNvSpPr txBox="1"/>
+          <p:nvPr/>
+        </p:nvSpPr>
+        <p:spPr>
+          <a:xfrm>
+            <a:off x="2240280" y="1344168"/>
+            <a:ext cx="3040379" cy="365760"/>
+          </a:xfrm>
+          <a:prstGeom prst="rect">
+            <a:avLst/>
+          </a:prstGeom>
+          <a:noFill/>
+        </p:spPr>
+        <p:txBody>
+          <a:bodyPr wrap="square" anchor="t" lIns="0" rIns="0" tIns="0" bIns="0">
+            <a:spAutoFit/>
+          </a:bodyPr>
+          <a:lstStyle/>
+          <a:p>
+            <a:pPr algn="l">
+              <a:spcAft>
+                <a:spcPts val="600"/>
+              </a:spcAft>
+            </a:pPr>
+            <a:r>
+              <a:rPr sz="1800" b="1" i="0">
+                <a:solidFill>
+                  <a:srgbClr val="343174"/>
+                </a:solidFill>
+                <a:latin typeface="Calibri"/>
+              </a:rPr>
+              <a:t>Moodle 5.2</a:t>
+            </a:r>
+          </a:p>
+        </p:txBody>
+      </p:sp>
+      <p:pic>
+        <p:nvPicPr>
+          <p:cNvPr id="5" name="Moodle 5.2 screenshot" descr="moodle_nav.png"/>
+          <p:cNvPicPr>
+            <a:picLocks noChangeAspect="1"/>
+          </p:cNvPicPr>
+          <p:nvPr/>
+        </p:nvPicPr>
+        <p:blipFill>
+          <a:blip r:embed="rId3"/>
+          <a:stretch>
+            <a:fillRect/>
+          </a:stretch>
+        </p:blipFill>
+        <p:spPr>
+          <a:xfrm>
+            <a:off x="2240280" y="1783080"/>
+            <a:ext cx="3040379" cy="2111374"/>
+          </a:xfrm>
+          <a:prstGeom prst="rect">
+            <a:avLst/>
+          </a:prstGeom>
+          <a:ln w="9525">
+            <a:solidFill>
+              <a:srgbClr val="C9CAD3"/>
+            </a:solidFill>
+          </a:ln>
+        </p:spPr>
+      </p:pic>
+      <p:sp>
+        <p:nvSpPr>
+          <p:cNvPr id="6" name="Moodle 5.2 caption"/>
+          <p:cNvSpPr txBox="1"/>
+          <p:nvPr/>
+        </p:nvSpPr>
+        <p:spPr>
+          <a:xfrm>
+            <a:off x="2240280" y="4031614"/>
+            <a:ext cx="3040379" cy="914400"/>
+          </a:xfrm>
+          <a:prstGeom prst="rect">
+            <a:avLst/>
+          </a:prstGeom>
+          <a:noFill/>
+        </p:spPr>
+        <p:txBody>
+          <a:bodyPr wrap="square" anchor="t" lIns="0" rIns="0" tIns="0" bIns="0">
+            <a:spAutoFit/>
+          </a:bodyPr>
+          <a:lstStyle/>
+          <a:p>
+            <a:pPr algn="l">
+              <a:spcAft>
+                <a:spcPts val="600"/>
+              </a:spcAft>
+            </a:pPr>
+            <a:r>
+              <a:rPr sz="1400" b="0" i="0">
+                <a:solidFill>
+                  <a:srgbClr val="22222A"/>
+                </a:solidFill>
+                <a:latin typeface="Calibri"/>
+              </a:rPr>
+              <a:t>Native plugin: At-risk insights in each course's menu, using Moodle login, roles and enrolments</a:t>
+            </a:r>
+          </a:p>
+        </p:txBody>
+      </p:sp>
+      <p:sp>
+        <p:nvSpPr>
+          <p:cNvPr id="7" name="Canvas label"/>
+          <p:cNvSpPr txBox="1"/>
+          <p:nvPr/>
+        </p:nvSpPr>
+        <p:spPr>
+          <a:xfrm>
+            <a:off x="5509260" y="1344168"/>
+            <a:ext cx="3040379" cy="365760"/>
+          </a:xfrm>
+          <a:prstGeom prst="rect">
+            <a:avLst/>
+          </a:prstGeom>
+          <a:noFill/>
+        </p:spPr>
+        <p:txBody>
+          <a:bodyPr wrap="square" anchor="t" lIns="0" rIns="0" tIns="0" bIns="0">
+            <a:spAutoFit/>
+          </a:bodyPr>
+          <a:lstStyle/>
+          <a:p>
+            <a:pPr algn="l">
+              <a:spcAft>
+                <a:spcPts val="600"/>
+              </a:spcAft>
+            </a:pPr>
+            <a:r>
+              <a:rPr sz="1800" b="1" i="0">
+                <a:solidFill>
+                  <a:srgbClr val="343174"/>
+                </a:solidFill>
+                <a:latin typeface="Calibri"/>
+              </a:rPr>
+              <a:t>Canvas</a:t>
+            </a:r>
+          </a:p>
+        </p:txBody>
+      </p:sp>
+      <p:pic>
+        <p:nvPicPr>
+          <p:cNvPr id="8" name="Canvas screenshot" descr="canvas_embed.png"/>
+          <p:cNvPicPr>
+            <a:picLocks noChangeAspect="1"/>
+          </p:cNvPicPr>
+          <p:nvPr/>
+        </p:nvPicPr>
+        <p:blipFill>
+          <a:blip r:embed="rId4"/>
+          <a:stretch>
+            <a:fillRect/>
+          </a:stretch>
+        </p:blipFill>
+        <p:spPr>
+          <a:xfrm>
+            <a:off x="5509260" y="1783080"/>
+            <a:ext cx="3040379" cy="2111374"/>
+          </a:xfrm>
+          <a:prstGeom prst="rect">
+            <a:avLst/>
+          </a:prstGeom>
+          <a:ln w="9525">
+            <a:solidFill>
+              <a:srgbClr val="C9CAD3"/>
+            </a:solidFill>
+          </a:ln>
+        </p:spPr>
+      </p:pic>
+      <p:sp>
+        <p:nvSpPr>
+          <p:cNvPr id="9" name="Canvas caption"/>
+          <p:cNvSpPr txBox="1"/>
+          <p:nvPr/>
+        </p:nvSpPr>
+        <p:spPr>
+          <a:xfrm>
+            <a:off x="5509260" y="4031614"/>
+            <a:ext cx="3040379" cy="914400"/>
+          </a:xfrm>
+          <a:prstGeom prst="rect">
+            <a:avLst/>
+          </a:prstGeom>
+          <a:noFill/>
+        </p:spPr>
+        <p:txBody>
+          <a:bodyPr wrap="square" anchor="t" lIns="0" rIns="0" tIns="0" bIns="0">
+            <a:spAutoFit/>
+          </a:bodyPr>
+          <a:lstStyle/>
+          <a:p>
+            <a:pPr algn="l">
+              <a:spcAft>
+                <a:spcPts val="600"/>
+              </a:spcAft>
+            </a:pPr>
+            <a:r>
+              <a:rPr sz="1400" b="0" i="0">
+                <a:solidFill>
+                  <a:srgbClr val="22222A"/>
+                </a:solidFill>
+                <a:latin typeface="Calibri"/>
+              </a:rPr>
+              <a:t>Dashboard embedded in the course through an External URL module item</a:t>
+            </a:r>
+          </a:p>
+        </p:txBody>
+      </p:sp>
+      <p:sp>
+        <p:nvSpPr>
+          <p:cNvPr id="10" name="LMS facts band"/>
           <p:cNvSpPr/>
           <p:nvPr/>
         </p:nvSpPr>
         <p:spPr>
           <a:xfrm>
-            <a:off x="2240280" y="1417320"/>
-            <a:ext cx="457200" cy="457200"/>
-          </a:xfrm>
-          <a:prstGeom prst="ellipse">
+            <a:off x="2240280" y="5120640"/>
+            <a:ext cx="6309359" cy="868680"/>
+          </a:xfrm>
+          <a:prstGeom prst="rect">
             <a:avLst/>
           </a:prstGeom>
           <a:solidFill>
-            <a:srgbClr val="343174"/>
+            <a:srgbClr val="F2F2F5"/>
           </a:solidFill>
           <a:ln>
             <a:noFill/>
@@ -16635,32 +18212,21 @@
           <a:effectLst/>
         </p:spPr>
         <p:txBody>
-          <a:bodyPr rtlCol="0" anchor="ctr" lIns="0" rIns="0" tIns="0" bIns="0"/>
-          <a:lstStyle/>
-          <a:p>
-            <a:pPr algn="ctr"/>
-            <a:r>
-              <a:rPr sz="1500" b="1" i="0">
-                <a:solidFill>
-                  <a:srgbClr val="FFFFFF"/>
-                </a:solidFill>
-                <a:latin typeface="Calibri"/>
-              </a:rPr>
-              <a:t>1</a:t>
-            </a:r>
-          </a:p>
-        </p:txBody>
-      </p:sp>
-      <p:sp>
-        <p:nvSpPr>
-          <p:cNvPr id="5" name="Item 1"/>
+          <a:bodyPr rtlCol="0" anchor="ctr"/>
+          <a:lstStyle/>
+          <a:p/>
+        </p:txBody>
+      </p:sp>
+      <p:sp>
+        <p:nvSpPr>
+          <p:cNvPr id="11" name="LMS facts"/>
           <p:cNvSpPr txBox="1"/>
           <p:nvPr/>
         </p:nvSpPr>
         <p:spPr>
           <a:xfrm>
-            <a:off x="2880360" y="1399032"/>
-            <a:ext cx="5669279" cy="1097280"/>
+            <a:off x="2423160" y="5120640"/>
+            <a:ext cx="5943599" cy="868680"/>
           </a:xfrm>
           <a:prstGeom prst="rect">
             <a:avLst/>
@@ -16668,322 +18234,33 @@
           <a:noFill/>
         </p:spPr>
         <p:txBody>
-          <a:bodyPr wrap="square" anchor="t" lIns="0" rIns="0" tIns="0" bIns="0">
+          <a:bodyPr wrap="square" anchor="ctr" lIns="0" rIns="0" tIns="0" bIns="0">
             <a:spAutoFit/>
           </a:bodyPr>
           <a:lstStyle/>
           <a:p>
             <a:pPr algn="l">
               <a:spcAft>
-                <a:spcPts val="200"/>
-              </a:spcAft>
-            </a:pPr>
-            <a:r>
-              <a:rPr sz="1800" b="1" i="0">
+                <a:spcPts val="600"/>
+              </a:spcAft>
+            </a:pPr>
+            <a:r>
+              <a:rPr sz="1500" b="1" i="0">
+                <a:solidFill>
+                  <a:srgbClr val="343174"/>
+                </a:solidFill>
+                <a:latin typeface="Calibri"/>
+              </a:rPr>
+              <a:t>All 22 module presentations loaded as courses in both LMSs: </a:t>
+            </a:r>
+            <a:r>
+              <a:rPr sz="1500" b="0" i="0">
                 <a:solidFill>
                   <a:srgbClr val="22222A"/>
                 </a:solidFill>
                 <a:latin typeface="Calibri"/>
               </a:rPr>
-              <a:t>Prediction and explanation in one running system</a:t>
-            </a:r>
-          </a:p>
-          <a:p>
-            <a:pPr algn="l">
-              <a:spcAft>
-                <a:spcPts val="200"/>
-              </a:spcAft>
-            </a:pPr>
-            <a:r>
-              <a:rPr sz="1500" b="0" i="0">
-                <a:solidFill>
-                  <a:srgbClr val="555560"/>
-                </a:solidFill>
-                <a:latin typeface="Calibri"/>
-              </a:rPr>
-              <a:t>The explanation layer serves the interface directly, not as an offline analysis.</a:t>
-            </a:r>
-          </a:p>
-        </p:txBody>
-      </p:sp>
-      <p:sp>
-        <p:nvSpPr>
-          <p:cNvPr id="6" name="Number 2"/>
-          <p:cNvSpPr/>
-          <p:nvPr/>
-        </p:nvSpPr>
-        <p:spPr>
-          <a:xfrm>
-            <a:off x="2240280" y="2560320"/>
-            <a:ext cx="457200" cy="457200"/>
-          </a:xfrm>
-          <a:prstGeom prst="ellipse">
-            <a:avLst/>
-          </a:prstGeom>
-          <a:solidFill>
-            <a:srgbClr val="343174"/>
-          </a:solidFill>
-          <a:ln>
-            <a:noFill/>
-          </a:ln>
-          <a:effectLst/>
-        </p:spPr>
-        <p:txBody>
-          <a:bodyPr rtlCol="0" anchor="ctr" lIns="0" rIns="0" tIns="0" bIns="0"/>
-          <a:lstStyle/>
-          <a:p>
-            <a:pPr algn="ctr"/>
-            <a:r>
-              <a:rPr sz="1500" b="1" i="0">
-                <a:solidFill>
-                  <a:srgbClr val="FFFFFF"/>
-                </a:solidFill>
-                <a:latin typeface="Calibri"/>
-              </a:rPr>
-              <a:t>2</a:t>
-            </a:r>
-          </a:p>
-        </p:txBody>
-      </p:sp>
-      <p:sp>
-        <p:nvSpPr>
-          <p:cNvPr id="7" name="Item 2"/>
-          <p:cNvSpPr txBox="1"/>
-          <p:nvPr/>
-        </p:nvSpPr>
-        <p:spPr>
-          <a:xfrm>
-            <a:off x="2880360" y="2542032"/>
-            <a:ext cx="5669279" cy="1097280"/>
-          </a:xfrm>
-          <a:prstGeom prst="rect">
-            <a:avLst/>
-          </a:prstGeom>
-          <a:noFill/>
-        </p:spPr>
-        <p:txBody>
-          <a:bodyPr wrap="square" anchor="t" lIns="0" rIns="0" tIns="0" bIns="0">
-            <a:spAutoFit/>
-          </a:bodyPr>
-          <a:lstStyle/>
-          <a:p>
-            <a:pPr algn="l">
-              <a:spcAft>
-                <a:spcPts val="200"/>
-              </a:spcAft>
-            </a:pPr>
-            <a:r>
-              <a:rPr sz="1800" b="1" i="0">
-                <a:solidFill>
-                  <a:srgbClr val="22222A"/>
-                </a:solidFill>
-                <a:latin typeface="Calibri"/>
-              </a:rPr>
-              <a:t>Role-aware treatment of explanation</a:t>
-            </a:r>
-          </a:p>
-          <a:p>
-            <a:pPr algn="l">
-              <a:spcAft>
-                <a:spcPts val="200"/>
-              </a:spcAft>
-            </a:pPr>
-            <a:r>
-              <a:rPr sz="1500" b="0" i="0">
-                <a:solidFill>
-                  <a:srgbClr val="555560"/>
-                </a:solidFill>
-                <a:latin typeface="Calibri"/>
-              </a:rPr>
-              <a:t>Distinct views derived from each role's responsibilities and questions.</a:t>
-            </a:r>
-          </a:p>
-        </p:txBody>
-      </p:sp>
-      <p:sp>
-        <p:nvSpPr>
-          <p:cNvPr id="8" name="Number 3"/>
-          <p:cNvSpPr/>
-          <p:nvPr/>
-        </p:nvSpPr>
-        <p:spPr>
-          <a:xfrm>
-            <a:off x="2240280" y="3703320"/>
-            <a:ext cx="457200" cy="457200"/>
-          </a:xfrm>
-          <a:prstGeom prst="ellipse">
-            <a:avLst/>
-          </a:prstGeom>
-          <a:solidFill>
-            <a:srgbClr val="343174"/>
-          </a:solidFill>
-          <a:ln>
-            <a:noFill/>
-          </a:ln>
-          <a:effectLst/>
-        </p:spPr>
-        <p:txBody>
-          <a:bodyPr rtlCol="0" anchor="ctr" lIns="0" rIns="0" tIns="0" bIns="0"/>
-          <a:lstStyle/>
-          <a:p>
-            <a:pPr algn="ctr"/>
-            <a:r>
-              <a:rPr sz="1500" b="1" i="0">
-                <a:solidFill>
-                  <a:srgbClr val="FFFFFF"/>
-                </a:solidFill>
-                <a:latin typeface="Calibri"/>
-              </a:rPr>
-              <a:t>3</a:t>
-            </a:r>
-          </a:p>
-        </p:txBody>
-      </p:sp>
-      <p:sp>
-        <p:nvSpPr>
-          <p:cNvPr id="9" name="Item 3"/>
-          <p:cNvSpPr txBox="1"/>
-          <p:nvPr/>
-        </p:nvSpPr>
-        <p:spPr>
-          <a:xfrm>
-            <a:off x="2880360" y="3685032"/>
-            <a:ext cx="5669279" cy="1097280"/>
-          </a:xfrm>
-          <a:prstGeom prst="rect">
-            <a:avLst/>
-          </a:prstGeom>
-          <a:noFill/>
-        </p:spPr>
-        <p:txBody>
-          <a:bodyPr wrap="square" anchor="t" lIns="0" rIns="0" tIns="0" bIns="0">
-            <a:spAutoFit/>
-          </a:bodyPr>
-          <a:lstStyle/>
-          <a:p>
-            <a:pPr algn="l">
-              <a:spcAft>
-                <a:spcPts val="200"/>
-              </a:spcAft>
-            </a:pPr>
-            <a:r>
-              <a:rPr sz="1800" b="1" i="0">
-                <a:solidFill>
-                  <a:srgbClr val="22222A"/>
-                </a:solidFill>
-                <a:latin typeface="Calibri"/>
-              </a:rPr>
-              <a:t>CommonKADS applied to explainable learning analytics</a:t>
-            </a:r>
-          </a:p>
-          <a:p>
-            <a:pPr algn="l">
-              <a:spcAft>
-                <a:spcPts val="200"/>
-              </a:spcAft>
-            </a:pPr>
-            <a:r>
-              <a:rPr sz="1500" b="0" i="0">
-                <a:solidFill>
-                  <a:srgbClr val="555560"/>
-                </a:solidFill>
-                <a:latin typeface="Calibri"/>
-              </a:rPr>
-              <a:t>Shows the design problem is largely a knowledge problem.</a:t>
-            </a:r>
-          </a:p>
-        </p:txBody>
-      </p:sp>
-      <p:sp>
-        <p:nvSpPr>
-          <p:cNvPr id="10" name="Number 4"/>
-          <p:cNvSpPr/>
-          <p:nvPr/>
-        </p:nvSpPr>
-        <p:spPr>
-          <a:xfrm>
-            <a:off x="2240280" y="4846320"/>
-            <a:ext cx="457200" cy="457200"/>
-          </a:xfrm>
-          <a:prstGeom prst="ellipse">
-            <a:avLst/>
-          </a:prstGeom>
-          <a:solidFill>
-            <a:srgbClr val="343174"/>
-          </a:solidFill>
-          <a:ln>
-            <a:noFill/>
-          </a:ln>
-          <a:effectLst/>
-        </p:spPr>
-        <p:txBody>
-          <a:bodyPr rtlCol="0" anchor="ctr" lIns="0" rIns="0" tIns="0" bIns="0"/>
-          <a:lstStyle/>
-          <a:p>
-            <a:pPr algn="ctr"/>
-            <a:r>
-              <a:rPr sz="1500" b="1" i="0">
-                <a:solidFill>
-                  <a:srgbClr val="FFFFFF"/>
-                </a:solidFill>
-                <a:latin typeface="Calibri"/>
-              </a:rPr>
-              <a:t>4</a:t>
-            </a:r>
-          </a:p>
-        </p:txBody>
-      </p:sp>
-      <p:sp>
-        <p:nvSpPr>
-          <p:cNvPr id="11" name="Item 4"/>
-          <p:cNvSpPr txBox="1"/>
-          <p:nvPr/>
-        </p:nvSpPr>
-        <p:spPr>
-          <a:xfrm>
-            <a:off x="2880360" y="4828032"/>
-            <a:ext cx="5669279" cy="1097280"/>
-          </a:xfrm>
-          <a:prstGeom prst="rect">
-            <a:avLst/>
-          </a:prstGeom>
-          <a:noFill/>
-        </p:spPr>
-        <p:txBody>
-          <a:bodyPr wrap="square" anchor="t" lIns="0" rIns="0" tIns="0" bIns="0">
-            <a:spAutoFit/>
-          </a:bodyPr>
-          <a:lstStyle/>
-          <a:p>
-            <a:pPr algn="l">
-              <a:spcAft>
-                <a:spcPts val="200"/>
-              </a:spcAft>
-            </a:pPr>
-            <a:r>
-              <a:rPr sz="1800" b="1" i="0">
-                <a:solidFill>
-                  <a:srgbClr val="22222A"/>
-                </a:solidFill>
-                <a:latin typeface="Calibri"/>
-              </a:rPr>
-              <a:t>Evidence on SHAP and LIME agreement</a:t>
-            </a:r>
-          </a:p>
-          <a:p>
-            <a:pPr algn="l">
-              <a:spcAft>
-                <a:spcPts val="200"/>
-              </a:spcAft>
-            </a:pPr>
-            <a:r>
-              <a:rPr sz="1500" b="0" i="0">
-                <a:solidFill>
-                  <a:srgbClr val="555560"/>
-                </a:solidFill>
-                <a:latin typeface="Calibri"/>
-              </a:rPr>
-              <a:t>Where the methods converge and differ, at global and local level.</a:t>
+              <a:t>28,785 students and 32,593 enrolments, all running locally under Docker Compose.</a:t>
             </a:r>
           </a:p>
         </p:txBody>
@@ -17036,7 +18313,7 @@
                 </a:solidFill>
                 <a:latin typeface="Calibri"/>
               </a:rPr>
-              <a:t>Limitations and Future Work</a:t>
+              <a:t>Contributions</a:t>
             </a:r>
           </a:p>
         </p:txBody>
@@ -17082,20 +18359,20 @@
       </p:sp>
       <p:sp>
         <p:nvSpPr>
-          <p:cNvPr id="4" name="Limitations card"/>
+          <p:cNvPr id="4" name="Number 1"/>
           <p:cNvSpPr/>
           <p:nvPr/>
         </p:nvSpPr>
         <p:spPr>
           <a:xfrm>
-            <a:off x="2240280" y="1371600"/>
-            <a:ext cx="3040379" cy="4572000"/>
-          </a:xfrm>
-          <a:prstGeom prst="rect">
+            <a:off x="2240280" y="1417320"/>
+            <a:ext cx="457200" cy="457200"/>
+          </a:xfrm>
+          <a:prstGeom prst="ellipse">
             <a:avLst/>
           </a:prstGeom>
           <a:solidFill>
-            <a:srgbClr val="F2F2F5"/>
+            <a:srgbClr val="343174"/>
           </a:solidFill>
           <a:ln>
             <a:noFill/>
@@ -17103,21 +18380,32 @@
           <a:effectLst/>
         </p:spPr>
         <p:txBody>
-          <a:bodyPr rtlCol="0" anchor="ctr"/>
-          <a:lstStyle/>
-          <a:p/>
-        </p:txBody>
-      </p:sp>
-      <p:sp>
-        <p:nvSpPr>
-          <p:cNvPr id="5" name="Limitations text"/>
+          <a:bodyPr rtlCol="0" anchor="ctr" lIns="0" rIns="0" tIns="0" bIns="0"/>
+          <a:lstStyle/>
+          <a:p>
+            <a:pPr algn="ctr"/>
+            <a:r>
+              <a:rPr sz="1500" b="1" i="0">
+                <a:solidFill>
+                  <a:srgbClr val="FFFFFF"/>
+                </a:solidFill>
+                <a:latin typeface="Calibri"/>
+              </a:rPr>
+              <a:t>1</a:t>
+            </a:r>
+          </a:p>
+        </p:txBody>
+      </p:sp>
+      <p:sp>
+        <p:nvSpPr>
+          <p:cNvPr id="5" name="Item 1"/>
           <p:cNvSpPr txBox="1"/>
           <p:nvPr/>
         </p:nvSpPr>
         <p:spPr>
           <a:xfrm>
-            <a:off x="2423160" y="1554480"/>
-            <a:ext cx="2674620" cy="4297680"/>
+            <a:off x="2880360" y="1399032"/>
+            <a:ext cx="5669279" cy="1097280"/>
           </a:xfrm>
           <a:prstGeom prst="rect">
             <a:avLst/>
@@ -17132,121 +18420,53 @@
           <a:p>
             <a:pPr algn="l">
               <a:spcAft>
-                <a:spcPts val="1400"/>
-              </a:spcAft>
-            </a:pPr>
-            <a:r>
-              <a:rPr sz="2000" b="1" i="0">
-                <a:solidFill>
-                  <a:srgbClr val="343174"/>
-                </a:solidFill>
-                <a:latin typeface="Calibri"/>
-              </a:rPr>
-              <a:t>Limitations</a:t>
-            </a:r>
-          </a:p>
-          <a:p>
-            <a:pPr algn="l" marL="201168" indent="-201168">
-              <a:spcAft>
-                <a:spcPts val="1400"/>
-              </a:spcAft>
-              <a:buClr>
-                <a:srgbClr val="343174"/>
-              </a:buClr>
-              <a:buFont typeface="Arial"/>
-              <a:buChar char="•"/>
-            </a:pPr>
-            <a:r>
-              <a:rPr sz="1700" b="0" i="0">
+                <a:spcPts val="200"/>
+              </a:spcAft>
+            </a:pPr>
+            <a:r>
+              <a:rPr sz="1800" b="1" i="0">
                 <a:solidFill>
                   <a:srgbClr val="22222A"/>
                 </a:solidFill>
                 <a:latin typeface="Calibri"/>
               </a:rPr>
-              <a:t>No practitioner data: trust, usability and decision quality untested</a:t>
-            </a:r>
-          </a:p>
-          <a:p>
-            <a:pPr algn="l" marL="201168" indent="-201168">
-              <a:spcAft>
-                <a:spcPts val="1400"/>
-              </a:spcAft>
-              <a:buClr>
-                <a:srgbClr val="343174"/>
-              </a:buClr>
-              <a:buFont typeface="Arial"/>
-              <a:buChar char="•"/>
-            </a:pPr>
-            <a:r>
-              <a:rPr sz="1700" b="0" i="0">
-                <a:solidFill>
-                  <a:srgbClr val="22222A"/>
-                </a:solidFill>
-                <a:latin typeface="Calibri"/>
-              </a:rPr>
-              <a:t>Retrospective features: no early-warning point evaluated</a:t>
-            </a:r>
-          </a:p>
-          <a:p>
-            <a:pPr algn="l" marL="201168" indent="-201168">
-              <a:spcAft>
-                <a:spcPts val="1400"/>
-              </a:spcAft>
-              <a:buClr>
-                <a:srgbClr val="343174"/>
-              </a:buClr>
-              <a:buFont typeface="Arial"/>
-              <a:buChar char="•"/>
-            </a:pPr>
-            <a:r>
-              <a:rPr sz="1700" b="0" i="0">
-                <a:solidFill>
-                  <a:srgbClr val="22222A"/>
-                </a:solidFill>
-                <a:latin typeface="Calibri"/>
-              </a:rPr>
-              <a:t>One dataset (OULAD) and context</a:t>
-            </a:r>
-          </a:p>
-          <a:p>
-            <a:pPr algn="l" marL="201168" indent="-201168">
-              <a:spcAft>
-                <a:spcPts val="1400"/>
-              </a:spcAft>
-              <a:buClr>
-                <a:srgbClr val="343174"/>
-              </a:buClr>
-              <a:buFont typeface="Arial"/>
-              <a:buChar char="•"/>
-            </a:pPr>
-            <a:r>
-              <a:rPr sz="1700" b="0" i="0">
-                <a:solidFill>
-                  <a:srgbClr val="22222A"/>
-                </a:solidFill>
-                <a:latin typeface="Calibri"/>
-              </a:rPr>
-              <a:t>Stability, fidelity, calibration and fairness checks not completed</a:t>
-            </a:r>
-          </a:p>
-        </p:txBody>
-      </p:sp>
-      <p:sp>
-        <p:nvSpPr>
-          <p:cNvPr id="6" name="Future work card"/>
+              <a:t>Prediction and explanation in one running system</a:t>
+            </a:r>
+          </a:p>
+          <a:p>
+            <a:pPr algn="l">
+              <a:spcAft>
+                <a:spcPts val="200"/>
+              </a:spcAft>
+            </a:pPr>
+            <a:r>
+              <a:rPr sz="1500" b="0" i="0">
+                <a:solidFill>
+                  <a:srgbClr val="555560"/>
+                </a:solidFill>
+                <a:latin typeface="Calibri"/>
+              </a:rPr>
+              <a:t>The explanation layer serves the interface directly, not as an offline analysis.</a:t>
+            </a:r>
+          </a:p>
+        </p:txBody>
+      </p:sp>
+      <p:sp>
+        <p:nvSpPr>
+          <p:cNvPr id="6" name="Number 2"/>
           <p:cNvSpPr/>
           <p:nvPr/>
         </p:nvSpPr>
         <p:spPr>
           <a:xfrm>
-            <a:off x="5509260" y="1371600"/>
-            <a:ext cx="3040379" cy="4572000"/>
-          </a:xfrm>
-          <a:prstGeom prst="rect">
+            <a:off x="2240280" y="2560320"/>
+            <a:ext cx="457200" cy="457200"/>
+          </a:xfrm>
+          <a:prstGeom prst="ellipse">
             <a:avLst/>
           </a:prstGeom>
           <a:solidFill>
-            <a:srgbClr val="F2F2F5"/>
+            <a:srgbClr val="343174"/>
           </a:solidFill>
           <a:ln>
             <a:noFill/>
@@ -17254,21 +18474,32 @@
           <a:effectLst/>
         </p:spPr>
         <p:txBody>
-          <a:bodyPr rtlCol="0" anchor="ctr"/>
-          <a:lstStyle/>
-          <a:p/>
-        </p:txBody>
-      </p:sp>
-      <p:sp>
-        <p:nvSpPr>
-          <p:cNvPr id="7" name="Future work text"/>
+          <a:bodyPr rtlCol="0" anchor="ctr" lIns="0" rIns="0" tIns="0" bIns="0"/>
+          <a:lstStyle/>
+          <a:p>
+            <a:pPr algn="ctr"/>
+            <a:r>
+              <a:rPr sz="1500" b="1" i="0">
+                <a:solidFill>
+                  <a:srgbClr val="FFFFFF"/>
+                </a:solidFill>
+                <a:latin typeface="Calibri"/>
+              </a:rPr>
+              <a:t>2</a:t>
+            </a:r>
+          </a:p>
+        </p:txBody>
+      </p:sp>
+      <p:sp>
+        <p:nvSpPr>
+          <p:cNvPr id="7" name="Item 2"/>
           <p:cNvSpPr txBox="1"/>
           <p:nvPr/>
         </p:nvSpPr>
         <p:spPr>
           <a:xfrm>
-            <a:off x="5692140" y="1554480"/>
-            <a:ext cx="2674620" cy="4297680"/>
+            <a:off x="2880360" y="2542032"/>
+            <a:ext cx="5669279" cy="1097280"/>
           </a:xfrm>
           <a:prstGeom prst="rect">
             <a:avLst/>
@@ -17283,122 +18514,221 @@
           <a:p>
             <a:pPr algn="l">
               <a:spcAft>
-                <a:spcPts val="1400"/>
-              </a:spcAft>
-            </a:pPr>
-            <a:r>
-              <a:rPr sz="2000" b="1" i="0">
-                <a:solidFill>
-                  <a:srgbClr val="343174"/>
-                </a:solidFill>
-                <a:latin typeface="Calibri"/>
-              </a:rPr>
-              <a:t>Future work</a:t>
-            </a:r>
-          </a:p>
-          <a:p>
-            <a:pPr algn="l" marL="201168" indent="-201168">
-              <a:spcAft>
-                <a:spcPts val="1400"/>
-              </a:spcAft>
-              <a:buClr>
-                <a:srgbClr val="343174"/>
-              </a:buClr>
-              <a:buFont typeface="Arial"/>
-              <a:buChar char="•"/>
-            </a:pPr>
-            <a:r>
-              <a:rPr sz="1700" b="0" i="0">
+                <a:spcPts val="200"/>
+              </a:spcAft>
+            </a:pPr>
+            <a:r>
+              <a:rPr sz="1800" b="1" i="0">
                 <a:solidFill>
                   <a:srgbClr val="22222A"/>
                 </a:solidFill>
                 <a:latin typeface="Calibri"/>
               </a:rPr>
-              <a:t>Early-warning evaluation at weeks 2, 4, 6 and 8</a:t>
-            </a:r>
-          </a:p>
-          <a:p>
-            <a:pPr algn="l" marL="201168" indent="-201168">
-              <a:spcAft>
-                <a:spcPts val="1400"/>
-              </a:spcAft>
-              <a:buClr>
-                <a:srgbClr val="343174"/>
-              </a:buClr>
-              <a:buFont typeface="Arial"/>
-              <a:buChar char="•"/>
-            </a:pPr>
-            <a:r>
-              <a:rPr sz="1700" b="0" i="0">
+              <a:t>Role-aware treatment of explanation</a:t>
+            </a:r>
+          </a:p>
+          <a:p>
+            <a:pPr algn="l">
+              <a:spcAft>
+                <a:spcPts val="200"/>
+              </a:spcAft>
+            </a:pPr>
+            <a:r>
+              <a:rPr sz="1500" b="0" i="0">
+                <a:solidFill>
+                  <a:srgbClr val="555560"/>
+                </a:solidFill>
+                <a:latin typeface="Calibri"/>
+              </a:rPr>
+              <a:t>Distinct views derived from each role's responsibilities and questions.</a:t>
+            </a:r>
+          </a:p>
+        </p:txBody>
+      </p:sp>
+      <p:sp>
+        <p:nvSpPr>
+          <p:cNvPr id="8" name="Number 3"/>
+          <p:cNvSpPr/>
+          <p:nvPr/>
+        </p:nvSpPr>
+        <p:spPr>
+          <a:xfrm>
+            <a:off x="2240280" y="3703320"/>
+            <a:ext cx="457200" cy="457200"/>
+          </a:xfrm>
+          <a:prstGeom prst="ellipse">
+            <a:avLst/>
+          </a:prstGeom>
+          <a:solidFill>
+            <a:srgbClr val="343174"/>
+          </a:solidFill>
+          <a:ln>
+            <a:noFill/>
+          </a:ln>
+          <a:effectLst/>
+        </p:spPr>
+        <p:txBody>
+          <a:bodyPr rtlCol="0" anchor="ctr" lIns="0" rIns="0" tIns="0" bIns="0"/>
+          <a:lstStyle/>
+          <a:p>
+            <a:pPr algn="ctr"/>
+            <a:r>
+              <a:rPr sz="1500" b="1" i="0">
+                <a:solidFill>
+                  <a:srgbClr val="FFFFFF"/>
+                </a:solidFill>
+                <a:latin typeface="Calibri"/>
+              </a:rPr>
+              <a:t>3</a:t>
+            </a:r>
+          </a:p>
+        </p:txBody>
+      </p:sp>
+      <p:sp>
+        <p:nvSpPr>
+          <p:cNvPr id="9" name="Item 3"/>
+          <p:cNvSpPr txBox="1"/>
+          <p:nvPr/>
+        </p:nvSpPr>
+        <p:spPr>
+          <a:xfrm>
+            <a:off x="2880360" y="3685032"/>
+            <a:ext cx="5669279" cy="1097280"/>
+          </a:xfrm>
+          <a:prstGeom prst="rect">
+            <a:avLst/>
+          </a:prstGeom>
+          <a:noFill/>
+        </p:spPr>
+        <p:txBody>
+          <a:bodyPr wrap="square" anchor="t" lIns="0" rIns="0" tIns="0" bIns="0">
+            <a:spAutoFit/>
+          </a:bodyPr>
+          <a:lstStyle/>
+          <a:p>
+            <a:pPr algn="l">
+              <a:spcAft>
+                <a:spcPts val="200"/>
+              </a:spcAft>
+            </a:pPr>
+            <a:r>
+              <a:rPr sz="1800" b="1" i="0">
                 <a:solidFill>
                   <a:srgbClr val="22222A"/>
                 </a:solidFill>
                 <a:latin typeface="Calibri"/>
               </a:rPr>
-              <a:t>Probability calibration (Platt, isotonic)</a:t>
-            </a:r>
-          </a:p>
-          <a:p>
-            <a:pPr algn="l" marL="201168" indent="-201168">
-              <a:spcAft>
-                <a:spcPts val="1400"/>
-              </a:spcAft>
-              <a:buClr>
-                <a:srgbClr val="343174"/>
-              </a:buClr>
-              <a:buFont typeface="Arial"/>
-              <a:buChar char="•"/>
-            </a:pPr>
-            <a:r>
-              <a:rPr sz="1700" b="0" i="0">
+              <a:t>CommonKADS applied to explainable learning analytics</a:t>
+            </a:r>
+          </a:p>
+          <a:p>
+            <a:pPr algn="l">
+              <a:spcAft>
+                <a:spcPts val="200"/>
+              </a:spcAft>
+            </a:pPr>
+            <a:r>
+              <a:rPr sz="1500" b="0" i="0">
+                <a:solidFill>
+                  <a:srgbClr val="555560"/>
+                </a:solidFill>
+                <a:latin typeface="Calibri"/>
+              </a:rPr>
+              <a:t>Shows the design problem is largely a knowledge problem.</a:t>
+            </a:r>
+          </a:p>
+        </p:txBody>
+      </p:sp>
+      <p:sp>
+        <p:nvSpPr>
+          <p:cNvPr id="10" name="Number 4"/>
+          <p:cNvSpPr/>
+          <p:nvPr/>
+        </p:nvSpPr>
+        <p:spPr>
+          <a:xfrm>
+            <a:off x="2240280" y="4846320"/>
+            <a:ext cx="457200" cy="457200"/>
+          </a:xfrm>
+          <a:prstGeom prst="ellipse">
+            <a:avLst/>
+          </a:prstGeom>
+          <a:solidFill>
+            <a:srgbClr val="343174"/>
+          </a:solidFill>
+          <a:ln>
+            <a:noFill/>
+          </a:ln>
+          <a:effectLst/>
+        </p:spPr>
+        <p:txBody>
+          <a:bodyPr rtlCol="0" anchor="ctr" lIns="0" rIns="0" tIns="0" bIns="0"/>
+          <a:lstStyle/>
+          <a:p>
+            <a:pPr algn="ctr"/>
+            <a:r>
+              <a:rPr sz="1500" b="1" i="0">
+                <a:solidFill>
+                  <a:srgbClr val="FFFFFF"/>
+                </a:solidFill>
+                <a:latin typeface="Calibri"/>
+              </a:rPr>
+              <a:t>4</a:t>
+            </a:r>
+          </a:p>
+        </p:txBody>
+      </p:sp>
+      <p:sp>
+        <p:nvSpPr>
+          <p:cNvPr id="11" name="Item 4"/>
+          <p:cNvSpPr txBox="1"/>
+          <p:nvPr/>
+        </p:nvSpPr>
+        <p:spPr>
+          <a:xfrm>
+            <a:off x="2880360" y="4828032"/>
+            <a:ext cx="5669279" cy="1097280"/>
+          </a:xfrm>
+          <a:prstGeom prst="rect">
+            <a:avLst/>
+          </a:prstGeom>
+          <a:noFill/>
+        </p:spPr>
+        <p:txBody>
+          <a:bodyPr wrap="square" anchor="t" lIns="0" rIns="0" tIns="0" bIns="0">
+            <a:spAutoFit/>
+          </a:bodyPr>
+          <a:lstStyle/>
+          <a:p>
+            <a:pPr algn="l">
+              <a:spcAft>
+                <a:spcPts val="200"/>
+              </a:spcAft>
+            </a:pPr>
+            <a:r>
+              <a:rPr sz="1800" b="1" i="0">
                 <a:solidFill>
                   <a:srgbClr val="22222A"/>
                 </a:solidFill>
                 <a:latin typeface="Calibri"/>
               </a:rPr>
-              <a:t>Subgroup fairness assessment</a:t>
-            </a:r>
-          </a:p>
-          <a:p>
-            <a:pPr algn="l" marL="201168" indent="-201168">
-              <a:spcAft>
-                <a:spcPts val="1400"/>
-              </a:spcAft>
-              <a:buClr>
-                <a:srgbClr val="343174"/>
-              </a:buClr>
-              <a:buFont typeface="Arial"/>
-              <a:buChar char="•"/>
-            </a:pPr>
-            <a:r>
-              <a:rPr sz="1700" b="0" i="0">
-                <a:solidFill>
-                  <a:srgbClr val="22222A"/>
-                </a:solidFill>
-                <a:latin typeface="Calibri"/>
-              </a:rPr>
-              <a:t>Practitioner study using TAM constructs</a:t>
-            </a:r>
-          </a:p>
-          <a:p>
-            <a:pPr algn="l" marL="201168" indent="-201168">
-              <a:spcAft>
-                <a:spcPts val="1400"/>
-              </a:spcAft>
-              <a:buClr>
-                <a:srgbClr val="343174"/>
-              </a:buClr>
-              <a:buFont typeface="Arial"/>
-              <a:buChar char="•"/>
-            </a:pPr>
-            <a:r>
-              <a:rPr sz="1700" b="0" i="0">
-                <a:solidFill>
-                  <a:srgbClr val="22222A"/>
-                </a:solidFill>
-                <a:latin typeface="Calibri"/>
-              </a:rPr>
-              <a:t>Other institutions and live data</a:t>
+              <a:t>Evidence on SHAP and LIME agreement</a:t>
+            </a:r>
+          </a:p>
+          <a:p>
+            <a:pPr algn="l">
+              <a:spcAft>
+                <a:spcPts val="200"/>
+              </a:spcAft>
+            </a:pPr>
+            <a:r>
+              <a:rPr sz="1500" b="0" i="0">
+                <a:solidFill>
+                  <a:srgbClr val="555560"/>
+                </a:solidFill>
+                <a:latin typeface="Calibri"/>
+              </a:rPr>
+              <a:t>Where the methods converge and differ, at global and local level.</a:t>
             </a:r>
           </a:p>
         </p:txBody>
@@ -17451,7 +18781,7 @@
                 </a:solidFill>
                 <a:latin typeface="Calibri"/>
               </a:rPr>
-              <a:t>Conclusion</a:t>
+              <a:t>Limitations and Future Work</a:t>
             </a:r>
           </a:p>
         </p:txBody>
@@ -17491,6 +18821,421 @@
                 <a:latin typeface="Calibri"/>
               </a:rPr>
               <a:t>21</a:t>
+            </a:r>
+          </a:p>
+        </p:txBody>
+      </p:sp>
+      <p:sp>
+        <p:nvSpPr>
+          <p:cNvPr id="4" name="Limitations card"/>
+          <p:cNvSpPr/>
+          <p:nvPr/>
+        </p:nvSpPr>
+        <p:spPr>
+          <a:xfrm>
+            <a:off x="2240280" y="1371600"/>
+            <a:ext cx="3040379" cy="4572000"/>
+          </a:xfrm>
+          <a:prstGeom prst="rect">
+            <a:avLst/>
+          </a:prstGeom>
+          <a:solidFill>
+            <a:srgbClr val="F2F2F5"/>
+          </a:solidFill>
+          <a:ln>
+            <a:noFill/>
+          </a:ln>
+          <a:effectLst/>
+        </p:spPr>
+        <p:txBody>
+          <a:bodyPr rtlCol="0" anchor="ctr"/>
+          <a:lstStyle/>
+          <a:p/>
+        </p:txBody>
+      </p:sp>
+      <p:sp>
+        <p:nvSpPr>
+          <p:cNvPr id="5" name="Limitations text"/>
+          <p:cNvSpPr txBox="1"/>
+          <p:nvPr/>
+        </p:nvSpPr>
+        <p:spPr>
+          <a:xfrm>
+            <a:off x="2423160" y="1554480"/>
+            <a:ext cx="2674620" cy="4297680"/>
+          </a:xfrm>
+          <a:prstGeom prst="rect">
+            <a:avLst/>
+          </a:prstGeom>
+          <a:noFill/>
+        </p:spPr>
+        <p:txBody>
+          <a:bodyPr wrap="square" anchor="t" lIns="0" rIns="0" tIns="0" bIns="0">
+            <a:spAutoFit/>
+          </a:bodyPr>
+          <a:lstStyle/>
+          <a:p>
+            <a:pPr algn="l">
+              <a:spcAft>
+                <a:spcPts val="1400"/>
+              </a:spcAft>
+            </a:pPr>
+            <a:r>
+              <a:rPr sz="2000" b="1" i="0">
+                <a:solidFill>
+                  <a:srgbClr val="343174"/>
+                </a:solidFill>
+                <a:latin typeface="Calibri"/>
+              </a:rPr>
+              <a:t>Limitations</a:t>
+            </a:r>
+          </a:p>
+          <a:p>
+            <a:pPr algn="l" marL="201168" indent="-201168">
+              <a:spcAft>
+                <a:spcPts val="1400"/>
+              </a:spcAft>
+              <a:buClr>
+                <a:srgbClr val="343174"/>
+              </a:buClr>
+              <a:buFont typeface="Arial"/>
+              <a:buChar char="•"/>
+            </a:pPr>
+            <a:r>
+              <a:rPr sz="1700" b="0" i="0">
+                <a:solidFill>
+                  <a:srgbClr val="22222A"/>
+                </a:solidFill>
+                <a:latin typeface="Calibri"/>
+              </a:rPr>
+              <a:t>No practitioner data: trust, usability and decision quality untested</a:t>
+            </a:r>
+          </a:p>
+          <a:p>
+            <a:pPr algn="l" marL="201168" indent="-201168">
+              <a:spcAft>
+                <a:spcPts val="1400"/>
+              </a:spcAft>
+              <a:buClr>
+                <a:srgbClr val="343174"/>
+              </a:buClr>
+              <a:buFont typeface="Arial"/>
+              <a:buChar char="•"/>
+            </a:pPr>
+            <a:r>
+              <a:rPr sz="1700" b="0" i="0">
+                <a:solidFill>
+                  <a:srgbClr val="22222A"/>
+                </a:solidFill>
+                <a:latin typeface="Calibri"/>
+              </a:rPr>
+              <a:t>Retrospective features: no early-warning point evaluated</a:t>
+            </a:r>
+          </a:p>
+          <a:p>
+            <a:pPr algn="l" marL="201168" indent="-201168">
+              <a:spcAft>
+                <a:spcPts val="1400"/>
+              </a:spcAft>
+              <a:buClr>
+                <a:srgbClr val="343174"/>
+              </a:buClr>
+              <a:buFont typeface="Arial"/>
+              <a:buChar char="•"/>
+            </a:pPr>
+            <a:r>
+              <a:rPr sz="1700" b="0" i="0">
+                <a:solidFill>
+                  <a:srgbClr val="22222A"/>
+                </a:solidFill>
+                <a:latin typeface="Calibri"/>
+              </a:rPr>
+              <a:t>One dataset (OULAD) and context</a:t>
+            </a:r>
+          </a:p>
+          <a:p>
+            <a:pPr algn="l" marL="201168" indent="-201168">
+              <a:spcAft>
+                <a:spcPts val="1400"/>
+              </a:spcAft>
+              <a:buClr>
+                <a:srgbClr val="343174"/>
+              </a:buClr>
+              <a:buFont typeface="Arial"/>
+              <a:buChar char="•"/>
+            </a:pPr>
+            <a:r>
+              <a:rPr sz="1700" b="0" i="0">
+                <a:solidFill>
+                  <a:srgbClr val="22222A"/>
+                </a:solidFill>
+                <a:latin typeface="Calibri"/>
+              </a:rPr>
+              <a:t>Stability, fidelity, calibration and fairness checks not completed</a:t>
+            </a:r>
+          </a:p>
+        </p:txBody>
+      </p:sp>
+      <p:sp>
+        <p:nvSpPr>
+          <p:cNvPr id="6" name="Future work card"/>
+          <p:cNvSpPr/>
+          <p:nvPr/>
+        </p:nvSpPr>
+        <p:spPr>
+          <a:xfrm>
+            <a:off x="5509260" y="1371600"/>
+            <a:ext cx="3040379" cy="4572000"/>
+          </a:xfrm>
+          <a:prstGeom prst="rect">
+            <a:avLst/>
+          </a:prstGeom>
+          <a:solidFill>
+            <a:srgbClr val="F2F2F5"/>
+          </a:solidFill>
+          <a:ln>
+            <a:noFill/>
+          </a:ln>
+          <a:effectLst/>
+        </p:spPr>
+        <p:txBody>
+          <a:bodyPr rtlCol="0" anchor="ctr"/>
+          <a:lstStyle/>
+          <a:p/>
+        </p:txBody>
+      </p:sp>
+      <p:sp>
+        <p:nvSpPr>
+          <p:cNvPr id="7" name="Future work text"/>
+          <p:cNvSpPr txBox="1"/>
+          <p:nvPr/>
+        </p:nvSpPr>
+        <p:spPr>
+          <a:xfrm>
+            <a:off x="5692140" y="1554480"/>
+            <a:ext cx="2674620" cy="4297680"/>
+          </a:xfrm>
+          <a:prstGeom prst="rect">
+            <a:avLst/>
+          </a:prstGeom>
+          <a:noFill/>
+        </p:spPr>
+        <p:txBody>
+          <a:bodyPr wrap="square" anchor="t" lIns="0" rIns="0" tIns="0" bIns="0">
+            <a:spAutoFit/>
+          </a:bodyPr>
+          <a:lstStyle/>
+          <a:p>
+            <a:pPr algn="l">
+              <a:spcAft>
+                <a:spcPts val="1400"/>
+              </a:spcAft>
+            </a:pPr>
+            <a:r>
+              <a:rPr sz="2000" b="1" i="0">
+                <a:solidFill>
+                  <a:srgbClr val="343174"/>
+                </a:solidFill>
+                <a:latin typeface="Calibri"/>
+              </a:rPr>
+              <a:t>Future work</a:t>
+            </a:r>
+          </a:p>
+          <a:p>
+            <a:pPr algn="l" marL="201168" indent="-201168">
+              <a:spcAft>
+                <a:spcPts val="1400"/>
+              </a:spcAft>
+              <a:buClr>
+                <a:srgbClr val="343174"/>
+              </a:buClr>
+              <a:buFont typeface="Arial"/>
+              <a:buChar char="•"/>
+            </a:pPr>
+            <a:r>
+              <a:rPr sz="1700" b="0" i="0">
+                <a:solidFill>
+                  <a:srgbClr val="22222A"/>
+                </a:solidFill>
+                <a:latin typeface="Calibri"/>
+              </a:rPr>
+              <a:t>Early-warning evaluation at weeks 2, 4, 6 and 8</a:t>
+            </a:r>
+          </a:p>
+          <a:p>
+            <a:pPr algn="l" marL="201168" indent="-201168">
+              <a:spcAft>
+                <a:spcPts val="1400"/>
+              </a:spcAft>
+              <a:buClr>
+                <a:srgbClr val="343174"/>
+              </a:buClr>
+              <a:buFont typeface="Arial"/>
+              <a:buChar char="•"/>
+            </a:pPr>
+            <a:r>
+              <a:rPr sz="1700" b="0" i="0">
+                <a:solidFill>
+                  <a:srgbClr val="22222A"/>
+                </a:solidFill>
+                <a:latin typeface="Calibri"/>
+              </a:rPr>
+              <a:t>Probability calibration (Platt, isotonic)</a:t>
+            </a:r>
+          </a:p>
+          <a:p>
+            <a:pPr algn="l" marL="201168" indent="-201168">
+              <a:spcAft>
+                <a:spcPts val="1400"/>
+              </a:spcAft>
+              <a:buClr>
+                <a:srgbClr val="343174"/>
+              </a:buClr>
+              <a:buFont typeface="Arial"/>
+              <a:buChar char="•"/>
+            </a:pPr>
+            <a:r>
+              <a:rPr sz="1700" b="0" i="0">
+                <a:solidFill>
+                  <a:srgbClr val="22222A"/>
+                </a:solidFill>
+                <a:latin typeface="Calibri"/>
+              </a:rPr>
+              <a:t>Subgroup fairness assessment</a:t>
+            </a:r>
+          </a:p>
+          <a:p>
+            <a:pPr algn="l" marL="201168" indent="-201168">
+              <a:spcAft>
+                <a:spcPts val="1400"/>
+              </a:spcAft>
+              <a:buClr>
+                <a:srgbClr val="343174"/>
+              </a:buClr>
+              <a:buFont typeface="Arial"/>
+              <a:buChar char="•"/>
+            </a:pPr>
+            <a:r>
+              <a:rPr sz="1700" b="0" i="0">
+                <a:solidFill>
+                  <a:srgbClr val="22222A"/>
+                </a:solidFill>
+                <a:latin typeface="Calibri"/>
+              </a:rPr>
+              <a:t>Practitioner study using TAM constructs</a:t>
+            </a:r>
+          </a:p>
+          <a:p>
+            <a:pPr algn="l" marL="201168" indent="-201168">
+              <a:spcAft>
+                <a:spcPts val="1400"/>
+              </a:spcAft>
+              <a:buClr>
+                <a:srgbClr val="343174"/>
+              </a:buClr>
+              <a:buFont typeface="Arial"/>
+              <a:buChar char="•"/>
+            </a:pPr>
+            <a:r>
+              <a:rPr sz="1700" b="0" i="0">
+                <a:solidFill>
+                  <a:srgbClr val="22222A"/>
+                </a:solidFill>
+                <a:latin typeface="Calibri"/>
+              </a:rPr>
+              <a:t>Other institutions and live data</a:t>
+            </a:r>
+          </a:p>
+        </p:txBody>
+      </p:sp>
+    </p:spTree>
+  </p:cSld>
+  <p:clrMapOvr>
+    <a:masterClrMapping/>
+  </p:clrMapOvr>
+</p:sld>
+</file>
+
+<file path=ppt/slides/slide24.xml><?xml version="1.0" encoding="utf-8"?>
+<p:sld xmlns:a="http://schemas.openxmlformats.org/drawingml/2006/main" xmlns:p="http://schemas.openxmlformats.org/presentationml/2006/main" xmlns:r="http://schemas.openxmlformats.org/officeDocument/2006/relationships">
+  <p:cSld>
+    <p:spTree>
+      <p:nvGrpSpPr>
+        <p:cNvPr id="1" name=""/>
+        <p:cNvGrpSpPr/>
+        <p:nvPr/>
+      </p:nvGrpSpPr>
+      <p:grpSpPr/>
+      <p:sp>
+        <p:nvSpPr>
+          <p:cNvPr id="2" name="Title 1"/>
+          <p:cNvSpPr>
+            <a:spLocks noGrp="1"/>
+          </p:cNvSpPr>
+          <p:nvPr>
+            <p:ph type="title"/>
+          </p:nvPr>
+        </p:nvSpPr>
+        <p:spPr>
+          <a:xfrm>
+            <a:off x="2240280" y="502920"/>
+            <a:ext cx="6309359" cy="731520"/>
+          </a:xfrm>
+        </p:spPr>
+        <p:txBody>
+          <a:bodyPr wrap="square" anchor="ctr" lIns="0" rIns="0">
+            <a:normAutofit/>
+          </a:bodyPr>
+          <a:lstStyle/>
+          <a:p>
+            <a:pPr algn="l"/>
+            <a:r>
+              <a:rPr sz="2800" b="1" i="0">
+                <a:solidFill>
+                  <a:srgbClr val="343174"/>
+                </a:solidFill>
+                <a:latin typeface="Calibri"/>
+              </a:rPr>
+              <a:t>Conclusion</a:t>
+            </a:r>
+          </a:p>
+        </p:txBody>
+      </p:sp>
+      <p:sp>
+        <p:nvSpPr>
+          <p:cNvPr id="3" name="Slide number"/>
+          <p:cNvSpPr txBox="1"/>
+          <p:nvPr/>
+        </p:nvSpPr>
+        <p:spPr>
+          <a:xfrm>
+            <a:off x="8001000" y="6108192"/>
+            <a:ext cx="548640" cy="256032"/>
+          </a:xfrm>
+          <a:prstGeom prst="rect">
+            <a:avLst/>
+          </a:prstGeom>
+          <a:noFill/>
+        </p:spPr>
+        <p:txBody>
+          <a:bodyPr wrap="square" anchor="t" lIns="0" rIns="0" tIns="0" bIns="0">
+            <a:spAutoFit/>
+          </a:bodyPr>
+          <a:lstStyle/>
+          <a:p>
+            <a:pPr algn="r">
+              <a:spcAft>
+                <a:spcPts val="600"/>
+              </a:spcAft>
+            </a:pPr>
+            <a:r>
+              <a:rPr sz="1100" b="0" i="0">
+                <a:solidFill>
+                  <a:srgbClr val="555560"/>
+                </a:solidFill>
+                <a:latin typeface="Calibri"/>
+              </a:rPr>
+              <a:t>22</a:t>
             </a:r>
           </a:p>
         </p:txBody>

</xml_diff>

<commit_message>
Defense deck: remove red underlines
</commit_message>
<xml_diff>
--- a/Internal_Defense_Presentation.pptx
+++ b/Internal_Defense_Presentation.pptx
@@ -8066,44 +8066,9 @@
           </a:p>
         </p:txBody>
       </p:sp>
-      <p:cxnSp>
-        <p:nvCxnSpPr>
-          <p:cNvPr id="3" name="Underline"/>
-          <p:cNvCxnSpPr/>
-          <p:nvPr/>
-        </p:nvCxnSpPr>
-        <p:spPr>
-          <a:xfrm>
-            <a:off x="2286000" y="1261872"/>
-            <a:ext cx="822960" cy="0"/>
-          </a:xfrm>
-          <a:prstGeom prst="line">
-            <a:avLst/>
-          </a:prstGeom>
-          <a:ln w="28575">
-            <a:solidFill>
-              <a:srgbClr val="C00000"/>
-            </a:solidFill>
-          </a:ln>
-        </p:spPr>
-        <p:style>
-          <a:lnRef idx="2">
-            <a:schemeClr val="accent1"/>
-          </a:lnRef>
-          <a:fillRef idx="0">
-            <a:schemeClr val="accent1"/>
-          </a:fillRef>
-          <a:effectRef idx="1">
-            <a:schemeClr val="accent1"/>
-          </a:effectRef>
-          <a:fontRef idx="minor">
-            <a:schemeClr val="tx1"/>
-          </a:fontRef>
-        </p:style>
-      </p:cxnSp>
-      <p:sp>
-        <p:nvSpPr>
-          <p:cNvPr id="4" name="Number 1"/>
+      <p:sp>
+        <p:nvSpPr>
+          <p:cNvPr id="3" name="Number 1"/>
           <p:cNvSpPr txBox="1"/>
           <p:nvPr/>
         </p:nvSpPr>
@@ -8158,7 +8123,7 @@
       </p:sp>
       <p:sp>
         <p:nvSpPr>
-          <p:cNvPr id="5" name="Number 2"/>
+          <p:cNvPr id="4" name="Number 2"/>
           <p:cNvSpPr txBox="1"/>
           <p:nvPr/>
         </p:nvSpPr>
@@ -8213,7 +8178,7 @@
       </p:sp>
       <p:sp>
         <p:nvSpPr>
-          <p:cNvPr id="6" name="Number 3"/>
+          <p:cNvPr id="5" name="Number 3"/>
           <p:cNvSpPr txBox="1"/>
           <p:nvPr/>
         </p:nvSpPr>
@@ -8266,44 +8231,9 @@
           </a:p>
         </p:txBody>
       </p:sp>
-      <p:cxnSp>
-        <p:nvCxnSpPr>
-          <p:cNvPr id="7" name="Recall underline"/>
-          <p:cNvCxnSpPr/>
-          <p:nvPr/>
-        </p:nvCxnSpPr>
-        <p:spPr>
-          <a:xfrm>
-            <a:off x="2286000" y="2450592"/>
-            <a:ext cx="1097280" cy="0"/>
-          </a:xfrm>
-          <a:prstGeom prst="line">
-            <a:avLst/>
-          </a:prstGeom>
-          <a:ln w="19050">
-            <a:solidFill>
-              <a:srgbClr val="C00000"/>
-            </a:solidFill>
-          </a:ln>
-        </p:spPr>
-        <p:style>
-          <a:lnRef idx="2">
-            <a:schemeClr val="accent1"/>
-          </a:lnRef>
-          <a:fillRef idx="0">
-            <a:schemeClr val="accent1"/>
-          </a:fillRef>
-          <a:effectRef idx="1">
-            <a:schemeClr val="accent1"/>
-          </a:effectRef>
-          <a:fontRef idx="minor">
-            <a:schemeClr val="tx1"/>
-          </a:fontRef>
-        </p:style>
-      </p:cxnSp>
-      <p:sp>
-        <p:nvSpPr>
-          <p:cNvPr id="8" name="XGBoost"/>
+      <p:sp>
+        <p:nvSpPr>
+          <p:cNvPr id="6" name="XGBoost"/>
           <p:cNvSpPr txBox="1"/>
           <p:nvPr/>
         </p:nvSpPr>
@@ -8423,7 +8353,7 @@
       </p:sp>
       <p:sp>
         <p:nvSpPr>
-          <p:cNvPr id="9" name="Comparison"/>
+          <p:cNvPr id="7" name="Comparison"/>
           <p:cNvSpPr txBox="1"/>
           <p:nvPr/>
         </p:nvSpPr>
@@ -8552,7 +8482,7 @@
       </p:sp>
       <p:sp>
         <p:nvSpPr>
-          <p:cNvPr id="10" name="Variability"/>
+          <p:cNvPr id="8" name="Variability"/>
           <p:cNvSpPr txBox="1"/>
           <p:nvPr/>
         </p:nvSpPr>
@@ -8663,44 +8593,9 @@
           </a:p>
         </p:txBody>
       </p:sp>
-      <p:cxnSp>
-        <p:nvCxnSpPr>
-          <p:cNvPr id="3" name="Underline"/>
-          <p:cNvCxnSpPr/>
-          <p:nvPr/>
-        </p:nvCxnSpPr>
-        <p:spPr>
-          <a:xfrm>
-            <a:off x="2286000" y="1261872"/>
-            <a:ext cx="822960" cy="0"/>
-          </a:xfrm>
-          <a:prstGeom prst="line">
-            <a:avLst/>
-          </a:prstGeom>
-          <a:ln w="28575">
-            <a:solidFill>
-              <a:srgbClr val="C00000"/>
-            </a:solidFill>
-          </a:ln>
-        </p:spPr>
-        <p:style>
-          <a:lnRef idx="2">
-            <a:schemeClr val="accent1"/>
-          </a:lnRef>
-          <a:fillRef idx="0">
-            <a:schemeClr val="accent1"/>
-          </a:fillRef>
-          <a:effectRef idx="1">
-            <a:schemeClr val="accent1"/>
-          </a:effectRef>
-          <a:fontRef idx="minor">
-            <a:schemeClr val="tx1"/>
-          </a:fontRef>
-        </p:style>
-      </p:cxnSp>
-      <p:sp>
-        <p:nvSpPr>
-          <p:cNvPr id="4" name="Global"/>
+      <p:sp>
+        <p:nvSpPr>
+          <p:cNvPr id="3" name="Global"/>
           <p:cNvSpPr txBox="1"/>
           <p:nvPr/>
         </p:nvSpPr>
@@ -8790,7 +8685,7 @@
       </p:sp>
       <p:sp>
         <p:nvSpPr>
-          <p:cNvPr id="5" name="Agreement"/>
+          <p:cNvPr id="4" name="Agreement"/>
           <p:cNvSpPr txBox="1"/>
           <p:nvPr/>
         </p:nvSpPr>
@@ -8910,7 +8805,7 @@
       </p:sp>
       <p:sp>
         <p:nvSpPr>
-          <p:cNvPr id="6" name="Example"/>
+          <p:cNvPr id="5" name="Example"/>
           <p:cNvSpPr txBox="1"/>
           <p:nvPr/>
         </p:nvSpPr>
@@ -8991,7 +8886,7 @@
       </p:sp>
       <p:sp>
         <p:nvSpPr>
-          <p:cNvPr id="7" name="Caution"/>
+          <p:cNvPr id="6" name="Caution"/>
           <p:cNvSpPr txBox="1"/>
           <p:nvPr/>
         </p:nvSpPr>
@@ -9123,44 +9018,9 @@
           </a:p>
         </p:txBody>
       </p:sp>
-      <p:cxnSp>
-        <p:nvCxnSpPr>
-          <p:cNvPr id="3" name="Underline"/>
-          <p:cNvCxnSpPr/>
-          <p:nvPr/>
-        </p:nvCxnSpPr>
-        <p:spPr>
-          <a:xfrm>
-            <a:off x="2286000" y="1261872"/>
-            <a:ext cx="822960" cy="0"/>
-          </a:xfrm>
-          <a:prstGeom prst="line">
-            <a:avLst/>
-          </a:prstGeom>
-          <a:ln w="28575">
-            <a:solidFill>
-              <a:srgbClr val="C00000"/>
-            </a:solidFill>
-          </a:ln>
-        </p:spPr>
-        <p:style>
-          <a:lnRef idx="2">
-            <a:schemeClr val="accent1"/>
-          </a:lnRef>
-          <a:fillRef idx="0">
-            <a:schemeClr val="accent1"/>
-          </a:fillRef>
-          <a:effectRef idx="1">
-            <a:schemeClr val="accent1"/>
-          </a:effectRef>
-          <a:fontRef idx="minor">
-            <a:schemeClr val="tx1"/>
-          </a:fontRef>
-        </p:style>
-      </p:cxnSp>
       <p:pic>
         <p:nvPicPr>
-          <p:cNvPr id="4" name="Moodle instructor view" descr="wide_instr.png"/>
+          <p:cNvPr id="3" name="Moodle instructor view" descr="wide_instr.png"/>
           <p:cNvPicPr>
             <a:picLocks noChangeAspect="1"/>
           </p:cNvPicPr>
@@ -9189,7 +9049,7 @@
       </p:pic>
       <p:sp>
         <p:nvSpPr>
-          <p:cNvPr id="5" name="Roles"/>
+          <p:cNvPr id="4" name="Roles"/>
           <p:cNvSpPr txBox="1"/>
           <p:nvPr/>
         </p:nvSpPr>
@@ -9338,44 +9198,9 @@
           </a:p>
         </p:txBody>
       </p:sp>
-      <p:cxnSp>
-        <p:nvCxnSpPr>
-          <p:cNvPr id="3" name="Underline"/>
-          <p:cNvCxnSpPr/>
-          <p:nvPr/>
-        </p:nvCxnSpPr>
-        <p:spPr>
-          <a:xfrm>
-            <a:off x="2286000" y="1261872"/>
-            <a:ext cx="822960" cy="0"/>
-          </a:xfrm>
-          <a:prstGeom prst="line">
-            <a:avLst/>
-          </a:prstGeom>
-          <a:ln w="28575">
-            <a:solidFill>
-              <a:srgbClr val="C00000"/>
-            </a:solidFill>
-          </a:ln>
-        </p:spPr>
-        <p:style>
-          <a:lnRef idx="2">
-            <a:schemeClr val="accent1"/>
-          </a:lnRef>
-          <a:fillRef idx="0">
-            <a:schemeClr val="accent1"/>
-          </a:fillRef>
-          <a:effectRef idx="1">
-            <a:schemeClr val="accent1"/>
-          </a:effectRef>
-          <a:fontRef idx="minor">
-            <a:schemeClr val="tx1"/>
-          </a:fontRef>
-        </p:style>
-      </p:cxnSp>
-      <p:sp>
-        <p:nvSpPr>
-          <p:cNvPr id="4" name="Contributions"/>
+      <p:sp>
+        <p:nvSpPr>
+          <p:cNvPr id="3" name="Contributions"/>
           <p:cNvSpPr txBox="1"/>
           <p:nvPr/>
         </p:nvSpPr>
@@ -9498,7 +9323,7 @@
       </p:sp>
       <p:sp>
         <p:nvSpPr>
-          <p:cNvPr id="5" name="Limitations"/>
+          <p:cNvPr id="4" name="Limitations"/>
           <p:cNvSpPr txBox="1"/>
           <p:nvPr/>
         </p:nvSpPr>
@@ -9672,44 +9497,9 @@
           </a:p>
         </p:txBody>
       </p:sp>
-      <p:cxnSp>
-        <p:nvCxnSpPr>
-          <p:cNvPr id="3" name="Underline"/>
-          <p:cNvCxnSpPr/>
-          <p:nvPr/>
-        </p:nvCxnSpPr>
-        <p:spPr>
-          <a:xfrm>
-            <a:off x="2286000" y="1261872"/>
-            <a:ext cx="822960" cy="0"/>
-          </a:xfrm>
-          <a:prstGeom prst="line">
-            <a:avLst/>
-          </a:prstGeom>
-          <a:ln w="28575">
-            <a:solidFill>
-              <a:srgbClr val="C00000"/>
-            </a:solidFill>
-          </a:ln>
-        </p:spPr>
-        <p:style>
-          <a:lnRef idx="2">
-            <a:schemeClr val="accent1"/>
-          </a:lnRef>
-          <a:fillRef idx="0">
-            <a:schemeClr val="accent1"/>
-          </a:fillRef>
-          <a:effectRef idx="1">
-            <a:schemeClr val="accent1"/>
-          </a:effectRef>
-          <a:fontRef idx="minor">
-            <a:schemeClr val="tx1"/>
-          </a:fontRef>
-        </p:style>
-      </p:cxnSp>
-      <p:sp>
-        <p:nvSpPr>
-          <p:cNvPr id="4" name="Answers"/>
+      <p:sp>
+        <p:nvSpPr>
+          <p:cNvPr id="3" name="Answers"/>
           <p:cNvSpPr txBox="1"/>
           <p:nvPr/>
         </p:nvSpPr>
@@ -9838,7 +9628,7 @@
       </p:sp>
       <p:sp>
         <p:nvSpPr>
-          <p:cNvPr id="5" name="Future work"/>
+          <p:cNvPr id="4" name="Future work"/>
           <p:cNvSpPr txBox="1"/>
           <p:nvPr/>
         </p:nvSpPr>
@@ -10147,44 +9937,9 @@
           </a:p>
         </p:txBody>
       </p:sp>
-      <p:cxnSp>
-        <p:nvCxnSpPr>
-          <p:cNvPr id="4" name="Underline"/>
-          <p:cNvCxnSpPr/>
-          <p:nvPr/>
-        </p:nvCxnSpPr>
-        <p:spPr>
-          <a:xfrm>
-            <a:off x="2286000" y="3154680"/>
-            <a:ext cx="914400" cy="0"/>
-          </a:xfrm>
-          <a:prstGeom prst="line">
-            <a:avLst/>
-          </a:prstGeom>
-          <a:ln w="28575">
-            <a:solidFill>
-              <a:srgbClr val="C00000"/>
-            </a:solidFill>
-          </a:ln>
-        </p:spPr>
-        <p:style>
-          <a:lnRef idx="2">
-            <a:schemeClr val="accent1"/>
-          </a:lnRef>
-          <a:fillRef idx="0">
-            <a:schemeClr val="accent1"/>
-          </a:fillRef>
-          <a:effectRef idx="1">
-            <a:schemeClr val="accent1"/>
-          </a:effectRef>
-          <a:fontRef idx="minor">
-            <a:schemeClr val="tx1"/>
-          </a:fontRef>
-        </p:style>
-      </p:cxnSp>
-      <p:sp>
-        <p:nvSpPr>
-          <p:cNvPr id="5" name="Cover details"/>
+      <p:sp>
+        <p:nvSpPr>
+          <p:cNvPr id="4" name="Cover details"/>
           <p:cNvSpPr txBox="1"/>
           <p:nvPr/>
         </p:nvSpPr>
@@ -10322,44 +10077,9 @@
           </a:p>
         </p:txBody>
       </p:sp>
-      <p:cxnSp>
-        <p:nvCxnSpPr>
-          <p:cNvPr id="3" name="Underline"/>
-          <p:cNvCxnSpPr/>
-          <p:nvPr/>
-        </p:nvCxnSpPr>
-        <p:spPr>
-          <a:xfrm>
-            <a:off x="2286000" y="1261872"/>
-            <a:ext cx="822960" cy="0"/>
-          </a:xfrm>
-          <a:prstGeom prst="line">
-            <a:avLst/>
-          </a:prstGeom>
-          <a:ln w="28575">
-            <a:solidFill>
-              <a:srgbClr val="C00000"/>
-            </a:solidFill>
-          </a:ln>
-        </p:spPr>
-        <p:style>
-          <a:lnRef idx="2">
-            <a:schemeClr val="accent1"/>
-          </a:lnRef>
-          <a:fillRef idx="0">
-            <a:schemeClr val="accent1"/>
-          </a:fillRef>
-          <a:effectRef idx="1">
-            <a:schemeClr val="accent1"/>
-          </a:effectRef>
-          <a:fontRef idx="minor">
-            <a:schemeClr val="tx1"/>
-          </a:fontRef>
-        </p:style>
-      </p:cxnSp>
-      <p:sp>
-        <p:nvSpPr>
-          <p:cNvPr id="4" name="Outline"/>
+      <p:sp>
+        <p:nvSpPr>
+          <p:cNvPr id="3" name="Outline"/>
           <p:cNvSpPr txBox="1"/>
           <p:nvPr/>
         </p:nvSpPr>
@@ -10633,44 +10353,9 @@
           </a:p>
         </p:txBody>
       </p:sp>
-      <p:cxnSp>
-        <p:nvCxnSpPr>
-          <p:cNvPr id="3" name="Underline"/>
-          <p:cNvCxnSpPr/>
-          <p:nvPr/>
-        </p:nvCxnSpPr>
-        <p:spPr>
-          <a:xfrm>
-            <a:off x="2286000" y="1261872"/>
-            <a:ext cx="822960" cy="0"/>
-          </a:xfrm>
-          <a:prstGeom prst="line">
-            <a:avLst/>
-          </a:prstGeom>
-          <a:ln w="28575">
-            <a:solidFill>
-              <a:srgbClr val="C00000"/>
-            </a:solidFill>
-          </a:ln>
-        </p:spPr>
-        <p:style>
-          <a:lnRef idx="2">
-            <a:schemeClr val="accent1"/>
-          </a:lnRef>
-          <a:fillRef idx="0">
-            <a:schemeClr val="accent1"/>
-          </a:fillRef>
-          <a:effectRef idx="1">
-            <a:schemeClr val="accent1"/>
-          </a:effectRef>
-          <a:fontRef idx="minor">
-            <a:schemeClr val="tx1"/>
-          </a:fontRef>
-        </p:style>
-      </p:cxnSp>
-      <p:sp>
-        <p:nvSpPr>
-          <p:cNvPr id="4" name="Context"/>
+      <p:sp>
+        <p:nvSpPr>
+          <p:cNvPr id="3" name="Context"/>
           <p:cNvSpPr txBox="1"/>
           <p:nvPr/>
         </p:nvSpPr>
@@ -10751,7 +10436,7 @@
       </p:sp>
       <p:sp>
         <p:nvSpPr>
-          <p:cNvPr id="5" name="Problem"/>
+          <p:cNvPr id="4" name="Problem"/>
           <p:cNvSpPr txBox="1"/>
           <p:nvPr/>
         </p:nvSpPr>
@@ -10853,7 +10538,7 @@
       </p:sp>
       <p:sp>
         <p:nvSpPr>
-          <p:cNvPr id="6" name="Gap"/>
+          <p:cNvPr id="5" name="Gap"/>
           <p:cNvSpPr txBox="1"/>
           <p:nvPr/>
         </p:nvSpPr>
@@ -10934,7 +10619,7 @@
       </p:sp>
       <p:sp>
         <p:nvSpPr>
-          <p:cNvPr id="7" name="Scale"/>
+          <p:cNvPr id="6" name="Scale"/>
           <p:cNvSpPr txBox="1"/>
           <p:nvPr/>
         </p:nvSpPr>
@@ -11072,44 +10757,9 @@
           </a:p>
         </p:txBody>
       </p:sp>
-      <p:cxnSp>
-        <p:nvCxnSpPr>
-          <p:cNvPr id="3" name="Underline"/>
-          <p:cNvCxnSpPr/>
-          <p:nvPr/>
-        </p:nvCxnSpPr>
-        <p:spPr>
-          <a:xfrm>
-            <a:off x="2286000" y="1261872"/>
-            <a:ext cx="822960" cy="0"/>
-          </a:xfrm>
-          <a:prstGeom prst="line">
-            <a:avLst/>
-          </a:prstGeom>
-          <a:ln w="28575">
-            <a:solidFill>
-              <a:srgbClr val="C00000"/>
-            </a:solidFill>
-          </a:ln>
-        </p:spPr>
-        <p:style>
-          <a:lnRef idx="2">
-            <a:schemeClr val="accent1"/>
-          </a:lnRef>
-          <a:fillRef idx="0">
-            <a:schemeClr val="accent1"/>
-          </a:fillRef>
-          <a:effectRef idx="1">
-            <a:schemeClr val="accent1"/>
-          </a:effectRef>
-          <a:fontRef idx="minor">
-            <a:schemeClr val="tx1"/>
-          </a:fontRef>
-        </p:style>
-      </p:cxnSp>
-      <p:sp>
-        <p:nvSpPr>
-          <p:cNvPr id="4" name="Aim"/>
+      <p:sp>
+        <p:nvSpPr>
+          <p:cNvPr id="3" name="Aim"/>
           <p:cNvSpPr txBox="1"/>
           <p:nvPr/>
         </p:nvSpPr>
@@ -11157,7 +10807,7 @@
       </p:sp>
       <p:sp>
         <p:nvSpPr>
-          <p:cNvPr id="5" name="Objectives"/>
+          <p:cNvPr id="4" name="Objectives"/>
           <p:cNvSpPr txBox="1"/>
           <p:nvPr/>
         </p:nvSpPr>
@@ -11286,7 +10936,7 @@
       </p:sp>
       <p:sp>
         <p:nvSpPr>
-          <p:cNvPr id="6" name="Research questions"/>
+          <p:cNvPr id="5" name="Research questions"/>
           <p:cNvSpPr txBox="1"/>
           <p:nvPr/>
         </p:nvSpPr>
@@ -11466,44 +11116,9 @@
           </a:p>
         </p:txBody>
       </p:sp>
-      <p:cxnSp>
-        <p:nvCxnSpPr>
-          <p:cNvPr id="3" name="Underline"/>
-          <p:cNvCxnSpPr/>
-          <p:nvPr/>
-        </p:nvCxnSpPr>
-        <p:spPr>
-          <a:xfrm>
-            <a:off x="2286000" y="1261872"/>
-            <a:ext cx="822960" cy="0"/>
-          </a:xfrm>
-          <a:prstGeom prst="line">
-            <a:avLst/>
-          </a:prstGeom>
-          <a:ln w="28575">
-            <a:solidFill>
-              <a:srgbClr val="C00000"/>
-            </a:solidFill>
-          </a:ln>
-        </p:spPr>
-        <p:style>
-          <a:lnRef idx="2">
-            <a:schemeClr val="accent1"/>
-          </a:lnRef>
-          <a:fillRef idx="0">
-            <a:schemeClr val="accent1"/>
-          </a:fillRef>
-          <a:effectRef idx="1">
-            <a:schemeClr val="accent1"/>
-          </a:effectRef>
-          <a:fontRef idx="minor">
-            <a:schemeClr val="tx1"/>
-          </a:fontRef>
-        </p:style>
-      </p:cxnSp>
-      <p:sp>
-        <p:nvSpPr>
-          <p:cNvPr id="4" name="CommonKADS"/>
+      <p:sp>
+        <p:nvSpPr>
+          <p:cNvPr id="3" name="CommonKADS"/>
           <p:cNvSpPr txBox="1"/>
           <p:nvPr/>
         </p:nvSpPr>
@@ -11605,7 +11220,7 @@
       </p:sp>
       <p:sp>
         <p:nvSpPr>
-          <p:cNvPr id="5" name="Supporting"/>
+          <p:cNvPr id="4" name="Supporting"/>
           <p:cNvSpPr txBox="1"/>
           <p:nvPr/>
         </p:nvSpPr>
@@ -11704,7 +11319,7 @@
       </p:sp>
       <p:sp>
         <p:nvSpPr>
-          <p:cNvPr id="6" name="Phases"/>
+          <p:cNvPr id="5" name="Phases"/>
           <p:cNvSpPr txBox="1"/>
           <p:nvPr/>
         </p:nvSpPr>
@@ -11843,7 +11458,7 @@
       </p:sp>
       <p:sp>
         <p:nvSpPr>
-          <p:cNvPr id="7" name="Scope"/>
+          <p:cNvPr id="6" name="Scope"/>
           <p:cNvSpPr txBox="1"/>
           <p:nvPr/>
         </p:nvSpPr>
@@ -11975,24 +11590,80 @@
           </a:p>
         </p:txBody>
       </p:sp>
+      <p:sp>
+        <p:nvSpPr>
+          <p:cNvPr id="3" name="Flow 1"/>
+          <p:cNvSpPr txBox="1"/>
+          <p:nvPr/>
+        </p:nvSpPr>
+        <p:spPr>
+          <a:xfrm>
+            <a:off x="2286000" y="1463040"/>
+            <a:ext cx="877824" cy="868680"/>
+          </a:xfrm>
+          <a:prstGeom prst="rect">
+            <a:avLst/>
+          </a:prstGeom>
+          <a:noFill/>
+        </p:spPr>
+        <p:txBody>
+          <a:bodyPr wrap="square" anchor="t" lIns="0" rIns="0" tIns="0" bIns="0">
+            <a:spAutoFit/>
+          </a:bodyPr>
+          <a:lstStyle/>
+          <a:p>
+            <a:pPr algn="l">
+              <a:spcAft>
+                <a:spcPts val="0"/>
+              </a:spcAft>
+            </a:pPr>
+            <a:r>
+              <a:rPr sz="1800" b="1" i="0">
+                <a:solidFill>
+                  <a:srgbClr val="1F3864"/>
+                </a:solidFill>
+                <a:latin typeface="Calibri"/>
+              </a:rPr>
+              <a:t>Data</a:t>
+            </a:r>
+          </a:p>
+          <a:p>
+            <a:pPr algn="l">
+              <a:spcAft>
+                <a:spcPts val="0"/>
+              </a:spcAft>
+            </a:pPr>
+            <a:r>
+              <a:rPr sz="1300" b="0" i="0">
+                <a:solidFill>
+                  <a:srgbClr val="59595F"/>
+                </a:solidFill>
+                <a:latin typeface="Calibri"/>
+              </a:rPr>
+              <a:t>OULAD features</a:t>
+            </a:r>
+          </a:p>
+        </p:txBody>
+      </p:sp>
       <p:cxnSp>
         <p:nvCxnSpPr>
-          <p:cNvPr id="3" name="Underline"/>
+          <p:cNvPr id="4" name="Flow arrow 1"/>
           <p:cNvCxnSpPr/>
           <p:nvPr/>
         </p:nvCxnSpPr>
         <p:spPr>
           <a:xfrm>
-            <a:off x="2286000" y="1261872"/>
-            <a:ext cx="822960" cy="0"/>
+            <a:off x="3182112" y="1645920"/>
+            <a:ext cx="256032" cy="0"/>
           </a:xfrm>
           <a:prstGeom prst="line">
             <a:avLst/>
           </a:prstGeom>
-          <a:ln w="28575">
+          <a:ln w="19050">
             <a:solidFill>
-              <a:srgbClr val="C00000"/>
+              <a:srgbClr val="59595F"/>
             </a:solidFill>
+            <a:tailEnd type="triangle" w="med" len="med"/>
           </a:ln>
         </p:spPr>
         <p:style>
@@ -12012,13 +11683,13 @@
       </p:cxnSp>
       <p:sp>
         <p:nvSpPr>
-          <p:cNvPr id="4" name="Flow 1"/>
+          <p:cNvPr id="5" name="Flow 2"/>
           <p:cNvSpPr txBox="1"/>
           <p:nvPr/>
         </p:nvSpPr>
         <p:spPr>
           <a:xfrm>
-            <a:off x="2286000" y="1463040"/>
+            <a:off x="3529584" y="1463040"/>
             <a:ext cx="877824" cy="868680"/>
           </a:xfrm>
           <a:prstGeom prst="rect">
@@ -12044,7 +11715,7 @@
                 </a:solidFill>
                 <a:latin typeface="Calibri"/>
               </a:rPr>
-              <a:t>Data</a:t>
+              <a:t>Model</a:t>
             </a:r>
           </a:p>
           <a:p>
@@ -12060,20 +11731,20 @@
                 </a:solidFill>
                 <a:latin typeface="Calibri"/>
               </a:rPr>
-              <a:t>OULAD features</a:t>
+              <a:t>XGBoost</a:t>
             </a:r>
           </a:p>
         </p:txBody>
       </p:sp>
       <p:cxnSp>
         <p:nvCxnSpPr>
-          <p:cNvPr id="5" name="Flow arrow 1"/>
+          <p:cNvPr id="6" name="Flow arrow 2"/>
           <p:cNvCxnSpPr/>
           <p:nvPr/>
         </p:nvCxnSpPr>
         <p:spPr>
           <a:xfrm>
-            <a:off x="3182112" y="1645920"/>
+            <a:off x="4425696" y="1645920"/>
             <a:ext cx="256032" cy="0"/>
           </a:xfrm>
           <a:prstGeom prst="line">
@@ -12103,13 +11774,13 @@
       </p:cxnSp>
       <p:sp>
         <p:nvSpPr>
-          <p:cNvPr id="6" name="Flow 2"/>
+          <p:cNvPr id="7" name="Flow 3"/>
           <p:cNvSpPr txBox="1"/>
           <p:nvPr/>
         </p:nvSpPr>
         <p:spPr>
           <a:xfrm>
-            <a:off x="3529584" y="1463040"/>
+            <a:off x="4773168" y="1463040"/>
             <a:ext cx="877824" cy="868680"/>
           </a:xfrm>
           <a:prstGeom prst="rect">
@@ -12135,7 +11806,7 @@
                 </a:solidFill>
                 <a:latin typeface="Calibri"/>
               </a:rPr>
-              <a:t>Model</a:t>
+              <a:t>Explain</a:t>
             </a:r>
           </a:p>
           <a:p>
@@ -12151,20 +11822,20 @@
                 </a:solidFill>
                 <a:latin typeface="Calibri"/>
               </a:rPr>
-              <a:t>XGBoost</a:t>
+              <a:t>TreeSHAP + LIME</a:t>
             </a:r>
           </a:p>
         </p:txBody>
       </p:sp>
       <p:cxnSp>
         <p:nvCxnSpPr>
-          <p:cNvPr id="7" name="Flow arrow 2"/>
+          <p:cNvPr id="8" name="Flow arrow 3"/>
           <p:cNvCxnSpPr/>
           <p:nvPr/>
         </p:nvCxnSpPr>
         <p:spPr>
           <a:xfrm>
-            <a:off x="4425696" y="1645920"/>
+            <a:off x="5669280" y="1645920"/>
             <a:ext cx="256032" cy="0"/>
           </a:xfrm>
           <a:prstGeom prst="line">
@@ -12194,13 +11865,13 @@
       </p:cxnSp>
       <p:sp>
         <p:nvSpPr>
-          <p:cNvPr id="8" name="Flow 3"/>
+          <p:cNvPr id="9" name="Flow 4"/>
           <p:cNvSpPr txBox="1"/>
           <p:nvPr/>
         </p:nvSpPr>
         <p:spPr>
           <a:xfrm>
-            <a:off x="4773168" y="1463040"/>
+            <a:off x="6016752" y="1463040"/>
             <a:ext cx="877824" cy="868680"/>
           </a:xfrm>
           <a:prstGeom prst="rect">
@@ -12226,7 +11897,7 @@
                 </a:solidFill>
                 <a:latin typeface="Calibri"/>
               </a:rPr>
-              <a:t>Explain</a:t>
+              <a:t>API</a:t>
             </a:r>
           </a:p>
           <a:p>
@@ -12242,20 +11913,20 @@
                 </a:solidFill>
                 <a:latin typeface="Calibri"/>
               </a:rPr>
-              <a:t>TreeSHAP + LIME</a:t>
+              <a:t>JWT, roles</a:t>
             </a:r>
           </a:p>
         </p:txBody>
       </p:sp>
       <p:cxnSp>
         <p:nvCxnSpPr>
-          <p:cNvPr id="9" name="Flow arrow 3"/>
+          <p:cNvPr id="10" name="Flow arrow 4"/>
           <p:cNvCxnSpPr/>
           <p:nvPr/>
         </p:nvCxnSpPr>
         <p:spPr>
           <a:xfrm>
-            <a:off x="5669280" y="1645920"/>
+            <a:off x="6912864" y="1645920"/>
             <a:ext cx="256032" cy="0"/>
           </a:xfrm>
           <a:prstGeom prst="line">
@@ -12285,13 +11956,13 @@
       </p:cxnSp>
       <p:sp>
         <p:nvSpPr>
-          <p:cNvPr id="10" name="Flow 4"/>
+          <p:cNvPr id="11" name="Flow 5"/>
           <p:cNvSpPr txBox="1"/>
           <p:nvPr/>
         </p:nvSpPr>
         <p:spPr>
           <a:xfrm>
-            <a:off x="6016752" y="1463040"/>
+            <a:off x="7260336" y="1463040"/>
             <a:ext cx="877824" cy="868680"/>
           </a:xfrm>
           <a:prstGeom prst="rect">
@@ -12317,7 +11988,7 @@
                 </a:solidFill>
                 <a:latin typeface="Calibri"/>
               </a:rPr>
-              <a:t>API</a:t>
+              <a:t>Views</a:t>
             </a:r>
           </a:p>
           <a:p>
@@ -12333,97 +12004,6 @@
                 </a:solidFill>
                 <a:latin typeface="Calibri"/>
               </a:rPr>
-              <a:t>JWT, roles</a:t>
-            </a:r>
-          </a:p>
-        </p:txBody>
-      </p:sp>
-      <p:cxnSp>
-        <p:nvCxnSpPr>
-          <p:cNvPr id="11" name="Flow arrow 4"/>
-          <p:cNvCxnSpPr/>
-          <p:nvPr/>
-        </p:nvCxnSpPr>
-        <p:spPr>
-          <a:xfrm>
-            <a:off x="6912864" y="1645920"/>
-            <a:ext cx="256032" cy="0"/>
-          </a:xfrm>
-          <a:prstGeom prst="line">
-            <a:avLst/>
-          </a:prstGeom>
-          <a:ln w="19050">
-            <a:solidFill>
-              <a:srgbClr val="59595F"/>
-            </a:solidFill>
-            <a:tailEnd type="triangle" w="med" len="med"/>
-          </a:ln>
-        </p:spPr>
-        <p:style>
-          <a:lnRef idx="2">
-            <a:schemeClr val="accent1"/>
-          </a:lnRef>
-          <a:fillRef idx="0">
-            <a:schemeClr val="accent1"/>
-          </a:fillRef>
-          <a:effectRef idx="1">
-            <a:schemeClr val="accent1"/>
-          </a:effectRef>
-          <a:fontRef idx="minor">
-            <a:schemeClr val="tx1"/>
-          </a:fontRef>
-        </p:style>
-      </p:cxnSp>
-      <p:sp>
-        <p:nvSpPr>
-          <p:cNvPr id="12" name="Flow 5"/>
-          <p:cNvSpPr txBox="1"/>
-          <p:nvPr/>
-        </p:nvSpPr>
-        <p:spPr>
-          <a:xfrm>
-            <a:off x="7260336" y="1463040"/>
-            <a:ext cx="877824" cy="868680"/>
-          </a:xfrm>
-          <a:prstGeom prst="rect">
-            <a:avLst/>
-          </a:prstGeom>
-          <a:noFill/>
-        </p:spPr>
-        <p:txBody>
-          <a:bodyPr wrap="square" anchor="t" lIns="0" rIns="0" tIns="0" bIns="0">
-            <a:spAutoFit/>
-          </a:bodyPr>
-          <a:lstStyle/>
-          <a:p>
-            <a:pPr algn="l">
-              <a:spcAft>
-                <a:spcPts val="0"/>
-              </a:spcAft>
-            </a:pPr>
-            <a:r>
-              <a:rPr sz="1800" b="1" i="0">
-                <a:solidFill>
-                  <a:srgbClr val="1F3864"/>
-                </a:solidFill>
-                <a:latin typeface="Calibri"/>
-              </a:rPr>
-              <a:t>Views</a:t>
-            </a:r>
-          </a:p>
-          <a:p>
-            <a:pPr algn="l">
-              <a:spcAft>
-                <a:spcPts val="0"/>
-              </a:spcAft>
-            </a:pPr>
-            <a:r>
-              <a:rPr sz="1300" b="0" i="0">
-                <a:solidFill>
-                  <a:srgbClr val="59595F"/>
-                </a:solidFill>
-                <a:latin typeface="Calibri"/>
-              </a:rPr>
               <a:t>3 role views</a:t>
             </a:r>
           </a:p>
@@ -12431,7 +12011,7 @@
       </p:sp>
       <p:sp>
         <p:nvSpPr>
-          <p:cNvPr id="13" name="Implementation"/>
+          <p:cNvPr id="12" name="Implementation"/>
           <p:cNvSpPr txBox="1"/>
           <p:nvPr/>
         </p:nvSpPr>
@@ -12560,7 +12140,7 @@
       </p:sp>
       <p:sp>
         <p:nvSpPr>
-          <p:cNvPr id="14" name="LMS"/>
+          <p:cNvPr id="13" name="LMS"/>
           <p:cNvSpPr txBox="1"/>
           <p:nvPr/>
         </p:nvSpPr>
@@ -12740,44 +12320,9 @@
           </a:p>
         </p:txBody>
       </p:sp>
-      <p:cxnSp>
-        <p:nvCxnSpPr>
-          <p:cNvPr id="3" name="Underline"/>
-          <p:cNvCxnSpPr/>
-          <p:nvPr/>
-        </p:nvCxnSpPr>
-        <p:spPr>
-          <a:xfrm>
-            <a:off x="2286000" y="1261872"/>
-            <a:ext cx="822960" cy="0"/>
-          </a:xfrm>
-          <a:prstGeom prst="line">
-            <a:avLst/>
-          </a:prstGeom>
-          <a:ln w="28575">
-            <a:solidFill>
-              <a:srgbClr val="C00000"/>
-            </a:solidFill>
-          </a:ln>
-        </p:spPr>
-        <p:style>
-          <a:lnRef idx="2">
-            <a:schemeClr val="accent1"/>
-          </a:lnRef>
-          <a:fillRef idx="0">
-            <a:schemeClr val="accent1"/>
-          </a:fillRef>
-          <a:effectRef idx="1">
-            <a:schemeClr val="accent1"/>
-          </a:effectRef>
-          <a:fontRef idx="minor">
-            <a:schemeClr val="tx1"/>
-          </a:fontRef>
-        </p:style>
-      </p:cxnSp>
-      <p:sp>
-        <p:nvSpPr>
-          <p:cNvPr id="4" name="Number 1"/>
+      <p:sp>
+        <p:nvSpPr>
+          <p:cNvPr id="3" name="Number 1"/>
           <p:cNvSpPr txBox="1"/>
           <p:nvPr/>
         </p:nvSpPr>
@@ -12832,7 +12377,7 @@
       </p:sp>
       <p:sp>
         <p:nvSpPr>
-          <p:cNvPr id="5" name="Number 2"/>
+          <p:cNvPr id="4" name="Number 2"/>
           <p:cNvSpPr txBox="1"/>
           <p:nvPr/>
         </p:nvSpPr>
@@ -12887,7 +12432,7 @@
       </p:sp>
       <p:sp>
         <p:nvSpPr>
-          <p:cNvPr id="6" name="Number 3"/>
+          <p:cNvPr id="5" name="Number 3"/>
           <p:cNvSpPr txBox="1"/>
           <p:nvPr/>
         </p:nvSpPr>
@@ -12942,7 +12487,7 @@
       </p:sp>
       <p:sp>
         <p:nvSpPr>
-          <p:cNvPr id="7" name="Dataset"/>
+          <p:cNvPr id="6" name="Dataset"/>
           <p:cNvSpPr txBox="1"/>
           <p:nvPr/>
         </p:nvSpPr>
@@ -13023,7 +12568,7 @@
       </p:sp>
       <p:sp>
         <p:nvSpPr>
-          <p:cNvPr id="8" name="Protocol"/>
+          <p:cNvPr id="7" name="Protocol"/>
           <p:cNvSpPr txBox="1"/>
           <p:nvPr/>
         </p:nvSpPr>
@@ -13104,7 +12649,7 @@
       </p:sp>
       <p:sp>
         <p:nvSpPr>
-          <p:cNvPr id="9" name="Recall"/>
+          <p:cNvPr id="8" name="Recall"/>
           <p:cNvSpPr txBox="1"/>
           <p:nvPr/>
         </p:nvSpPr>
@@ -13185,7 +12730,7 @@
       </p:sp>
       <p:sp>
         <p:nvSpPr>
-          <p:cNvPr id="10" name="Limit"/>
+          <p:cNvPr id="9" name="Limit"/>
           <p:cNvSpPr txBox="1"/>
           <p:nvPr/>
         </p:nvSpPr>

</xml_diff>

<commit_message>
Defense deck: plain-language technical slides and speaker notes
</commit_message>
<xml_diff>
--- a/Internal_Defense_Presentation.pptx
+++ b/Internal_Defense_Presentation.pptx
@@ -1075,7 +1075,7 @@
           <a:lstStyle/>
           <a:p>
             <a:r>
-              <a:t>My methodology is knowledge engineering, using CommonKADS from Schreiber and colleagues. I chose it because the core problem is a knowledge problem: how to represent what the model produces, the prediction and its explanation, and deliver it to each role in the form that role needs. CommonKADS gives six models, from the organisation down to the system design. The work went through four phases. Design science structures the research process, and TAM was only a design lens. To be clear about scope: knowledge was acquired from published literature, not interviews, and no practitioner data was collected, so usability was not measured.</a:t>
+              <a:t>My methodology is knowledge engineering, using CommonKADS. It is a method for working out who needs what knowledge, and in what form. That matters here because the real problem is not just predicting risk, it is getting the right explanation to the right person. CommonKADS has six models: the organisation, the tasks, the agents or roles, the knowledge, how it is communicated, and the system design. I went through four phases: gathering knowledge from the literature, modelling it, building the system and testing it on OULAD. Design science gave the research steps, and the Technology Acceptance Model only guided the design. I did not interview users or run a user study, so usability and trust are not measured.</a:t>
             </a:r>
           </a:p>
         </p:txBody>
@@ -1145,7 +1145,7 @@
           <a:lstStyle/>
           <a:p>
             <a:r>
-              <a:t>The system has five layers, which come from the CommonKADS Design Model. The data layer builds features from OULAD. The prediction engine serves an XGBoost pipeline. The explainability module caches global TreeSHAP values and runs LIME on demand. The API layer handles login and role-based access, and the presentation layer gives three role views. It was integrated with two LMSs: a native Moodle plugin that uses Moodle's own login and roles, and an embedded page in Canvas. Everything runs locally under Docker Compose.</a:t>
+              <a:t>The system works as a pipeline. The data layer builds features from OULAD. The model, XGBoost, predicts risk. XGBoost builds 300 small decision trees, each one correcting the mistakes of the previous ones. The explanation layer gives the reasons: SHAP values are computed in advance so the dashboard loads fast, and LIME runs when a staff member clicks a student. The API checks who is logged in and only shows the view for that role. I tested it inside two real learning management systems: as a plugin in Moodle, using Moodle's own login and roles, and embedded in a Canvas course. Everything runs in Docker containers, so the setup can be repeated.</a:t>
             </a:r>
           </a:p>
         </p:txBody>
@@ -1215,7 +1215,7 @@
           <a:lstStyle/>
           <a:p>
             <a:r>
-              <a:t>The data is the Open University Learning Analytics Dataset, from Kuzilek and colleagues: 32,593 student records across 22 module presentations. A student is at risk if they withdrew or failed, which is 52.8 percent, so the classes are only mildly imbalanced. There are 24 input columns, 59 features after encoding, in three families. For evaluation I grouped the folds by course presentation, so the model is always tested on a presentation it never saw. Recall is the main metric, because a missed at-risk student gets no support, while a false alarm can simply be reviewed and set aside. One limit: features cover the whole presentation, so this is retrospective classification, not early warning.</a:t>
+              <a:t>I used OULAD, a public, anonymised dataset from the UK Open University that many studies use as a benchmark. Each of the 32,593 records is one student taking one course in one semester; some students took more than one course. There are 22 course runs, from 7 modules over 4 semesters. 52.8 percent withdrew or failed, which is my at-risk group, so the two groups are roughly balanced. To test the model fairly, I trained it on three semesters and tested it on the fourth, then rotated, so it was never tested on a semester it had already seen. I focused on recall, because missing a struggling student is worse than a false alarm, which only costs a quick check. One honest limit: the features cover the whole semester, so this shows the model can classify after the fact, not yet that it works early in the semester.</a:t>
             </a:r>
           </a:p>
         </p:txBody>
@@ -1285,7 +1285,7 @@
           <a:lstStyle/>
           <a:p>
             <a:r>
-              <a:t>These are out-of-fold results over all 32,593 records. Recall is 0.909: the model caught 15,634 of the 17,208 at-risk students and missed 1,574. The cost is 2,422 false alarms, about 15.7 percent of the not-at-risk group. F1 is 0.887 and ROC-AUC 0.962. I compared three ensembles under the same protocol. Random Forest had the best F1, 0.898, but XGBoost had the best recall, which was my pre-set criterion, so I kept XGBoost. Performance varied across presentations, with accuracy from 0.846 to 0.916, so the pooled numbers should be generalised with care.</a:t>
+              <a:t>Here are the main results. Recall is 0.909: out of every 10 students who actually withdrew or failed, the model finds about 9. Precision is 0.866: when the model flags a student, it is right about 87 percent of the time. ROC-AUC is 0.962: if you pick one at-risk and one safe student, the model ranks the at-risk one higher 96 percent of the time. In real numbers, it caught 15,634 at-risk students, missed 1,574, and raised 2,422 false alarms, about one in six safe students, which a teacher would review and set aside. F1, which balances finding students against false alarms, is 0.887. Random Forest had a slightly better F1, 0.898, but I set recall as my rule before comparing, and XGBoost had the best recall, so I kept it. Results varied by semester, with accuracy from 0.846 to 0.916, so the overall figure is an average.</a:t>
             </a:r>
           </a:p>
         </p:txBody>
@@ -1355,7 +1355,7 @@
           <a:lstStyle/>
           <a:p>
             <a:r>
-              <a:t>Globally, across all students, SHAP shows that the number of assessments submitted dominates, more than four times the next feature, followed by active days, module FFF and mean score. LIME, on 40 sampled students, puts the same feature first and shares six more in its top ten. Per student, the two methods share on average 0.635 of their top five features, so agreement is partial, which is why the dashboard shows both. For example, for student s678287 SHAP says assessments submitted adds 5.3 log-odds towards at-risk, and LIME agrees on four of the top five. One caution: clicks in the 28 days before deadlines pushes towards at-risk, which is counter-intuitive; it correlates 0.98 with total clicks, so it is most likely collinearity. These are attributions of the model's reasoning, not causes.</a:t>
+              <a:t>This is how the predictions are explained. Across all students, whether a student submits assessments is by far the strongest signal, more than four times stronger than the next one, followed by active days, the module and mean score. I used two methods. SHAP shows how much each factor pushed a single prediction up or down. LIME is a second, independent way of explaining the same prediction, so I can cross-check. Per student, about three of the top five factors match, so they partly agree, and the dashboard shows both. For example, student s678287 is predicted above 99.9 percent at risk. They submitted almost no assessments, and that was the biggest push, and LIME agrees on four of the top five factors. Two cautions. This shows how the model reasons, not why a student is struggling. And one click result looks odd because two click measures move almost exactly together, with a correlation of 0.98. The staff member still decides what to do.</a:t>
             </a:r>
           </a:p>
         </p:txBody>
@@ -8075,7 +8075,7 @@
         <p:spPr>
           <a:xfrm>
             <a:off x="2286000" y="1417320"/>
-            <a:ext cx="1981200" cy="1005840"/>
+            <a:ext cx="1981200" cy="1325880"/>
           </a:xfrm>
           <a:prstGeom prst="rect">
             <a:avLst/>
@@ -8094,7 +8094,7 @@
               </a:spcAft>
             </a:pPr>
             <a:r>
-              <a:rPr sz="4400" b="1" i="0">
+              <a:rPr sz="4000" b="1" i="0">
                 <a:solidFill>
                   <a:srgbClr val="1F3864"/>
                 </a:solidFill>
@@ -8110,13 +8110,29 @@
               </a:spcAft>
             </a:pPr>
             <a:r>
-              <a:rPr sz="1400" b="0" i="0">
+              <a:rPr sz="1300" b="0" i="0">
                 <a:solidFill>
                   <a:srgbClr val="59595F"/>
                 </a:solidFill>
                 <a:latin typeface="Calibri"/>
               </a:rPr>
-              <a:t>Recall</a:t>
+              <a:t>Recall: finds about</a:t>
+            </a:r>
+          </a:p>
+          <a:p>
+            <a:pPr algn="l">
+              <a:spcAft>
+                <a:spcPts val="0"/>
+              </a:spcAft>
+            </a:pPr>
+            <a:r>
+              <a:rPr sz="1300" b="0" i="0">
+                <a:solidFill>
+                  <a:srgbClr val="59595F"/>
+                </a:solidFill>
+                <a:latin typeface="Calibri"/>
+              </a:rPr>
+              <a:t>9 in 10 at-risk students</a:t>
             </a:r>
           </a:p>
         </p:txBody>
@@ -8130,7 +8146,7 @@
         <p:spPr>
           <a:xfrm>
             <a:off x="4358640" y="1417320"/>
-            <a:ext cx="1981200" cy="1005840"/>
+            <a:ext cx="1981200" cy="1325880"/>
           </a:xfrm>
           <a:prstGeom prst="rect">
             <a:avLst/>
@@ -8149,13 +8165,13 @@
               </a:spcAft>
             </a:pPr>
             <a:r>
-              <a:rPr sz="4400" b="1" i="0">
+              <a:rPr sz="4000" b="1" i="0">
                 <a:solidFill>
                   <a:srgbClr val="1F3864"/>
                 </a:solidFill>
                 <a:latin typeface="Calibri"/>
               </a:rPr>
-              <a:t>0.887</a:t>
+              <a:t>0.866</a:t>
             </a:r>
           </a:p>
           <a:p>
@@ -8165,13 +8181,29 @@
               </a:spcAft>
             </a:pPr>
             <a:r>
-              <a:rPr sz="1400" b="0" i="0">
+              <a:rPr sz="1300" b="0" i="0">
                 <a:solidFill>
                   <a:srgbClr val="59595F"/>
                 </a:solidFill>
                 <a:latin typeface="Calibri"/>
               </a:rPr>
-              <a:t>F1-score</a:t>
+              <a:t>Precision: a flag is</a:t>
+            </a:r>
+          </a:p>
+          <a:p>
+            <a:pPr algn="l">
+              <a:spcAft>
+                <a:spcPts val="0"/>
+              </a:spcAft>
+            </a:pPr>
+            <a:r>
+              <a:rPr sz="1300" b="0" i="0">
+                <a:solidFill>
+                  <a:srgbClr val="59595F"/>
+                </a:solidFill>
+                <a:latin typeface="Calibri"/>
+              </a:rPr>
+              <a:t>right about 87% of the time</a:t>
             </a:r>
           </a:p>
         </p:txBody>
@@ -8185,7 +8217,7 @@
         <p:spPr>
           <a:xfrm>
             <a:off x="6431280" y="1417320"/>
-            <a:ext cx="1981200" cy="1005840"/>
+            <a:ext cx="1981200" cy="1325880"/>
           </a:xfrm>
           <a:prstGeom prst="rect">
             <a:avLst/>
@@ -8204,7 +8236,7 @@
               </a:spcAft>
             </a:pPr>
             <a:r>
-              <a:rPr sz="4400" b="1" i="0">
+              <a:rPr sz="4000" b="1" i="0">
                 <a:solidFill>
                   <a:srgbClr val="1F3864"/>
                 </a:solidFill>
@@ -8220,27 +8252,43 @@
               </a:spcAft>
             </a:pPr>
             <a:r>
-              <a:rPr sz="1400" b="0" i="0">
+              <a:rPr sz="1300" b="0" i="0">
                 <a:solidFill>
                   <a:srgbClr val="59595F"/>
                 </a:solidFill>
                 <a:latin typeface="Calibri"/>
               </a:rPr>
-              <a:t>ROC-AUC</a:t>
-            </a:r>
-          </a:p>
-        </p:txBody>
-      </p:sp>
-      <p:sp>
-        <p:nvSpPr>
-          <p:cNvPr id="6" name="XGBoost"/>
+              <a:t>ROC-AUC: ranks the at-risk</a:t>
+            </a:r>
+          </a:p>
+          <a:p>
+            <a:pPr algn="l">
+              <a:spcAft>
+                <a:spcPts val="0"/>
+              </a:spcAft>
+            </a:pPr>
+            <a:r>
+              <a:rPr sz="1300" b="0" i="0">
+                <a:solidFill>
+                  <a:srgbClr val="59595F"/>
+                </a:solidFill>
+                <a:latin typeface="Calibri"/>
+              </a:rPr>
+              <a:t>student first 96% of the time</a:t>
+            </a:r>
+          </a:p>
+        </p:txBody>
+      </p:sp>
+      <p:sp>
+        <p:nvSpPr>
+          <p:cNvPr id="6" name="Outcomes"/>
           <p:cNvSpPr txBox="1"/>
           <p:nvPr/>
         </p:nvSpPr>
         <p:spPr>
           <a:xfrm>
-            <a:off x="2286000" y="2743200"/>
-            <a:ext cx="2926080" cy="3383280"/>
+            <a:off x="2286000" y="2926080"/>
+            <a:ext cx="2926080" cy="3200400"/>
           </a:xfrm>
           <a:prstGeom prst="rect">
             <a:avLst/>
@@ -8265,7 +8313,7 @@
                 </a:solidFill>
                 <a:latin typeface="Calibri"/>
               </a:rPr>
-              <a:t>PROTOTYPE XGBOOST</a:t>
+              <a:t>WHAT HAPPENED (32,593 RECORDS)</a:t>
             </a:r>
           </a:p>
           <a:p>
@@ -8280,31 +8328,22 @@
               <a:buChar char="•"/>
             </a:pPr>
             <a:r>
-              <a:rPr sz="1700" b="0" i="0">
+              <a:rPr sz="1600" b="1" i="0">
                 <a:solidFill>
                   <a:srgbClr val="26262E"/>
                 </a:solidFill>
                 <a:latin typeface="Calibri"/>
               </a:rPr>
-              <a:t>Caught </a:t>
-            </a:r>
-            <a:r>
-              <a:rPr sz="1700" b="1" i="0">
+              <a:t>15,634 </a:t>
+            </a:r>
+            <a:r>
+              <a:rPr sz="1600" b="0" i="0">
                 <a:solidFill>
                   <a:srgbClr val="26262E"/>
                 </a:solidFill>
                 <a:latin typeface="Calibri"/>
               </a:rPr>
-              <a:t>15,634 of 17,208</a:t>
-            </a:r>
-            <a:r>
-              <a:rPr sz="1700" b="0" i="0">
-                <a:solidFill>
-                  <a:srgbClr val="26262E"/>
-                </a:solidFill>
-                <a:latin typeface="Calibri"/>
-              </a:rPr>
-              <a:t> at-risk students</a:t>
+              <a:t>at-risk students caught</a:t>
             </a:r>
           </a:p>
           <a:p>
@@ -8319,13 +8358,22 @@
               <a:buChar char="•"/>
             </a:pPr>
             <a:r>
-              <a:rPr sz="1700" b="0" i="0">
+              <a:rPr sz="1600" b="1" i="0">
                 <a:solidFill>
                   <a:srgbClr val="26262E"/>
                 </a:solidFill>
                 <a:latin typeface="Calibri"/>
               </a:rPr>
-              <a:t>1,574 missed; 2,422 false alarms (15.7%)</a:t>
+              <a:t>1,574 </a:t>
+            </a:r>
+            <a:r>
+              <a:rPr sz="1600" b="0" i="0">
+                <a:solidFill>
+                  <a:srgbClr val="26262E"/>
+                </a:solidFill>
+                <a:latin typeface="Calibri"/>
+              </a:rPr>
+              <a:t>missed</a:t>
             </a:r>
           </a:p>
           <a:p>
@@ -8340,52 +8388,22 @@
               <a:buChar char="•"/>
             </a:pPr>
             <a:r>
-              <a:rPr sz="1700" b="0" i="0">
+              <a:rPr sz="1600" b="1" i="0">
                 <a:solidFill>
                   <a:srgbClr val="26262E"/>
                 </a:solidFill>
                 <a:latin typeface="Calibri"/>
               </a:rPr>
-              <a:t>Accuracy 0.877, precision 0.866</a:t>
-            </a:r>
-          </a:p>
-        </p:txBody>
-      </p:sp>
-      <p:sp>
-        <p:nvSpPr>
-          <p:cNvPr id="7" name="Comparison"/>
-          <p:cNvSpPr txBox="1"/>
-          <p:nvPr/>
-        </p:nvSpPr>
-        <p:spPr>
-          <a:xfrm>
-            <a:off x="5577840" y="2743200"/>
-            <a:ext cx="2926080" cy="2103120"/>
-          </a:xfrm>
-          <a:prstGeom prst="rect">
-            <a:avLst/>
-          </a:prstGeom>
-          <a:noFill/>
-        </p:spPr>
-        <p:txBody>
-          <a:bodyPr wrap="square" anchor="t" lIns="0" rIns="0" tIns="0" bIns="0">
-            <a:spAutoFit/>
-          </a:bodyPr>
-          <a:lstStyle/>
-          <a:p>
-            <a:pPr algn="l">
-              <a:spcAft>
-                <a:spcPts val="600"/>
-              </a:spcAft>
-            </a:pPr>
-            <a:r>
-              <a:rPr sz="1400" b="1" i="0">
-                <a:solidFill>
-                  <a:srgbClr val="C00000"/>
-                </a:solidFill>
-                <a:latin typeface="Calibri"/>
-              </a:rPr>
-              <a:t>THREE-MODEL COMPARISON</a:t>
+              <a:t>2,422 </a:t>
+            </a:r>
+            <a:r>
+              <a:rPr sz="1600" b="0" i="0">
+                <a:solidFill>
+                  <a:srgbClr val="26262E"/>
+                </a:solidFill>
+                <a:latin typeface="Calibri"/>
+              </a:rPr>
+              <a:t>false alarms (1 in 6 safe students)</a:t>
             </a:r>
           </a:p>
           <a:p>
@@ -8400,22 +8418,70 @@
               <a:buChar char="•"/>
             </a:pPr>
             <a:r>
-              <a:rPr sz="1700" b="1" i="0">
+              <a:rPr sz="1600" b="0" i="0">
                 <a:solidFill>
                   <a:srgbClr val="26262E"/>
                 </a:solidFill>
                 <a:latin typeface="Calibri"/>
               </a:rPr>
-              <a:t>Random Forest: </a:t>
-            </a:r>
-            <a:r>
-              <a:rPr sz="1700" b="0" i="0">
+              <a:t>Overall: </a:t>
+            </a:r>
+            <a:r>
+              <a:rPr sz="1600" b="1" i="0">
                 <a:solidFill>
                   <a:srgbClr val="26262E"/>
                 </a:solidFill>
                 <a:latin typeface="Calibri"/>
               </a:rPr>
-              <a:t>best F1 (0.898)</a:t>
+              <a:t>F1 0.887</a:t>
+            </a:r>
+            <a:r>
+              <a:rPr sz="1600" b="0" i="0">
+                <a:solidFill>
+                  <a:srgbClr val="26262E"/>
+                </a:solidFill>
+                <a:latin typeface="Calibri"/>
+              </a:rPr>
+              <a:t>, accuracy 0.877</a:t>
+            </a:r>
+          </a:p>
+        </p:txBody>
+      </p:sp>
+      <p:sp>
+        <p:nvSpPr>
+          <p:cNvPr id="7" name="Comparison"/>
+          <p:cNvSpPr txBox="1"/>
+          <p:nvPr/>
+        </p:nvSpPr>
+        <p:spPr>
+          <a:xfrm>
+            <a:off x="5577840" y="2926080"/>
+            <a:ext cx="2926080" cy="2011680"/>
+          </a:xfrm>
+          <a:prstGeom prst="rect">
+            <a:avLst/>
+          </a:prstGeom>
+          <a:noFill/>
+        </p:spPr>
+        <p:txBody>
+          <a:bodyPr wrap="square" anchor="t" lIns="0" rIns="0" tIns="0" bIns="0">
+            <a:spAutoFit/>
+          </a:bodyPr>
+          <a:lstStyle/>
+          <a:p>
+            <a:pPr algn="l">
+              <a:spcAft>
+                <a:spcPts val="600"/>
+              </a:spcAft>
+            </a:pPr>
+            <a:r>
+              <a:rPr sz="1400" b="1" i="0">
+                <a:solidFill>
+                  <a:srgbClr val="C00000"/>
+                </a:solidFill>
+                <a:latin typeface="Calibri"/>
+              </a:rPr>
+              <a:t>WHY XGBOOST?</a:t>
             </a:r>
           </a:p>
           <a:p>
@@ -8430,22 +8496,13 @@
               <a:buChar char="•"/>
             </a:pPr>
             <a:r>
-              <a:rPr sz="1700" b="1" i="0">
+              <a:rPr sz="1600" b="0" i="0">
                 <a:solidFill>
                   <a:srgbClr val="26262E"/>
                 </a:solidFill>
                 <a:latin typeface="Calibri"/>
               </a:rPr>
-              <a:t>Gradient Boosting: </a:t>
-            </a:r>
-            <a:r>
-              <a:rPr sz="1700" b="0" i="0">
-                <a:solidFill>
-                  <a:srgbClr val="26262E"/>
-                </a:solidFill>
-                <a:latin typeface="Calibri"/>
-              </a:rPr>
-              <a:t>F1 0.893</a:t>
+              <a:t>Random Forest: best F1 (0.898)</a:t>
             </a:r>
           </a:p>
           <a:p>
@@ -8460,22 +8517,13 @@
               <a:buChar char="•"/>
             </a:pPr>
             <a:r>
-              <a:rPr sz="1700" b="1" i="0">
+              <a:rPr sz="1600" b="0" i="0">
                 <a:solidFill>
                   <a:srgbClr val="26262E"/>
                 </a:solidFill>
                 <a:latin typeface="Calibri"/>
               </a:rPr>
-              <a:t>XGBoost: </a:t>
-            </a:r>
-            <a:r>
-              <a:rPr sz="1700" b="0" i="0">
-                <a:solidFill>
-                  <a:srgbClr val="26262E"/>
-                </a:solidFill>
-                <a:latin typeface="Calibri"/>
-              </a:rPr>
-              <a:t>best recall, so retained</a:t>
+              <a:t>XGBoost: best recall (0.909), my pre-set rule, so kept</a:t>
             </a:r>
           </a:p>
         </p:txBody>
@@ -8488,7 +8536,7 @@
         </p:nvSpPr>
         <p:spPr>
           <a:xfrm>
-            <a:off x="5577840" y="4800600"/>
+            <a:off x="5577840" y="4846320"/>
             <a:ext cx="2926080" cy="1280160"/>
           </a:xfrm>
           <a:prstGeom prst="rect">
@@ -8514,7 +8562,7 @@
                 </a:solidFill>
                 <a:latin typeface="Calibri"/>
               </a:rPr>
-              <a:t>VARIABILITY</a:t>
+              <a:t>VARIES BY SEMESTER</a:t>
             </a:r>
           </a:p>
           <a:p>
@@ -8529,13 +8577,13 @@
               <a:buChar char="•"/>
             </a:pPr>
             <a:r>
-              <a:rPr sz="1700" b="0" i="0">
+              <a:rPr sz="1600" b="0" i="0">
                 <a:solidFill>
                   <a:srgbClr val="26262E"/>
                 </a:solidFill>
                 <a:latin typeface="Calibri"/>
               </a:rPr>
-              <a:t>Accuracy 0.846 to 0.916 across presentations</a:t>
+              <a:t>Accuracy 0.846 to 0.916</a:t>
             </a:r>
           </a:p>
         </p:txBody>
@@ -8602,7 +8650,7 @@
         <p:spPr>
           <a:xfrm>
             <a:off x="2286000" y="1463040"/>
-            <a:ext cx="2926080" cy="1828800"/>
+            <a:ext cx="2926080" cy="2011680"/>
           </a:xfrm>
           <a:prstGeom prst="rect">
             <a:avLst/>
@@ -8627,7 +8675,7 @@
                 </a:solidFill>
                 <a:latin typeface="Calibri"/>
               </a:rPr>
-              <a:t>GLOBAL (SHAP, ALL 32,593)</a:t>
+              <a:t>WHAT DRIVES PREDICTIONS</a:t>
             </a:r>
           </a:p>
           <a:p>
@@ -8642,22 +8690,22 @@
               <a:buChar char="•"/>
             </a:pPr>
             <a:r>
-              <a:rPr sz="1700" b="1" i="0">
+              <a:rPr sz="1600" b="1" i="0">
                 <a:solidFill>
                   <a:srgbClr val="26262E"/>
                 </a:solidFill>
                 <a:latin typeface="Calibri"/>
               </a:rPr>
-              <a:t>Assessments submitted </a:t>
-            </a:r>
-            <a:r>
-              <a:rPr sz="1700" b="0" i="0">
+              <a:t>Submitting assessments </a:t>
+            </a:r>
+            <a:r>
+              <a:rPr sz="1600" b="0" i="0">
                 <a:solidFill>
                   <a:srgbClr val="26262E"/>
                 </a:solidFill>
                 <a:latin typeface="Calibri"/>
               </a:rPr>
-              <a:t>dominates: over 4× the next feature</a:t>
+              <a:t>is the strongest signal, over 4× the next</a:t>
             </a:r>
           </a:p>
           <a:p>
@@ -8672,7 +8720,7 @@
               <a:buChar char="•"/>
             </a:pPr>
             <a:r>
-              <a:rPr sz="1700" b="0" i="0">
+              <a:rPr sz="1600" b="0" i="0">
                 <a:solidFill>
                   <a:srgbClr val="26262E"/>
                 </a:solidFill>
@@ -8691,7 +8739,7 @@
         </p:nvSpPr>
         <p:spPr>
           <a:xfrm>
-            <a:off x="2286000" y="3520440"/>
+            <a:off x="2286000" y="3566160"/>
             <a:ext cx="2926080" cy="2651760"/>
           </a:xfrm>
           <a:prstGeom prst="rect">
@@ -8717,7 +8765,7 @@
                 </a:solidFill>
                 <a:latin typeface="Calibri"/>
               </a:rPr>
-              <a:t>SHAP VS LIME</a:t>
+              <a:t>TWO METHODS, CROSS-CHECKED</a:t>
             </a:r>
           </a:p>
           <a:p>
@@ -8732,13 +8780,22 @@
               <a:buChar char="•"/>
             </a:pPr>
             <a:r>
-              <a:rPr sz="1700" b="0" i="0">
+              <a:rPr sz="1600" b="1" i="0">
                 <a:solidFill>
                   <a:srgbClr val="26262E"/>
                 </a:solidFill>
                 <a:latin typeface="Calibri"/>
               </a:rPr>
-              <a:t>Same top feature; 6 more shared in each top 10</a:t>
+              <a:t>SHAP: </a:t>
+            </a:r>
+            <a:r>
+              <a:rPr sz="1600" b="0" i="0">
+                <a:solidFill>
+                  <a:srgbClr val="26262E"/>
+                </a:solidFill>
+                <a:latin typeface="Calibri"/>
+              </a:rPr>
+              <a:t>how much each factor pushed one prediction</a:t>
             </a:r>
           </a:p>
           <a:p>
@@ -8753,31 +8810,22 @@
               <a:buChar char="•"/>
             </a:pPr>
             <a:r>
-              <a:rPr sz="1700" b="0" i="0">
+              <a:rPr sz="1600" b="1" i="0">
                 <a:solidFill>
                   <a:srgbClr val="26262E"/>
                 </a:solidFill>
                 <a:latin typeface="Calibri"/>
               </a:rPr>
-              <a:t>Per-student top-5 overlap </a:t>
-            </a:r>
-            <a:r>
-              <a:rPr sz="1700" b="1" i="0">
+              <a:t>LIME: </a:t>
+            </a:r>
+            <a:r>
+              <a:rPr sz="1600" b="0" i="0">
                 <a:solidFill>
                   <a:srgbClr val="26262E"/>
                 </a:solidFill>
                 <a:latin typeface="Calibri"/>
               </a:rPr>
-              <a:t>0.635</a:t>
-            </a:r>
-            <a:r>
-              <a:rPr sz="1700" b="0" i="0">
-                <a:solidFill>
-                  <a:srgbClr val="26262E"/>
-                </a:solidFill>
-                <a:latin typeface="Calibri"/>
-              </a:rPr>
-              <a:t> (SD 0.197)</a:t>
+              <a:t>a second, independent explanation</a:t>
             </a:r>
           </a:p>
           <a:p>
@@ -8792,13 +8840,31 @@
               <a:buChar char="•"/>
             </a:pPr>
             <a:r>
-              <a:rPr sz="1700" b="0" i="0">
+              <a:rPr sz="1600" b="0" i="0">
                 <a:solidFill>
                   <a:srgbClr val="26262E"/>
                 </a:solidFill>
                 <a:latin typeface="Calibri"/>
               </a:rPr>
-              <a:t>Partial agreement, so the dashboard shows both</a:t>
+              <a:t>Per student, about </a:t>
+            </a:r>
+            <a:r>
+              <a:rPr sz="1600" b="1" i="0">
+                <a:solidFill>
+                  <a:srgbClr val="26262E"/>
+                </a:solidFill>
+                <a:latin typeface="Calibri"/>
+              </a:rPr>
+              <a:t>3 of the top 5</a:t>
+            </a:r>
+            <a:r>
+              <a:rPr sz="1600" b="0" i="0">
+                <a:solidFill>
+                  <a:srgbClr val="26262E"/>
+                </a:solidFill>
+                <a:latin typeface="Calibri"/>
+              </a:rPr>
+              <a:t> factors match (0.635)</a:t>
             </a:r>
           </a:p>
         </p:txBody>
@@ -8837,7 +8903,7 @@
                 </a:solidFill>
                 <a:latin typeface="Calibri"/>
               </a:rPr>
-              <a:t>ONE STUDENT (S678287, &gt;99.9%)</a:t>
+              <a:t>EXAMPLE: STUDENT S678287</a:t>
             </a:r>
           </a:p>
           <a:p>
@@ -8852,13 +8918,13 @@
               <a:buChar char="•"/>
             </a:pPr>
             <a:r>
-              <a:rPr sz="1700" b="0" i="0">
+              <a:rPr sz="1600" b="0" i="0">
                 <a:solidFill>
                   <a:srgbClr val="26262E"/>
                 </a:solidFill>
                 <a:latin typeface="Calibri"/>
               </a:rPr>
-              <a:t>SHAP: assessments submitted +5.30, module FFF +1.71, active days +1.15</a:t>
+              <a:t>Predicted &gt;99.9% at risk</a:t>
             </a:r>
           </a:p>
           <a:p>
@@ -8873,52 +8939,13 @@
               <a:buChar char="•"/>
             </a:pPr>
             <a:r>
-              <a:rPr sz="1700" b="0" i="0">
+              <a:rPr sz="1600" b="0" i="0">
                 <a:solidFill>
                   <a:srgbClr val="26262E"/>
                 </a:solidFill>
                 <a:latin typeface="Calibri"/>
               </a:rPr>
-              <a:t>LIME agrees on 4 of the top 5</a:t>
-            </a:r>
-          </a:p>
-        </p:txBody>
-      </p:sp>
-      <p:sp>
-        <p:nvSpPr>
-          <p:cNvPr id="6" name="Caution"/>
-          <p:cNvSpPr txBox="1"/>
-          <p:nvPr/>
-        </p:nvSpPr>
-        <p:spPr>
-          <a:xfrm>
-            <a:off x="5577840" y="3520440"/>
-            <a:ext cx="2926080" cy="2651760"/>
-          </a:xfrm>
-          <a:prstGeom prst="rect">
-            <a:avLst/>
-          </a:prstGeom>
-          <a:noFill/>
-        </p:spPr>
-        <p:txBody>
-          <a:bodyPr wrap="square" anchor="t" lIns="0" rIns="0" tIns="0" bIns="0">
-            <a:spAutoFit/>
-          </a:bodyPr>
-          <a:lstStyle/>
-          <a:p>
-            <a:pPr algn="l">
-              <a:spcAft>
-                <a:spcPts val="600"/>
-              </a:spcAft>
-            </a:pPr>
-            <a:r>
-              <a:rPr sz="1400" b="1" i="0">
-                <a:solidFill>
-                  <a:srgbClr val="C00000"/>
-                </a:solidFill>
-                <a:latin typeface="Calibri"/>
-              </a:rPr>
-              <a:t>CAUTION</a:t>
+              <a:t>Submitted almost no assessments: the biggest push (SHAP +5.30)</a:t>
             </a:r>
           </a:p>
           <a:p>
@@ -8933,13 +8960,52 @@
               <a:buChar char="•"/>
             </a:pPr>
             <a:r>
-              <a:rPr sz="1700" b="0" i="0">
+              <a:rPr sz="1600" b="0" i="0">
                 <a:solidFill>
                   <a:srgbClr val="26262E"/>
                 </a:solidFill>
                 <a:latin typeface="Calibri"/>
               </a:rPr>
-              <a:t>Attributions, not causes</a:t>
+              <a:t>LIME agrees on 4 of the top 5</a:t>
+            </a:r>
+          </a:p>
+        </p:txBody>
+      </p:sp>
+      <p:sp>
+        <p:nvSpPr>
+          <p:cNvPr id="6" name="Caution"/>
+          <p:cNvSpPr txBox="1"/>
+          <p:nvPr/>
+        </p:nvSpPr>
+        <p:spPr>
+          <a:xfrm>
+            <a:off x="5577840" y="3566160"/>
+            <a:ext cx="2926080" cy="2651760"/>
+          </a:xfrm>
+          <a:prstGeom prst="rect">
+            <a:avLst/>
+          </a:prstGeom>
+          <a:noFill/>
+        </p:spPr>
+        <p:txBody>
+          <a:bodyPr wrap="square" anchor="t" lIns="0" rIns="0" tIns="0" bIns="0">
+            <a:spAutoFit/>
+          </a:bodyPr>
+          <a:lstStyle/>
+          <a:p>
+            <a:pPr algn="l">
+              <a:spcAft>
+                <a:spcPts val="600"/>
+              </a:spcAft>
+            </a:pPr>
+            <a:r>
+              <a:rPr sz="1400" b="1" i="0">
+                <a:solidFill>
+                  <a:srgbClr val="C00000"/>
+                </a:solidFill>
+                <a:latin typeface="Calibri"/>
+              </a:rPr>
+              <a:t>READ WITH CARE</a:t>
             </a:r>
           </a:p>
           <a:p>
@@ -8954,13 +9020,55 @@
               <a:buChar char="•"/>
             </a:pPr>
             <a:r>
-              <a:rPr sz="1700" b="0" i="0">
+              <a:rPr sz="1600" b="0" i="0">
                 <a:solidFill>
                   <a:srgbClr val="26262E"/>
                 </a:solidFill>
                 <a:latin typeface="Calibri"/>
               </a:rPr>
-              <a:t>Clicks 28 days before deadlines push towards risk: likely collinearity (ρ = 0.98 with total clicks)</a:t>
+              <a:t>Shows how the model reasons, not why a student struggles</a:t>
+            </a:r>
+          </a:p>
+          <a:p>
+            <a:pPr algn="l" marL="201168" indent="-201168">
+              <a:spcAft>
+                <a:spcPts val="600"/>
+              </a:spcAft>
+              <a:buClr>
+                <a:srgbClr val="1F3864"/>
+              </a:buClr>
+              <a:buFont typeface="Arial"/>
+              <a:buChar char="•"/>
+            </a:pPr>
+            <a:r>
+              <a:rPr sz="1600" b="0" i="0">
+                <a:solidFill>
+                  <a:srgbClr val="26262E"/>
+                </a:solidFill>
+                <a:latin typeface="Calibri"/>
+              </a:rPr>
+              <a:t>One odd click result: two click measures move together (ρ = 0.98)</a:t>
+            </a:r>
+          </a:p>
+          <a:p>
+            <a:pPr algn="l" marL="201168" indent="-201168">
+              <a:spcAft>
+                <a:spcPts val="600"/>
+              </a:spcAft>
+              <a:buClr>
+                <a:srgbClr val="1F3864"/>
+              </a:buClr>
+              <a:buFont typeface="Arial"/>
+              <a:buChar char="•"/>
+            </a:pPr>
+            <a:r>
+              <a:rPr sz="1600" b="0" i="0">
+                <a:solidFill>
+                  <a:srgbClr val="26262E"/>
+                </a:solidFill>
+                <a:latin typeface="Calibri"/>
+              </a:rPr>
+              <a:t>The staff member still decides</a:t>
             </a:r>
           </a:p>
         </p:txBody>
@@ -11192,7 +11300,7 @@
                 </a:solidFill>
                 <a:latin typeface="Calibri"/>
               </a:rPr>
-              <a:t>Six models: Organisation, Task, Agent, Knowledge, Communication, Design</a:t>
+              <a:t>Helps decide which role needs what knowledge, in what form</a:t>
             </a:r>
           </a:p>
           <a:p>
@@ -11213,7 +11321,7 @@
                 </a:solidFill>
                 <a:latin typeface="Calibri"/>
               </a:rPr>
-              <a:t>Chosen because the core problem is delivering the right explanation to each role</a:t>
+              <a:t>Six models: Organisation, Task, Agent, Knowledge, Communication, Design</a:t>
             </a:r>
           </a:p>
         </p:txBody>
@@ -11282,7 +11390,7 @@
                 </a:solidFill>
                 <a:latin typeface="Calibri"/>
               </a:rPr>
-              <a:t>(Peffers et al., 2007): research process</a:t>
+              <a:t>(Peffers et al., 2007): steps for building and testing the system</a:t>
             </a:r>
           </a:p>
           <a:p>
@@ -11312,7 +11420,7 @@
                 </a:solidFill>
                 <a:latin typeface="Calibri"/>
               </a:rPr>
-              <a:t>(Davis, 1989): design lens only</a:t>
+              <a:t>(Davis, 1989): design guide only, not measured</a:t>
             </a:r>
           </a:p>
         </p:txBody>
@@ -11376,7 +11484,7 @@
                 </a:solidFill>
                 <a:latin typeface="Calibri"/>
               </a:rPr>
-              <a:t>Knowledge acquisition and organisation analysis</a:t>
+              <a:t>Gather knowledge from the literature</a:t>
             </a:r>
           </a:p>
           <a:p>
@@ -11401,7 +11509,7 @@
                 </a:solidFill>
                 <a:latin typeface="Calibri"/>
               </a:rPr>
-              <a:t>Knowledge and system modelling</a:t>
+              <a:t>Model it with CommonKADS</a:t>
             </a:r>
           </a:p>
           <a:p>
@@ -11426,7 +11534,7 @@
                 </a:solidFill>
                 <a:latin typeface="Calibri"/>
               </a:rPr>
-              <a:t>Artefact design and development</a:t>
+              <a:t>Build the system</a:t>
             </a:r>
           </a:p>
           <a:p>
@@ -11451,7 +11559,7 @@
                 </a:solidFill>
                 <a:latin typeface="Calibri"/>
               </a:rPr>
-              <a:t>Technical evaluation on OULAD</a:t>
+              <a:t>Test it on OULAD data</a:t>
             </a:r>
           </a:p>
         </p:txBody>
@@ -11511,7 +11619,7 @@
                 </a:solidFill>
                 <a:latin typeface="Calibri"/>
               </a:rPr>
-              <a:t>Knowledge drawn from published literature</a:t>
+              <a:t>No interviews or user study</a:t>
             </a:r>
           </a:p>
           <a:p>
@@ -11532,7 +11640,7 @@
                 </a:solidFill>
                 <a:latin typeface="Calibri"/>
               </a:rPr>
-              <a:t>No practitioner data; usability not measured</a:t>
+              <a:t>So usability and trust are not measured</a:t>
             </a:r>
           </a:p>
         </p:txBody>
@@ -11640,7 +11748,7 @@
                 </a:solidFill>
                 <a:latin typeface="Calibri"/>
               </a:rPr>
-              <a:t>OULAD features</a:t>
+              <a:t>builds features</a:t>
             </a:r>
           </a:p>
         </p:txBody>
@@ -11731,7 +11839,7 @@
                 </a:solidFill>
                 <a:latin typeface="Calibri"/>
               </a:rPr>
-              <a:t>XGBoost</a:t>
+              <a:t>predicts risk</a:t>
             </a:r>
           </a:p>
         </p:txBody>
@@ -11822,7 +11930,7 @@
                 </a:solidFill>
                 <a:latin typeface="Calibri"/>
               </a:rPr>
-              <a:t>TreeSHAP + LIME</a:t>
+              <a:t>gives reasons</a:t>
             </a:r>
           </a:p>
         </p:txBody>
@@ -11913,7 +12021,7 @@
                 </a:solidFill>
                 <a:latin typeface="Calibri"/>
               </a:rPr>
-              <a:t>JWT, roles</a:t>
+              <a:t>checks role</a:t>
             </a:r>
           </a:p>
         </p:txBody>
@@ -12004,21 +12112,21 @@
                 </a:solidFill>
                 <a:latin typeface="Calibri"/>
               </a:rPr>
-              <a:t>3 role views</a:t>
-            </a:r>
-          </a:p>
-        </p:txBody>
-      </p:sp>
-      <p:sp>
-        <p:nvSpPr>
-          <p:cNvPr id="12" name="Implementation"/>
+              <a:t>shows each role</a:t>
+            </a:r>
+          </a:p>
+        </p:txBody>
+      </p:sp>
+      <p:sp>
+        <p:nvSpPr>
+          <p:cNvPr id="12" name="How it works"/>
           <p:cNvSpPr txBox="1"/>
           <p:nvPr/>
         </p:nvSpPr>
         <p:spPr>
           <a:xfrm>
             <a:off x="2286000" y="2651760"/>
-            <a:ext cx="6217920" cy="1554480"/>
+            <a:ext cx="6217920" cy="1645920"/>
           </a:xfrm>
           <a:prstGeom prst="rect">
             <a:avLst/>
@@ -12043,7 +12151,7 @@
                 </a:solidFill>
                 <a:latin typeface="Calibri"/>
               </a:rPr>
-              <a:t>IMPLEMENTATION</a:t>
+              <a:t>HOW IT WORKS</a:t>
             </a:r>
           </a:p>
           <a:p>
@@ -12064,7 +12172,7 @@
                 </a:solidFill>
                 <a:latin typeface="Calibri"/>
               </a:rPr>
-              <a:t>Model: </a:t>
+              <a:t>XGBoost: </a:t>
             </a:r>
             <a:r>
               <a:rPr sz="1600" b="0" i="0">
@@ -12073,7 +12181,7 @@
                 </a:solidFill>
                 <a:latin typeface="Calibri"/>
               </a:rPr>
-              <a:t>XGBoost, 300 trees, depth 5; saved as a versioned artefact</a:t>
+              <a:t>300 small decision trees, each correcting the last</a:t>
             </a:r>
           </a:p>
           <a:p>
@@ -12103,7 +12211,7 @@
                 </a:solidFill>
                 <a:latin typeface="Calibri"/>
               </a:rPr>
-              <a:t>global TreeSHAP cached; LIME generated on demand</a:t>
+              <a:t>SHAP stored in advance; LIME runs when a student is clicked</a:t>
             </a:r>
           </a:p>
           <a:p>
@@ -12124,7 +12232,7 @@
                 </a:solidFill>
                 <a:latin typeface="Calibri"/>
               </a:rPr>
-              <a:t>Access: </a:t>
+              <a:t>Login: </a:t>
             </a:r>
             <a:r>
               <a:rPr sz="1600" b="0" i="0">
@@ -12133,20 +12241,20 @@
                 </a:solidFill>
                 <a:latin typeface="Calibri"/>
               </a:rPr>
-              <a:t>JWT login with role-based access control</a:t>
-            </a:r>
-          </a:p>
-        </p:txBody>
-      </p:sp>
-      <p:sp>
-        <p:nvSpPr>
-          <p:cNvPr id="13" name="LMS"/>
+              <a:t>each user sees only the view for their role</a:t>
+            </a:r>
+          </a:p>
+        </p:txBody>
+      </p:sp>
+      <p:sp>
+        <p:nvSpPr>
+          <p:cNvPr id="13" name="Where it runs"/>
           <p:cNvSpPr txBox="1"/>
           <p:nvPr/>
         </p:nvSpPr>
         <p:spPr>
           <a:xfrm>
-            <a:off x="2286000" y="4389120"/>
+            <a:off x="2286000" y="4434840"/>
             <a:ext cx="6217920" cy="1737360"/>
           </a:xfrm>
           <a:prstGeom prst="rect">
@@ -12172,7 +12280,7 @@
                 </a:solidFill>
                 <a:latin typeface="Calibri"/>
               </a:rPr>
-              <a:t>LMS INTEGRATION (TESTED)</a:t>
+              <a:t>WHERE IT RUNS (TESTED)</a:t>
             </a:r>
           </a:p>
           <a:p>
@@ -12202,7 +12310,7 @@
                 </a:solidFill>
                 <a:latin typeface="Calibri"/>
               </a:rPr>
-              <a:t>native plugin using Moodle login, roles and enrolments</a:t>
+              <a:t>plugin inside each course, using Moodle login and roles</a:t>
             </a:r>
           </a:p>
           <a:p>
@@ -12232,7 +12340,7 @@
                 </a:solidFill>
                 <a:latin typeface="Calibri"/>
               </a:rPr>
-              <a:t>dashboard embedded as an External URL module item</a:t>
+              <a:t>dashboard embedded as a link item in the course</a:t>
             </a:r>
           </a:p>
           <a:p>
@@ -12253,7 +12361,7 @@
                 </a:solidFill>
                 <a:latin typeface="Calibri"/>
               </a:rPr>
-              <a:t>Deployment: </a:t>
+              <a:t>Docker Compose: </a:t>
             </a:r>
             <a:r>
               <a:rPr sz="1600" b="0" i="0">
@@ -12262,7 +12370,7 @@
                 </a:solidFill>
                 <a:latin typeface="Calibri"/>
               </a:rPr>
-              <a:t>Docker Compose; 22 module presentations loaded as courses</a:t>
+              <a:t>all parts run together, so the setup can be repeated</a:t>
             </a:r>
           </a:p>
         </p:txBody>
@@ -12329,7 +12437,7 @@
         <p:spPr>
           <a:xfrm>
             <a:off x="2286000" y="1417320"/>
-            <a:ext cx="1981200" cy="1005840"/>
+            <a:ext cx="1981200" cy="1325880"/>
           </a:xfrm>
           <a:prstGeom prst="rect">
             <a:avLst/>
@@ -12364,13 +12472,29 @@
               </a:spcAft>
             </a:pPr>
             <a:r>
-              <a:rPr sz="1400" b="0" i="0">
+              <a:rPr sz="1300" b="0" i="0">
                 <a:solidFill>
                   <a:srgbClr val="59595F"/>
                 </a:solidFill>
                 <a:latin typeface="Calibri"/>
               </a:rPr>
-              <a:t>student records</a:t>
+              <a:t>records: one student in</a:t>
+            </a:r>
+          </a:p>
+          <a:p>
+            <a:pPr algn="l">
+              <a:spcAft>
+                <a:spcPts val="0"/>
+              </a:spcAft>
+            </a:pPr>
+            <a:r>
+              <a:rPr sz="1300" b="0" i="0">
+                <a:solidFill>
+                  <a:srgbClr val="59595F"/>
+                </a:solidFill>
+                <a:latin typeface="Calibri"/>
+              </a:rPr>
+              <a:t>one course run</a:t>
             </a:r>
           </a:p>
         </p:txBody>
@@ -12384,7 +12508,7 @@
         <p:spPr>
           <a:xfrm>
             <a:off x="4358640" y="1417320"/>
-            <a:ext cx="1981200" cy="1005840"/>
+            <a:ext cx="1981200" cy="1325880"/>
           </a:xfrm>
           <a:prstGeom prst="rect">
             <a:avLst/>
@@ -12419,13 +12543,29 @@
               </a:spcAft>
             </a:pPr>
             <a:r>
-              <a:rPr sz="1400" b="0" i="0">
+              <a:rPr sz="1300" b="0" i="0">
                 <a:solidFill>
                   <a:srgbClr val="59595F"/>
                 </a:solidFill>
                 <a:latin typeface="Calibri"/>
               </a:rPr>
-              <a:t>module presentations</a:t>
+              <a:t>course runs</a:t>
+            </a:r>
+          </a:p>
+          <a:p>
+            <a:pPr algn="l">
+              <a:spcAft>
+                <a:spcPts val="0"/>
+              </a:spcAft>
+            </a:pPr>
+            <a:r>
+              <a:rPr sz="1300" b="0" i="0">
+                <a:solidFill>
+                  <a:srgbClr val="59595F"/>
+                </a:solidFill>
+                <a:latin typeface="Calibri"/>
+              </a:rPr>
+              <a:t>(7 modules, 4 semesters)</a:t>
             </a:r>
           </a:p>
         </p:txBody>
@@ -12439,7 +12579,7 @@
         <p:spPr>
           <a:xfrm>
             <a:off x="6431280" y="1417320"/>
-            <a:ext cx="1981200" cy="1005840"/>
+            <a:ext cx="1981200" cy="1325880"/>
           </a:xfrm>
           <a:prstGeom prst="rect">
             <a:avLst/>
@@ -12474,13 +12614,29 @@
               </a:spcAft>
             </a:pPr>
             <a:r>
-              <a:rPr sz="1400" b="0" i="0">
+              <a:rPr sz="1300" b="0" i="0">
                 <a:solidFill>
                   <a:srgbClr val="59595F"/>
                 </a:solidFill>
                 <a:latin typeface="Calibri"/>
               </a:rPr>
-              <a:t>at risk (withdrawn or fail)</a:t>
+              <a:t>withdrew or failed</a:t>
+            </a:r>
+          </a:p>
+          <a:p>
+            <a:pPr algn="l">
+              <a:spcAft>
+                <a:spcPts val="0"/>
+              </a:spcAft>
+            </a:pPr>
+            <a:r>
+              <a:rPr sz="1300" b="0" i="0">
+                <a:solidFill>
+                  <a:srgbClr val="59595F"/>
+                </a:solidFill>
+                <a:latin typeface="Calibri"/>
+              </a:rPr>
+              <a:t>(the at-risk group)</a:t>
             </a:r>
           </a:p>
         </p:txBody>
@@ -12493,8 +12649,8 @@
         </p:nvSpPr>
         <p:spPr>
           <a:xfrm>
-            <a:off x="2286000" y="2651760"/>
-            <a:ext cx="2926080" cy="3474720"/>
+            <a:off x="2286000" y="2880360"/>
+            <a:ext cx="2926080" cy="1600200"/>
           </a:xfrm>
           <a:prstGeom prst="rect">
             <a:avLst/>
@@ -12519,7 +12675,7 @@
                 </a:solidFill>
                 <a:latin typeface="Calibri"/>
               </a:rPr>
-              <a:t>DATASET: OULAD</a:t>
+              <a:t>DATA</a:t>
             </a:r>
           </a:p>
           <a:p>
@@ -12534,13 +12690,13 @@
               <a:buChar char="•"/>
             </a:pPr>
             <a:r>
-              <a:rPr sz="1700" b="0" i="0">
+              <a:rPr sz="1600" b="0" i="0">
                 <a:solidFill>
                   <a:srgbClr val="26262E"/>
                 </a:solidFill>
                 <a:latin typeface="Calibri"/>
               </a:rPr>
-              <a:t>Kuzilek et al. (2017)</a:t>
+              <a:t>OULAD: public, anonymised benchmark (Kuzilek et al., 2017)</a:t>
             </a:r>
           </a:p>
           <a:p>
@@ -12555,13 +12711,13 @@
               <a:buChar char="•"/>
             </a:pPr>
             <a:r>
-              <a:rPr sz="1700" b="0" i="0">
+              <a:rPr sz="1600" b="0" i="0">
                 <a:solidFill>
                   <a:srgbClr val="26262E"/>
                 </a:solidFill>
                 <a:latin typeface="Calibri"/>
               </a:rPr>
-              <a:t>24 inputs, 59 features: engagement, assessment, demographic</a:t>
+              <a:t>Clicks, assessments and demographics: 59 features</a:t>
             </a:r>
           </a:p>
         </p:txBody>
@@ -12574,8 +12730,8 @@
         </p:nvSpPr>
         <p:spPr>
           <a:xfrm>
-            <a:off x="2286000" y="4160520"/>
-            <a:ext cx="2926080" cy="2011680"/>
+            <a:off x="2286000" y="4526280"/>
+            <a:ext cx="2926080" cy="1645920"/>
           </a:xfrm>
           <a:prstGeom prst="rect">
             <a:avLst/>
@@ -12600,7 +12756,7 @@
                 </a:solidFill>
                 <a:latin typeface="Calibri"/>
               </a:rPr>
-              <a:t>PROTOCOL</a:t>
+              <a:t>HOW IT WAS TESTED</a:t>
             </a:r>
           </a:p>
           <a:p>
@@ -12615,13 +12771,13 @@
               <a:buChar char="•"/>
             </a:pPr>
             <a:r>
-              <a:rPr sz="1700" b="0" i="0">
+              <a:rPr sz="1600" b="0" i="0">
                 <a:solidFill>
                   <a:srgbClr val="26262E"/>
                 </a:solidFill>
                 <a:latin typeface="Calibri"/>
               </a:rPr>
-              <a:t>GroupKFold by course presentation (4 folds)</a:t>
+              <a:t>Trained on 3 semesters, tested on the 4th, then rotated</a:t>
             </a:r>
           </a:p>
           <a:p>
@@ -12636,13 +12792,13 @@
               <a:buChar char="•"/>
             </a:pPr>
             <a:r>
-              <a:rPr sz="1700" b="0" i="0">
+              <a:rPr sz="1600" b="0" i="0">
                 <a:solidFill>
                   <a:srgbClr val="26262E"/>
                 </a:solidFill>
                 <a:latin typeface="Calibri"/>
               </a:rPr>
-              <a:t>Tested only on presentations unseen in training</a:t>
+              <a:t>Never tested on a semester it had seen</a:t>
             </a:r>
           </a:p>
         </p:txBody>
@@ -12655,8 +12811,8 @@
         </p:nvSpPr>
         <p:spPr>
           <a:xfrm>
-            <a:off x="5577840" y="2651760"/>
-            <a:ext cx="2926080" cy="1737360"/>
+            <a:off x="5577840" y="2880360"/>
+            <a:ext cx="2926080" cy="1600200"/>
           </a:xfrm>
           <a:prstGeom prst="rect">
             <a:avLst/>
@@ -12696,13 +12852,13 @@
               <a:buChar char="•"/>
             </a:pPr>
             <a:r>
-              <a:rPr sz="1700" b="0" i="0">
+              <a:rPr sz="1600" b="0" i="0">
                 <a:solidFill>
                   <a:srgbClr val="26262E"/>
                 </a:solidFill>
                 <a:latin typeface="Calibri"/>
               </a:rPr>
-              <a:t>A missed at-risk student gets no support</a:t>
+              <a:t>Missing a struggling student is worse</a:t>
             </a:r>
           </a:p>
           <a:p>
@@ -12717,13 +12873,13 @@
               <a:buChar char="•"/>
             </a:pPr>
             <a:r>
-              <a:rPr sz="1700" b="0" i="0">
+              <a:rPr sz="1600" b="0" i="0">
                 <a:solidFill>
                   <a:srgbClr val="26262E"/>
                 </a:solidFill>
                 <a:latin typeface="Calibri"/>
               </a:rPr>
-              <a:t>A false alarm is reviewed and set aside by staff</a:t>
+              <a:t>A false alarm only costs a quick staff check</a:t>
             </a:r>
           </a:p>
         </p:txBody>
@@ -12736,8 +12892,8 @@
         </p:nvSpPr>
         <p:spPr>
           <a:xfrm>
-            <a:off x="5577840" y="4160520"/>
-            <a:ext cx="2926080" cy="2011680"/>
+            <a:off x="5577840" y="4526280"/>
+            <a:ext cx="2926080" cy="1645920"/>
           </a:xfrm>
           <a:prstGeom prst="rect">
             <a:avLst/>
@@ -12762,7 +12918,7 @@
                 </a:solidFill>
                 <a:latin typeface="Calibri"/>
               </a:rPr>
-              <a:t>IMPORTANT LIMIT</a:t>
+              <a:t>HONEST LIMIT</a:t>
             </a:r>
           </a:p>
           <a:p>
@@ -12777,13 +12933,13 @@
               <a:buChar char="•"/>
             </a:pPr>
             <a:r>
-              <a:rPr sz="1700" b="0" i="0">
+              <a:rPr sz="1600" b="0" i="0">
                 <a:solidFill>
                   <a:srgbClr val="26262E"/>
                 </a:solidFill>
                 <a:latin typeface="Calibri"/>
               </a:rPr>
-              <a:t>Features span the whole presentation</a:t>
+              <a:t>Features cover the whole semester</a:t>
             </a:r>
           </a:p>
           <a:p>
@@ -12798,13 +12954,13 @@
               <a:buChar char="•"/>
             </a:pPr>
             <a:r>
-              <a:rPr sz="1700" b="0" i="0">
+              <a:rPr sz="1600" b="0" i="0">
                 <a:solidFill>
                   <a:srgbClr val="26262E"/>
                 </a:solidFill>
                 <a:latin typeface="Calibri"/>
               </a:rPr>
-              <a:t>Retrospective classification, not yet early warning</a:t>
+              <a:t>So this is after-the-fact, not yet early warning</a:t>
             </a:r>
           </a:p>
         </p:txBody>

</xml_diff>

<commit_message>
Defense deck: formal academic section headings
</commit_message>
<xml_diff>
--- a/Internal_Defense_Presentation.pptx
+++ b/Internal_Defense_Presentation.pptx
@@ -8307,13 +8307,13 @@
               </a:spcAft>
             </a:pPr>
             <a:r>
-              <a:rPr sz="1400" b="1" i="0">
+              <a:rPr sz="1300" b="1" i="0">
                 <a:solidFill>
                   <a:srgbClr val="C00000"/>
                 </a:solidFill>
                 <a:latin typeface="Calibri"/>
               </a:rPr>
-              <a:t>WHAT HAPPENED (32,593 RECORDS)</a:t>
+              <a:t>CLASSIFICATION OUTCOMES (N = 32,593)</a:t>
             </a:r>
           </a:p>
           <a:p>
@@ -8475,13 +8475,13 @@
               </a:spcAft>
             </a:pPr>
             <a:r>
-              <a:rPr sz="1400" b="1" i="0">
+              <a:rPr sz="1300" b="1" i="0">
                 <a:solidFill>
                   <a:srgbClr val="C00000"/>
                 </a:solidFill>
                 <a:latin typeface="Calibri"/>
               </a:rPr>
-              <a:t>WHY XGBOOST?</a:t>
+              <a:t>MODEL SELECTION RATIONALE</a:t>
             </a:r>
           </a:p>
           <a:p>
@@ -8556,13 +8556,13 @@
               </a:spcAft>
             </a:pPr>
             <a:r>
-              <a:rPr sz="1400" b="1" i="0">
+              <a:rPr sz="1300" b="1" i="0">
                 <a:solidFill>
                   <a:srgbClr val="C00000"/>
                 </a:solidFill>
                 <a:latin typeface="Calibri"/>
               </a:rPr>
-              <a:t>VARIES BY SEMESTER</a:t>
+              <a:t>VARIABILITY BY PRESENTATION</a:t>
             </a:r>
           </a:p>
           <a:p>
@@ -8669,13 +8669,13 @@
               </a:spcAft>
             </a:pPr>
             <a:r>
-              <a:rPr sz="1400" b="1" i="0">
+              <a:rPr sz="1300" b="1" i="0">
                 <a:solidFill>
                   <a:srgbClr val="C00000"/>
                 </a:solidFill>
                 <a:latin typeface="Calibri"/>
               </a:rPr>
-              <a:t>WHAT DRIVES PREDICTIONS</a:t>
+              <a:t>GLOBAL FEATURE IMPORTANCE (SHAP)</a:t>
             </a:r>
           </a:p>
           <a:p>
@@ -8759,13 +8759,13 @@
               </a:spcAft>
             </a:pPr>
             <a:r>
-              <a:rPr sz="1400" b="1" i="0">
+              <a:rPr sz="1300" b="1" i="0">
                 <a:solidFill>
                   <a:srgbClr val="C00000"/>
                 </a:solidFill>
                 <a:latin typeface="Calibri"/>
               </a:rPr>
-              <a:t>TWO METHODS, CROSS-CHECKED</a:t>
+              <a:t>CROSS-METHOD AGREEMENT</a:t>
             </a:r>
           </a:p>
           <a:p>
@@ -8897,13 +8897,13 @@
               </a:spcAft>
             </a:pPr>
             <a:r>
-              <a:rPr sz="1400" b="1" i="0">
+              <a:rPr sz="1300" b="1" i="0">
                 <a:solidFill>
                   <a:srgbClr val="C00000"/>
                 </a:solidFill>
                 <a:latin typeface="Calibri"/>
               </a:rPr>
-              <a:t>EXAMPLE: STUDENT S678287</a:t>
+              <a:t>LOCAL EXPLANATION: STUDENT S678287</a:t>
             </a:r>
           </a:p>
           <a:p>
@@ -8999,13 +8999,13 @@
               </a:spcAft>
             </a:pPr>
             <a:r>
-              <a:rPr sz="1400" b="1" i="0">
+              <a:rPr sz="1300" b="1" i="0">
                 <a:solidFill>
                   <a:srgbClr val="C00000"/>
                 </a:solidFill>
                 <a:latin typeface="Calibri"/>
               </a:rPr>
-              <a:t>READ WITH CARE</a:t>
+              <a:t>INTERPRETIVE CAVEATS</a:t>
             </a:r>
           </a:p>
           <a:p>
@@ -9121,7 +9121,7 @@
                 </a:solidFill>
                 <a:latin typeface="Calibri"/>
               </a:rPr>
-              <a:t>The Role-Aware Dashboard in Moodle</a:t>
+              <a:t>Prototype: Role-Aware Dashboard in Moodle</a:t>
             </a:r>
           </a:p>
         </p:txBody>
@@ -9334,7 +9334,7 @@
               </a:spcAft>
             </a:pPr>
             <a:r>
-              <a:rPr sz="1400" b="1" i="0">
+              <a:rPr sz="1300" b="1" i="0">
                 <a:solidFill>
                   <a:srgbClr val="C00000"/>
                 </a:solidFill>
@@ -9457,7 +9457,7 @@
               </a:spcAft>
             </a:pPr>
             <a:r>
-              <a:rPr sz="1400" b="1" i="0">
+              <a:rPr sz="1300" b="1" i="0">
                 <a:solidFill>
                   <a:srgbClr val="C00000"/>
                 </a:solidFill>
@@ -9633,13 +9633,13 @@
               </a:spcAft>
             </a:pPr>
             <a:r>
-              <a:rPr sz="1400" b="1" i="0">
+              <a:rPr sz="1300" b="1" i="0">
                 <a:solidFill>
                   <a:srgbClr val="C00000"/>
                 </a:solidFill>
                 <a:latin typeface="Calibri"/>
               </a:rPr>
-              <a:t>ANSWERS</a:t>
+              <a:t>ANSWERS TO THE RESEARCH QUESTIONS</a:t>
             </a:r>
           </a:p>
           <a:p>
@@ -9762,7 +9762,7 @@
               </a:spcAft>
             </a:pPr>
             <a:r>
-              <a:rPr sz="1400" b="1" i="0">
+              <a:rPr sz="1300" b="1" i="0">
                 <a:solidFill>
                   <a:srgbClr val="C00000"/>
                 </a:solidFill>
@@ -10489,7 +10489,7 @@
               </a:spcAft>
             </a:pPr>
             <a:r>
-              <a:rPr sz="1400" b="1" i="0">
+              <a:rPr sz="1300" b="1" i="0">
                 <a:solidFill>
                   <a:srgbClr val="C00000"/>
                 </a:solidFill>
@@ -10570,13 +10570,13 @@
               </a:spcAft>
             </a:pPr>
             <a:r>
-              <a:rPr sz="1400" b="1" i="0">
+              <a:rPr sz="1300" b="1" i="0">
                 <a:solidFill>
                   <a:srgbClr val="C00000"/>
                 </a:solidFill>
                 <a:latin typeface="Calibri"/>
               </a:rPr>
-              <a:t>THE PROBLEM</a:t>
+              <a:t>PROBLEM STATEMENT</a:t>
             </a:r>
           </a:p>
           <a:p>
@@ -10672,13 +10672,13 @@
               </a:spcAft>
             </a:pPr>
             <a:r>
-              <a:rPr sz="1400" b="1" i="0">
+              <a:rPr sz="1300" b="1" i="0">
                 <a:solidFill>
                   <a:srgbClr val="C00000"/>
                 </a:solidFill>
                 <a:latin typeface="Calibri"/>
               </a:rPr>
-              <a:t>THE GAP</a:t>
+              <a:t>RESEARCH GAP</a:t>
             </a:r>
           </a:p>
           <a:p>
@@ -10941,13 +10941,13 @@
               </a:spcAft>
             </a:pPr>
             <a:r>
-              <a:rPr sz="1400" b="1" i="0">
+              <a:rPr sz="1300" b="1" i="0">
                 <a:solidFill>
                   <a:srgbClr val="C00000"/>
                 </a:solidFill>
                 <a:latin typeface="Calibri"/>
               </a:rPr>
-              <a:t>OBJECTIVES</a:t>
+              <a:t>SPECIFIC OBJECTIVES</a:t>
             </a:r>
           </a:p>
           <a:p>
@@ -11070,7 +11070,7 @@
               </a:spcAft>
             </a:pPr>
             <a:r>
-              <a:rPr sz="1400" b="1" i="0">
+              <a:rPr sz="1300" b="1" i="0">
                 <a:solidFill>
                   <a:srgbClr val="C00000"/>
                 </a:solidFill>
@@ -11252,13 +11252,13 @@
               </a:spcAft>
             </a:pPr>
             <a:r>
-              <a:rPr sz="1400" b="1" i="0">
+              <a:rPr sz="1300" b="1" i="0">
                 <a:solidFill>
                   <a:srgbClr val="C00000"/>
                 </a:solidFill>
                 <a:latin typeface="Calibri"/>
               </a:rPr>
-              <a:t>PRIMARY: COMMONKADS</a:t>
+              <a:t>PRIMARY METHODOLOGY</a:t>
             </a:r>
           </a:p>
           <a:p>
@@ -11273,13 +11273,22 @@
               <a:buChar char="•"/>
             </a:pPr>
             <a:r>
+              <a:rPr sz="1700" b="1" i="0">
+                <a:solidFill>
+                  <a:srgbClr val="26262E"/>
+                </a:solidFill>
+                <a:latin typeface="Calibri"/>
+              </a:rPr>
+              <a:t>CommonKADS: </a:t>
+            </a:r>
+            <a:r>
               <a:rPr sz="1700" b="0" i="0">
                 <a:solidFill>
                   <a:srgbClr val="26262E"/>
                 </a:solidFill>
                 <a:latin typeface="Calibri"/>
               </a:rPr>
-              <a:t>Knowledge engineering methodology (Schreiber et al., 2000)</a:t>
+              <a:t>knowledge engineering methodology (Schreiber et al., 2000)</a:t>
             </a:r>
           </a:p>
           <a:p>
@@ -11354,13 +11363,13 @@
               </a:spcAft>
             </a:pPr>
             <a:r>
-              <a:rPr sz="1400" b="1" i="0">
+              <a:rPr sz="1300" b="1" i="0">
                 <a:solidFill>
                   <a:srgbClr val="C00000"/>
                 </a:solidFill>
                 <a:latin typeface="Calibri"/>
               </a:rPr>
-              <a:t>SUPPORTING</a:t>
+              <a:t>SUPPORTING FRAMEWORKS</a:t>
             </a:r>
           </a:p>
           <a:p>
@@ -11453,13 +11462,13 @@
               </a:spcAft>
             </a:pPr>
             <a:r>
-              <a:rPr sz="1400" b="1" i="0">
+              <a:rPr sz="1300" b="1" i="0">
                 <a:solidFill>
                   <a:srgbClr val="C00000"/>
                 </a:solidFill>
                 <a:latin typeface="Calibri"/>
               </a:rPr>
-              <a:t>FOUR PHASES</a:t>
+              <a:t>RESEARCH PHASES</a:t>
             </a:r>
           </a:p>
           <a:p>
@@ -11592,13 +11601,13 @@
               </a:spcAft>
             </a:pPr>
             <a:r>
-              <a:rPr sz="1400" b="1" i="0">
+              <a:rPr sz="1300" b="1" i="0">
                 <a:solidFill>
                   <a:srgbClr val="C00000"/>
                 </a:solidFill>
                 <a:latin typeface="Calibri"/>
               </a:rPr>
-              <a:t>SCOPE</a:t>
+              <a:t>SCOPE AND DELIMITATIONS</a:t>
             </a:r>
           </a:p>
           <a:p>
@@ -11748,7 +11757,7 @@
                 </a:solidFill>
                 <a:latin typeface="Calibri"/>
               </a:rPr>
-              <a:t>builds features</a:t>
+              <a:t>feature engineering</a:t>
             </a:r>
           </a:p>
         </p:txBody>
@@ -11839,7 +11848,7 @@
                 </a:solidFill>
                 <a:latin typeface="Calibri"/>
               </a:rPr>
-              <a:t>predicts risk</a:t>
+              <a:t>risk classification</a:t>
             </a:r>
           </a:p>
         </p:txBody>
@@ -11930,7 +11939,7 @@
                 </a:solidFill>
                 <a:latin typeface="Calibri"/>
               </a:rPr>
-              <a:t>gives reasons</a:t>
+              <a:t>SHAP and LIME</a:t>
             </a:r>
           </a:p>
         </p:txBody>
@@ -12021,7 +12030,7 @@
                 </a:solidFill>
                 <a:latin typeface="Calibri"/>
               </a:rPr>
-              <a:t>checks role</a:t>
+              <a:t>role-based access</a:t>
             </a:r>
           </a:p>
         </p:txBody>
@@ -12112,7 +12121,7 @@
                 </a:solidFill>
                 <a:latin typeface="Calibri"/>
               </a:rPr>
-              <a:t>shows each role</a:t>
+              <a:t>role-specific dashboards</a:t>
             </a:r>
           </a:p>
         </p:txBody>
@@ -12145,13 +12154,13 @@
               </a:spcAft>
             </a:pPr>
             <a:r>
-              <a:rPr sz="1400" b="1" i="0">
+              <a:rPr sz="1300" b="1" i="0">
                 <a:solidFill>
                   <a:srgbClr val="C00000"/>
                 </a:solidFill>
                 <a:latin typeface="Calibri"/>
               </a:rPr>
-              <a:t>HOW IT WORKS</a:t>
+              <a:t>IMPLEMENTATION DETAILS</a:t>
             </a:r>
           </a:p>
           <a:p>
@@ -12274,13 +12283,13 @@
               </a:spcAft>
             </a:pPr>
             <a:r>
-              <a:rPr sz="1400" b="1" i="0">
+              <a:rPr sz="1300" b="1" i="0">
                 <a:solidFill>
                   <a:srgbClr val="C00000"/>
                 </a:solidFill>
                 <a:latin typeface="Calibri"/>
               </a:rPr>
-              <a:t>WHERE IT RUNS (TESTED)</a:t>
+              <a:t>LMS INTEGRATION AND DEPLOYMENT</a:t>
             </a:r>
           </a:p>
           <a:p>
@@ -12669,13 +12678,13 @@
               </a:spcAft>
             </a:pPr>
             <a:r>
-              <a:rPr sz="1400" b="1" i="0">
+              <a:rPr sz="1300" b="1" i="0">
                 <a:solidFill>
                   <a:srgbClr val="C00000"/>
                 </a:solidFill>
                 <a:latin typeface="Calibri"/>
               </a:rPr>
-              <a:t>DATA</a:t>
+              <a:t>DATASET</a:t>
             </a:r>
           </a:p>
           <a:p>
@@ -12750,13 +12759,13 @@
               </a:spcAft>
             </a:pPr>
             <a:r>
-              <a:rPr sz="1400" b="1" i="0">
+              <a:rPr sz="1300" b="1" i="0">
                 <a:solidFill>
                   <a:srgbClr val="C00000"/>
                 </a:solidFill>
                 <a:latin typeface="Calibri"/>
               </a:rPr>
-              <a:t>HOW IT WAS TESTED</a:t>
+              <a:t>VALIDATION PROTOCOL</a:t>
             </a:r>
           </a:p>
           <a:p>
@@ -12831,13 +12840,13 @@
               </a:spcAft>
             </a:pPr>
             <a:r>
-              <a:rPr sz="1400" b="1" i="0">
+              <a:rPr sz="1300" b="1" i="0">
                 <a:solidFill>
                   <a:srgbClr val="C00000"/>
                 </a:solidFill>
                 <a:latin typeface="Calibri"/>
               </a:rPr>
-              <a:t>WHY RECALL FIRST?</a:t>
+              <a:t>PRIMARY METRIC: RECALL</a:t>
             </a:r>
           </a:p>
           <a:p>
@@ -12912,13 +12921,13 @@
               </a:spcAft>
             </a:pPr>
             <a:r>
-              <a:rPr sz="1400" b="1" i="0">
+              <a:rPr sz="1300" b="1" i="0">
                 <a:solidFill>
                   <a:srgbClr val="C00000"/>
                 </a:solidFill>
                 <a:latin typeface="Calibri"/>
               </a:rPr>
-              <a:t>HONEST LIMIT</a:t>
+              <a:t>METHODOLOGICAL LIMITATION</a:t>
             </a:r>
           </a:p>
           <a:p>

</xml_diff>

<commit_message>
Defense deck: slides aligned with presentation script; script in speaker notes
</commit_message>
<xml_diff>
--- a/Internal_Defense_Presentation.pptx
+++ b/Internal_Defense_Presentation.pptx
@@ -515,7 +515,7 @@
           <a:lstStyle/>
           <a:p>
             <a:r>
-              <a:t>Good morning. I am Daniel Larry, and this is my MSc thesis, supervised by Dr. Zainab Shamsiya Usman. I built and technically evaluated a dashboard that predicts which students are at risk of failing or withdrawing, explains each prediction with SHAP and LIME, and presents that explanation differently to instructors, academic advisors and administrators.</a:t>
+              <a:t>Good morning, members of the panel. My name is Daniel Larry, and today I will be presenting my MSc thesis, titled A Role-Aware Explainable AI Dashboard for Student At-Risk Classification in Learning Management Systems, under the supervision of Dr. Zainab Shamsiya Usman. The central idea behind this research is simple: it is not enough for an AI system to predict that a student is at risk. We also need to understand why it made that prediction and present that information in a way that supports the people responsible for those students. That is the problem my research set out to address.</a:t>
             </a:r>
           </a:p>
         </p:txBody>
@@ -585,7 +585,7 @@
           <a:lstStyle/>
           <a:p>
             <a:r>
-              <a:t>This is the dashboard running inside Moodle, in course FFF-2014J. It is the instructor view: students ranked by risk, and for the selected student, SHAP and LIME side by side with a note on how far they agree. The same prediction is shown at three levels. Instructors see individual students. Advisors see their caseload across modules, with reasoning averaged across those students. Administrators see the whole institution, including how accurate the model is. These views were derived from the CommonKADS Agent Model and the literature; they have not yet been tested with real staff.</a:t>
+              <a:t>This slide shows how the research translates into a working interface. The instructor view presents individual students ranked by risk, with SHAP and LIME explanations displayed side by side for a selected student. The advisor view presents a caseload across modules, with reasoning aggregated across the relevant students. The administrator view provides an institution-level perspective, including model performance and the main drivers identified by the model. The prediction system remains the same, but the way the information is organised changes according to the responsibilities of each role. That is the central design contribution of the dashboard. I should emphasise that these role-specific views were derived from CommonKADS and the literature. Although the system was implemented, real staff have not yet evaluated whether the views meet their needs in practice.</a:t>
             </a:r>
           </a:p>
         </p:txBody>
@@ -655,7 +655,7 @@
           <a:lstStyle/>
           <a:p>
             <a:r>
-              <a:t>There are four contributions. Prediction and explanation run together in one working system, integrated with Moodle and Canvas. Explanations are tailored to each staff role. CommonKADS is applied to explainable learning analytics, which shows the design problem is mainly a knowledge problem. And there is evidence on where SHAP and LIME agree and differ. The limitations are just as important. No practitioners used the system, so trust, usability and decision quality are untested. The evaluation is retrospective. It uses one dataset. And the planned stability, fidelity, calibration and fairness checks were not completed.</a:t>
+              <a:t>The research makes four main contributions. First, it integrates prediction and explanation into a working system connected to learning management platforms. Second, it demonstrates a role-aware dashboard design that provides individual, caseload, and institution-level views. Third, it applies CommonKADS to the design of an explainable learning analytics system. Fourth, it provides an empirical comparison of where SHAP and LIME agree and differ in explaining the model's predictions. However, these contributions must be considered alongside the limitations. The evaluation used one dataset, the features support retrospective rather than early-warning classification, and no practitioner study was conducted. Additional checks on explanation stability, fidelity, probability calibration, and fairness were also not completed. I consider these limitations important because a technically promising system is not automatically a system that is reliable, fair, or useful in real educational settings.</a:t>
             </a:r>
           </a:p>
         </p:txBody>
@@ -725,7 +725,7 @@
           <a:lstStyle/>
           <a:p>
             <a:r>
-              <a:t>To answer the research questions. RQ1: SHAP and LIME were integrated into a pipeline designed with CommonKADS; they agree on the main drivers and partly differ per student. RQ2: individual, caseload and cohort views were derived from the Agent Model and implemented in Moodle and Canvas. RQ3: the technical preconditions are in place, with high recall, reasons traceable to recorded behaviour, and two methods cross-checked; whether practitioners actually benefit is the next study. Future work: early-warning evaluation at weeks 2 to 8, calibration, fairness by subgroup, and a practitioner study. Thank you.</a:t>
+              <a:t>To conclude, the first research question was addressed by integrating SHAP and LIME into a CommonKADS-informed prediction and explanation pipeline. The methods agreed on the main global driver but showed only partial agreement for individual students. The second question was addressed through the design and implementation of instructor, advisor, and administrator views in Moodle and Canvas. For the third question, the technical evaluation provides evidence of predictive performance and an implemented explanation workflow. However, whether practitioners can use these explanations effectively remains an open question. The next stage of the research would evaluate early-warning performance using data available at weeks two, four, six, and eight; assess probability calibration and fairness across subgroups; and conduct a practitioner study informed by the Technology Acceptance Model. Ultimately, the goal is not simply to predict which students may be at risk. It is to make those predictions more interpretable and appropriately accessible to the people who may be able to support them. Thank you for listening. I welcome your questions and comments.</a:t>
             </a:r>
           </a:p>
         </p:txBody>
@@ -865,7 +865,7 @@
           <a:lstStyle/>
           <a:p>
             <a:r>
-              <a:t>In ten minutes I will cover the problem and my research questions, the methodology, the system I built, the results of the technical evaluation, how the dashboard explains its predictions to each role, and then the contributions, limitations and conclusions.</a:t>
+              <a:t>I will briefly explain the problem, the approach I took, how I built the system, and what the evaluation revealed. I will then demonstrate how the same prediction and its explanation are presented differently to instructors, academic advisors, and administrators, before discussing the contributions and limitations of the work.</a:t>
             </a:r>
           </a:p>
         </p:txBody>
@@ -935,7 +935,7 @@
           <a:lstStyle/>
           <a:p>
             <a:r>
-              <a:t>Learning management systems record how students engage, and models trained on that data can flag students who may fail or withdraw. On benchmarks such as OULAD, ensemble models already do this well. The problem is what happens after the flag. Most systems give a score without a reason, and the same view goes to instructors, advisors and administrators, even though they make very different decisions. SHAP and LIME can explain predictions, but they are rarely built into working dashboards. In the literature I reviewed, I found no system that serves all three staff roles from one prediction model with role-specific explanations; the only role-specific XAI dashboard I found, by Afzaal and colleagues, is for students.</a:t>
+              <a:t>Learning management systems record how students engage with their courses. This includes their activity, assessment submissions, and other learning-related interactions. Machine learning models can use these records to identify students who may fail or withdraw. So, the challenge is not necessarily getting a prediction. The bigger problem is what happens after the prediction. If a system flags a student as being at risk but cannot provide an understandable explanation, the staff member receiving that information has limited insight into why the student was flagged. There is also a difference in what different staff members need. An instructor may need to understand an individual student's behaviour. An academic advisor may need to review several students across modules. An administrator may need an institution-wide picture. Yet these needs are not the same. Explainable AI methods such as SHAP and LIME can help interpret model predictions, but integrating those explanations into a working dashboard and tailoring them to different staff roles is the specific problem I investigated. In my literature review, I identified a gap around serving these three staff roles through one prediction system with role-specific explanations. That brings me to the aim of the research.</a:t>
             </a:r>
           </a:p>
         </p:txBody>
@@ -1005,7 +1005,7 @@
           <a:lstStyle/>
           <a:p>
             <a:r>
-              <a:t>The aim was to investigate how a role-aware explainable AI dashboard can support at-risk prediction in an LMS, using OULAD. The three objectives were to review the literature, to build and evaluate the model with SHAP and LIME, and to design, implement and technically evaluate the role-aware dashboard. The research questions are on the right, exactly as in the thesis. Note that RQ3 asks about technical potential, because this study did not include a user study.</a:t>
+              <a:t>The aim was to investigate how a role-aware explainable AI dashboard could support student at-risk prediction in learning management systems, using the Open University Learning Analytics Dataset. The work had three main objectives. First, to review the existing literature on student-risk prediction, machine learning, and explainable AI. Second, to build and evaluate an ensemble prediction model and integrate SHAP and LIME. Third, to design, implement, and technically evaluate a dashboard that presents explanations according to the needs of different staff roles. These objectives informed three research questions covering the integration of explainability, the design of role-specific dashboard views, and the technical potential of the resulting system. I want to clarify one point about the third question: I evaluated the system technically. I did not conduct a practitioner study, so I am not claiming that its usability or effect on staff decision-making has already been established.</a:t>
             </a:r>
           </a:p>
         </p:txBody>
@@ -1075,7 +1075,7 @@
           <a:lstStyle/>
           <a:p>
             <a:r>
-              <a:t>My methodology is knowledge engineering, using CommonKADS. It is a method for working out who needs what knowledge, and in what form. That matters here because the real problem is not just predicting risk, it is getting the right explanation to the right person. CommonKADS has six models: the organisation, the tasks, the agents or roles, the knowledge, how it is communicated, and the system design. I went through four phases: gathering knowledge from the literature, modelling it, building the system and testing it on OULAD. Design science gave the research steps, and the Technology Acceptance Model only guided the design. I did not interview users or run a user study, so usability and trust are not measured.</a:t>
+              <a:t>For the methodology, I used CommonKADS as the primary knowledge engineering framework. The reason for this choice is that the research is not only about producing a prediction. It is also about representing the knowledge behind that prediction and deciding how to communicate it to different users. CommonKADS provides six models that help structure this process, from the organisational context and tasks to the agents, knowledge, communication, and system design. I organised the work into four phases: knowledge acquisition and organisational analysis, knowledge and system modelling, artefact design and development, and technical evaluation. Design Science Research Methodology provided additional structure for the research process, while the Technology Acceptance Model informed the design as a theoretical lens. It was not empirically tested. The knowledge was drawn from published literature rather than interviews with practitioners. That distinction matters because the role-specific requirements were literature-derived, not validated through direct user research.</a:t>
             </a:r>
           </a:p>
         </p:txBody>
@@ -1145,7 +1145,7 @@
           <a:lstStyle/>
           <a:p>
             <a:r>
-              <a:t>The system works as a pipeline. The data layer builds features from OULAD. The model, XGBoost, predicts risk. XGBoost builds 300 small decision trees, each one correcting the mistakes of the previous ones. The explanation layer gives the reasons: SHAP values are computed in advance so the dashboard loads fast, and LIME runs when a staff member clicks a student. The API checks who is logged in and only shows the view for that role. I tested it inside two real learning management systems: as a plugin in Moodle, using Moodle's own login and roles, and embedded in a Canvas course. Everything runs in Docker containers, so the setup can be repeated.</a:t>
+              <a:t>The system has five main layers. The data layer processes the OULAD data and prepares the features used for prediction. The prediction engine uses XGBoost. The model was configured with 300 trees and a maximum depth of five. Next is the explainability layer. I used TreeSHAP to examine the model's feature contributions and cached the global explanations. LIME generates local explanations when requested. The API layer uses Flask and JSON Web Tokens for authentication and role-based access control. The presentation layer is a React dashboard with three different views. I also integrated the system with two learning management platforms. Moodle uses a native plugin that relies on its existing login, roles, and enrolments. Canvas provides access through an embedded external URL module. The important point here is that I did not stop at training a model or producing explanation charts. I implemented the prediction, explanation, access-control, and dashboard components as one integrated system.</a:t>
             </a:r>
           </a:p>
         </p:txBody>
@@ -1215,7 +1215,7 @@
           <a:lstStyle/>
           <a:p>
             <a:r>
-              <a:t>I used OULAD, a public, anonymised dataset from the UK Open University that many studies use as a benchmark. Each of the 32,593 records is one student taking one course in one semester; some students took more than one course. There are 22 course runs, from 7 modules over 4 semesters. 52.8 percent withdrew or failed, which is my at-risk group, so the two groups are roughly balanced. To test the model fairly, I trained it on three semesters and tested it on the fourth, then rotated, so it was never tested on a semester it had already seen. I focused on recall, because missing a struggling student is worse than a false alarm, which only costs a quick check. One honest limit: the features cover the whole semester, so this shows the model can classify after the fact, not yet that it works early in the semester.</a:t>
+              <a:t>For evaluation, I used the Open University Learning Analytics Dataset, published by Kuzilek and colleagues. The dataset contains 32,593 student records across 22 module presentations. For this study, students who withdrew or failed were classified as at risk. This represented 52.8 percent of the records. The feature set included engagement, assessment, and demographic information, resulting in 59 features after encoding. A key methodological decision was using four-fold GroupKFold evaluation by course presentation. This means that each test fold contained course presentations that were not used to train the model for that fold. I prioritised recall because missing a student who is genuinely at risk may mean that the student receives no additional attention from the system. A false alarm can instead be reviewed by staff. However, there is an important limitation. The features span the whole course presentation. Therefore, this evaluation demonstrates retrospective classification, not whether the model can identify students early enough for timely intervention.</a:t>
             </a:r>
           </a:p>
         </p:txBody>
@@ -1285,7 +1285,7 @@
           <a:lstStyle/>
           <a:p>
             <a:r>
-              <a:t>Here are the main results. Recall is 0.909: out of every 10 students who actually withdrew or failed, the model finds about 9. Precision is 0.866: when the model flags a student, it is right about 87 percent of the time. ROC-AUC is 0.962: if you pick one at-risk and one safe student, the model ranks the at-risk one higher 96 percent of the time. In real numbers, it caught 15,634 at-risk students, missed 1,574, and raised 2,422 false alarms, about one in six safe students, which a teacher would review and set aside. F1, which balances finding students against false alarms, is 0.887. Random Forest had a slightly better F1, 0.898, but I set recall as my rule before comparing, and XGBoost had the best recall, so I kept it. Results varied by semester, with accuracy from 0.846 to 0.916, so the overall figure is an average.</a:t>
+              <a:t>Now, to the results. The selected XGBoost model achieved a recall of 0.909, an F1-score of 0.887, and an ROC-AUC of 0.962 under the evaluation protocol. In practical terms, the model identified 15,634 of the 17,208 students classified as at risk, while missing 1,574. It also generated 2,422 false alarms among students who were not at risk. I compared XGBoost with Random Forest and Gradient Boosting under the same evaluation protocol. Random Forest achieved the highest F1-score at 0.898, while XGBoost achieved the highest recall at 0.909. So why did I retain XGBoost when Random Forest had the better F1-score? Because recall was my pre-established selection criterion. The research prioritised identifying as many at-risk students as possible, while recognising that this comes with a false-positive cost. I am not claiming that XGBoost was the best model under every metric. I am saying it was the best fit for the selection criterion I established. Performance also varied across course presentations, with accuracy ranging from 0.846 to 0.916. That variation is important and means the pooled results should be interpreted with care.</a:t>
             </a:r>
           </a:p>
         </p:txBody>
@@ -1355,7 +1355,7 @@
           <a:lstStyle/>
           <a:p>
             <a:r>
-              <a:t>This is how the predictions are explained. Across all students, whether a student submits assessments is by far the strongest signal, more than four times stronger than the next one, followed by active days, the module and mean score. I used two methods. SHAP shows how much each factor pushed a single prediction up or down. LIME is a second, independent way of explaining the same prediction, so I can cross-check. Per student, about three of the top five factors match, so they partly agree, and the dashboard shows both. For example, student s678287 is predicted above 99.9 percent at risk. They submitted almost no assessments, and that was the biggest push, and LIME agrees on four of the top five factors. Two cautions. This shows how the model reasons, not why a student is struggling. And one click result looks odd because two click measures move almost exactly together, with a correlation of 0.98. The staff member still decides what to do.</a:t>
+              <a:t>Predictive performance tells us how well the model classifies students. Explainability helps us examine the information behind its predictions. Globally, the number of assessments submitted was the most influential feature in the SHAP analysis, contributing more than four times as much as the next feature. Other prominent features included active days, module FFF, and mean assessment score. I also compared SHAP and LIME on a sample of 40 students. Both methods identified assessments submitted as the leading feature, and six additional features overlapped in their respective top-ten rankings. At the individual level, their average top-five overlap was 0.635, with a standard deviation of 0.197. This indicates partial agreement, rather than complete agreement. That is one reason I retained both methods in the dashboard: they provide complementary perspectives on the model's reasoning. There is also an important caution. These explanations describe how features contribute to the model's prediction. They do not establish that those features cause a student to fail or withdraw. For example, clicks recorded in the 28 days before deadlines showed a counter-intuitive relationship with risk. Their correlation with total clicks was 0.98, suggesting that collinearity may be influencing the attribution. This is precisely why explanations need to be interpreted critically rather than treated as definitive evidence of causation.</a:t>
             </a:r>
           </a:p>
         </p:txBody>
@@ -8094,7 +8094,7 @@
               </a:spcAft>
             </a:pPr>
             <a:r>
-              <a:rPr sz="4000" b="1" i="0">
+              <a:rPr sz="4400" b="1" i="0">
                 <a:solidFill>
                   <a:srgbClr val="1F3864"/>
                 </a:solidFill>
@@ -8110,15 +8110,38 @@
               </a:spcAft>
             </a:pPr>
             <a:r>
-              <a:rPr sz="1300" b="0" i="0">
+              <a:rPr sz="1500" b="0" i="0">
                 <a:solidFill>
                   <a:srgbClr val="59595F"/>
                 </a:solidFill>
                 <a:latin typeface="Calibri"/>
               </a:rPr>
-              <a:t>Recall: finds about</a:t>
-            </a:r>
-          </a:p>
+              <a:t>Recall</a:t>
+            </a:r>
+          </a:p>
+        </p:txBody>
+      </p:sp>
+      <p:sp>
+        <p:nvSpPr>
+          <p:cNvPr id="4" name="Number 2"/>
+          <p:cNvSpPr txBox="1"/>
+          <p:nvPr/>
+        </p:nvSpPr>
+        <p:spPr>
+          <a:xfrm>
+            <a:off x="4358640" y="1417320"/>
+            <a:ext cx="1981200" cy="1325880"/>
+          </a:xfrm>
+          <a:prstGeom prst="rect">
+            <a:avLst/>
+          </a:prstGeom>
+          <a:noFill/>
+        </p:spPr>
+        <p:txBody>
+          <a:bodyPr wrap="square" anchor="t" lIns="0" rIns="0" tIns="0" bIns="0">
+            <a:spAutoFit/>
+          </a:bodyPr>
+          <a:lstStyle/>
           <a:p>
             <a:pPr algn="l">
               <a:spcAft>
@@ -8126,38 +8149,15 @@
               </a:spcAft>
             </a:pPr>
             <a:r>
-              <a:rPr sz="1300" b="0" i="0">
-                <a:solidFill>
-                  <a:srgbClr val="59595F"/>
-                </a:solidFill>
-                <a:latin typeface="Calibri"/>
-              </a:rPr>
-              <a:t>9 in 10 at-risk students</a:t>
-            </a:r>
-          </a:p>
-        </p:txBody>
-      </p:sp>
-      <p:sp>
-        <p:nvSpPr>
-          <p:cNvPr id="4" name="Number 2"/>
-          <p:cNvSpPr txBox="1"/>
-          <p:nvPr/>
-        </p:nvSpPr>
-        <p:spPr>
-          <a:xfrm>
-            <a:off x="4358640" y="1417320"/>
-            <a:ext cx="1981200" cy="1325880"/>
-          </a:xfrm>
-          <a:prstGeom prst="rect">
-            <a:avLst/>
-          </a:prstGeom>
-          <a:noFill/>
-        </p:spPr>
-        <p:txBody>
-          <a:bodyPr wrap="square" anchor="t" lIns="0" rIns="0" tIns="0" bIns="0">
-            <a:spAutoFit/>
-          </a:bodyPr>
-          <a:lstStyle/>
+              <a:rPr sz="4400" b="1" i="0">
+                <a:solidFill>
+                  <a:srgbClr val="1F3864"/>
+                </a:solidFill>
+                <a:latin typeface="Calibri"/>
+              </a:rPr>
+              <a:t>0.887</a:t>
+            </a:r>
+          </a:p>
           <a:p>
             <a:pPr algn="l">
               <a:spcAft>
@@ -8165,15 +8165,38 @@
               </a:spcAft>
             </a:pPr>
             <a:r>
-              <a:rPr sz="4000" b="1" i="0">
-                <a:solidFill>
-                  <a:srgbClr val="1F3864"/>
-                </a:solidFill>
-                <a:latin typeface="Calibri"/>
-              </a:rPr>
-              <a:t>0.866</a:t>
-            </a:r>
-          </a:p>
+              <a:rPr sz="1500" b="0" i="0">
+                <a:solidFill>
+                  <a:srgbClr val="59595F"/>
+                </a:solidFill>
+                <a:latin typeface="Calibri"/>
+              </a:rPr>
+              <a:t>F1-score</a:t>
+            </a:r>
+          </a:p>
+        </p:txBody>
+      </p:sp>
+      <p:sp>
+        <p:nvSpPr>
+          <p:cNvPr id="5" name="Number 3"/>
+          <p:cNvSpPr txBox="1"/>
+          <p:nvPr/>
+        </p:nvSpPr>
+        <p:spPr>
+          <a:xfrm>
+            <a:off x="6431280" y="1417320"/>
+            <a:ext cx="1981200" cy="1325880"/>
+          </a:xfrm>
+          <a:prstGeom prst="rect">
+            <a:avLst/>
+          </a:prstGeom>
+          <a:noFill/>
+        </p:spPr>
+        <p:txBody>
+          <a:bodyPr wrap="square" anchor="t" lIns="0" rIns="0" tIns="0" bIns="0">
+            <a:spAutoFit/>
+          </a:bodyPr>
+          <a:lstStyle/>
           <a:p>
             <a:pPr algn="l">
               <a:spcAft>
@@ -8181,13 +8204,13 @@
               </a:spcAft>
             </a:pPr>
             <a:r>
-              <a:rPr sz="1300" b="0" i="0">
-                <a:solidFill>
-                  <a:srgbClr val="59595F"/>
-                </a:solidFill>
-                <a:latin typeface="Calibri"/>
-              </a:rPr>
-              <a:t>Precision: a flag is</a:t>
+              <a:rPr sz="4400" b="1" i="0">
+                <a:solidFill>
+                  <a:srgbClr val="1F3864"/>
+                </a:solidFill>
+                <a:latin typeface="Calibri"/>
+              </a:rPr>
+              <a:t>0.962</a:t>
             </a:r>
           </a:p>
           <a:p>
@@ -8197,84 +8220,13 @@
               </a:spcAft>
             </a:pPr>
             <a:r>
-              <a:rPr sz="1300" b="0" i="0">
+              <a:rPr sz="1500" b="0" i="0">
                 <a:solidFill>
                   <a:srgbClr val="59595F"/>
                 </a:solidFill>
                 <a:latin typeface="Calibri"/>
               </a:rPr>
-              <a:t>right about 87% of the time</a:t>
-            </a:r>
-          </a:p>
-        </p:txBody>
-      </p:sp>
-      <p:sp>
-        <p:nvSpPr>
-          <p:cNvPr id="5" name="Number 3"/>
-          <p:cNvSpPr txBox="1"/>
-          <p:nvPr/>
-        </p:nvSpPr>
-        <p:spPr>
-          <a:xfrm>
-            <a:off x="6431280" y="1417320"/>
-            <a:ext cx="1981200" cy="1325880"/>
-          </a:xfrm>
-          <a:prstGeom prst="rect">
-            <a:avLst/>
-          </a:prstGeom>
-          <a:noFill/>
-        </p:spPr>
-        <p:txBody>
-          <a:bodyPr wrap="square" anchor="t" lIns="0" rIns="0" tIns="0" bIns="0">
-            <a:spAutoFit/>
-          </a:bodyPr>
-          <a:lstStyle/>
-          <a:p>
-            <a:pPr algn="l">
-              <a:spcAft>
-                <a:spcPts val="0"/>
-              </a:spcAft>
-            </a:pPr>
-            <a:r>
-              <a:rPr sz="4000" b="1" i="0">
-                <a:solidFill>
-                  <a:srgbClr val="1F3864"/>
-                </a:solidFill>
-                <a:latin typeface="Calibri"/>
-              </a:rPr>
-              <a:t>0.962</a:t>
-            </a:r>
-          </a:p>
-          <a:p>
-            <a:pPr algn="l">
-              <a:spcAft>
-                <a:spcPts val="0"/>
-              </a:spcAft>
-            </a:pPr>
-            <a:r>
-              <a:rPr sz="1300" b="0" i="0">
-                <a:solidFill>
-                  <a:srgbClr val="59595F"/>
-                </a:solidFill>
-                <a:latin typeface="Calibri"/>
-              </a:rPr>
-              <a:t>ROC-AUC: ranks the at-risk</a:t>
-            </a:r>
-          </a:p>
-          <a:p>
-            <a:pPr algn="l">
-              <a:spcAft>
-                <a:spcPts val="0"/>
-              </a:spcAft>
-            </a:pPr>
-            <a:r>
-              <a:rPr sz="1300" b="0" i="0">
-                <a:solidFill>
-                  <a:srgbClr val="59595F"/>
-                </a:solidFill>
-                <a:latin typeface="Calibri"/>
-              </a:rPr>
-              <a:t>student first 96% of the time</a:t>
+              <a:t>ROC-AUC</a:t>
             </a:r>
           </a:p>
         </p:txBody>
@@ -8287,8 +8239,8 @@
         </p:nvSpPr>
         <p:spPr>
           <a:xfrm>
-            <a:off x="2286000" y="2926080"/>
-            <a:ext cx="2926080" cy="3200400"/>
+            <a:off x="2286000" y="2743200"/>
+            <a:ext cx="6217920" cy="914400"/>
           </a:xfrm>
           <a:prstGeom prst="rect">
             <a:avLst/>
@@ -8313,7 +8265,7 @@
                 </a:solidFill>
                 <a:latin typeface="Calibri"/>
               </a:rPr>
-              <a:t>CLASSIFICATION OUTCOMES (N = 32,593)</a:t>
+              <a:t>CLASSIFICATION OUTCOMES</a:t>
             </a:r>
           </a:p>
           <a:p>
@@ -8328,22 +8280,106 @@
               <a:buChar char="•"/>
             </a:pPr>
             <a:r>
-              <a:rPr sz="1600" b="1" i="0">
+              <a:rPr sz="1700" b="0" i="0">
                 <a:solidFill>
                   <a:srgbClr val="26262E"/>
                 </a:solidFill>
                 <a:latin typeface="Calibri"/>
               </a:rPr>
-              <a:t>15,634 </a:t>
-            </a:r>
-            <a:r>
-              <a:rPr sz="1600" b="0" i="0">
+              <a:t>Identified </a:t>
+            </a:r>
+            <a:r>
+              <a:rPr sz="1700" b="1" i="0">
                 <a:solidFill>
                   <a:srgbClr val="26262E"/>
                 </a:solidFill>
                 <a:latin typeface="Calibri"/>
               </a:rPr>
-              <a:t>at-risk students caught</a:t>
+              <a:t>15,634 of 17,208</a:t>
+            </a:r>
+            <a:r>
+              <a:rPr sz="1700" b="0" i="0">
+                <a:solidFill>
+                  <a:srgbClr val="26262E"/>
+                </a:solidFill>
+                <a:latin typeface="Calibri"/>
+              </a:rPr>
+              <a:t> at-risk students; </a:t>
+            </a:r>
+            <a:r>
+              <a:rPr sz="1700" b="1" i="0">
+                <a:solidFill>
+                  <a:srgbClr val="26262E"/>
+                </a:solidFill>
+                <a:latin typeface="Calibri"/>
+              </a:rPr>
+              <a:t>1,574</a:t>
+            </a:r>
+            <a:r>
+              <a:rPr sz="1700" b="0" i="0">
+                <a:solidFill>
+                  <a:srgbClr val="26262E"/>
+                </a:solidFill>
+                <a:latin typeface="Calibri"/>
+              </a:rPr>
+              <a:t> missed; </a:t>
+            </a:r>
+            <a:r>
+              <a:rPr sz="1700" b="1" i="0">
+                <a:solidFill>
+                  <a:srgbClr val="26262E"/>
+                </a:solidFill>
+                <a:latin typeface="Calibri"/>
+              </a:rPr>
+              <a:t>2,422</a:t>
+            </a:r>
+            <a:r>
+              <a:rPr sz="1700" b="0" i="0">
+                <a:solidFill>
+                  <a:srgbClr val="26262E"/>
+                </a:solidFill>
+                <a:latin typeface="Calibri"/>
+              </a:rPr>
+              <a:t> false alarms</a:t>
+            </a:r>
+          </a:p>
+        </p:txBody>
+      </p:sp>
+      <p:sp>
+        <p:nvSpPr>
+          <p:cNvPr id="7" name="Comparison"/>
+          <p:cNvSpPr txBox="1"/>
+          <p:nvPr/>
+        </p:nvSpPr>
+        <p:spPr>
+          <a:xfrm>
+            <a:off x="2286000" y="3703320"/>
+            <a:ext cx="6217920" cy="1463040"/>
+          </a:xfrm>
+          <a:prstGeom prst="rect">
+            <a:avLst/>
+          </a:prstGeom>
+          <a:noFill/>
+        </p:spPr>
+        <p:txBody>
+          <a:bodyPr wrap="square" anchor="t" lIns="0" rIns="0" tIns="0" bIns="0">
+            <a:spAutoFit/>
+          </a:bodyPr>
+          <a:lstStyle/>
+          <a:p>
+            <a:pPr algn="l">
+              <a:spcAft>
+                <a:spcPts val="600"/>
+              </a:spcAft>
+            </a:pPr>
+            <a:r>
+              <a:rPr sz="1300" b="1" i="0">
+                <a:solidFill>
+                  <a:srgbClr val="C00000"/>
+                </a:solidFill>
+                <a:latin typeface="Calibri"/>
+              </a:rPr>
+              <a:t>MODEL SELECTION</a:t>
             </a:r>
           </a:p>
           <a:p>
@@ -8358,22 +8394,22 @@
               <a:buChar char="•"/>
             </a:pPr>
             <a:r>
-              <a:rPr sz="1600" b="1" i="0">
+              <a:rPr sz="1700" b="1" i="0">
                 <a:solidFill>
                   <a:srgbClr val="26262E"/>
                 </a:solidFill>
                 <a:latin typeface="Calibri"/>
               </a:rPr>
-              <a:t>1,574 </a:t>
-            </a:r>
-            <a:r>
-              <a:rPr sz="1600" b="0" i="0">
+              <a:t>Random Forest: </a:t>
+            </a:r>
+            <a:r>
+              <a:rPr sz="1700" b="0" i="0">
                 <a:solidFill>
                   <a:srgbClr val="26262E"/>
                 </a:solidFill>
                 <a:latin typeface="Calibri"/>
               </a:rPr>
-              <a:t>missed</a:t>
+              <a:t>highest F1-score (0.898)</a:t>
             </a:r>
           </a:p>
           <a:p>
@@ -8388,22 +8424,61 @@
               <a:buChar char="•"/>
             </a:pPr>
             <a:r>
-              <a:rPr sz="1600" b="1" i="0">
+              <a:rPr sz="1700" b="1" i="0">
                 <a:solidFill>
                   <a:srgbClr val="26262E"/>
                 </a:solidFill>
                 <a:latin typeface="Calibri"/>
               </a:rPr>
-              <a:t>2,422 </a:t>
-            </a:r>
-            <a:r>
-              <a:rPr sz="1600" b="0" i="0">
+              <a:t>XGBoost: </a:t>
+            </a:r>
+            <a:r>
+              <a:rPr sz="1700" b="0" i="0">
                 <a:solidFill>
                   <a:srgbClr val="26262E"/>
                 </a:solidFill>
                 <a:latin typeface="Calibri"/>
               </a:rPr>
-              <a:t>false alarms (1 in 6 safe students)</a:t>
+              <a:t>highest recall (0.909), retained by the pre-set criterion</a:t>
+            </a:r>
+          </a:p>
+        </p:txBody>
+      </p:sp>
+      <p:sp>
+        <p:nvSpPr>
+          <p:cNvPr id="8" name="Variability"/>
+          <p:cNvSpPr txBox="1"/>
+          <p:nvPr/>
+        </p:nvSpPr>
+        <p:spPr>
+          <a:xfrm>
+            <a:off x="2286000" y="5212079"/>
+            <a:ext cx="6217920" cy="914400"/>
+          </a:xfrm>
+          <a:prstGeom prst="rect">
+            <a:avLst/>
+          </a:prstGeom>
+          <a:noFill/>
+        </p:spPr>
+        <p:txBody>
+          <a:bodyPr wrap="square" anchor="t" lIns="0" rIns="0" tIns="0" bIns="0">
+            <a:spAutoFit/>
+          </a:bodyPr>
+          <a:lstStyle/>
+          <a:p>
+            <a:pPr algn="l">
+              <a:spcAft>
+                <a:spcPts val="600"/>
+              </a:spcAft>
+            </a:pPr>
+            <a:r>
+              <a:rPr sz="1300" b="1" i="0">
+                <a:solidFill>
+                  <a:srgbClr val="C00000"/>
+                </a:solidFill>
+                <a:latin typeface="Calibri"/>
+              </a:rPr>
+              <a:t>VARIABILITY</a:t>
             </a:r>
           </a:p>
           <a:p>
@@ -8418,172 +8493,13 @@
               <a:buChar char="•"/>
             </a:pPr>
             <a:r>
-              <a:rPr sz="1600" b="0" i="0">
+              <a:rPr sz="1700" b="0" i="0">
                 <a:solidFill>
                   <a:srgbClr val="26262E"/>
                 </a:solidFill>
                 <a:latin typeface="Calibri"/>
               </a:rPr>
-              <a:t>Overall: </a:t>
-            </a:r>
-            <a:r>
-              <a:rPr sz="1600" b="1" i="0">
-                <a:solidFill>
-                  <a:srgbClr val="26262E"/>
-                </a:solidFill>
-                <a:latin typeface="Calibri"/>
-              </a:rPr>
-              <a:t>F1 0.887</a:t>
-            </a:r>
-            <a:r>
-              <a:rPr sz="1600" b="0" i="0">
-                <a:solidFill>
-                  <a:srgbClr val="26262E"/>
-                </a:solidFill>
-                <a:latin typeface="Calibri"/>
-              </a:rPr>
-              <a:t>, accuracy 0.877</a:t>
-            </a:r>
-          </a:p>
-        </p:txBody>
-      </p:sp>
-      <p:sp>
-        <p:nvSpPr>
-          <p:cNvPr id="7" name="Comparison"/>
-          <p:cNvSpPr txBox="1"/>
-          <p:nvPr/>
-        </p:nvSpPr>
-        <p:spPr>
-          <a:xfrm>
-            <a:off x="5577840" y="2926080"/>
-            <a:ext cx="2926080" cy="2011680"/>
-          </a:xfrm>
-          <a:prstGeom prst="rect">
-            <a:avLst/>
-          </a:prstGeom>
-          <a:noFill/>
-        </p:spPr>
-        <p:txBody>
-          <a:bodyPr wrap="square" anchor="t" lIns="0" rIns="0" tIns="0" bIns="0">
-            <a:spAutoFit/>
-          </a:bodyPr>
-          <a:lstStyle/>
-          <a:p>
-            <a:pPr algn="l">
-              <a:spcAft>
-                <a:spcPts val="600"/>
-              </a:spcAft>
-            </a:pPr>
-            <a:r>
-              <a:rPr sz="1300" b="1" i="0">
-                <a:solidFill>
-                  <a:srgbClr val="C00000"/>
-                </a:solidFill>
-                <a:latin typeface="Calibri"/>
-              </a:rPr>
-              <a:t>MODEL SELECTION RATIONALE</a:t>
-            </a:r>
-          </a:p>
-          <a:p>
-            <a:pPr algn="l" marL="201168" indent="-201168">
-              <a:spcAft>
-                <a:spcPts val="600"/>
-              </a:spcAft>
-              <a:buClr>
-                <a:srgbClr val="1F3864"/>
-              </a:buClr>
-              <a:buFont typeface="Arial"/>
-              <a:buChar char="•"/>
-            </a:pPr>
-            <a:r>
-              <a:rPr sz="1600" b="0" i="0">
-                <a:solidFill>
-                  <a:srgbClr val="26262E"/>
-                </a:solidFill>
-                <a:latin typeface="Calibri"/>
-              </a:rPr>
-              <a:t>Random Forest: best F1 (0.898)</a:t>
-            </a:r>
-          </a:p>
-          <a:p>
-            <a:pPr algn="l" marL="201168" indent="-201168">
-              <a:spcAft>
-                <a:spcPts val="600"/>
-              </a:spcAft>
-              <a:buClr>
-                <a:srgbClr val="1F3864"/>
-              </a:buClr>
-              <a:buFont typeface="Arial"/>
-              <a:buChar char="•"/>
-            </a:pPr>
-            <a:r>
-              <a:rPr sz="1600" b="0" i="0">
-                <a:solidFill>
-                  <a:srgbClr val="26262E"/>
-                </a:solidFill>
-                <a:latin typeface="Calibri"/>
-              </a:rPr>
-              <a:t>XGBoost: best recall (0.909), my pre-set rule, so kept</a:t>
-            </a:r>
-          </a:p>
-        </p:txBody>
-      </p:sp>
-      <p:sp>
-        <p:nvSpPr>
-          <p:cNvPr id="8" name="Variability"/>
-          <p:cNvSpPr txBox="1"/>
-          <p:nvPr/>
-        </p:nvSpPr>
-        <p:spPr>
-          <a:xfrm>
-            <a:off x="5577840" y="4846320"/>
-            <a:ext cx="2926080" cy="1280160"/>
-          </a:xfrm>
-          <a:prstGeom prst="rect">
-            <a:avLst/>
-          </a:prstGeom>
-          <a:noFill/>
-        </p:spPr>
-        <p:txBody>
-          <a:bodyPr wrap="square" anchor="t" lIns="0" rIns="0" tIns="0" bIns="0">
-            <a:spAutoFit/>
-          </a:bodyPr>
-          <a:lstStyle/>
-          <a:p>
-            <a:pPr algn="l">
-              <a:spcAft>
-                <a:spcPts val="600"/>
-              </a:spcAft>
-            </a:pPr>
-            <a:r>
-              <a:rPr sz="1300" b="1" i="0">
-                <a:solidFill>
-                  <a:srgbClr val="C00000"/>
-                </a:solidFill>
-                <a:latin typeface="Calibri"/>
-              </a:rPr>
-              <a:t>VARIABILITY BY PRESENTATION</a:t>
-            </a:r>
-          </a:p>
-          <a:p>
-            <a:pPr algn="l" marL="201168" indent="-201168">
-              <a:spcAft>
-                <a:spcPts val="600"/>
-              </a:spcAft>
-              <a:buClr>
-                <a:srgbClr val="1F3864"/>
-              </a:buClr>
-              <a:buFont typeface="Arial"/>
-              <a:buChar char="•"/>
-            </a:pPr>
-            <a:r>
-              <a:rPr sz="1600" b="0" i="0">
-                <a:solidFill>
-                  <a:srgbClr val="26262E"/>
-                </a:solidFill>
-                <a:latin typeface="Calibri"/>
-              </a:rPr>
-              <a:t>Accuracy 0.846 to 0.916</a:t>
+              <a:t>Accuracy 0.846 to 0.916 across presentations: interpret pooled results with care</a:t>
             </a:r>
           </a:p>
         </p:txBody>
@@ -8643,14 +8559,14 @@
       </p:sp>
       <p:sp>
         <p:nvSpPr>
-          <p:cNvPr id="3" name="Global"/>
+          <p:cNvPr id="3" name="Key message"/>
           <p:cNvSpPr txBox="1"/>
           <p:nvPr/>
         </p:nvSpPr>
         <p:spPr>
           <a:xfrm>
-            <a:off x="2286000" y="1463040"/>
-            <a:ext cx="2926080" cy="2011680"/>
+            <a:off x="2286000" y="1371600"/>
+            <a:ext cx="6217920" cy="731520"/>
           </a:xfrm>
           <a:prstGeom prst="rect">
             <a:avLst/>
@@ -8669,13 +8585,52 @@
               </a:spcAft>
             </a:pPr>
             <a:r>
+              <a:rPr sz="1900" b="1" i="0">
+                <a:solidFill>
+                  <a:srgbClr val="1F3864"/>
+                </a:solidFill>
+                <a:latin typeface="Calibri"/>
+              </a:rPr>
+              <a:t>Assessments submitted: the strongest feature, over four times the next.</a:t>
+            </a:r>
+          </a:p>
+        </p:txBody>
+      </p:sp>
+      <p:sp>
+        <p:nvSpPr>
+          <p:cNvPr id="4" name="Global"/>
+          <p:cNvSpPr txBox="1"/>
+          <p:nvPr/>
+        </p:nvSpPr>
+        <p:spPr>
+          <a:xfrm>
+            <a:off x="2286000" y="2240280"/>
+            <a:ext cx="6217920" cy="914400"/>
+          </a:xfrm>
+          <a:prstGeom prst="rect">
+            <a:avLst/>
+          </a:prstGeom>
+          <a:noFill/>
+        </p:spPr>
+        <p:txBody>
+          <a:bodyPr wrap="square" anchor="t" lIns="0" rIns="0" tIns="0" bIns="0">
+            <a:spAutoFit/>
+          </a:bodyPr>
+          <a:lstStyle/>
+          <a:p>
+            <a:pPr algn="l">
+              <a:spcAft>
+                <a:spcPts val="600"/>
+              </a:spcAft>
+            </a:pPr>
+            <a:r>
               <a:rPr sz="1300" b="1" i="0">
                 <a:solidFill>
                   <a:srgbClr val="C00000"/>
                 </a:solidFill>
                 <a:latin typeface="Calibri"/>
               </a:rPr>
-              <a:t>GLOBAL FEATURE IMPORTANCE (SHAP)</a:t>
+              <a:t>OTHER PROMINENT FEATURES</a:t>
             </a:r>
           </a:p>
           <a:p>
@@ -8690,22 +8645,52 @@
               <a:buChar char="•"/>
             </a:pPr>
             <a:r>
-              <a:rPr sz="1600" b="1" i="0">
+              <a:rPr sz="1700" b="0" i="0">
                 <a:solidFill>
                   <a:srgbClr val="26262E"/>
                 </a:solidFill>
                 <a:latin typeface="Calibri"/>
               </a:rPr>
-              <a:t>Submitting assessments </a:t>
-            </a:r>
-            <a:r>
-              <a:rPr sz="1600" b="0" i="0">
-                <a:solidFill>
-                  <a:srgbClr val="26262E"/>
-                </a:solidFill>
-                <a:latin typeface="Calibri"/>
-              </a:rPr>
-              <a:t>is the strongest signal, over 4× the next</a:t>
+              <a:t>Active days, module FFF, mean assessment score</a:t>
+            </a:r>
+          </a:p>
+        </p:txBody>
+      </p:sp>
+      <p:sp>
+        <p:nvSpPr>
+          <p:cNvPr id="5" name="Agreement"/>
+          <p:cNvSpPr txBox="1"/>
+          <p:nvPr/>
+        </p:nvSpPr>
+        <p:spPr>
+          <a:xfrm>
+            <a:off x="2286000" y="3200400"/>
+            <a:ext cx="6217920" cy="1463040"/>
+          </a:xfrm>
+          <a:prstGeom prst="rect">
+            <a:avLst/>
+          </a:prstGeom>
+          <a:noFill/>
+        </p:spPr>
+        <p:txBody>
+          <a:bodyPr wrap="square" anchor="t" lIns="0" rIns="0" tIns="0" bIns="0">
+            <a:spAutoFit/>
+          </a:bodyPr>
+          <a:lstStyle/>
+          <a:p>
+            <a:pPr algn="l">
+              <a:spcAft>
+                <a:spcPts val="600"/>
+              </a:spcAft>
+            </a:pPr>
+            <a:r>
+              <a:rPr sz="1300" b="1" i="0">
+                <a:solidFill>
+                  <a:srgbClr val="C00000"/>
+                </a:solidFill>
+                <a:latin typeface="Calibri"/>
+              </a:rPr>
+              <a:t>SHAP VS LIME (40 STUDENTS)</a:t>
             </a:r>
           </a:p>
           <a:p>
@@ -8720,52 +8705,13 @@
               <a:buChar char="•"/>
             </a:pPr>
             <a:r>
-              <a:rPr sz="1600" b="0" i="0">
+              <a:rPr sz="1700" b="0" i="0">
                 <a:solidFill>
                   <a:srgbClr val="26262E"/>
                 </a:solidFill>
                 <a:latin typeface="Calibri"/>
               </a:rPr>
-              <a:t>Then active days, module FFF, mean score</a:t>
-            </a:r>
-          </a:p>
-        </p:txBody>
-      </p:sp>
-      <p:sp>
-        <p:nvSpPr>
-          <p:cNvPr id="4" name="Agreement"/>
-          <p:cNvSpPr txBox="1"/>
-          <p:nvPr/>
-        </p:nvSpPr>
-        <p:spPr>
-          <a:xfrm>
-            <a:off x="2286000" y="3566160"/>
-            <a:ext cx="2926080" cy="2651760"/>
-          </a:xfrm>
-          <a:prstGeom prst="rect">
-            <a:avLst/>
-          </a:prstGeom>
-          <a:noFill/>
-        </p:spPr>
-        <p:txBody>
-          <a:bodyPr wrap="square" anchor="t" lIns="0" rIns="0" tIns="0" bIns="0">
-            <a:spAutoFit/>
-          </a:bodyPr>
-          <a:lstStyle/>
-          <a:p>
-            <a:pPr algn="l">
-              <a:spcAft>
-                <a:spcPts val="600"/>
-              </a:spcAft>
-            </a:pPr>
-            <a:r>
-              <a:rPr sz="1300" b="1" i="0">
-                <a:solidFill>
-                  <a:srgbClr val="C00000"/>
-                </a:solidFill>
-                <a:latin typeface="Calibri"/>
-              </a:rPr>
-              <a:t>CROSS-METHOD AGREEMENT</a:t>
+              <a:t>Same leading feature; six further features shared in the top ten</a:t>
             </a:r>
           </a:p>
           <a:p>
@@ -8780,22 +8726,70 @@
               <a:buChar char="•"/>
             </a:pPr>
             <a:r>
-              <a:rPr sz="1600" b="1" i="0">
+              <a:rPr sz="1700" b="0" i="0">
                 <a:solidFill>
                   <a:srgbClr val="26262E"/>
                 </a:solidFill>
                 <a:latin typeface="Calibri"/>
               </a:rPr>
-              <a:t>SHAP: </a:t>
-            </a:r>
-            <a:r>
-              <a:rPr sz="1600" b="0" i="0">
+              <a:t>Mean per-student top-5 overlap </a:t>
+            </a:r>
+            <a:r>
+              <a:rPr sz="1700" b="1" i="0">
                 <a:solidFill>
                   <a:srgbClr val="26262E"/>
                 </a:solidFill>
                 <a:latin typeface="Calibri"/>
               </a:rPr>
-              <a:t>how much each factor pushed one prediction</a:t>
+              <a:t>0.635</a:t>
+            </a:r>
+            <a:r>
+              <a:rPr sz="1700" b="0" i="0">
+                <a:solidFill>
+                  <a:srgbClr val="26262E"/>
+                </a:solidFill>
+                <a:latin typeface="Calibri"/>
+              </a:rPr>
+              <a:t> (SD 0.197): partial agreement</a:t>
+            </a:r>
+          </a:p>
+        </p:txBody>
+      </p:sp>
+      <p:sp>
+        <p:nvSpPr>
+          <p:cNvPr id="6" name="Caution"/>
+          <p:cNvSpPr txBox="1"/>
+          <p:nvPr/>
+        </p:nvSpPr>
+        <p:spPr>
+          <a:xfrm>
+            <a:off x="2286000" y="4709160"/>
+            <a:ext cx="6217920" cy="1463040"/>
+          </a:xfrm>
+          <a:prstGeom prst="rect">
+            <a:avLst/>
+          </a:prstGeom>
+          <a:noFill/>
+        </p:spPr>
+        <p:txBody>
+          <a:bodyPr wrap="square" anchor="t" lIns="0" rIns="0" tIns="0" bIns="0">
+            <a:spAutoFit/>
+          </a:bodyPr>
+          <a:lstStyle/>
+          <a:p>
+            <a:pPr algn="l">
+              <a:spcAft>
+                <a:spcPts val="600"/>
+              </a:spcAft>
+            </a:pPr>
+            <a:r>
+              <a:rPr sz="1300" b="1" i="0">
+                <a:solidFill>
+                  <a:srgbClr val="C00000"/>
+                </a:solidFill>
+                <a:latin typeface="Calibri"/>
+              </a:rPr>
+              <a:t>INTERPRETIVE CAUTION</a:t>
             </a:r>
           </a:p>
           <a:p>
@@ -8810,22 +8804,13 @@
               <a:buChar char="•"/>
             </a:pPr>
             <a:r>
-              <a:rPr sz="1600" b="1" i="0">
+              <a:rPr sz="1700" b="0" i="0">
                 <a:solidFill>
                   <a:srgbClr val="26262E"/>
                 </a:solidFill>
                 <a:latin typeface="Calibri"/>
               </a:rPr>
-              <a:t>LIME: </a:t>
-            </a:r>
-            <a:r>
-              <a:rPr sz="1600" b="0" i="0">
-                <a:solidFill>
-                  <a:srgbClr val="26262E"/>
-                </a:solidFill>
-                <a:latin typeface="Calibri"/>
-              </a:rPr>
-              <a:t>a second, independent explanation</a:t>
+              <a:t>Attributions describe the model, not causes of failure or withdrawal</a:t>
             </a:r>
           </a:p>
           <a:p>
@@ -8840,235 +8825,13 @@
               <a:buChar char="•"/>
             </a:pPr>
             <a:r>
-              <a:rPr sz="1600" b="0" i="0">
+              <a:rPr sz="1700" b="0" i="0">
                 <a:solidFill>
                   <a:srgbClr val="26262E"/>
                 </a:solidFill>
                 <a:latin typeface="Calibri"/>
               </a:rPr>
-              <a:t>Per student, about </a:t>
-            </a:r>
-            <a:r>
-              <a:rPr sz="1600" b="1" i="0">
-                <a:solidFill>
-                  <a:srgbClr val="26262E"/>
-                </a:solidFill>
-                <a:latin typeface="Calibri"/>
-              </a:rPr>
-              <a:t>3 of the top 5</a:t>
-            </a:r>
-            <a:r>
-              <a:rPr sz="1600" b="0" i="0">
-                <a:solidFill>
-                  <a:srgbClr val="26262E"/>
-                </a:solidFill>
-                <a:latin typeface="Calibri"/>
-              </a:rPr>
-              <a:t> factors match (0.635)</a:t>
-            </a:r>
-          </a:p>
-        </p:txBody>
-      </p:sp>
-      <p:sp>
-        <p:nvSpPr>
-          <p:cNvPr id="5" name="Example"/>
-          <p:cNvSpPr txBox="1"/>
-          <p:nvPr/>
-        </p:nvSpPr>
-        <p:spPr>
-          <a:xfrm>
-            <a:off x="5577840" y="1463040"/>
-            <a:ext cx="2926080" cy="2011680"/>
-          </a:xfrm>
-          <a:prstGeom prst="rect">
-            <a:avLst/>
-          </a:prstGeom>
-          <a:noFill/>
-        </p:spPr>
-        <p:txBody>
-          <a:bodyPr wrap="square" anchor="t" lIns="0" rIns="0" tIns="0" bIns="0">
-            <a:spAutoFit/>
-          </a:bodyPr>
-          <a:lstStyle/>
-          <a:p>
-            <a:pPr algn="l">
-              <a:spcAft>
-                <a:spcPts val="600"/>
-              </a:spcAft>
-            </a:pPr>
-            <a:r>
-              <a:rPr sz="1300" b="1" i="0">
-                <a:solidFill>
-                  <a:srgbClr val="C00000"/>
-                </a:solidFill>
-                <a:latin typeface="Calibri"/>
-              </a:rPr>
-              <a:t>LOCAL EXPLANATION: STUDENT S678287</a:t>
-            </a:r>
-          </a:p>
-          <a:p>
-            <a:pPr algn="l" marL="201168" indent="-201168">
-              <a:spcAft>
-                <a:spcPts val="600"/>
-              </a:spcAft>
-              <a:buClr>
-                <a:srgbClr val="1F3864"/>
-              </a:buClr>
-              <a:buFont typeface="Arial"/>
-              <a:buChar char="•"/>
-            </a:pPr>
-            <a:r>
-              <a:rPr sz="1600" b="0" i="0">
-                <a:solidFill>
-                  <a:srgbClr val="26262E"/>
-                </a:solidFill>
-                <a:latin typeface="Calibri"/>
-              </a:rPr>
-              <a:t>Predicted &gt;99.9% at risk</a:t>
-            </a:r>
-          </a:p>
-          <a:p>
-            <a:pPr algn="l" marL="201168" indent="-201168">
-              <a:spcAft>
-                <a:spcPts val="600"/>
-              </a:spcAft>
-              <a:buClr>
-                <a:srgbClr val="1F3864"/>
-              </a:buClr>
-              <a:buFont typeface="Arial"/>
-              <a:buChar char="•"/>
-            </a:pPr>
-            <a:r>
-              <a:rPr sz="1600" b="0" i="0">
-                <a:solidFill>
-                  <a:srgbClr val="26262E"/>
-                </a:solidFill>
-                <a:latin typeface="Calibri"/>
-              </a:rPr>
-              <a:t>Submitted almost no assessments: the biggest push (SHAP +5.30)</a:t>
-            </a:r>
-          </a:p>
-          <a:p>
-            <a:pPr algn="l" marL="201168" indent="-201168">
-              <a:spcAft>
-                <a:spcPts val="600"/>
-              </a:spcAft>
-              <a:buClr>
-                <a:srgbClr val="1F3864"/>
-              </a:buClr>
-              <a:buFont typeface="Arial"/>
-              <a:buChar char="•"/>
-            </a:pPr>
-            <a:r>
-              <a:rPr sz="1600" b="0" i="0">
-                <a:solidFill>
-                  <a:srgbClr val="26262E"/>
-                </a:solidFill>
-                <a:latin typeface="Calibri"/>
-              </a:rPr>
-              <a:t>LIME agrees on 4 of the top 5</a:t>
-            </a:r>
-          </a:p>
-        </p:txBody>
-      </p:sp>
-      <p:sp>
-        <p:nvSpPr>
-          <p:cNvPr id="6" name="Caution"/>
-          <p:cNvSpPr txBox="1"/>
-          <p:nvPr/>
-        </p:nvSpPr>
-        <p:spPr>
-          <a:xfrm>
-            <a:off x="5577840" y="3566160"/>
-            <a:ext cx="2926080" cy="2651760"/>
-          </a:xfrm>
-          <a:prstGeom prst="rect">
-            <a:avLst/>
-          </a:prstGeom>
-          <a:noFill/>
-        </p:spPr>
-        <p:txBody>
-          <a:bodyPr wrap="square" anchor="t" lIns="0" rIns="0" tIns="0" bIns="0">
-            <a:spAutoFit/>
-          </a:bodyPr>
-          <a:lstStyle/>
-          <a:p>
-            <a:pPr algn="l">
-              <a:spcAft>
-                <a:spcPts val="600"/>
-              </a:spcAft>
-            </a:pPr>
-            <a:r>
-              <a:rPr sz="1300" b="1" i="0">
-                <a:solidFill>
-                  <a:srgbClr val="C00000"/>
-                </a:solidFill>
-                <a:latin typeface="Calibri"/>
-              </a:rPr>
-              <a:t>INTERPRETIVE CAVEATS</a:t>
-            </a:r>
-          </a:p>
-          <a:p>
-            <a:pPr algn="l" marL="201168" indent="-201168">
-              <a:spcAft>
-                <a:spcPts val="600"/>
-              </a:spcAft>
-              <a:buClr>
-                <a:srgbClr val="1F3864"/>
-              </a:buClr>
-              <a:buFont typeface="Arial"/>
-              <a:buChar char="•"/>
-            </a:pPr>
-            <a:r>
-              <a:rPr sz="1600" b="0" i="0">
-                <a:solidFill>
-                  <a:srgbClr val="26262E"/>
-                </a:solidFill>
-                <a:latin typeface="Calibri"/>
-              </a:rPr>
-              <a:t>Shows how the model reasons, not why a student struggles</a:t>
-            </a:r>
-          </a:p>
-          <a:p>
-            <a:pPr algn="l" marL="201168" indent="-201168">
-              <a:spcAft>
-                <a:spcPts val="600"/>
-              </a:spcAft>
-              <a:buClr>
-                <a:srgbClr val="1F3864"/>
-              </a:buClr>
-              <a:buFont typeface="Arial"/>
-              <a:buChar char="•"/>
-            </a:pPr>
-            <a:r>
-              <a:rPr sz="1600" b="0" i="0">
-                <a:solidFill>
-                  <a:srgbClr val="26262E"/>
-                </a:solidFill>
-                <a:latin typeface="Calibri"/>
-              </a:rPr>
-              <a:t>One odd click result: two click measures move together (ρ = 0.98)</a:t>
-            </a:r>
-          </a:p>
-          <a:p>
-            <a:pPr algn="l" marL="201168" indent="-201168">
-              <a:spcAft>
-                <a:spcPts val="600"/>
-              </a:spcAft>
-              <a:buClr>
-                <a:srgbClr val="1F3864"/>
-              </a:buClr>
-              <a:buFont typeface="Arial"/>
-              <a:buChar char="•"/>
-            </a:pPr>
-            <a:r>
-              <a:rPr sz="1600" b="0" i="0">
-                <a:solidFill>
-                  <a:srgbClr val="26262E"/>
-                </a:solidFill>
-                <a:latin typeface="Calibri"/>
-              </a:rPr>
-              <a:t>The staff member still decides</a:t>
+              <a:t>Clicks 28 days before deadlines vs total clicks: ρ = 0.98 (collinearity)</a:t>
             </a:r>
           </a:p>
         </p:txBody>
@@ -9121,7 +8884,7 @@
                 </a:solidFill>
                 <a:latin typeface="Calibri"/>
               </a:rPr>
-              <a:t>Prototype: Role-Aware Dashboard in Moodle</a:t>
+              <a:t>The Role-Aware Dashboard in Moodle</a:t>
             </a:r>
           </a:p>
         </p:txBody>
@@ -9223,7 +8986,7 @@
                 </a:solidFill>
                 <a:latin typeface="Calibri"/>
               </a:rPr>
-              <a:t>caseload across modules, averaged reasoning</a:t>
+              <a:t>caseload across modules</a:t>
             </a:r>
           </a:p>
           <a:p>
@@ -9248,7 +9011,7 @@
                 </a:solidFill>
                 <a:latin typeface="Calibri"/>
               </a:rPr>
-              <a:t>whole institution, model performance and drivers</a:t>
+              <a:t>institution-level performance and drivers</a:t>
             </a:r>
           </a:p>
         </p:txBody>
@@ -9361,7 +9124,7 @@
                 </a:solidFill>
                 <a:latin typeface="Calibri"/>
               </a:rPr>
-              <a:t>Prediction and explanation in one working, LMS-integrated system</a:t>
+              <a:t>Prediction and explanation in one LMS-connected system</a:t>
             </a:r>
           </a:p>
           <a:p>
@@ -9382,7 +9145,7 @@
                 </a:solidFill>
                 <a:latin typeface="Calibri"/>
               </a:rPr>
-              <a:t>Explanations tailored to each staff role</a:t>
+              <a:t>Individual, caseload and institution-level views</a:t>
             </a:r>
           </a:p>
           <a:p>
@@ -9424,7 +9187,7 @@
                 </a:solidFill>
                 <a:latin typeface="Calibri"/>
               </a:rPr>
-              <a:t>Evidence on where SHAP and LIME agree and differ</a:t>
+              <a:t>Comparison of SHAP and LIME agreement</a:t>
             </a:r>
           </a:p>
         </p:txBody>
@@ -9484,7 +9247,7 @@
                 </a:solidFill>
                 <a:latin typeface="Calibri"/>
               </a:rPr>
-              <a:t>No practitioner study: trust, usability and decision quality untested</a:t>
+              <a:t>One dataset</a:t>
             </a:r>
           </a:p>
           <a:p>
@@ -9505,7 +9268,7 @@
                 </a:solidFill>
                 <a:latin typeface="Calibri"/>
               </a:rPr>
-              <a:t>Retrospective features, not early warning</a:t>
+              <a:t>Retrospective, not early-warning classification</a:t>
             </a:r>
           </a:p>
           <a:p>
@@ -9526,7 +9289,7 @@
                 </a:solidFill>
                 <a:latin typeface="Calibri"/>
               </a:rPr>
-              <a:t>One dataset (OULAD)</a:t>
+              <a:t>No practitioner study</a:t>
             </a:r>
           </a:p>
           <a:p>
@@ -9547,7 +9310,7 @@
                 </a:solidFill>
                 <a:latin typeface="Calibri"/>
               </a:rPr>
-              <a:t>Stability, fidelity, calibration and fairness checks not completed</a:t>
+              <a:t>Stability, fidelity, calibration and fairness not yet assessed</a:t>
             </a:r>
           </a:p>
         </p:txBody>
@@ -9614,7 +9377,7 @@
         <p:spPr>
           <a:xfrm>
             <a:off x="2286000" y="1463040"/>
-            <a:ext cx="3291840" cy="4754880"/>
+            <a:ext cx="3291840" cy="3291840"/>
           </a:xfrm>
           <a:prstGeom prst="rect">
             <a:avLst/>
@@ -9629,7 +9392,7 @@
           <a:p>
             <a:pPr algn="l">
               <a:spcAft>
-                <a:spcPts val="1200"/>
+                <a:spcPts val="1000"/>
               </a:spcAft>
             </a:pPr>
             <a:r>
@@ -9645,7 +9408,7 @@
           <a:p>
             <a:pPr algn="l" marL="201168" indent="-201168">
               <a:spcAft>
-                <a:spcPts val="1200"/>
+                <a:spcPts val="1000"/>
               </a:spcAft>
               <a:buClr>
                 <a:srgbClr val="1F3864"/>
@@ -9654,7 +9417,7 @@
               <a:buChar char="•"/>
             </a:pPr>
             <a:r>
-              <a:rPr sz="1700" b="1" i="0">
+              <a:rPr sz="1600" b="1" i="0">
                 <a:solidFill>
                   <a:srgbClr val="26262E"/>
                 </a:solidFill>
@@ -9663,19 +9426,19 @@
               <a:t>RQ1 </a:t>
             </a:r>
             <a:r>
-              <a:rPr sz="1700" b="0" i="0">
+              <a:rPr sz="1600" b="0" i="0">
                 <a:solidFill>
                   <a:srgbClr val="26262E"/>
                 </a:solidFill>
                 <a:latin typeface="Calibri"/>
               </a:rPr>
-              <a:t>SHAP and LIME integrated in a CommonKADS pipeline; agree on main drivers, partly differ per student</a:t>
+              <a:t>SHAP and LIME integrated; agree on the main driver, partly per student</a:t>
             </a:r>
           </a:p>
           <a:p>
             <a:pPr algn="l" marL="201168" indent="-201168">
               <a:spcAft>
-                <a:spcPts val="1200"/>
+                <a:spcPts val="1000"/>
               </a:spcAft>
               <a:buClr>
                 <a:srgbClr val="1F3864"/>
@@ -9684,7 +9447,7 @@
               <a:buChar char="•"/>
             </a:pPr>
             <a:r>
-              <a:rPr sz="1700" b="1" i="0">
+              <a:rPr sz="1600" b="1" i="0">
                 <a:solidFill>
                   <a:srgbClr val="26262E"/>
                 </a:solidFill>
@@ -9693,19 +9456,19 @@
               <a:t>RQ2 </a:t>
             </a:r>
             <a:r>
-              <a:rPr sz="1700" b="0" i="0">
+              <a:rPr sz="1600" b="0" i="0">
                 <a:solidFill>
                   <a:srgbClr val="26262E"/>
                 </a:solidFill>
                 <a:latin typeface="Calibri"/>
               </a:rPr>
-              <a:t>individual, caseload and cohort views, implemented in Moodle and Canvas</a:t>
+              <a:t>instructor, advisor and administrator views in Moodle and Canvas</a:t>
             </a:r>
           </a:p>
           <a:p>
             <a:pPr algn="l" marL="201168" indent="-201168">
               <a:spcAft>
-                <a:spcPts val="1200"/>
+                <a:spcPts val="1000"/>
               </a:spcAft>
               <a:buClr>
                 <a:srgbClr val="1F3864"/>
@@ -9714,7 +9477,7 @@
               <a:buChar char="•"/>
             </a:pPr>
             <a:r>
-              <a:rPr sz="1700" b="1" i="0">
+              <a:rPr sz="1600" b="1" i="0">
                 <a:solidFill>
                   <a:srgbClr val="26262E"/>
                 </a:solidFill>
@@ -9723,13 +9486,13 @@
               <a:t>RQ3 </a:t>
             </a:r>
             <a:r>
-              <a:rPr sz="1700" b="0" i="0">
+              <a:rPr sz="1600" b="0" i="0">
                 <a:solidFill>
                   <a:srgbClr val="26262E"/>
                 </a:solidFill>
                 <a:latin typeface="Calibri"/>
               </a:rPr>
-              <a:t>technical preconditions in place; practitioner value still to be shown</a:t>
+              <a:t>technical evidence established; practitioner use still open</a:t>
             </a:r>
           </a:p>
         </p:txBody>
@@ -9743,7 +9506,7 @@
         <p:spPr>
           <a:xfrm>
             <a:off x="5943600" y="1463040"/>
-            <a:ext cx="2560320" cy="4754880"/>
+            <a:ext cx="2560320" cy="3291840"/>
           </a:xfrm>
           <a:prstGeom prst="rect">
             <a:avLst/>
@@ -9758,7 +9521,7 @@
           <a:p>
             <a:pPr algn="l">
               <a:spcAft>
-                <a:spcPts val="1200"/>
+                <a:spcPts val="1000"/>
               </a:spcAft>
             </a:pPr>
             <a:r>
@@ -9774,7 +9537,7 @@
           <a:p>
             <a:pPr algn="l" marL="201168" indent="-201168">
               <a:spcAft>
-                <a:spcPts val="1200"/>
+                <a:spcPts val="1000"/>
               </a:spcAft>
               <a:buClr>
                 <a:srgbClr val="1F3864"/>
@@ -9783,19 +9546,19 @@
               <a:buChar char="•"/>
             </a:pPr>
             <a:r>
-              <a:rPr sz="1700" b="0" i="0">
+              <a:rPr sz="1600" b="0" i="0">
                 <a:solidFill>
                   <a:srgbClr val="26262E"/>
                 </a:solidFill>
                 <a:latin typeface="Calibri"/>
               </a:rPr>
-              <a:t>Early-warning evaluation (weeks 2, 4, 6, 8)</a:t>
+              <a:t>Early warning at weeks 2, 4, 6, 8</a:t>
             </a:r>
           </a:p>
           <a:p>
             <a:pPr algn="l" marL="201168" indent="-201168">
               <a:spcAft>
-                <a:spcPts val="1200"/>
+                <a:spcPts val="1000"/>
               </a:spcAft>
               <a:buClr>
                 <a:srgbClr val="1F3864"/>
@@ -9804,19 +9567,19 @@
               <a:buChar char="•"/>
             </a:pPr>
             <a:r>
-              <a:rPr sz="1700" b="0" i="0">
+              <a:rPr sz="1600" b="0" i="0">
                 <a:solidFill>
                   <a:srgbClr val="26262E"/>
                 </a:solidFill>
                 <a:latin typeface="Calibri"/>
               </a:rPr>
-              <a:t>Probability calibration</a:t>
+              <a:t>Calibration and subgroup fairness</a:t>
             </a:r>
           </a:p>
           <a:p>
             <a:pPr algn="l" marL="201168" indent="-201168">
               <a:spcAft>
-                <a:spcPts val="1200"/>
+                <a:spcPts val="1000"/>
               </a:spcAft>
               <a:buClr>
                 <a:srgbClr val="1F3864"/>
@@ -9825,34 +9588,52 @@
               <a:buChar char="•"/>
             </a:pPr>
             <a:r>
-              <a:rPr sz="1700" b="0" i="0">
+              <a:rPr sz="1600" b="0" i="0">
                 <a:solidFill>
                   <a:srgbClr val="26262E"/>
                 </a:solidFill>
                 <a:latin typeface="Calibri"/>
               </a:rPr>
-              <a:t>Fairness by subgroup</a:t>
-            </a:r>
-          </a:p>
-          <a:p>
-            <a:pPr algn="l" marL="201168" indent="-201168">
+              <a:t>Practitioner study (TAM)</a:t>
+            </a:r>
+          </a:p>
+        </p:txBody>
+      </p:sp>
+      <p:sp>
+        <p:nvSpPr>
+          <p:cNvPr id="5" name="Closing"/>
+          <p:cNvSpPr txBox="1"/>
+          <p:nvPr/>
+        </p:nvSpPr>
+        <p:spPr>
+          <a:xfrm>
+            <a:off x="2286000" y="5029200"/>
+            <a:ext cx="6217920" cy="1005840"/>
+          </a:xfrm>
+          <a:prstGeom prst="rect">
+            <a:avLst/>
+          </a:prstGeom>
+          <a:noFill/>
+        </p:spPr>
+        <p:txBody>
+          <a:bodyPr wrap="square" anchor="t" lIns="0" rIns="0" tIns="0" bIns="0">
+            <a:spAutoFit/>
+          </a:bodyPr>
+          <a:lstStyle/>
+          <a:p>
+            <a:pPr algn="l">
               <a:spcAft>
-                <a:spcPts val="1200"/>
+                <a:spcPts val="600"/>
               </a:spcAft>
-              <a:buClr>
-                <a:srgbClr val="1F3864"/>
-              </a:buClr>
-              <a:buFont typeface="Arial"/>
-              <a:buChar char="•"/>
             </a:pPr>
             <a:r>
-              <a:rPr sz="1700" b="0" i="0">
-                <a:solidFill>
-                  <a:srgbClr val="26262E"/>
-                </a:solidFill>
-                <a:latin typeface="Calibri"/>
-              </a:rPr>
-              <a:t>Practitioner study (TAM constructs)</a:t>
+              <a:rPr sz="1800" b="1" i="0">
+                <a:solidFill>
+                  <a:srgbClr val="1F3864"/>
+                </a:solidFill>
+                <a:latin typeface="Calibri"/>
+              </a:rPr>
+              <a:t>The goal is not only to predict risk, but to make predictions interpretable and accessible to the people who support students.</a:t>
             </a:r>
           </a:p>
         </p:txBody>
@@ -10209,7 +9990,7 @@
           <a:p>
             <a:pPr algn="l">
               <a:spcAft>
-                <a:spcPts val="1200"/>
+                <a:spcPts val="1400"/>
               </a:spcAft>
             </a:pPr>
             <a:r>
@@ -10228,13 +10009,13 @@
                 </a:solidFill>
                 <a:latin typeface="Calibri"/>
               </a:rPr>
-              <a:t>Background &amp; Problem Statement</a:t>
+              <a:t>The problem: prediction without explanation</a:t>
             </a:r>
           </a:p>
           <a:p>
             <a:pPr algn="l">
               <a:spcAft>
-                <a:spcPts val="1200"/>
+                <a:spcPts val="1400"/>
               </a:spcAft>
             </a:pPr>
             <a:r>
@@ -10253,13 +10034,13 @@
                 </a:solidFill>
                 <a:latin typeface="Calibri"/>
               </a:rPr>
-              <a:t>Aim, Objectives &amp; Research Questions</a:t>
+              <a:t>Aim, objectives and research questions</a:t>
             </a:r>
           </a:p>
           <a:p>
             <a:pPr algn="l">
               <a:spcAft>
-                <a:spcPts val="1200"/>
+                <a:spcPts val="1400"/>
               </a:spcAft>
             </a:pPr>
             <a:r>
@@ -10278,13 +10059,13 @@
                 </a:solidFill>
                 <a:latin typeface="Calibri"/>
               </a:rPr>
-              <a:t>Methodology: Knowledge Engineering</a:t>
+              <a:t>Methodology: knowledge engineering</a:t>
             </a:r>
           </a:p>
           <a:p>
             <a:pPr algn="l">
               <a:spcAft>
-                <a:spcPts val="1200"/>
+                <a:spcPts val="1400"/>
               </a:spcAft>
             </a:pPr>
             <a:r>
@@ -10303,13 +10084,13 @@
                 </a:solidFill>
                 <a:latin typeface="Calibri"/>
               </a:rPr>
-              <a:t>System Architecture &amp; Implementation</a:t>
+              <a:t>System architecture and implementation</a:t>
             </a:r>
           </a:p>
           <a:p>
             <a:pPr algn="l">
               <a:spcAft>
-                <a:spcPts val="1200"/>
+                <a:spcPts val="1400"/>
               </a:spcAft>
             </a:pPr>
             <a:r>
@@ -10328,13 +10109,13 @@
                 </a:solidFill>
                 <a:latin typeface="Calibri"/>
               </a:rPr>
-              <a:t>Dataset &amp; Evaluation Protocol</a:t>
+              <a:t>Evaluation: prediction and explainability</a:t>
             </a:r>
           </a:p>
           <a:p>
             <a:pPr algn="l">
               <a:spcAft>
-                <a:spcPts val="1200"/>
+                <a:spcPts val="1400"/>
               </a:spcAft>
             </a:pPr>
             <a:r>
@@ -10353,13 +10134,13 @@
                 </a:solidFill>
                 <a:latin typeface="Calibri"/>
               </a:rPr>
-              <a:t>Results: Prediction &amp; Explainability</a:t>
+              <a:t>Role-specific views in Moodle</a:t>
             </a:r>
           </a:p>
           <a:p>
             <a:pPr algn="l">
               <a:spcAft>
-                <a:spcPts val="1200"/>
+                <a:spcPts val="1400"/>
               </a:spcAft>
             </a:pPr>
             <a:r>
@@ -10378,32 +10159,7 @@
                 </a:solidFill>
                 <a:latin typeface="Calibri"/>
               </a:rPr>
-              <a:t>The Role-Aware Dashboard in Moodle</a:t>
-            </a:r>
-          </a:p>
-          <a:p>
-            <a:pPr algn="l">
-              <a:spcAft>
-                <a:spcPts val="1200"/>
-              </a:spcAft>
-            </a:pPr>
-            <a:r>
-              <a:rPr sz="2100" b="1" i="0">
-                <a:solidFill>
-                  <a:srgbClr val="C00000"/>
-                </a:solidFill>
-                <a:latin typeface="Calibri"/>
-              </a:rPr>
-              <a:t>8.  </a:t>
-            </a:r>
-            <a:r>
-              <a:rPr sz="2100" b="0" i="0">
-                <a:solidFill>
-                  <a:srgbClr val="26262E"/>
-                </a:solidFill>
-                <a:latin typeface="Calibri"/>
-              </a:rPr>
-              <a:t>Contributions, Limitations &amp; Conclusion</a:t>
+              <a:t>Contributions, limitations and conclusion</a:t>
             </a:r>
           </a:p>
         </p:txBody>
@@ -10463,14 +10219,14 @@
       </p:sp>
       <p:sp>
         <p:nvSpPr>
-          <p:cNvPr id="3" name="Context"/>
+          <p:cNvPr id="3" name="Key message"/>
           <p:cNvSpPr txBox="1"/>
           <p:nvPr/>
         </p:nvSpPr>
         <p:spPr>
           <a:xfrm>
-            <a:off x="2286000" y="1463040"/>
-            <a:ext cx="2926080" cy="1737360"/>
+            <a:off x="2286000" y="1371600"/>
+            <a:ext cx="6217920" cy="731520"/>
           </a:xfrm>
           <a:prstGeom prst="rect">
             <a:avLst/>
@@ -10489,13 +10245,52 @@
               </a:spcAft>
             </a:pPr>
             <a:r>
+              <a:rPr sz="1900" b="1" i="0">
+                <a:solidFill>
+                  <a:srgbClr val="1F3864"/>
+                </a:solidFill>
+                <a:latin typeface="Calibri"/>
+              </a:rPr>
+              <a:t>The challenge is not obtaining a prediction; it is what happens after it.</a:t>
+            </a:r>
+          </a:p>
+        </p:txBody>
+      </p:sp>
+      <p:sp>
+        <p:nvSpPr>
+          <p:cNvPr id="4" name="Problem"/>
+          <p:cNvSpPr txBox="1"/>
+          <p:nvPr/>
+        </p:nvSpPr>
+        <p:spPr>
+          <a:xfrm>
+            <a:off x="2286000" y="2240280"/>
+            <a:ext cx="2926080" cy="2011680"/>
+          </a:xfrm>
+          <a:prstGeom prst="rect">
+            <a:avLst/>
+          </a:prstGeom>
+          <a:noFill/>
+        </p:spPr>
+        <p:txBody>
+          <a:bodyPr wrap="square" anchor="t" lIns="0" rIns="0" tIns="0" bIns="0">
+            <a:spAutoFit/>
+          </a:bodyPr>
+          <a:lstStyle/>
+          <a:p>
+            <a:pPr algn="l">
+              <a:spcAft>
+                <a:spcPts val="600"/>
+              </a:spcAft>
+            </a:pPr>
+            <a:r>
               <a:rPr sz="1300" b="1" i="0">
                 <a:solidFill>
                   <a:srgbClr val="C00000"/>
                 </a:solidFill>
                 <a:latin typeface="Calibri"/>
               </a:rPr>
-              <a:t>CONTEXT</a:t>
+              <a:t>PROBLEM STATEMENT</a:t>
             </a:r>
           </a:p>
           <a:p>
@@ -10516,7 +10311,7 @@
                 </a:solidFill>
                 <a:latin typeface="Calibri"/>
               </a:rPr>
-              <a:t>LMS logs record how students engage</a:t>
+              <a:t>LMS data enable accurate at-risk prediction</a:t>
             </a:r>
           </a:p>
           <a:p>
@@ -10537,46 +10332,7 @@
                 </a:solidFill>
                 <a:latin typeface="Calibri"/>
               </a:rPr>
-              <a:t>Ensemble models already flag at-risk students accurately on OULAD</a:t>
-            </a:r>
-          </a:p>
-        </p:txBody>
-      </p:sp>
-      <p:sp>
-        <p:nvSpPr>
-          <p:cNvPr id="4" name="Problem"/>
-          <p:cNvSpPr txBox="1"/>
-          <p:nvPr/>
-        </p:nvSpPr>
-        <p:spPr>
-          <a:xfrm>
-            <a:off x="2286000" y="3246120"/>
-            <a:ext cx="2926080" cy="2194560"/>
-          </a:xfrm>
-          <a:prstGeom prst="rect">
-            <a:avLst/>
-          </a:prstGeom>
-          <a:noFill/>
-        </p:spPr>
-        <p:txBody>
-          <a:bodyPr wrap="square" anchor="t" lIns="0" rIns="0" tIns="0" bIns="0">
-            <a:spAutoFit/>
-          </a:bodyPr>
-          <a:lstStyle/>
-          <a:p>
-            <a:pPr algn="l">
-              <a:spcAft>
-                <a:spcPts val="600"/>
-              </a:spcAft>
-            </a:pPr>
-            <a:r>
-              <a:rPr sz="1300" b="1" i="0">
-                <a:solidFill>
-                  <a:srgbClr val="C00000"/>
-                </a:solidFill>
-                <a:latin typeface="Calibri"/>
-              </a:rPr>
-              <a:t>PROBLEM STATEMENT</a:t>
+              <a:t>Risk scores are delivered without explanation</a:t>
             </a:r>
           </a:p>
           <a:p>
@@ -10597,7 +10353,46 @@
                 </a:solidFill>
                 <a:latin typeface="Calibri"/>
               </a:rPr>
-              <a:t>Predictions arrive as scores, without reasons</a:t>
+              <a:t>SHAP and LIME are rarely built into dashboards</a:t>
+            </a:r>
+          </a:p>
+        </p:txBody>
+      </p:sp>
+      <p:sp>
+        <p:nvSpPr>
+          <p:cNvPr id="5" name="Needs"/>
+          <p:cNvSpPr txBox="1"/>
+          <p:nvPr/>
+        </p:nvSpPr>
+        <p:spPr>
+          <a:xfrm>
+            <a:off x="5577840" y="2240280"/>
+            <a:ext cx="2926080" cy="2011680"/>
+          </a:xfrm>
+          <a:prstGeom prst="rect">
+            <a:avLst/>
+          </a:prstGeom>
+          <a:noFill/>
+        </p:spPr>
+        <p:txBody>
+          <a:bodyPr wrap="square" anchor="t" lIns="0" rIns="0" tIns="0" bIns="0">
+            <a:spAutoFit/>
+          </a:bodyPr>
+          <a:lstStyle/>
+          <a:p>
+            <a:pPr algn="l">
+              <a:spcAft>
+                <a:spcPts val="600"/>
+              </a:spcAft>
+            </a:pPr>
+            <a:r>
+              <a:rPr sz="1300" b="1" i="0">
+                <a:solidFill>
+                  <a:srgbClr val="C00000"/>
+                </a:solidFill>
+                <a:latin typeface="Calibri"/>
+              </a:rPr>
+              <a:t>DISTINCT STAFF NEEDS</a:t>
             </a:r>
           </a:p>
           <a:p>
@@ -10612,13 +10407,22 @@
               <a:buChar char="•"/>
             </a:pPr>
             <a:r>
+              <a:rPr sz="1700" b="1" i="0">
+                <a:solidFill>
+                  <a:srgbClr val="26262E"/>
+                </a:solidFill>
+                <a:latin typeface="Calibri"/>
+              </a:rPr>
+              <a:t>Instructor: </a:t>
+            </a:r>
+            <a:r>
               <a:rPr sz="1700" b="0" i="0">
                 <a:solidFill>
                   <a:srgbClr val="26262E"/>
                 </a:solidFill>
                 <a:latin typeface="Calibri"/>
               </a:rPr>
-              <a:t>Instructors, advisors and administrators get the same view</a:t>
+              <a:t>individual students</a:t>
             </a:r>
           </a:p>
           <a:p>
@@ -10633,52 +10437,22 @@
               <a:buChar char="•"/>
             </a:pPr>
             <a:r>
+              <a:rPr sz="1700" b="1" i="0">
+                <a:solidFill>
+                  <a:srgbClr val="26262E"/>
+                </a:solidFill>
+                <a:latin typeface="Calibri"/>
+              </a:rPr>
+              <a:t>Advisor: </a:t>
+            </a:r>
+            <a:r>
               <a:rPr sz="1700" b="0" i="0">
                 <a:solidFill>
                   <a:srgbClr val="26262E"/>
                 </a:solidFill>
                 <a:latin typeface="Calibri"/>
               </a:rPr>
-              <a:t>SHAP and LIME are rarely built into working dashboards</a:t>
-            </a:r>
-          </a:p>
-        </p:txBody>
-      </p:sp>
-      <p:sp>
-        <p:nvSpPr>
-          <p:cNvPr id="5" name="Gap"/>
-          <p:cNvSpPr txBox="1"/>
-          <p:nvPr/>
-        </p:nvSpPr>
-        <p:spPr>
-          <a:xfrm>
-            <a:off x="5577840" y="1463040"/>
-            <a:ext cx="2926080" cy="2651760"/>
-          </a:xfrm>
-          <a:prstGeom prst="rect">
-            <a:avLst/>
-          </a:prstGeom>
-          <a:noFill/>
-        </p:spPr>
-        <p:txBody>
-          <a:bodyPr wrap="square" anchor="t" lIns="0" rIns="0" tIns="0" bIns="0">
-            <a:spAutoFit/>
-          </a:bodyPr>
-          <a:lstStyle/>
-          <a:p>
-            <a:pPr algn="l">
-              <a:spcAft>
-                <a:spcPts val="600"/>
-              </a:spcAft>
-            </a:pPr>
-            <a:r>
-              <a:rPr sz="1300" b="1" i="0">
-                <a:solidFill>
-                  <a:srgbClr val="C00000"/>
-                </a:solidFill>
-                <a:latin typeface="Calibri"/>
-              </a:rPr>
-              <a:t>RESEARCH GAP</a:t>
+              <a:t>caseload across modules</a:t>
             </a:r>
           </a:p>
           <a:p>
@@ -10693,13 +10467,61 @@
               <a:buChar char="•"/>
             </a:pPr>
             <a:r>
+              <a:rPr sz="1700" b="1" i="0">
+                <a:solidFill>
+                  <a:srgbClr val="26262E"/>
+                </a:solidFill>
+                <a:latin typeface="Calibri"/>
+              </a:rPr>
+              <a:t>Administrator: </a:t>
+            </a:r>
+            <a:r>
               <a:rPr sz="1700" b="0" i="0">
                 <a:solidFill>
                   <a:srgbClr val="26262E"/>
                 </a:solidFill>
                 <a:latin typeface="Calibri"/>
               </a:rPr>
-              <a:t>No reviewed study serves all three staff roles from one prediction system with role-specific explanations</a:t>
+              <a:t>institution-wide picture</a:t>
+            </a:r>
+          </a:p>
+        </p:txBody>
+      </p:sp>
+      <p:sp>
+        <p:nvSpPr>
+          <p:cNvPr id="6" name="Gap"/>
+          <p:cNvSpPr txBox="1"/>
+          <p:nvPr/>
+        </p:nvSpPr>
+        <p:spPr>
+          <a:xfrm>
+            <a:off x="2286000" y="4526280"/>
+            <a:ext cx="6217920" cy="1463040"/>
+          </a:xfrm>
+          <a:prstGeom prst="rect">
+            <a:avLst/>
+          </a:prstGeom>
+          <a:noFill/>
+        </p:spPr>
+        <p:txBody>
+          <a:bodyPr wrap="square" anchor="t" lIns="0" rIns="0" tIns="0" bIns="0">
+            <a:spAutoFit/>
+          </a:bodyPr>
+          <a:lstStyle/>
+          <a:p>
+            <a:pPr algn="l">
+              <a:spcAft>
+                <a:spcPts val="600"/>
+              </a:spcAft>
+            </a:pPr>
+            <a:r>
+              <a:rPr sz="1300" b="1" i="0">
+                <a:solidFill>
+                  <a:srgbClr val="C00000"/>
+                </a:solidFill>
+                <a:latin typeface="Calibri"/>
+              </a:rPr>
+              <a:t>RESEARCH GAP</a:t>
             </a:r>
           </a:p>
           <a:p>
@@ -10720,94 +10542,7 @@
                 </a:solidFill>
                 <a:latin typeface="Calibri"/>
               </a:rPr>
-              <a:t>The only role-specific XAI dashboard found targets students (Afzaal et al., 2021)</a:t>
-            </a:r>
-          </a:p>
-        </p:txBody>
-      </p:sp>
-      <p:sp>
-        <p:nvSpPr>
-          <p:cNvPr id="6" name="Scale"/>
-          <p:cNvSpPr txBox="1"/>
-          <p:nvPr/>
-        </p:nvSpPr>
-        <p:spPr>
-          <a:xfrm>
-            <a:off x="5577840" y="3977639"/>
-            <a:ext cx="2926080" cy="2194560"/>
-          </a:xfrm>
-          <a:prstGeom prst="rect">
-            <a:avLst/>
-          </a:prstGeom>
-          <a:noFill/>
-        </p:spPr>
-        <p:txBody>
-          <a:bodyPr wrap="square" anchor="t" lIns="0" rIns="0" tIns="0" bIns="0">
-            <a:spAutoFit/>
-          </a:bodyPr>
-          <a:lstStyle/>
-          <a:p>
-            <a:pPr algn="l">
-              <a:spcAft>
-                <a:spcPts val="200"/>
-              </a:spcAft>
-            </a:pPr>
-            <a:r>
-              <a:rPr sz="3600" b="1" i="0">
-                <a:solidFill>
-                  <a:srgbClr val="1F3864"/>
-                </a:solidFill>
-                <a:latin typeface="Calibri"/>
-              </a:rPr>
-              <a:t>32,593</a:t>
-            </a:r>
-          </a:p>
-          <a:p>
-            <a:pPr algn="l">
-              <a:spcAft>
-                <a:spcPts val="200"/>
-              </a:spcAft>
-            </a:pPr>
-            <a:r>
-              <a:rPr sz="1400" b="0" i="0">
-                <a:solidFill>
-                  <a:srgbClr val="59595F"/>
-                </a:solidFill>
-                <a:latin typeface="Calibri"/>
-              </a:rPr>
-              <a:t>student records (OULAD)</a:t>
-            </a:r>
-          </a:p>
-          <a:p>
-            <a:pPr algn="l">
-              <a:spcAft>
-                <a:spcPts val="200"/>
-              </a:spcAft>
-            </a:pPr>
-            <a:r>
-              <a:rPr sz="3600" b="1" i="0">
-                <a:solidFill>
-                  <a:srgbClr val="1F3864"/>
-                </a:solidFill>
-                <a:latin typeface="Calibri"/>
-              </a:rPr>
-              <a:t>3 roles</a:t>
-            </a:r>
-          </a:p>
-          <a:p>
-            <a:pPr algn="l">
-              <a:spcAft>
-                <a:spcPts val="200"/>
-              </a:spcAft>
-            </a:pPr>
-            <a:r>
-              <a:rPr sz="1400" b="0" i="0">
-                <a:solidFill>
-                  <a:srgbClr val="59595F"/>
-                </a:solidFill>
-                <a:latin typeface="Calibri"/>
-              </a:rPr>
-              <a:t>instructor, advisor, administrator</a:t>
+              <a:t>No reviewed system serves all three roles from one prediction model with role-specific explanations (the only role-specific XAI dashboard found targets students: Afzaal et al., 2021)</a:t>
             </a:r>
           </a:p>
         </p:txBody>
@@ -10908,7 +10643,7 @@
                 </a:solidFill>
                 <a:latin typeface="Calibri"/>
               </a:rPr>
-              <a:t>investigate how a role-aware explainable AI dashboard can support at-risk student prediction in LMS environments, using OULAD</a:t>
+              <a:t>to investigate how a role-aware explainable AI dashboard can support at-risk student prediction in LMS environments, using OULAD</a:t>
             </a:r>
           </a:p>
         </p:txBody>
@@ -10922,7 +10657,7 @@
         <p:spPr>
           <a:xfrm>
             <a:off x="2286000" y="2331720"/>
-            <a:ext cx="2148840" cy="3931920"/>
+            <a:ext cx="2148840" cy="2743200"/>
           </a:xfrm>
           <a:prstGeom prst="rect">
             <a:avLst/>
@@ -10977,7 +10712,7 @@
                 </a:solidFill>
                 <a:latin typeface="Calibri"/>
               </a:rPr>
-              <a:t>Review predictors, ML models and XAI methods</a:t>
+              <a:t>Review the literature on risk prediction, ML and XAI</a:t>
             </a:r>
           </a:p>
           <a:p>
@@ -11007,7 +10742,7 @@
                 </a:solidFill>
                 <a:latin typeface="Calibri"/>
               </a:rPr>
-              <a:t>Build and evaluate an ensemble model on OULAD with SHAP and LIME</a:t>
+              <a:t>Build and evaluate an ensemble model with SHAP and LIME</a:t>
             </a:r>
           </a:p>
           <a:p>
@@ -11037,14 +10772,62 @@
                 </a:solidFill>
                 <a:latin typeface="Calibri"/>
               </a:rPr>
-              <a:t>Design, implement and technically evaluate a role-aware XAI dashboard</a:t>
-            </a:r>
-          </a:p>
-        </p:txBody>
-      </p:sp>
-      <p:sp>
-        <p:nvSpPr>
-          <p:cNvPr id="5" name="Research questions"/>
+              <a:t>Design, implement and technically evaluate a role-aware dashboard</a:t>
+            </a:r>
+          </a:p>
+        </p:txBody>
+      </p:sp>
+      <p:sp>
+        <p:nvSpPr>
+          <p:cNvPr id="5" name="Scope note"/>
+          <p:cNvSpPr txBox="1"/>
+          <p:nvPr/>
+        </p:nvSpPr>
+        <p:spPr>
+          <a:xfrm>
+            <a:off x="2286000" y="5166360"/>
+            <a:ext cx="2148840" cy="1005840"/>
+          </a:xfrm>
+          <a:prstGeom prst="rect">
+            <a:avLst/>
+          </a:prstGeom>
+          <a:noFill/>
+        </p:spPr>
+        <p:txBody>
+          <a:bodyPr wrap="square" anchor="t" lIns="0" rIns="0" tIns="0" bIns="0">
+            <a:spAutoFit/>
+          </a:bodyPr>
+          <a:lstStyle/>
+          <a:p>
+            <a:pPr algn="l">
+              <a:spcAft>
+                <a:spcPts val="600"/>
+              </a:spcAft>
+            </a:pPr>
+            <a:r>
+              <a:rPr sz="1400" b="1" i="0">
+                <a:solidFill>
+                  <a:srgbClr val="C00000"/>
+                </a:solidFill>
+                <a:latin typeface="Calibri"/>
+              </a:rPr>
+              <a:t>Scope: </a:t>
+            </a:r>
+            <a:r>
+              <a:rPr sz="1400" b="0" i="0">
+                <a:solidFill>
+                  <a:srgbClr val="26262E"/>
+                </a:solidFill>
+                <a:latin typeface="Calibri"/>
+              </a:rPr>
+              <a:t>technical evaluation only; no practitioner study</a:t>
+            </a:r>
+          </a:p>
+        </p:txBody>
+      </p:sp>
+      <p:sp>
+        <p:nvSpPr>
+          <p:cNvPr id="6" name="Research questions"/>
           <p:cNvSpPr txBox="1"/>
           <p:nvPr/>
         </p:nvSpPr>
@@ -11226,14 +11009,53 @@
       </p:sp>
       <p:sp>
         <p:nvSpPr>
-          <p:cNvPr id="3" name="CommonKADS"/>
+          <p:cNvPr id="3" name="Key message"/>
           <p:cNvSpPr txBox="1"/>
           <p:nvPr/>
         </p:nvSpPr>
         <p:spPr>
           <a:xfrm>
-            <a:off x="2286000" y="1463040"/>
-            <a:ext cx="2926080" cy="2926080"/>
+            <a:off x="2286000" y="1371600"/>
+            <a:ext cx="6217920" cy="731520"/>
+          </a:xfrm>
+          <a:prstGeom prst="rect">
+            <a:avLst/>
+          </a:prstGeom>
+          <a:noFill/>
+        </p:spPr>
+        <p:txBody>
+          <a:bodyPr wrap="square" anchor="t" lIns="0" rIns="0" tIns="0" bIns="0">
+            <a:spAutoFit/>
+          </a:bodyPr>
+          <a:lstStyle/>
+          <a:p>
+            <a:pPr algn="l">
+              <a:spcAft>
+                <a:spcPts val="600"/>
+              </a:spcAft>
+            </a:pPr>
+            <a:r>
+              <a:rPr sz="1900" b="1" i="0">
+                <a:solidFill>
+                  <a:srgbClr val="1F3864"/>
+                </a:solidFill>
+                <a:latin typeface="Calibri"/>
+              </a:rPr>
+              <a:t>Representing the knowledge behind each prediction, and communicating it to each role.</a:t>
+            </a:r>
+          </a:p>
+        </p:txBody>
+      </p:sp>
+      <p:sp>
+        <p:nvSpPr>
+          <p:cNvPr id="4" name="CommonKADS"/>
+          <p:cNvSpPr txBox="1"/>
+          <p:nvPr/>
+        </p:nvSpPr>
+        <p:spPr>
+          <a:xfrm>
+            <a:off x="2286000" y="2240280"/>
+            <a:ext cx="2926080" cy="2194560"/>
           </a:xfrm>
           <a:prstGeom prst="rect">
             <a:avLst/>
@@ -11279,7 +11101,7 @@
                 </a:solidFill>
                 <a:latin typeface="Calibri"/>
               </a:rPr>
-              <a:t>CommonKADS: </a:t>
+              <a:t>CommonKADS </a:t>
             </a:r>
             <a:r>
               <a:rPr sz="1700" b="0" i="0">
@@ -11288,7 +11110,7 @@
                 </a:solidFill>
                 <a:latin typeface="Calibri"/>
               </a:rPr>
-              <a:t>knowledge engineering methodology (Schreiber et al., 2000)</a:t>
+              <a:t>(Schreiber et al., 2000)</a:t>
             </a:r>
           </a:p>
           <a:p>
@@ -11309,7 +11131,185 @@
                 </a:solidFill>
                 <a:latin typeface="Calibri"/>
               </a:rPr>
-              <a:t>Helps decide which role needs what knowledge, in what form</a:t>
+              <a:t>Six models: organisation, task, agent, knowledge, communication, design</a:t>
+            </a:r>
+          </a:p>
+        </p:txBody>
+      </p:sp>
+      <p:sp>
+        <p:nvSpPr>
+          <p:cNvPr id="5" name="Phases"/>
+          <p:cNvSpPr txBox="1"/>
+          <p:nvPr/>
+        </p:nvSpPr>
+        <p:spPr>
+          <a:xfrm>
+            <a:off x="5577840" y="2240280"/>
+            <a:ext cx="2926080" cy="2377440"/>
+          </a:xfrm>
+          <a:prstGeom prst="rect">
+            <a:avLst/>
+          </a:prstGeom>
+          <a:noFill/>
+        </p:spPr>
+        <p:txBody>
+          <a:bodyPr wrap="square" anchor="t" lIns="0" rIns="0" tIns="0" bIns="0">
+            <a:spAutoFit/>
+          </a:bodyPr>
+          <a:lstStyle/>
+          <a:p>
+            <a:pPr algn="l">
+              <a:spcAft>
+                <a:spcPts val="800"/>
+              </a:spcAft>
+            </a:pPr>
+            <a:r>
+              <a:rPr sz="1300" b="1" i="0">
+                <a:solidFill>
+                  <a:srgbClr val="C00000"/>
+                </a:solidFill>
+                <a:latin typeface="Calibri"/>
+              </a:rPr>
+              <a:t>RESEARCH PHASES</a:t>
+            </a:r>
+          </a:p>
+          <a:p>
+            <a:pPr algn="l">
+              <a:spcAft>
+                <a:spcPts val="800"/>
+              </a:spcAft>
+            </a:pPr>
+            <a:r>
+              <a:rPr sz="1600" b="1" i="0">
+                <a:solidFill>
+                  <a:srgbClr val="C00000"/>
+                </a:solidFill>
+                <a:latin typeface="Calibri"/>
+              </a:rPr>
+              <a:t>1.  </a:t>
+            </a:r>
+            <a:r>
+              <a:rPr sz="1600" b="0" i="0">
+                <a:solidFill>
+                  <a:srgbClr val="26262E"/>
+                </a:solidFill>
+                <a:latin typeface="Calibri"/>
+              </a:rPr>
+              <a:t>Knowledge acquisition and organisational analysis</a:t>
+            </a:r>
+          </a:p>
+          <a:p>
+            <a:pPr algn="l">
+              <a:spcAft>
+                <a:spcPts val="800"/>
+              </a:spcAft>
+            </a:pPr>
+            <a:r>
+              <a:rPr sz="1600" b="1" i="0">
+                <a:solidFill>
+                  <a:srgbClr val="C00000"/>
+                </a:solidFill>
+                <a:latin typeface="Calibri"/>
+              </a:rPr>
+              <a:t>2.  </a:t>
+            </a:r>
+            <a:r>
+              <a:rPr sz="1600" b="0" i="0">
+                <a:solidFill>
+                  <a:srgbClr val="26262E"/>
+                </a:solidFill>
+                <a:latin typeface="Calibri"/>
+              </a:rPr>
+              <a:t>Knowledge and system modelling</a:t>
+            </a:r>
+          </a:p>
+          <a:p>
+            <a:pPr algn="l">
+              <a:spcAft>
+                <a:spcPts val="800"/>
+              </a:spcAft>
+            </a:pPr>
+            <a:r>
+              <a:rPr sz="1600" b="1" i="0">
+                <a:solidFill>
+                  <a:srgbClr val="C00000"/>
+                </a:solidFill>
+                <a:latin typeface="Calibri"/>
+              </a:rPr>
+              <a:t>3.  </a:t>
+            </a:r>
+            <a:r>
+              <a:rPr sz="1600" b="0" i="0">
+                <a:solidFill>
+                  <a:srgbClr val="26262E"/>
+                </a:solidFill>
+                <a:latin typeface="Calibri"/>
+              </a:rPr>
+              <a:t>Artefact design and development</a:t>
+            </a:r>
+          </a:p>
+          <a:p>
+            <a:pPr algn="l">
+              <a:spcAft>
+                <a:spcPts val="800"/>
+              </a:spcAft>
+            </a:pPr>
+            <a:r>
+              <a:rPr sz="1600" b="1" i="0">
+                <a:solidFill>
+                  <a:srgbClr val="C00000"/>
+                </a:solidFill>
+                <a:latin typeface="Calibri"/>
+              </a:rPr>
+              <a:t>4.  </a:t>
+            </a:r>
+            <a:r>
+              <a:rPr sz="1600" b="0" i="0">
+                <a:solidFill>
+                  <a:srgbClr val="26262E"/>
+                </a:solidFill>
+                <a:latin typeface="Calibri"/>
+              </a:rPr>
+              <a:t>Technical evaluation</a:t>
+            </a:r>
+          </a:p>
+        </p:txBody>
+      </p:sp>
+      <p:sp>
+        <p:nvSpPr>
+          <p:cNvPr id="6" name="Supporting"/>
+          <p:cNvSpPr txBox="1"/>
+          <p:nvPr/>
+        </p:nvSpPr>
+        <p:spPr>
+          <a:xfrm>
+            <a:off x="2286000" y="4709160"/>
+            <a:ext cx="2926080" cy="1463040"/>
+          </a:xfrm>
+          <a:prstGeom prst="rect">
+            <a:avLst/>
+          </a:prstGeom>
+          <a:noFill/>
+        </p:spPr>
+        <p:txBody>
+          <a:bodyPr wrap="square" anchor="t" lIns="0" rIns="0" tIns="0" bIns="0">
+            <a:spAutoFit/>
+          </a:bodyPr>
+          <a:lstStyle/>
+          <a:p>
+            <a:pPr algn="l">
+              <a:spcAft>
+                <a:spcPts val="600"/>
+              </a:spcAft>
+            </a:pPr>
+            <a:r>
+              <a:rPr sz="1300" b="1" i="0">
+                <a:solidFill>
+                  <a:srgbClr val="C00000"/>
+                </a:solidFill>
+                <a:latin typeface="Calibri"/>
+              </a:rPr>
+              <a:t>SUPPORTING FRAMEWORKS</a:t>
             </a:r>
           </a:p>
           <a:p>
@@ -11324,52 +11324,22 @@
               <a:buChar char="•"/>
             </a:pPr>
             <a:r>
-              <a:rPr sz="1700" b="0" i="0">
+              <a:rPr sz="1600" b="1" i="0">
                 <a:solidFill>
                   <a:srgbClr val="26262E"/>
                 </a:solidFill>
                 <a:latin typeface="Calibri"/>
               </a:rPr>
-              <a:t>Six models: Organisation, Task, Agent, Knowledge, Communication, Design</a:t>
-            </a:r>
-          </a:p>
-        </p:txBody>
-      </p:sp>
-      <p:sp>
-        <p:nvSpPr>
-          <p:cNvPr id="4" name="Supporting"/>
-          <p:cNvSpPr txBox="1"/>
-          <p:nvPr/>
-        </p:nvSpPr>
-        <p:spPr>
-          <a:xfrm>
-            <a:off x="2286000" y="4480560"/>
-            <a:ext cx="2926080" cy="1645920"/>
-          </a:xfrm>
-          <a:prstGeom prst="rect">
-            <a:avLst/>
-          </a:prstGeom>
-          <a:noFill/>
-        </p:spPr>
-        <p:txBody>
-          <a:bodyPr wrap="square" anchor="t" lIns="0" rIns="0" tIns="0" bIns="0">
-            <a:spAutoFit/>
-          </a:bodyPr>
-          <a:lstStyle/>
-          <a:p>
-            <a:pPr algn="l">
-              <a:spcAft>
-                <a:spcPts val="600"/>
-              </a:spcAft>
-            </a:pPr>
-            <a:r>
-              <a:rPr sz="1300" b="1" i="0">
-                <a:solidFill>
-                  <a:srgbClr val="C00000"/>
-                </a:solidFill>
-                <a:latin typeface="Calibri"/>
-              </a:rPr>
-              <a:t>SUPPORTING FRAMEWORKS</a:t>
+              <a:t>DSRM: </a:t>
+            </a:r>
+            <a:r>
+              <a:rPr sz="1600" b="0" i="0">
+                <a:solidFill>
+                  <a:srgbClr val="26262E"/>
+                </a:solidFill>
+                <a:latin typeface="Calibri"/>
+              </a:rPr>
+              <a:t>research process</a:t>
             </a:r>
           </a:p>
           <a:p>
@@ -11384,22 +11354,61 @@
               <a:buChar char="•"/>
             </a:pPr>
             <a:r>
-              <a:rPr sz="1700" b="1" i="0">
+              <a:rPr sz="1600" b="1" i="0">
                 <a:solidFill>
                   <a:srgbClr val="26262E"/>
                 </a:solidFill>
                 <a:latin typeface="Calibri"/>
               </a:rPr>
-              <a:t>DSRM </a:t>
-            </a:r>
-            <a:r>
-              <a:rPr sz="1700" b="0" i="0">
+              <a:t>TAM: </a:t>
+            </a:r>
+            <a:r>
+              <a:rPr sz="1600" b="0" i="0">
                 <a:solidFill>
                   <a:srgbClr val="26262E"/>
                 </a:solidFill>
                 <a:latin typeface="Calibri"/>
               </a:rPr>
-              <a:t>(Peffers et al., 2007): steps for building and testing the system</a:t>
+              <a:t>design lens; not tested</a:t>
+            </a:r>
+          </a:p>
+        </p:txBody>
+      </p:sp>
+      <p:sp>
+        <p:nvSpPr>
+          <p:cNvPr id="7" name="Scope"/>
+          <p:cNvSpPr txBox="1"/>
+          <p:nvPr/>
+        </p:nvSpPr>
+        <p:spPr>
+          <a:xfrm>
+            <a:off x="5577840" y="4709160"/>
+            <a:ext cx="2926080" cy="1463040"/>
+          </a:xfrm>
+          <a:prstGeom prst="rect">
+            <a:avLst/>
+          </a:prstGeom>
+          <a:noFill/>
+        </p:spPr>
+        <p:txBody>
+          <a:bodyPr wrap="square" anchor="t" lIns="0" rIns="0" tIns="0" bIns="0">
+            <a:spAutoFit/>
+          </a:bodyPr>
+          <a:lstStyle/>
+          <a:p>
+            <a:pPr algn="l">
+              <a:spcAft>
+                <a:spcPts val="600"/>
+              </a:spcAft>
+            </a:pPr>
+            <a:r>
+              <a:rPr sz="1300" b="1" i="0">
+                <a:solidFill>
+                  <a:srgbClr val="C00000"/>
+                </a:solidFill>
+                <a:latin typeface="Calibri"/>
+              </a:rPr>
+              <a:t>SCOPE</a:t>
             </a:r>
           </a:p>
           <a:p>
@@ -11414,242 +11423,13 @@
               <a:buChar char="•"/>
             </a:pPr>
             <a:r>
-              <a:rPr sz="1700" b="1" i="0">
+              <a:rPr sz="1600" b="0" i="0">
                 <a:solidFill>
                   <a:srgbClr val="26262E"/>
                 </a:solidFill>
                 <a:latin typeface="Calibri"/>
               </a:rPr>
-              <a:t>TAM </a:t>
-            </a:r>
-            <a:r>
-              <a:rPr sz="1700" b="0" i="0">
-                <a:solidFill>
-                  <a:srgbClr val="26262E"/>
-                </a:solidFill>
-                <a:latin typeface="Calibri"/>
-              </a:rPr>
-              <a:t>(Davis, 1989): design guide only, not measured</a:t>
-            </a:r>
-          </a:p>
-        </p:txBody>
-      </p:sp>
-      <p:sp>
-        <p:nvSpPr>
-          <p:cNvPr id="5" name="Phases"/>
-          <p:cNvSpPr txBox="1"/>
-          <p:nvPr/>
-        </p:nvSpPr>
-        <p:spPr>
-          <a:xfrm>
-            <a:off x="5577840" y="1463040"/>
-            <a:ext cx="2926080" cy="2651760"/>
-          </a:xfrm>
-          <a:prstGeom prst="rect">
-            <a:avLst/>
-          </a:prstGeom>
-          <a:noFill/>
-        </p:spPr>
-        <p:txBody>
-          <a:bodyPr wrap="square" anchor="t" lIns="0" rIns="0" tIns="0" bIns="0">
-            <a:spAutoFit/>
-          </a:bodyPr>
-          <a:lstStyle/>
-          <a:p>
-            <a:pPr algn="l">
-              <a:spcAft>
-                <a:spcPts val="1000"/>
-              </a:spcAft>
-            </a:pPr>
-            <a:r>
-              <a:rPr sz="1300" b="1" i="0">
-                <a:solidFill>
-                  <a:srgbClr val="C00000"/>
-                </a:solidFill>
-                <a:latin typeface="Calibri"/>
-              </a:rPr>
-              <a:t>RESEARCH PHASES</a:t>
-            </a:r>
-          </a:p>
-          <a:p>
-            <a:pPr algn="l">
-              <a:spcAft>
-                <a:spcPts val="1000"/>
-              </a:spcAft>
-            </a:pPr>
-            <a:r>
-              <a:rPr sz="1700" b="1" i="0">
-                <a:solidFill>
-                  <a:srgbClr val="C00000"/>
-                </a:solidFill>
-                <a:latin typeface="Calibri"/>
-              </a:rPr>
-              <a:t>1.  </a:t>
-            </a:r>
-            <a:r>
-              <a:rPr sz="1700" b="0" i="0">
-                <a:solidFill>
-                  <a:srgbClr val="26262E"/>
-                </a:solidFill>
-                <a:latin typeface="Calibri"/>
-              </a:rPr>
-              <a:t>Gather knowledge from the literature</a:t>
-            </a:r>
-          </a:p>
-          <a:p>
-            <a:pPr algn="l">
-              <a:spcAft>
-                <a:spcPts val="1000"/>
-              </a:spcAft>
-            </a:pPr>
-            <a:r>
-              <a:rPr sz="1700" b="1" i="0">
-                <a:solidFill>
-                  <a:srgbClr val="C00000"/>
-                </a:solidFill>
-                <a:latin typeface="Calibri"/>
-              </a:rPr>
-              <a:t>2.  </a:t>
-            </a:r>
-            <a:r>
-              <a:rPr sz="1700" b="0" i="0">
-                <a:solidFill>
-                  <a:srgbClr val="26262E"/>
-                </a:solidFill>
-                <a:latin typeface="Calibri"/>
-              </a:rPr>
-              <a:t>Model it with CommonKADS</a:t>
-            </a:r>
-          </a:p>
-          <a:p>
-            <a:pPr algn="l">
-              <a:spcAft>
-                <a:spcPts val="1000"/>
-              </a:spcAft>
-            </a:pPr>
-            <a:r>
-              <a:rPr sz="1700" b="1" i="0">
-                <a:solidFill>
-                  <a:srgbClr val="C00000"/>
-                </a:solidFill>
-                <a:latin typeface="Calibri"/>
-              </a:rPr>
-              <a:t>3.  </a:t>
-            </a:r>
-            <a:r>
-              <a:rPr sz="1700" b="0" i="0">
-                <a:solidFill>
-                  <a:srgbClr val="26262E"/>
-                </a:solidFill>
-                <a:latin typeface="Calibri"/>
-              </a:rPr>
-              <a:t>Build the system</a:t>
-            </a:r>
-          </a:p>
-          <a:p>
-            <a:pPr algn="l">
-              <a:spcAft>
-                <a:spcPts val="1000"/>
-              </a:spcAft>
-            </a:pPr>
-            <a:r>
-              <a:rPr sz="1700" b="1" i="0">
-                <a:solidFill>
-                  <a:srgbClr val="C00000"/>
-                </a:solidFill>
-                <a:latin typeface="Calibri"/>
-              </a:rPr>
-              <a:t>4.  </a:t>
-            </a:r>
-            <a:r>
-              <a:rPr sz="1700" b="0" i="0">
-                <a:solidFill>
-                  <a:srgbClr val="26262E"/>
-                </a:solidFill>
-                <a:latin typeface="Calibri"/>
-              </a:rPr>
-              <a:t>Test it on OULAD data</a:t>
-            </a:r>
-          </a:p>
-        </p:txBody>
-      </p:sp>
-      <p:sp>
-        <p:nvSpPr>
-          <p:cNvPr id="6" name="Scope"/>
-          <p:cNvSpPr txBox="1"/>
-          <p:nvPr/>
-        </p:nvSpPr>
-        <p:spPr>
-          <a:xfrm>
-            <a:off x="5577840" y="4480560"/>
-            <a:ext cx="2926080" cy="1645920"/>
-          </a:xfrm>
-          <a:prstGeom prst="rect">
-            <a:avLst/>
-          </a:prstGeom>
-          <a:noFill/>
-        </p:spPr>
-        <p:txBody>
-          <a:bodyPr wrap="square" anchor="t" lIns="0" rIns="0" tIns="0" bIns="0">
-            <a:spAutoFit/>
-          </a:bodyPr>
-          <a:lstStyle/>
-          <a:p>
-            <a:pPr algn="l">
-              <a:spcAft>
-                <a:spcPts val="600"/>
-              </a:spcAft>
-            </a:pPr>
-            <a:r>
-              <a:rPr sz="1300" b="1" i="0">
-                <a:solidFill>
-                  <a:srgbClr val="C00000"/>
-                </a:solidFill>
-                <a:latin typeface="Calibri"/>
-              </a:rPr>
-              <a:t>SCOPE AND DELIMITATIONS</a:t>
-            </a:r>
-          </a:p>
-          <a:p>
-            <a:pPr algn="l" marL="201168" indent="-201168">
-              <a:spcAft>
-                <a:spcPts val="600"/>
-              </a:spcAft>
-              <a:buClr>
-                <a:srgbClr val="1F3864"/>
-              </a:buClr>
-              <a:buFont typeface="Arial"/>
-              <a:buChar char="•"/>
-            </a:pPr>
-            <a:r>
-              <a:rPr sz="1700" b="0" i="0">
-                <a:solidFill>
-                  <a:srgbClr val="26262E"/>
-                </a:solidFill>
-                <a:latin typeface="Calibri"/>
-              </a:rPr>
-              <a:t>No interviews or user study</a:t>
-            </a:r>
-          </a:p>
-          <a:p>
-            <a:pPr algn="l" marL="201168" indent="-201168">
-              <a:spcAft>
-                <a:spcPts val="600"/>
-              </a:spcAft>
-              <a:buClr>
-                <a:srgbClr val="1F3864"/>
-              </a:buClr>
-              <a:buFont typeface="Arial"/>
-              <a:buChar char="•"/>
-            </a:pPr>
-            <a:r>
-              <a:rPr sz="1700" b="0" i="0">
-                <a:solidFill>
-                  <a:srgbClr val="26262E"/>
-                </a:solidFill>
-                <a:latin typeface="Calibri"/>
-              </a:rPr>
-              <a:t>So usability and trust are not measured</a:t>
+              <a:t>Requirements derived from literature, not user research</a:t>
             </a:r>
           </a:p>
         </p:txBody>
@@ -11709,13 +11489,52 @@
       </p:sp>
       <p:sp>
         <p:nvSpPr>
-          <p:cNvPr id="3" name="Flow 1"/>
+          <p:cNvPr id="3" name="Key message"/>
           <p:cNvSpPr txBox="1"/>
           <p:nvPr/>
         </p:nvSpPr>
         <p:spPr>
           <a:xfrm>
-            <a:off x="2286000" y="1463040"/>
+            <a:off x="2286000" y="1371600"/>
+            <a:ext cx="6217920" cy="731520"/>
+          </a:xfrm>
+          <a:prstGeom prst="rect">
+            <a:avLst/>
+          </a:prstGeom>
+          <a:noFill/>
+        </p:spPr>
+        <p:txBody>
+          <a:bodyPr wrap="square" anchor="t" lIns="0" rIns="0" tIns="0" bIns="0">
+            <a:spAutoFit/>
+          </a:bodyPr>
+          <a:lstStyle/>
+          <a:p>
+            <a:pPr algn="l">
+              <a:spcAft>
+                <a:spcPts val="600"/>
+              </a:spcAft>
+            </a:pPr>
+            <a:r>
+              <a:rPr sz="1900" b="1" i="0">
+                <a:solidFill>
+                  <a:srgbClr val="1F3864"/>
+                </a:solidFill>
+                <a:latin typeface="Calibri"/>
+              </a:rPr>
+              <a:t>One integrated system, not only a trained model.</a:t>
+            </a:r>
+          </a:p>
+        </p:txBody>
+      </p:sp>
+      <p:sp>
+        <p:nvSpPr>
+          <p:cNvPr id="4" name="Flow 1"/>
+          <p:cNvSpPr txBox="1"/>
+          <p:nvPr/>
+        </p:nvSpPr>
+        <p:spPr>
+          <a:xfrm>
+            <a:off x="2286000" y="2194560"/>
             <a:ext cx="877824" cy="868680"/>
           </a:xfrm>
           <a:prstGeom prst="rect">
@@ -11757,20 +11576,20 @@
                 </a:solidFill>
                 <a:latin typeface="Calibri"/>
               </a:rPr>
-              <a:t>feature engineering</a:t>
+              <a:t>OULAD features</a:t>
             </a:r>
           </a:p>
         </p:txBody>
       </p:sp>
       <p:cxnSp>
         <p:nvCxnSpPr>
-          <p:cNvPr id="4" name="Flow arrow 1"/>
+          <p:cNvPr id="5" name="Flow arrow 1"/>
           <p:cNvCxnSpPr/>
           <p:nvPr/>
         </p:nvCxnSpPr>
         <p:spPr>
           <a:xfrm>
-            <a:off x="3182112" y="1645920"/>
+            <a:off x="3182112" y="2377440"/>
             <a:ext cx="256032" cy="0"/>
           </a:xfrm>
           <a:prstGeom prst="line">
@@ -11800,13 +11619,13 @@
       </p:cxnSp>
       <p:sp>
         <p:nvSpPr>
-          <p:cNvPr id="5" name="Flow 2"/>
+          <p:cNvPr id="6" name="Flow 2"/>
           <p:cNvSpPr txBox="1"/>
           <p:nvPr/>
         </p:nvSpPr>
         <p:spPr>
           <a:xfrm>
-            <a:off x="3529584" y="1463040"/>
+            <a:off x="3529584" y="2194560"/>
             <a:ext cx="877824" cy="868680"/>
           </a:xfrm>
           <a:prstGeom prst="rect">
@@ -11848,20 +11667,20 @@
                 </a:solidFill>
                 <a:latin typeface="Calibri"/>
               </a:rPr>
-              <a:t>risk classification</a:t>
+              <a:t>XGBoost</a:t>
             </a:r>
           </a:p>
         </p:txBody>
       </p:sp>
       <p:cxnSp>
         <p:nvCxnSpPr>
-          <p:cNvPr id="6" name="Flow arrow 2"/>
+          <p:cNvPr id="7" name="Flow arrow 2"/>
           <p:cNvCxnSpPr/>
           <p:nvPr/>
         </p:nvCxnSpPr>
         <p:spPr>
           <a:xfrm>
-            <a:off x="4425696" y="1645920"/>
+            <a:off x="4425696" y="2377440"/>
             <a:ext cx="256032" cy="0"/>
           </a:xfrm>
           <a:prstGeom prst="line">
@@ -11891,13 +11710,13 @@
       </p:cxnSp>
       <p:sp>
         <p:nvSpPr>
-          <p:cNvPr id="7" name="Flow 3"/>
+          <p:cNvPr id="8" name="Flow 3"/>
           <p:cNvSpPr txBox="1"/>
           <p:nvPr/>
         </p:nvSpPr>
         <p:spPr>
           <a:xfrm>
-            <a:off x="4773168" y="1463040"/>
+            <a:off x="4773168" y="2194560"/>
             <a:ext cx="877824" cy="868680"/>
           </a:xfrm>
           <a:prstGeom prst="rect">
@@ -11939,20 +11758,20 @@
                 </a:solidFill>
                 <a:latin typeface="Calibri"/>
               </a:rPr>
-              <a:t>SHAP and LIME</a:t>
+              <a:t>TreeSHAP, LIME</a:t>
             </a:r>
           </a:p>
         </p:txBody>
       </p:sp>
       <p:cxnSp>
         <p:nvCxnSpPr>
-          <p:cNvPr id="8" name="Flow arrow 3"/>
+          <p:cNvPr id="9" name="Flow arrow 3"/>
           <p:cNvCxnSpPr/>
           <p:nvPr/>
         </p:nvCxnSpPr>
         <p:spPr>
           <a:xfrm>
-            <a:off x="5669280" y="1645920"/>
+            <a:off x="5669280" y="2377440"/>
             <a:ext cx="256032" cy="0"/>
           </a:xfrm>
           <a:prstGeom prst="line">
@@ -11982,13 +11801,13 @@
       </p:cxnSp>
       <p:sp>
         <p:nvSpPr>
-          <p:cNvPr id="9" name="Flow 4"/>
+          <p:cNvPr id="10" name="Flow 4"/>
           <p:cNvSpPr txBox="1"/>
           <p:nvPr/>
         </p:nvSpPr>
         <p:spPr>
           <a:xfrm>
-            <a:off x="6016752" y="1463040"/>
+            <a:off x="6016752" y="2194560"/>
             <a:ext cx="877824" cy="868680"/>
           </a:xfrm>
           <a:prstGeom prst="rect">
@@ -12030,20 +11849,20 @@
                 </a:solidFill>
                 <a:latin typeface="Calibri"/>
               </a:rPr>
-              <a:t>role-based access</a:t>
+              <a:t>Flask, JWT</a:t>
             </a:r>
           </a:p>
         </p:txBody>
       </p:sp>
       <p:cxnSp>
         <p:nvCxnSpPr>
-          <p:cNvPr id="10" name="Flow arrow 4"/>
+          <p:cNvPr id="11" name="Flow arrow 4"/>
           <p:cNvCxnSpPr/>
           <p:nvPr/>
         </p:nvCxnSpPr>
         <p:spPr>
           <a:xfrm>
-            <a:off x="6912864" y="1645920"/>
+            <a:off x="6912864" y="2377440"/>
             <a:ext cx="256032" cy="0"/>
           </a:xfrm>
           <a:prstGeom prst="line">
@@ -12073,13 +11892,13 @@
       </p:cxnSp>
       <p:sp>
         <p:nvSpPr>
-          <p:cNvPr id="11" name="Flow 5"/>
+          <p:cNvPr id="12" name="Flow 5"/>
           <p:cNvSpPr txBox="1"/>
           <p:nvPr/>
         </p:nvSpPr>
         <p:spPr>
           <a:xfrm>
-            <a:off x="7260336" y="1463040"/>
+            <a:off x="7260336" y="2194560"/>
             <a:ext cx="877824" cy="868680"/>
           </a:xfrm>
           <a:prstGeom prst="rect">
@@ -12121,21 +11940,21 @@
                 </a:solidFill>
                 <a:latin typeface="Calibri"/>
               </a:rPr>
-              <a:t>role-specific dashboards</a:t>
-            </a:r>
-          </a:p>
-        </p:txBody>
-      </p:sp>
-      <p:sp>
-        <p:nvSpPr>
-          <p:cNvPr id="12" name="How it works"/>
+              <a:t>React, 3 roles</a:t>
+            </a:r>
+          </a:p>
+        </p:txBody>
+      </p:sp>
+      <p:sp>
+        <p:nvSpPr>
+          <p:cNvPr id="13" name="How it works"/>
           <p:cNvSpPr txBox="1"/>
           <p:nvPr/>
         </p:nvSpPr>
         <p:spPr>
           <a:xfrm>
-            <a:off x="2286000" y="2651760"/>
-            <a:ext cx="6217920" cy="1645920"/>
+            <a:off x="2286000" y="3291840"/>
+            <a:ext cx="6217920" cy="1463040"/>
           </a:xfrm>
           <a:prstGeom prst="rect">
             <a:avLst/>
@@ -12190,7 +12009,7 @@
                 </a:solidFill>
                 <a:latin typeface="Calibri"/>
               </a:rPr>
-              <a:t>300 small decision trees, each correcting the last</a:t>
+              <a:t>300 trees, maximum depth 5</a:t>
             </a:r>
           </a:p>
           <a:p>
@@ -12220,7 +12039,7 @@
                 </a:solidFill>
                 <a:latin typeface="Calibri"/>
               </a:rPr>
-              <a:t>SHAP stored in advance; LIME runs when a student is clicked</a:t>
+              <a:t>global TreeSHAP cached; LIME generated on request</a:t>
             </a:r>
           </a:p>
           <a:p>
@@ -12241,7 +12060,7 @@
                 </a:solidFill>
                 <a:latin typeface="Calibri"/>
               </a:rPr>
-              <a:t>Login: </a:t>
+              <a:t>Access: </a:t>
             </a:r>
             <a:r>
               <a:rPr sz="1600" b="0" i="0">
@@ -12250,21 +12069,21 @@
                 </a:solidFill>
                 <a:latin typeface="Calibri"/>
               </a:rPr>
-              <a:t>each user sees only the view for their role</a:t>
-            </a:r>
-          </a:p>
-        </p:txBody>
-      </p:sp>
-      <p:sp>
-        <p:nvSpPr>
-          <p:cNvPr id="13" name="Where it runs"/>
+              <a:t>JWT authentication with role-based access control</a:t>
+            </a:r>
+          </a:p>
+        </p:txBody>
+      </p:sp>
+      <p:sp>
+        <p:nvSpPr>
+          <p:cNvPr id="14" name="LMS"/>
           <p:cNvSpPr txBox="1"/>
           <p:nvPr/>
         </p:nvSpPr>
         <p:spPr>
           <a:xfrm>
-            <a:off x="2286000" y="4434840"/>
-            <a:ext cx="6217920" cy="1737360"/>
+            <a:off x="2286000" y="4846320"/>
+            <a:ext cx="6217920" cy="1280160"/>
           </a:xfrm>
           <a:prstGeom prst="rect">
             <a:avLst/>
@@ -12289,7 +12108,7 @@
                 </a:solidFill>
                 <a:latin typeface="Calibri"/>
               </a:rPr>
-              <a:t>LMS INTEGRATION AND DEPLOYMENT</a:t>
+              <a:t>LMS INTEGRATION</a:t>
             </a:r>
           </a:p>
           <a:p>
@@ -12310,7 +12129,7 @@
                 </a:solidFill>
                 <a:latin typeface="Calibri"/>
               </a:rPr>
-              <a:t>Moodle 5.2: </a:t>
+              <a:t>Moodle: </a:t>
             </a:r>
             <a:r>
               <a:rPr sz="1600" b="0" i="0">
@@ -12319,7 +12138,7 @@
                 </a:solidFill>
                 <a:latin typeface="Calibri"/>
               </a:rPr>
-              <a:t>plugin inside each course, using Moodle login and roles</a:t>
+              <a:t>native plugin using existing login, roles and enrolments</a:t>
             </a:r>
           </a:p>
           <a:p>
@@ -12349,37 +12168,7 @@
                 </a:solidFill>
                 <a:latin typeface="Calibri"/>
               </a:rPr>
-              <a:t>dashboard embedded as a link item in the course</a:t>
-            </a:r>
-          </a:p>
-          <a:p>
-            <a:pPr algn="l" marL="201168" indent="-201168">
-              <a:spcAft>
-                <a:spcPts val="600"/>
-              </a:spcAft>
-              <a:buClr>
-                <a:srgbClr val="1F3864"/>
-              </a:buClr>
-              <a:buFont typeface="Arial"/>
-              <a:buChar char="•"/>
-            </a:pPr>
-            <a:r>
-              <a:rPr sz="1600" b="1" i="0">
-                <a:solidFill>
-                  <a:srgbClr val="26262E"/>
-                </a:solidFill>
-                <a:latin typeface="Calibri"/>
-              </a:rPr>
-              <a:t>Docker Compose: </a:t>
-            </a:r>
-            <a:r>
-              <a:rPr sz="1600" b="0" i="0">
-                <a:solidFill>
-                  <a:srgbClr val="26262E"/>
-                </a:solidFill>
-                <a:latin typeface="Calibri"/>
-              </a:rPr>
-              <a:t>all parts run together, so the setup can be repeated</a:t>
+              <a:t>embedded External URL module</a:t>
             </a:r>
           </a:p>
         </p:txBody>
@@ -12446,7 +12235,7 @@
         <p:spPr>
           <a:xfrm>
             <a:off x="2286000" y="1417320"/>
-            <a:ext cx="1981200" cy="1325880"/>
+            <a:ext cx="1463040" cy="1325880"/>
           </a:xfrm>
           <a:prstGeom prst="rect">
             <a:avLst/>
@@ -12465,7 +12254,7 @@
               </a:spcAft>
             </a:pPr>
             <a:r>
-              <a:rPr sz="3600" b="1" i="0">
+              <a:rPr sz="3200" b="1" i="0">
                 <a:solidFill>
                   <a:srgbClr val="1F3864"/>
                 </a:solidFill>
@@ -12487,9 +12276,32 @@
                 </a:solidFill>
                 <a:latin typeface="Calibri"/>
               </a:rPr>
-              <a:t>records: one student in</a:t>
-            </a:r>
-          </a:p>
+              <a:t>student records</a:t>
+            </a:r>
+          </a:p>
+        </p:txBody>
+      </p:sp>
+      <p:sp>
+        <p:nvSpPr>
+          <p:cNvPr id="4" name="Number 2"/>
+          <p:cNvSpPr txBox="1"/>
+          <p:nvPr/>
+        </p:nvSpPr>
+        <p:spPr>
+          <a:xfrm>
+            <a:off x="3840480" y="1417320"/>
+            <a:ext cx="1463040" cy="1325880"/>
+          </a:xfrm>
+          <a:prstGeom prst="rect">
+            <a:avLst/>
+          </a:prstGeom>
+          <a:noFill/>
+        </p:spPr>
+        <p:txBody>
+          <a:bodyPr wrap="square" anchor="t" lIns="0" rIns="0" tIns="0" bIns="0">
+            <a:spAutoFit/>
+          </a:bodyPr>
+          <a:lstStyle/>
           <a:p>
             <a:pPr algn="l">
               <a:spcAft>
@@ -12497,38 +12309,15 @@
               </a:spcAft>
             </a:pPr>
             <a:r>
-              <a:rPr sz="1300" b="0" i="0">
-                <a:solidFill>
-                  <a:srgbClr val="59595F"/>
-                </a:solidFill>
-                <a:latin typeface="Calibri"/>
-              </a:rPr>
-              <a:t>one course run</a:t>
-            </a:r>
-          </a:p>
-        </p:txBody>
-      </p:sp>
-      <p:sp>
-        <p:nvSpPr>
-          <p:cNvPr id="4" name="Number 2"/>
-          <p:cNvSpPr txBox="1"/>
-          <p:nvPr/>
-        </p:nvSpPr>
-        <p:spPr>
-          <a:xfrm>
-            <a:off x="4358640" y="1417320"/>
-            <a:ext cx="1981200" cy="1325880"/>
-          </a:xfrm>
-          <a:prstGeom prst="rect">
-            <a:avLst/>
-          </a:prstGeom>
-          <a:noFill/>
-        </p:spPr>
-        <p:txBody>
-          <a:bodyPr wrap="square" anchor="t" lIns="0" rIns="0" tIns="0" bIns="0">
-            <a:spAutoFit/>
-          </a:bodyPr>
-          <a:lstStyle/>
+              <a:rPr sz="3200" b="1" i="0">
+                <a:solidFill>
+                  <a:srgbClr val="1F3864"/>
+                </a:solidFill>
+                <a:latin typeface="Calibri"/>
+              </a:rPr>
+              <a:t>22</a:t>
+            </a:r>
+          </a:p>
           <a:p>
             <a:pPr algn="l">
               <a:spcAft>
@@ -12536,15 +12325,38 @@
               </a:spcAft>
             </a:pPr>
             <a:r>
-              <a:rPr sz="3600" b="1" i="0">
-                <a:solidFill>
-                  <a:srgbClr val="1F3864"/>
-                </a:solidFill>
-                <a:latin typeface="Calibri"/>
-              </a:rPr>
-              <a:t>22</a:t>
-            </a:r>
-          </a:p>
+              <a:rPr sz="1300" b="0" i="0">
+                <a:solidFill>
+                  <a:srgbClr val="59595F"/>
+                </a:solidFill>
+                <a:latin typeface="Calibri"/>
+              </a:rPr>
+              <a:t>presentations</a:t>
+            </a:r>
+          </a:p>
+        </p:txBody>
+      </p:sp>
+      <p:sp>
+        <p:nvSpPr>
+          <p:cNvPr id="5" name="Number 3"/>
+          <p:cNvSpPr txBox="1"/>
+          <p:nvPr/>
+        </p:nvSpPr>
+        <p:spPr>
+          <a:xfrm>
+            <a:off x="5394960" y="1417320"/>
+            <a:ext cx="1463040" cy="1325880"/>
+          </a:xfrm>
+          <a:prstGeom prst="rect">
+            <a:avLst/>
+          </a:prstGeom>
+          <a:noFill/>
+        </p:spPr>
+        <p:txBody>
+          <a:bodyPr wrap="square" anchor="t" lIns="0" rIns="0" tIns="0" bIns="0">
+            <a:spAutoFit/>
+          </a:bodyPr>
+          <a:lstStyle/>
           <a:p>
             <a:pPr algn="l">
               <a:spcAft>
@@ -12552,13 +12364,13 @@
               </a:spcAft>
             </a:pPr>
             <a:r>
-              <a:rPr sz="1300" b="0" i="0">
-                <a:solidFill>
-                  <a:srgbClr val="59595F"/>
-                </a:solidFill>
-                <a:latin typeface="Calibri"/>
-              </a:rPr>
-              <a:t>course runs</a:t>
+              <a:rPr sz="3200" b="1" i="0">
+                <a:solidFill>
+                  <a:srgbClr val="1F3864"/>
+                </a:solidFill>
+                <a:latin typeface="Calibri"/>
+              </a:rPr>
+              <a:t>52.8%</a:t>
             </a:r>
           </a:p>
           <a:p>
@@ -12574,21 +12386,21 @@
                 </a:solidFill>
                 <a:latin typeface="Calibri"/>
               </a:rPr>
-              <a:t>(7 modules, 4 semesters)</a:t>
-            </a:r>
-          </a:p>
-        </p:txBody>
-      </p:sp>
-      <p:sp>
-        <p:nvSpPr>
-          <p:cNvPr id="5" name="Number 3"/>
+              <a:t>at risk</a:t>
+            </a:r>
+          </a:p>
+        </p:txBody>
+      </p:sp>
+      <p:sp>
+        <p:nvSpPr>
+          <p:cNvPr id="6" name="Number 4"/>
           <p:cNvSpPr txBox="1"/>
           <p:nvPr/>
         </p:nvSpPr>
         <p:spPr>
           <a:xfrm>
-            <a:off x="6431280" y="1417320"/>
-            <a:ext cx="1981200" cy="1325880"/>
+            <a:off x="6949440" y="1417320"/>
+            <a:ext cx="1463040" cy="1325880"/>
           </a:xfrm>
           <a:prstGeom prst="rect">
             <a:avLst/>
@@ -12607,13 +12419,13 @@
               </a:spcAft>
             </a:pPr>
             <a:r>
-              <a:rPr sz="3600" b="1" i="0">
+              <a:rPr sz="3200" b="1" i="0">
                 <a:solidFill>
                   <a:srgbClr val="1F3864"/>
                 </a:solidFill>
                 <a:latin typeface="Calibri"/>
               </a:rPr>
-              <a:t>52.8%</a:t>
+              <a:t>59</a:t>
             </a:r>
           </a:p>
           <a:p>
@@ -12629,37 +12441,21 @@
                 </a:solidFill>
                 <a:latin typeface="Calibri"/>
               </a:rPr>
-              <a:t>withdrew or failed</a:t>
-            </a:r>
-          </a:p>
-          <a:p>
-            <a:pPr algn="l">
-              <a:spcAft>
-                <a:spcPts val="0"/>
-              </a:spcAft>
-            </a:pPr>
-            <a:r>
-              <a:rPr sz="1300" b="0" i="0">
-                <a:solidFill>
-                  <a:srgbClr val="59595F"/>
-                </a:solidFill>
-                <a:latin typeface="Calibri"/>
-              </a:rPr>
-              <a:t>(the at-risk group)</a:t>
-            </a:r>
-          </a:p>
-        </p:txBody>
-      </p:sp>
-      <p:sp>
-        <p:nvSpPr>
-          <p:cNvPr id="6" name="Dataset"/>
+              <a:t>features</a:t>
+            </a:r>
+          </a:p>
+        </p:txBody>
+      </p:sp>
+      <p:sp>
+        <p:nvSpPr>
+          <p:cNvPr id="7" name="Dataset"/>
           <p:cNvSpPr txBox="1"/>
           <p:nvPr/>
         </p:nvSpPr>
         <p:spPr>
           <a:xfrm>
-            <a:off x="2286000" y="2880360"/>
-            <a:ext cx="2926080" cy="1600200"/>
+            <a:off x="2286000" y="2743200"/>
+            <a:ext cx="6217920" cy="914400"/>
           </a:xfrm>
           <a:prstGeom prst="rect">
             <a:avLst/>
@@ -12699,13 +12495,52 @@
               <a:buChar char="•"/>
             </a:pPr>
             <a:r>
-              <a:rPr sz="1600" b="0" i="0">
+              <a:rPr sz="1700" b="0" i="0">
                 <a:solidFill>
                   <a:srgbClr val="26262E"/>
                 </a:solidFill>
                 <a:latin typeface="Calibri"/>
               </a:rPr>
-              <a:t>OULAD: public, anonymised benchmark (Kuzilek et al., 2017)</a:t>
+              <a:t>OULAD (Kuzilek et al., 2017); at risk = withdrew or failed; engagement, assessment and demographic features</a:t>
+            </a:r>
+          </a:p>
+        </p:txBody>
+      </p:sp>
+      <p:sp>
+        <p:nvSpPr>
+          <p:cNvPr id="8" name="Protocol"/>
+          <p:cNvSpPr txBox="1"/>
+          <p:nvPr/>
+        </p:nvSpPr>
+        <p:spPr>
+          <a:xfrm>
+            <a:off x="2286000" y="3703320"/>
+            <a:ext cx="6217920" cy="914400"/>
+          </a:xfrm>
+          <a:prstGeom prst="rect">
+            <a:avLst/>
+          </a:prstGeom>
+          <a:noFill/>
+        </p:spPr>
+        <p:txBody>
+          <a:bodyPr wrap="square" anchor="t" lIns="0" rIns="0" tIns="0" bIns="0">
+            <a:spAutoFit/>
+          </a:bodyPr>
+          <a:lstStyle/>
+          <a:p>
+            <a:pPr algn="l">
+              <a:spcAft>
+                <a:spcPts val="600"/>
+              </a:spcAft>
+            </a:pPr>
+            <a:r>
+              <a:rPr sz="1300" b="1" i="0">
+                <a:solidFill>
+                  <a:srgbClr val="C00000"/>
+                </a:solidFill>
+                <a:latin typeface="Calibri"/>
+              </a:rPr>
+              <a:t>VALIDATION PROTOCOL</a:t>
             </a:r>
           </a:p>
           <a:p>
@@ -12720,27 +12555,27 @@
               <a:buChar char="•"/>
             </a:pPr>
             <a:r>
-              <a:rPr sz="1600" b="0" i="0">
+              <a:rPr sz="1700" b="0" i="0">
                 <a:solidFill>
                   <a:srgbClr val="26262E"/>
                 </a:solidFill>
                 <a:latin typeface="Calibri"/>
               </a:rPr>
-              <a:t>Clicks, assessments and demographics: 59 features</a:t>
-            </a:r>
-          </a:p>
-        </p:txBody>
-      </p:sp>
-      <p:sp>
-        <p:nvSpPr>
-          <p:cNvPr id="7" name="Protocol"/>
+              <a:t>Four-fold GroupKFold by course presentation: test presentations unseen in training</a:t>
+            </a:r>
+          </a:p>
+        </p:txBody>
+      </p:sp>
+      <p:sp>
+        <p:nvSpPr>
+          <p:cNvPr id="9" name="Recall"/>
           <p:cNvSpPr txBox="1"/>
           <p:nvPr/>
         </p:nvSpPr>
         <p:spPr>
           <a:xfrm>
-            <a:off x="2286000" y="4526280"/>
-            <a:ext cx="2926080" cy="1645920"/>
+            <a:off x="2286000" y="4663440"/>
+            <a:ext cx="2926080" cy="1463040"/>
           </a:xfrm>
           <a:prstGeom prst="rect">
             <a:avLst/>
@@ -12765,7 +12600,7 @@
                 </a:solidFill>
                 <a:latin typeface="Calibri"/>
               </a:rPr>
-              <a:t>VALIDATION PROTOCOL</a:t>
+              <a:t>PRIMARY METRIC: RECALL</a:t>
             </a:r>
           </a:p>
           <a:p>
@@ -12780,13 +12615,52 @@
               <a:buChar char="•"/>
             </a:pPr>
             <a:r>
-              <a:rPr sz="1600" b="0" i="0">
+              <a:rPr sz="1700" b="0" i="0">
                 <a:solidFill>
                   <a:srgbClr val="26262E"/>
                 </a:solidFill>
                 <a:latin typeface="Calibri"/>
               </a:rPr>
-              <a:t>Trained on 3 semesters, tested on the 4th, then rotated</a:t>
+              <a:t>A missed at-risk student receives no attention</a:t>
+            </a:r>
+          </a:p>
+        </p:txBody>
+      </p:sp>
+      <p:sp>
+        <p:nvSpPr>
+          <p:cNvPr id="10" name="Limit"/>
+          <p:cNvSpPr txBox="1"/>
+          <p:nvPr/>
+        </p:nvSpPr>
+        <p:spPr>
+          <a:xfrm>
+            <a:off x="5577840" y="4663440"/>
+            <a:ext cx="2926080" cy="1463040"/>
+          </a:xfrm>
+          <a:prstGeom prst="rect">
+            <a:avLst/>
+          </a:prstGeom>
+          <a:noFill/>
+        </p:spPr>
+        <p:txBody>
+          <a:bodyPr wrap="square" anchor="t" lIns="0" rIns="0" tIns="0" bIns="0">
+            <a:spAutoFit/>
+          </a:bodyPr>
+          <a:lstStyle/>
+          <a:p>
+            <a:pPr algn="l">
+              <a:spcAft>
+                <a:spcPts val="600"/>
+              </a:spcAft>
+            </a:pPr>
+            <a:r>
+              <a:rPr sz="1300" b="1" i="0">
+                <a:solidFill>
+                  <a:srgbClr val="C00000"/>
+                </a:solidFill>
+                <a:latin typeface="Calibri"/>
+              </a:rPr>
+              <a:t>METHODOLOGICAL LIMITATION</a:t>
             </a:r>
           </a:p>
           <a:p>
@@ -12801,175 +12675,13 @@
               <a:buChar char="•"/>
             </a:pPr>
             <a:r>
-              <a:rPr sz="1600" b="0" i="0">
+              <a:rPr sz="1700" b="0" i="0">
                 <a:solidFill>
                   <a:srgbClr val="26262E"/>
                 </a:solidFill>
                 <a:latin typeface="Calibri"/>
               </a:rPr>
-              <a:t>Never tested on a semester it had seen</a:t>
-            </a:r>
-          </a:p>
-        </p:txBody>
-      </p:sp>
-      <p:sp>
-        <p:nvSpPr>
-          <p:cNvPr id="8" name="Recall"/>
-          <p:cNvSpPr txBox="1"/>
-          <p:nvPr/>
-        </p:nvSpPr>
-        <p:spPr>
-          <a:xfrm>
-            <a:off x="5577840" y="2880360"/>
-            <a:ext cx="2926080" cy="1600200"/>
-          </a:xfrm>
-          <a:prstGeom prst="rect">
-            <a:avLst/>
-          </a:prstGeom>
-          <a:noFill/>
-        </p:spPr>
-        <p:txBody>
-          <a:bodyPr wrap="square" anchor="t" lIns="0" rIns="0" tIns="0" bIns="0">
-            <a:spAutoFit/>
-          </a:bodyPr>
-          <a:lstStyle/>
-          <a:p>
-            <a:pPr algn="l">
-              <a:spcAft>
-                <a:spcPts val="600"/>
-              </a:spcAft>
-            </a:pPr>
-            <a:r>
-              <a:rPr sz="1300" b="1" i="0">
-                <a:solidFill>
-                  <a:srgbClr val="C00000"/>
-                </a:solidFill>
-                <a:latin typeface="Calibri"/>
-              </a:rPr>
-              <a:t>PRIMARY METRIC: RECALL</a:t>
-            </a:r>
-          </a:p>
-          <a:p>
-            <a:pPr algn="l" marL="201168" indent="-201168">
-              <a:spcAft>
-                <a:spcPts val="600"/>
-              </a:spcAft>
-              <a:buClr>
-                <a:srgbClr val="1F3864"/>
-              </a:buClr>
-              <a:buFont typeface="Arial"/>
-              <a:buChar char="•"/>
-            </a:pPr>
-            <a:r>
-              <a:rPr sz="1600" b="0" i="0">
-                <a:solidFill>
-                  <a:srgbClr val="26262E"/>
-                </a:solidFill>
-                <a:latin typeface="Calibri"/>
-              </a:rPr>
-              <a:t>Missing a struggling student is worse</a:t>
-            </a:r>
-          </a:p>
-          <a:p>
-            <a:pPr algn="l" marL="201168" indent="-201168">
-              <a:spcAft>
-                <a:spcPts val="600"/>
-              </a:spcAft>
-              <a:buClr>
-                <a:srgbClr val="1F3864"/>
-              </a:buClr>
-              <a:buFont typeface="Arial"/>
-              <a:buChar char="•"/>
-            </a:pPr>
-            <a:r>
-              <a:rPr sz="1600" b="0" i="0">
-                <a:solidFill>
-                  <a:srgbClr val="26262E"/>
-                </a:solidFill>
-                <a:latin typeface="Calibri"/>
-              </a:rPr>
-              <a:t>A false alarm only costs a quick staff check</a:t>
-            </a:r>
-          </a:p>
-        </p:txBody>
-      </p:sp>
-      <p:sp>
-        <p:nvSpPr>
-          <p:cNvPr id="9" name="Limit"/>
-          <p:cNvSpPr txBox="1"/>
-          <p:nvPr/>
-        </p:nvSpPr>
-        <p:spPr>
-          <a:xfrm>
-            <a:off x="5577840" y="4526280"/>
-            <a:ext cx="2926080" cy="1645920"/>
-          </a:xfrm>
-          <a:prstGeom prst="rect">
-            <a:avLst/>
-          </a:prstGeom>
-          <a:noFill/>
-        </p:spPr>
-        <p:txBody>
-          <a:bodyPr wrap="square" anchor="t" lIns="0" rIns="0" tIns="0" bIns="0">
-            <a:spAutoFit/>
-          </a:bodyPr>
-          <a:lstStyle/>
-          <a:p>
-            <a:pPr algn="l">
-              <a:spcAft>
-                <a:spcPts val="600"/>
-              </a:spcAft>
-            </a:pPr>
-            <a:r>
-              <a:rPr sz="1300" b="1" i="0">
-                <a:solidFill>
-                  <a:srgbClr val="C00000"/>
-                </a:solidFill>
-                <a:latin typeface="Calibri"/>
-              </a:rPr>
-              <a:t>METHODOLOGICAL LIMITATION</a:t>
-            </a:r>
-          </a:p>
-          <a:p>
-            <a:pPr algn="l" marL="201168" indent="-201168">
-              <a:spcAft>
-                <a:spcPts val="600"/>
-              </a:spcAft>
-              <a:buClr>
-                <a:srgbClr val="1F3864"/>
-              </a:buClr>
-              <a:buFont typeface="Arial"/>
-              <a:buChar char="•"/>
-            </a:pPr>
-            <a:r>
-              <a:rPr sz="1600" b="0" i="0">
-                <a:solidFill>
-                  <a:srgbClr val="26262E"/>
-                </a:solidFill>
-                <a:latin typeface="Calibri"/>
-              </a:rPr>
-              <a:t>Features cover the whole semester</a:t>
-            </a:r>
-          </a:p>
-          <a:p>
-            <a:pPr algn="l" marL="201168" indent="-201168">
-              <a:spcAft>
-                <a:spcPts val="600"/>
-              </a:spcAft>
-              <a:buClr>
-                <a:srgbClr val="1F3864"/>
-              </a:buClr>
-              <a:buFont typeface="Arial"/>
-              <a:buChar char="•"/>
-            </a:pPr>
-            <a:r>
-              <a:rPr sz="1600" b="0" i="0">
-                <a:solidFill>
-                  <a:srgbClr val="26262E"/>
-                </a:solidFill>
-                <a:latin typeface="Calibri"/>
-              </a:rPr>
-              <a:t>So this is after-the-fact, not yet early warning</a:t>
+              <a:t>Retrospective classification, not early warning</a:t>
             </a:r>
           </a:p>
         </p:txBody>

</xml_diff>

<commit_message>
Defense deck: formal outline wording
</commit_message>
<xml_diff>
--- a/Internal_Defense_Presentation.pptx
+++ b/Internal_Defense_Presentation.pptx
@@ -9990,7 +9990,7 @@
           <a:p>
             <a:pPr algn="l">
               <a:spcAft>
-                <a:spcPts val="1400"/>
+                <a:spcPts val="1200"/>
               </a:spcAft>
             </a:pPr>
             <a:r>
@@ -10009,13 +10009,13 @@
                 </a:solidFill>
                 <a:latin typeface="Calibri"/>
               </a:rPr>
-              <a:t>The problem: prediction without explanation</a:t>
+              <a:t>Background &amp; Problem Statement</a:t>
             </a:r>
           </a:p>
           <a:p>
             <a:pPr algn="l">
               <a:spcAft>
-                <a:spcPts val="1400"/>
+                <a:spcPts val="1200"/>
               </a:spcAft>
             </a:pPr>
             <a:r>
@@ -10034,13 +10034,13 @@
                 </a:solidFill>
                 <a:latin typeface="Calibri"/>
               </a:rPr>
-              <a:t>Aim, objectives and research questions</a:t>
+              <a:t>Aim, Objectives &amp; Research Questions</a:t>
             </a:r>
           </a:p>
           <a:p>
             <a:pPr algn="l">
               <a:spcAft>
-                <a:spcPts val="1400"/>
+                <a:spcPts val="1200"/>
               </a:spcAft>
             </a:pPr>
             <a:r>
@@ -10059,13 +10059,13 @@
                 </a:solidFill>
                 <a:latin typeface="Calibri"/>
               </a:rPr>
-              <a:t>Methodology: knowledge engineering</a:t>
+              <a:t>Methodology: Knowledge Engineering</a:t>
             </a:r>
           </a:p>
           <a:p>
             <a:pPr algn="l">
               <a:spcAft>
-                <a:spcPts val="1400"/>
+                <a:spcPts val="1200"/>
               </a:spcAft>
             </a:pPr>
             <a:r>
@@ -10084,13 +10084,13 @@
                 </a:solidFill>
                 <a:latin typeface="Calibri"/>
               </a:rPr>
-              <a:t>System architecture and implementation</a:t>
+              <a:t>System Architecture &amp; Implementation</a:t>
             </a:r>
           </a:p>
           <a:p>
             <a:pPr algn="l">
               <a:spcAft>
-                <a:spcPts val="1400"/>
+                <a:spcPts val="1200"/>
               </a:spcAft>
             </a:pPr>
             <a:r>
@@ -10109,13 +10109,13 @@
                 </a:solidFill>
                 <a:latin typeface="Calibri"/>
               </a:rPr>
-              <a:t>Evaluation: prediction and explainability</a:t>
+              <a:t>Dataset &amp; Evaluation Protocol</a:t>
             </a:r>
           </a:p>
           <a:p>
             <a:pPr algn="l">
               <a:spcAft>
-                <a:spcPts val="1400"/>
+                <a:spcPts val="1200"/>
               </a:spcAft>
             </a:pPr>
             <a:r>
@@ -10134,13 +10134,13 @@
                 </a:solidFill>
                 <a:latin typeface="Calibri"/>
               </a:rPr>
-              <a:t>Role-specific views in Moodle</a:t>
+              <a:t>Results: Prediction &amp; Explainability</a:t>
             </a:r>
           </a:p>
           <a:p>
             <a:pPr algn="l">
               <a:spcAft>
-                <a:spcPts val="1400"/>
+                <a:spcPts val="1200"/>
               </a:spcAft>
             </a:pPr>
             <a:r>
@@ -10159,7 +10159,32 @@
                 </a:solidFill>
                 <a:latin typeface="Calibri"/>
               </a:rPr>
-              <a:t>Contributions, limitations and conclusion</a:t>
+              <a:t>The Role-Aware Dashboard in Moodle</a:t>
+            </a:r>
+          </a:p>
+          <a:p>
+            <a:pPr algn="l">
+              <a:spcAft>
+                <a:spcPts val="1200"/>
+              </a:spcAft>
+            </a:pPr>
+            <a:r>
+              <a:rPr sz="2100" b="1" i="0">
+                <a:solidFill>
+                  <a:srgbClr val="C00000"/>
+                </a:solidFill>
+                <a:latin typeface="Calibri"/>
+              </a:rPr>
+              <a:t>8.  </a:t>
+            </a:r>
+            <a:r>
+              <a:rPr sz="2100" b="0" i="0">
+                <a:solidFill>
+                  <a:srgbClr val="26262E"/>
+                </a:solidFill>
+                <a:latin typeface="Calibri"/>
+              </a:rPr>
+              <a:t>Contributions, Limitations &amp; Conclusion</a:t>
             </a:r>
           </a:p>
         </p:txBody>

</xml_diff>

<commit_message>
Defense deck: defensible research gap wording
</commit_message>
<xml_diff>
--- a/Internal_Defense_Presentation.pptx
+++ b/Internal_Defense_Presentation.pptx
@@ -10520,8 +10520,8 @@
         </p:nvSpPr>
         <p:spPr>
           <a:xfrm>
-            <a:off x="2286000" y="4526280"/>
-            <a:ext cx="6217920" cy="1463040"/>
+            <a:off x="2286000" y="4434840"/>
+            <a:ext cx="6217920" cy="1737360"/>
           </a:xfrm>
           <a:prstGeom prst="rect">
             <a:avLst/>
@@ -10567,7 +10567,28 @@
                 </a:solidFill>
                 <a:latin typeface="Calibri"/>
               </a:rPr>
-              <a:t>No reviewed system serves all three roles from one prediction model with role-specific explanations (the only role-specific XAI dashboard found targets students: Afzaal et al., 2021)</a:t>
+              <a:t>In the literature reviewed, no system served instructors, advisors and administrators from a single prediction model with role-specific explanations</a:t>
+            </a:r>
+          </a:p>
+          <a:p>
+            <a:pPr algn="l" marL="201168" indent="-201168">
+              <a:spcAft>
+                <a:spcPts val="600"/>
+              </a:spcAft>
+              <a:buClr>
+                <a:srgbClr val="1F3864"/>
+              </a:buClr>
+              <a:buFont typeface="Arial"/>
+              <a:buChar char="•"/>
+            </a:pPr>
+            <a:r>
+              <a:rPr sz="1700" b="0" i="0">
+                <a:solidFill>
+                  <a:srgbClr val="26262E"/>
+                </a:solidFill>
+                <a:latin typeface="Calibri"/>
+              </a:rPr>
+              <a:t>Existing XAI dashboards target a single user group (e.g., students: Afzaal et al., 2021)</a:t>
             </a:r>
           </a:p>
         </p:txBody>

</xml_diff>

<commit_message>
Defense deck: add Canvas and Docker deployment screenshots
</commit_message>
<xml_diff>
--- a/Internal_Defense_Presentation.pptx
+++ b/Internal_Defense_Presentation.pptx
@@ -18,6 +18,7 @@
     <p:sldId id="285" r:id="rId19"/>
     <p:sldId id="286" r:id="rId20"/>
     <p:sldId id="287" r:id="rId21"/>
+    <p:sldId id="288" r:id="rId22"/>
     <p:sldId id="274" r:id="rId4"/>
   </p:sldIdLst>
   <p:sldSz cx="9144000" cy="6858000" type="screen4x3"/>
@@ -655,7 +656,7 @@
           <a:lstStyle/>
           <a:p>
             <a:r>
-              <a:t>The research makes four main contributions. First, it integrates prediction and explanation into a working system connected to learning management platforms. Second, it demonstrates a role-aware dashboard design that provides individual, caseload, and institution-level views. Third, it applies CommonKADS to the design of an explainable learning analytics system. Fourth, it provides an empirical comparison of where SHAP and LIME agree and differ in explaining the model's predictions. However, these contributions must be considered alongside the limitations. The evaluation used one dataset, the features support retrospective rather than early-warning classification, and no practitioner study was conducted. Additional checks on explanation stability, fidelity, probability calibration, and fairness were also not completed. I consider these limitations important because a technically promising system is not automatically a system that is reliable, fair, or useful in real educational settings.</a:t>
+              <a:t>The same dashboard also runs inside Canvas. On the left is the Canvas course FFF-2014J, where the dashboard is embedded as an External URL module item, so staff open it from inside their course. On the right is the Docker deployment. The whole environment runs in containers: PostgreSQL, Moodle, Canvas and the XAI dashboard API, which serves the predictions and explanations. All 22 OULAD module presentations were loaded as courses in both systems, with 28,785 students and 32,593 enrolments. This shows the prototype works inside the platforms institutions already use, and that the setup can be reproduced.</a:t>
             </a:r>
           </a:p>
         </p:txBody>
@@ -725,7 +726,7 @@
           <a:lstStyle/>
           <a:p>
             <a:r>
-              <a:t>To conclude, the first research question was addressed by integrating SHAP and LIME into a CommonKADS-informed prediction and explanation pipeline. The methods agreed on the main global driver but showed only partial agreement for individual students. The second question was addressed through the design and implementation of instructor, advisor, and administrator views in Moodle and Canvas. For the third question, the technical evaluation provides evidence of predictive performance and an implemented explanation workflow. However, whether practitioners can use these explanations effectively remains an open question. The next stage of the research would evaluate early-warning performance using data available at weeks two, four, six, and eight; assess probability calibration and fairness across subgroups; and conduct a practitioner study informed by the Technology Acceptance Model. Ultimately, the goal is not simply to predict which students may be at risk. It is to make those predictions more interpretable and appropriately accessible to the people who may be able to support them. Thank you for listening. I welcome your questions and comments.</a:t>
+              <a:t>The research makes four main contributions. First, it integrates prediction and explanation into a working system connected to learning management platforms. Second, it demonstrates a role-aware dashboard design that provides individual, caseload, and institution-level views. Third, it applies CommonKADS to the design of an explainable learning analytics system. Fourth, it provides an empirical comparison of where SHAP and LIME agree and differ in explaining the model's predictions. However, these contributions must be considered alongside the limitations. The evaluation used one dataset, the features support retrospective rather than early-warning classification, and no practitioner study was conducted. Additional checks on explanation stability, fidelity, probability calibration, and fairness were also not completed. I consider these limitations important because a technically promising system is not automatically a system that is reliable, fair, or useful in real educational settings.</a:t>
             </a:r>
           </a:p>
         </p:txBody>
@@ -751,6 +752,76 @@
 </file>
 
 <file path=ppt/notesSlides/notesSlide13.xml><?xml version="1.0" encoding="utf-8"?>
+<p:notes xmlns:a="http://schemas.openxmlformats.org/drawingml/2006/main" xmlns:p="http://schemas.openxmlformats.org/presentationml/2006/main" xmlns:r="http://schemas.openxmlformats.org/officeDocument/2006/relationships">
+  <p:cSld>
+    <p:spTree>
+      <p:nvGrpSpPr>
+        <p:cNvPr id="1" name=""/>
+        <p:cNvGrpSpPr/>
+        <p:nvPr/>
+      </p:nvGrpSpPr>
+      <p:grpSpPr>
+        <a:xfrm>
+          <a:off x="0" y="0"/>
+          <a:ext cx="0" cy="0"/>
+          <a:chOff x="0" y="0"/>
+          <a:chExt cx="0" cy="0"/>
+        </a:xfrm>
+      </p:grpSpPr>
+      <p:sp>
+        <p:nvSpPr>
+          <p:cNvPr id="2" name="Slide Image Placeholder 1"/>
+          <p:cNvSpPr>
+            <a:spLocks noGrp="1"/>
+          </p:cNvSpPr>
+          <p:nvPr>
+            <p:ph type="sldImg" idx="2"/>
+          </p:nvPr>
+        </p:nvSpPr>
+        <p:spPr/>
+      </p:sp>
+      <p:sp>
+        <p:nvSpPr>
+          <p:cNvPr id="3" name="Notes Placeholder 2"/>
+          <p:cNvSpPr>
+            <a:spLocks noGrp="1"/>
+          </p:cNvSpPr>
+          <p:nvPr>
+            <p:ph type="body" idx="3" sz="quarter"/>
+          </p:nvPr>
+        </p:nvSpPr>
+        <p:spPr/>
+        <p:txBody>
+          <a:bodyPr/>
+          <a:lstStyle/>
+          <a:p>
+            <a:r>
+              <a:t>To conclude, the first research question was addressed by integrating SHAP and LIME into a CommonKADS-informed prediction and explanation pipeline. The methods agreed on the main global driver but showed only partial agreement for individual students. The second question was addressed through the design and implementation of instructor, advisor, and administrator views in Moodle and Canvas. For the third question, the technical evaluation provides evidence of predictive performance and an implemented explanation workflow. However, whether practitioners can use these explanations effectively remains an open question. The next stage of the research would evaluate early-warning performance using data available at weeks two, four, six, and eight; assess probability calibration and fairness across subgroups; and conduct a practitioner study informed by the Technology Acceptance Model. Ultimately, the goal is not simply to predict which students may be at risk. It is to make those predictions more interpretable and appropriately accessible to the people who may be able to support them. Thank you for listening. I welcome your questions and comments.</a:t>
+            </a:r>
+          </a:p>
+        </p:txBody>
+      </p:sp>
+      <p:sp>
+        <p:nvSpPr>
+          <p:cNvPr id="4" name="Slide Number Placeholder 3"/>
+          <p:cNvSpPr>
+            <a:spLocks noGrp="1"/>
+          </p:cNvSpPr>
+          <p:nvPr>
+            <p:ph type="sldNum" idx="5" sz="quarter"/>
+          </p:nvPr>
+        </p:nvSpPr>
+        <p:spPr/>
+      </p:sp>
+    </p:spTree>
+  </p:cSld>
+  <p:clrMapOvr>
+    <a:masterClrMapping/>
+  </p:clrMapOvr>
+</p:notes>
+</file>
+
+<file path=ppt/notesSlides/notesSlide14.xml><?xml version="1.0" encoding="utf-8"?>
 <p:notes xmlns:a="http://schemas.openxmlformats.org/drawingml/2006/main" xmlns:p="http://schemas.openxmlformats.org/presentationml/2006/main" xmlns:r="http://schemas.openxmlformats.org/officeDocument/2006/relationships">
   <p:cSld>
     <p:spTree>
@@ -9322,21 +9393,21 @@
                 </a:solidFill>
                 <a:latin typeface="Calibri"/>
               </a:rPr>
-              <a:t>Contributions &amp; Limitations</a:t>
-            </a:r>
-          </a:p>
-        </p:txBody>
-      </p:sp>
-      <p:sp>
-        <p:nvSpPr>
-          <p:cNvPr id="3" name="Contributions"/>
+              <a:t>Deployment: Canvas Integration &amp; Docker</a:t>
+            </a:r>
+          </a:p>
+        </p:txBody>
+      </p:sp>
+      <p:sp>
+        <p:nvSpPr>
+          <p:cNvPr id="3" name="Canvas label"/>
           <p:cNvSpPr txBox="1"/>
           <p:nvPr/>
         </p:nvSpPr>
         <p:spPr>
           <a:xfrm>
-            <a:off x="2286000" y="1463040"/>
-            <a:ext cx="2926080" cy="4754880"/>
+            <a:off x="2286000" y="1371600"/>
+            <a:ext cx="6217920" cy="320040"/>
           </a:xfrm>
           <a:prstGeom prst="rect">
             <a:avLst/>
@@ -9351,7 +9422,7 @@
           <a:p>
             <a:pPr algn="l">
               <a:spcAft>
-                <a:spcPts val="1400"/>
+                <a:spcPts val="600"/>
               </a:spcAft>
             </a:pPr>
             <a:r>
@@ -9361,105 +9432,59 @@
                 </a:solidFill>
                 <a:latin typeface="Calibri"/>
               </a:rPr>
-              <a:t>CONTRIBUTIONS</a:t>
-            </a:r>
-          </a:p>
-          <a:p>
-            <a:pPr algn="l" marL="201168" indent="-201168">
-              <a:spcAft>
-                <a:spcPts val="1400"/>
-              </a:spcAft>
-              <a:buClr>
-                <a:srgbClr val="1F3864"/>
-              </a:buClr>
-              <a:buFont typeface="Arial"/>
-              <a:buChar char="•"/>
-            </a:pPr>
-            <a:r>
-              <a:rPr sz="1800" b="0" i="0">
-                <a:solidFill>
-                  <a:srgbClr val="26262E"/>
-                </a:solidFill>
-                <a:latin typeface="Calibri"/>
-              </a:rPr>
-              <a:t>Prediction and explanation in one LMS-connected system</a:t>
-            </a:r>
-          </a:p>
-          <a:p>
-            <a:pPr algn="l" marL="201168" indent="-201168">
-              <a:spcAft>
-                <a:spcPts val="1400"/>
-              </a:spcAft>
-              <a:buClr>
-                <a:srgbClr val="1F3864"/>
-              </a:buClr>
-              <a:buFont typeface="Arial"/>
-              <a:buChar char="•"/>
-            </a:pPr>
-            <a:r>
-              <a:rPr sz="1800" b="0" i="0">
-                <a:solidFill>
-                  <a:srgbClr val="26262E"/>
-                </a:solidFill>
-                <a:latin typeface="Calibri"/>
-              </a:rPr>
-              <a:t>Individual, caseload and institution-level views</a:t>
-            </a:r>
-          </a:p>
-          <a:p>
-            <a:pPr algn="l" marL="201168" indent="-201168">
-              <a:spcAft>
-                <a:spcPts val="1400"/>
-              </a:spcAft>
-              <a:buClr>
-                <a:srgbClr val="1F3864"/>
-              </a:buClr>
-              <a:buFont typeface="Arial"/>
-              <a:buChar char="•"/>
-            </a:pPr>
-            <a:r>
-              <a:rPr sz="1800" b="0" i="0">
-                <a:solidFill>
-                  <a:srgbClr val="26262E"/>
-                </a:solidFill>
-                <a:latin typeface="Calibri"/>
-              </a:rPr>
-              <a:t>CommonKADS applied to explainable learning analytics</a:t>
-            </a:r>
-          </a:p>
-          <a:p>
-            <a:pPr algn="l" marL="201168" indent="-201168">
-              <a:spcAft>
-                <a:spcPts val="1400"/>
-              </a:spcAft>
-              <a:buClr>
-                <a:srgbClr val="1F3864"/>
-              </a:buClr>
-              <a:buFont typeface="Arial"/>
-              <a:buChar char="•"/>
-            </a:pPr>
-            <a:r>
-              <a:rPr sz="1800" b="0" i="0">
-                <a:solidFill>
-                  <a:srgbClr val="26262E"/>
-                </a:solidFill>
-                <a:latin typeface="Calibri"/>
-              </a:rPr>
-              <a:t>Comparison of SHAP and LIME agreement</a:t>
-            </a:r>
-          </a:p>
-        </p:txBody>
-      </p:sp>
-      <p:sp>
-        <p:nvSpPr>
-          <p:cNvPr id="4" name="Limitations"/>
+              <a:t>CANVAS LMS  </a:t>
+            </a:r>
+            <a:r>
+              <a:rPr sz="1300" b="0" i="0">
+                <a:solidFill>
+                  <a:srgbClr val="59595F"/>
+                </a:solidFill>
+                <a:latin typeface="Calibri"/>
+              </a:rPr>
+              <a:t>course FFF-2014J, dashboard embedded as an External URL module item</a:t>
+            </a:r>
+          </a:p>
+        </p:txBody>
+      </p:sp>
+      <p:pic>
+        <p:nvPicPr>
+          <p:cNvPr id="4" name="Canvas screenshot" descr="canvas_crop.png"/>
+          <p:cNvPicPr>
+            <a:picLocks noChangeAspect="1"/>
+          </p:cNvPicPr>
+          <p:nvPr/>
+        </p:nvPicPr>
+        <p:blipFill>
+          <a:blip r:embed="rId3"/>
+          <a:stretch>
+            <a:fillRect/>
+          </a:stretch>
+        </p:blipFill>
+        <p:spPr>
+          <a:xfrm>
+            <a:off x="2286000" y="1691640"/>
+            <a:ext cx="5394960" cy="2860964"/>
+          </a:xfrm>
+          <a:prstGeom prst="rect">
+            <a:avLst/>
+          </a:prstGeom>
+          <a:ln w="9525">
+            <a:solidFill>
+              <a:srgbClr val="C9CAD3"/>
+            </a:solidFill>
+          </a:ln>
+        </p:spPr>
+      </p:pic>
+      <p:sp>
+        <p:nvSpPr>
+          <p:cNvPr id="5" name="Docker label"/>
           <p:cNvSpPr txBox="1"/>
           <p:nvPr/>
         </p:nvSpPr>
         <p:spPr>
           <a:xfrm>
-            <a:off x="5577840" y="1463040"/>
-            <a:ext cx="2926080" cy="4754880"/>
+            <a:off x="2286000" y="4689764"/>
+            <a:ext cx="6217920" cy="320040"/>
           </a:xfrm>
           <a:prstGeom prst="rect">
             <a:avLst/>
@@ -9474,7 +9499,7 @@
           <a:p>
             <a:pPr algn="l">
               <a:spcAft>
-                <a:spcPts val="1400"/>
+                <a:spcPts val="600"/>
               </a:spcAft>
             </a:pPr>
             <a:r>
@@ -9484,95 +9509,49 @@
                 </a:solidFill>
                 <a:latin typeface="Calibri"/>
               </a:rPr>
-              <a:t>LIMITATIONS</a:t>
-            </a:r>
-          </a:p>
-          <a:p>
-            <a:pPr algn="l" marL="201168" indent="-201168">
-              <a:spcAft>
-                <a:spcPts val="1400"/>
-              </a:spcAft>
-              <a:buClr>
-                <a:srgbClr val="1F3864"/>
-              </a:buClr>
-              <a:buFont typeface="Arial"/>
-              <a:buChar char="•"/>
-            </a:pPr>
-            <a:r>
-              <a:rPr sz="1800" b="0" i="0">
-                <a:solidFill>
-                  <a:srgbClr val="26262E"/>
-                </a:solidFill>
-                <a:latin typeface="Calibri"/>
-              </a:rPr>
-              <a:t>One dataset</a:t>
-            </a:r>
-          </a:p>
-          <a:p>
-            <a:pPr algn="l" marL="201168" indent="-201168">
-              <a:spcAft>
-                <a:spcPts val="1400"/>
-              </a:spcAft>
-              <a:buClr>
-                <a:srgbClr val="1F3864"/>
-              </a:buClr>
-              <a:buFont typeface="Arial"/>
-              <a:buChar char="•"/>
-            </a:pPr>
-            <a:r>
-              <a:rPr sz="1800" b="0" i="0">
-                <a:solidFill>
-                  <a:srgbClr val="26262E"/>
-                </a:solidFill>
-                <a:latin typeface="Calibri"/>
-              </a:rPr>
-              <a:t>Retrospective, not early-warning classification</a:t>
-            </a:r>
-          </a:p>
-          <a:p>
-            <a:pPr algn="l" marL="201168" indent="-201168">
-              <a:spcAft>
-                <a:spcPts val="1400"/>
-              </a:spcAft>
-              <a:buClr>
-                <a:srgbClr val="1F3864"/>
-              </a:buClr>
-              <a:buFont typeface="Arial"/>
-              <a:buChar char="•"/>
-            </a:pPr>
-            <a:r>
-              <a:rPr sz="1800" b="0" i="0">
-                <a:solidFill>
-                  <a:srgbClr val="26262E"/>
-                </a:solidFill>
-                <a:latin typeface="Calibri"/>
-              </a:rPr>
-              <a:t>No practitioner study</a:t>
-            </a:r>
-          </a:p>
-          <a:p>
-            <a:pPr algn="l" marL="201168" indent="-201168">
-              <a:spcAft>
-                <a:spcPts val="1400"/>
-              </a:spcAft>
-              <a:buClr>
-                <a:srgbClr val="1F3864"/>
-              </a:buClr>
-              <a:buFont typeface="Arial"/>
-              <a:buChar char="•"/>
-            </a:pPr>
-            <a:r>
-              <a:rPr sz="1800" b="0" i="0">
-                <a:solidFill>
-                  <a:srgbClr val="26262E"/>
-                </a:solidFill>
-                <a:latin typeface="Calibri"/>
-              </a:rPr>
-              <a:t>Stability, fidelity, calibration and fairness not yet assessed</a:t>
-            </a:r>
-          </a:p>
-        </p:txBody>
-      </p:sp>
+              <a:t>DOCKER COMPOSE  </a:t>
+            </a:r>
+            <a:r>
+              <a:rPr sz="1300" b="0" i="0">
+                <a:solidFill>
+                  <a:srgbClr val="59595F"/>
+                </a:solidFill>
+                <a:latin typeface="Calibri"/>
+              </a:rPr>
+              <a:t>PostgreSQL, Moodle, Canvas and the XAI dashboard API</a:t>
+            </a:r>
+          </a:p>
+        </p:txBody>
+      </p:sp>
+      <p:pic>
+        <p:nvPicPr>
+          <p:cNvPr id="6" name="Docker screenshot" descr="docker_crop.png"/>
+          <p:cNvPicPr>
+            <a:picLocks noChangeAspect="1"/>
+          </p:cNvPicPr>
+          <p:nvPr/>
+        </p:nvPicPr>
+        <p:blipFill>
+          <a:blip r:embed="rId4"/>
+          <a:stretch>
+            <a:fillRect/>
+          </a:stretch>
+        </p:blipFill>
+        <p:spPr>
+          <a:xfrm>
+            <a:off x="2286000" y="5009804"/>
+            <a:ext cx="6217920" cy="1367942"/>
+          </a:xfrm>
+          <a:prstGeom prst="rect">
+            <a:avLst/>
+          </a:prstGeom>
+          <a:ln w="9525">
+            <a:solidFill>
+              <a:srgbClr val="C9CAD3"/>
+            </a:solidFill>
+          </a:ln>
+        </p:spPr>
+      </p:pic>
     </p:spTree>
   </p:cSld>
   <p:clrMapOvr>
@@ -9582,6 +9561,305 @@
 </file>
 
 <file path=ppt/slides/slide14.xml><?xml version="1.0" encoding="utf-8"?>
+<p:sld xmlns:a="http://schemas.openxmlformats.org/drawingml/2006/main" xmlns:p="http://schemas.openxmlformats.org/presentationml/2006/main" xmlns:r="http://schemas.openxmlformats.org/officeDocument/2006/relationships">
+  <p:cSld>
+    <p:spTree>
+      <p:nvGrpSpPr>
+        <p:cNvPr id="1" name=""/>
+        <p:cNvGrpSpPr/>
+        <p:nvPr/>
+      </p:nvGrpSpPr>
+      <p:grpSpPr/>
+      <p:sp>
+        <p:nvSpPr>
+          <p:cNvPr id="2" name="Title 1"/>
+          <p:cNvSpPr>
+            <a:spLocks noGrp="1"/>
+          </p:cNvSpPr>
+          <p:nvPr>
+            <p:ph type="title"/>
+          </p:nvPr>
+        </p:nvSpPr>
+        <p:spPr>
+          <a:xfrm>
+            <a:off x="2286000" y="502920"/>
+            <a:ext cx="6217920" cy="685800"/>
+          </a:xfrm>
+        </p:spPr>
+        <p:txBody>
+          <a:bodyPr wrap="square" anchor="b" lIns="0" rIns="0" bIns="0">
+            <a:normAutofit/>
+          </a:bodyPr>
+          <a:lstStyle/>
+          <a:p>
+            <a:pPr algn="l"/>
+            <a:r>
+              <a:rPr sz="2800" b="1" i="0">
+                <a:solidFill>
+                  <a:srgbClr val="1F3864"/>
+                </a:solidFill>
+                <a:latin typeface="Calibri"/>
+              </a:rPr>
+              <a:t>Contributions &amp; Limitations</a:t>
+            </a:r>
+          </a:p>
+        </p:txBody>
+      </p:sp>
+      <p:sp>
+        <p:nvSpPr>
+          <p:cNvPr id="3" name="Contributions"/>
+          <p:cNvSpPr txBox="1"/>
+          <p:nvPr/>
+        </p:nvSpPr>
+        <p:spPr>
+          <a:xfrm>
+            <a:off x="2286000" y="1463040"/>
+            <a:ext cx="2926080" cy="4754880"/>
+          </a:xfrm>
+          <a:prstGeom prst="rect">
+            <a:avLst/>
+          </a:prstGeom>
+          <a:noFill/>
+        </p:spPr>
+        <p:txBody>
+          <a:bodyPr wrap="square" anchor="t" lIns="0" rIns="0" tIns="0" bIns="0">
+            <a:spAutoFit/>
+          </a:bodyPr>
+          <a:lstStyle/>
+          <a:p>
+            <a:pPr algn="l">
+              <a:spcAft>
+                <a:spcPts val="1400"/>
+              </a:spcAft>
+            </a:pPr>
+            <a:r>
+              <a:rPr sz="1300" b="1" i="0">
+                <a:solidFill>
+                  <a:srgbClr val="C00000"/>
+                </a:solidFill>
+                <a:latin typeface="Calibri"/>
+              </a:rPr>
+              <a:t>CONTRIBUTIONS</a:t>
+            </a:r>
+          </a:p>
+          <a:p>
+            <a:pPr algn="l" marL="201168" indent="-201168">
+              <a:spcAft>
+                <a:spcPts val="1400"/>
+              </a:spcAft>
+              <a:buClr>
+                <a:srgbClr val="1F3864"/>
+              </a:buClr>
+              <a:buFont typeface="Arial"/>
+              <a:buChar char="•"/>
+            </a:pPr>
+            <a:r>
+              <a:rPr sz="1800" b="0" i="0">
+                <a:solidFill>
+                  <a:srgbClr val="26262E"/>
+                </a:solidFill>
+                <a:latin typeface="Calibri"/>
+              </a:rPr>
+              <a:t>Prediction and explanation in one LMS-connected system</a:t>
+            </a:r>
+          </a:p>
+          <a:p>
+            <a:pPr algn="l" marL="201168" indent="-201168">
+              <a:spcAft>
+                <a:spcPts val="1400"/>
+              </a:spcAft>
+              <a:buClr>
+                <a:srgbClr val="1F3864"/>
+              </a:buClr>
+              <a:buFont typeface="Arial"/>
+              <a:buChar char="•"/>
+            </a:pPr>
+            <a:r>
+              <a:rPr sz="1800" b="0" i="0">
+                <a:solidFill>
+                  <a:srgbClr val="26262E"/>
+                </a:solidFill>
+                <a:latin typeface="Calibri"/>
+              </a:rPr>
+              <a:t>Individual, caseload and institution-level views</a:t>
+            </a:r>
+          </a:p>
+          <a:p>
+            <a:pPr algn="l" marL="201168" indent="-201168">
+              <a:spcAft>
+                <a:spcPts val="1400"/>
+              </a:spcAft>
+              <a:buClr>
+                <a:srgbClr val="1F3864"/>
+              </a:buClr>
+              <a:buFont typeface="Arial"/>
+              <a:buChar char="•"/>
+            </a:pPr>
+            <a:r>
+              <a:rPr sz="1800" b="0" i="0">
+                <a:solidFill>
+                  <a:srgbClr val="26262E"/>
+                </a:solidFill>
+                <a:latin typeface="Calibri"/>
+              </a:rPr>
+              <a:t>CommonKADS applied to explainable learning analytics</a:t>
+            </a:r>
+          </a:p>
+          <a:p>
+            <a:pPr algn="l" marL="201168" indent="-201168">
+              <a:spcAft>
+                <a:spcPts val="1400"/>
+              </a:spcAft>
+              <a:buClr>
+                <a:srgbClr val="1F3864"/>
+              </a:buClr>
+              <a:buFont typeface="Arial"/>
+              <a:buChar char="•"/>
+            </a:pPr>
+            <a:r>
+              <a:rPr sz="1800" b="0" i="0">
+                <a:solidFill>
+                  <a:srgbClr val="26262E"/>
+                </a:solidFill>
+                <a:latin typeface="Calibri"/>
+              </a:rPr>
+              <a:t>Comparison of SHAP and LIME agreement</a:t>
+            </a:r>
+          </a:p>
+        </p:txBody>
+      </p:sp>
+      <p:sp>
+        <p:nvSpPr>
+          <p:cNvPr id="4" name="Limitations"/>
+          <p:cNvSpPr txBox="1"/>
+          <p:nvPr/>
+        </p:nvSpPr>
+        <p:spPr>
+          <a:xfrm>
+            <a:off x="5577840" y="1463040"/>
+            <a:ext cx="2926080" cy="4754880"/>
+          </a:xfrm>
+          <a:prstGeom prst="rect">
+            <a:avLst/>
+          </a:prstGeom>
+          <a:noFill/>
+        </p:spPr>
+        <p:txBody>
+          <a:bodyPr wrap="square" anchor="t" lIns="0" rIns="0" tIns="0" bIns="0">
+            <a:spAutoFit/>
+          </a:bodyPr>
+          <a:lstStyle/>
+          <a:p>
+            <a:pPr algn="l">
+              <a:spcAft>
+                <a:spcPts val="1400"/>
+              </a:spcAft>
+            </a:pPr>
+            <a:r>
+              <a:rPr sz="1300" b="1" i="0">
+                <a:solidFill>
+                  <a:srgbClr val="C00000"/>
+                </a:solidFill>
+                <a:latin typeface="Calibri"/>
+              </a:rPr>
+              <a:t>LIMITATIONS</a:t>
+            </a:r>
+          </a:p>
+          <a:p>
+            <a:pPr algn="l" marL="201168" indent="-201168">
+              <a:spcAft>
+                <a:spcPts val="1400"/>
+              </a:spcAft>
+              <a:buClr>
+                <a:srgbClr val="1F3864"/>
+              </a:buClr>
+              <a:buFont typeface="Arial"/>
+              <a:buChar char="•"/>
+            </a:pPr>
+            <a:r>
+              <a:rPr sz="1800" b="0" i="0">
+                <a:solidFill>
+                  <a:srgbClr val="26262E"/>
+                </a:solidFill>
+                <a:latin typeface="Calibri"/>
+              </a:rPr>
+              <a:t>One dataset</a:t>
+            </a:r>
+          </a:p>
+          <a:p>
+            <a:pPr algn="l" marL="201168" indent="-201168">
+              <a:spcAft>
+                <a:spcPts val="1400"/>
+              </a:spcAft>
+              <a:buClr>
+                <a:srgbClr val="1F3864"/>
+              </a:buClr>
+              <a:buFont typeface="Arial"/>
+              <a:buChar char="•"/>
+            </a:pPr>
+            <a:r>
+              <a:rPr sz="1800" b="0" i="0">
+                <a:solidFill>
+                  <a:srgbClr val="26262E"/>
+                </a:solidFill>
+                <a:latin typeface="Calibri"/>
+              </a:rPr>
+              <a:t>Retrospective, not early-warning classification</a:t>
+            </a:r>
+          </a:p>
+          <a:p>
+            <a:pPr algn="l" marL="201168" indent="-201168">
+              <a:spcAft>
+                <a:spcPts val="1400"/>
+              </a:spcAft>
+              <a:buClr>
+                <a:srgbClr val="1F3864"/>
+              </a:buClr>
+              <a:buFont typeface="Arial"/>
+              <a:buChar char="•"/>
+            </a:pPr>
+            <a:r>
+              <a:rPr sz="1800" b="0" i="0">
+                <a:solidFill>
+                  <a:srgbClr val="26262E"/>
+                </a:solidFill>
+                <a:latin typeface="Calibri"/>
+              </a:rPr>
+              <a:t>No practitioner study</a:t>
+            </a:r>
+          </a:p>
+          <a:p>
+            <a:pPr algn="l" marL="201168" indent="-201168">
+              <a:spcAft>
+                <a:spcPts val="1400"/>
+              </a:spcAft>
+              <a:buClr>
+                <a:srgbClr val="1F3864"/>
+              </a:buClr>
+              <a:buFont typeface="Arial"/>
+              <a:buChar char="•"/>
+            </a:pPr>
+            <a:r>
+              <a:rPr sz="1800" b="0" i="0">
+                <a:solidFill>
+                  <a:srgbClr val="26262E"/>
+                </a:solidFill>
+                <a:latin typeface="Calibri"/>
+              </a:rPr>
+              <a:t>Stability, fidelity, calibration and fairness not yet assessed</a:t>
+            </a:r>
+          </a:p>
+        </p:txBody>
+      </p:sp>
+    </p:spTree>
+  </p:cSld>
+  <p:clrMapOvr>
+    <a:masterClrMapping/>
+  </p:clrMapOvr>
+</p:sld>
+</file>
+
+<file path=ppt/slides/slide15.xml><?xml version="1.0" encoding="utf-8"?>
 <p:sld xmlns:a="http://schemas.openxmlformats.org/drawingml/2006/main" xmlns:p="http://schemas.openxmlformats.org/presentationml/2006/main" xmlns:r="http://schemas.openxmlformats.org/officeDocument/2006/relationships">
   <p:cSld>
     <p:spTree>

</xml_diff>